<commit_message>
Présentation comptes de paiement : page d'accueil et sommaire du modèle RCI ajoutés
Co-Authored-By: Claude Opus 5.5 <noreply@anthropic.com>
Claude-Session: https://claude.ai/code/session_01NEhkcxCB327Mdpf33KqYQU
</commit_message>
<xml_diff>
--- a/RCI_Besoins_Tresorerie_Comptes_Paiement_30-09-2026.pptx
+++ b/RCI_Besoins_Tresorerie_Comptes_Paiement_30-09-2026.pptx
@@ -8,9 +8,11 @@
     <p:sldId id="256" r:id="rId2"/>
     <p:sldId id="257" r:id="rId3"/>
     <p:sldId id="258" r:id="rId4"/>
+    <p:sldId id="259" r:id="rId5"/>
+    <p:sldId id="260" r:id="rId6"/>
   </p:sldIdLst>
   <p:notesMasterIdLst>
-    <p:notesMasterId r:id="rId5"/>
+    <p:notesMasterId r:id="rId7"/>
   </p:notesMasterIdLst>
   <p:sldSz cx="12192000" cy="6858000"/>
   <p:notesSz cx="6858000" cy="12192000"/>
@@ -504,7 +506,7 @@
           <a:p>
             <a:r>
               <a:rPr lang="en-US" dirty="0"/>
-              <a:t>Source : Reporting_Hebdo_CIV_30-09-2026.xlsx. Fonctionnement = balance âgée de l'audit au 30/09 (hors intragroupe), impôts, cotisations, salaires et flux SCO AO du reporting du 21/09. Projets = cash plans des bilans financiers du 02/10 (montants non réglés) ; octobre placé dans la semaine connue de PICI Projets, sinon en S2. Comptes payeurs : comptes « Dédié besoin de fonctionnement » des sociétés (y compris BNI-RIVIERA courant), comptes « Dédié paiement CPI » des projets, compte Debt Service de FIRST. Déficits mesurés en fin S5, entité par entité, sans compensation.</a:t>
+              <a:t>Couverture. Position de trésorerie CI au 30/09/2026 ; audit des décaissements fournisseurs du 30/09/2026 ; cash plans des bilans financiers du 02/10/2026 (Riviera Park, Village Notre Père) ; reporting cash hebdomadaire CIV.</a:t>
             </a:r>
             <a:endParaRPr lang="en-US" dirty="0"/>
           </a:p>
@@ -592,7 +594,7 @@
           <a:p>
             <a:r>
               <a:rPr lang="en-US" dirty="0"/>
-              <a:t>Trésorerie 30/09 = comptes de l'entité dans la position CI. SCO AO : fournisseurs projet payés depuis les comptes « Dédié paiement Projet SCO » (BACI-Projet 22,6 et BACI-AGORA 0,2) ; le reste (salaires 24,3, cotisations 16,6, fournisseurs 21,7, protocole Thulium 15,0, impôts 9,5, moins 3,6 d'encaissement client) depuis BACI courant 5,4, BOA 0,9 et Ecobank 0,1. FIRST : la redevance Diaby a exactement le montant du compte STANBIC-FIRST_LL (42,5) ; à confirmer avant de l'y imputer. Village Notre Père, autres : foncier 3,8 et autres dépenses 13,1. Riviera Park, autres : autres dépenses 37,5 et foncier 26,6.</a:t>
+              <a:t/>
             </a:r>
             <a:endParaRPr lang="en-US" dirty="0"/>
           </a:p>
@@ -680,6 +682,182 @@
           <a:p>
             <a:r>
               <a:rPr lang="en-US" dirty="0"/>
+              <a:t>Source : Reporting_Hebdo_CIV_30-09-2026.xlsx. Fonctionnement = balance âgée de l'audit au 30/09 (hors intragroupe), impôts, cotisations, salaires et flux SCO AO du reporting du 21/09. Projets = cash plans des bilans financiers du 02/10 (montants non réglés) ; octobre placé dans la semaine connue de PICI Projets, sinon en S2. Comptes payeurs : comptes « Dédié besoin de fonctionnement » des sociétés (y compris BNI-RIVIERA courant), comptes « Dédié paiement CPI » des projets, compte Debt Service de FIRST. Déficits mesurés en fin S5, entité par entité, sans compensation.</a:t>
+            </a:r>
+            <a:endParaRPr lang="en-US" dirty="0"/>
+          </a:p>
+        </p:txBody>
+      </p:sp>
+      <p:sp>
+        <p:nvSpPr>
+          <p:cNvPr id="4" name="Slide Number Placeholder 3"/>
+          <p:cNvSpPr>
+            <a:spLocks noGrp="1"/>
+          </p:cNvSpPr>
+          <p:nvPr>
+            <p:ph type="sldNum" sz="quarter" idx="10"/>
+          </p:nvPr>
+        </p:nvSpPr>
+        <p:spPr/>
+        <p:txBody>
+          <a:bodyPr/>
+          <a:lstStyle/>
+          <a:p>
+            <a:fld id="{F7021451-1387-4CA6-816F-3879F97B5CBC}" type="slidenum">
+              <a:rPr lang="en-US"/>
+              <a:t>3</a:t>
+            </a:fld>
+            <a:endParaRPr lang="en-US"/>
+          </a:p>
+        </p:txBody>
+      </p:sp>
+    </p:spTree>
+    <p:extLst>
+      <p:ext uri="{BB962C8B-B14F-4D97-AF65-F5344CB8AC3E}">
+        <p14:creationId xmlns:p14="http://schemas.microsoft.com/office/powerpoint/2010/main" val="1024086991"/>
+      </p:ext>
+    </p:extLst>
+  </p:cSld>
+  <p:clrMapOvr>
+    <a:masterClrMapping/>
+  </p:clrMapOvr>
+</p:notes>
+</file>
+
+<file path=ppt/notesSlides/notesSlide4.xml><?xml version="1.0" encoding="utf-8"?>
+<p:notes xmlns:a="http://schemas.openxmlformats.org/drawingml/2006/main" xmlns:r="http://schemas.openxmlformats.org/officeDocument/2006/relationships" xmlns:p="http://schemas.openxmlformats.org/presentationml/2006/main">
+  <p:cSld>
+    <p:spTree>
+      <p:nvGrpSpPr>
+        <p:cNvPr id="1" name=""/>
+        <p:cNvGrpSpPr/>
+        <p:nvPr/>
+      </p:nvGrpSpPr>
+      <p:grpSpPr>
+        <a:xfrm>
+          <a:off x="0" y="0"/>
+          <a:ext cx="0" cy="0"/>
+          <a:chOff x="0" y="0"/>
+          <a:chExt cx="0" cy="0"/>
+        </a:xfrm>
+      </p:grpSpPr>
+      <p:sp>
+        <p:nvSpPr>
+          <p:cNvPr id="2" name="Slide Image Placeholder 1"/>
+          <p:cNvSpPr>
+            <a:spLocks noGrp="1" noRot="1" noChangeAspect="1"/>
+          </p:cNvSpPr>
+          <p:nvPr>
+            <p:ph type="sldImg"/>
+          </p:nvPr>
+        </p:nvSpPr>
+        <p:spPr/>
+      </p:sp>
+      <p:sp>
+        <p:nvSpPr>
+          <p:cNvPr id="3" name="Notes Placeholder 2"/>
+          <p:cNvSpPr>
+            <a:spLocks noGrp="1"/>
+          </p:cNvSpPr>
+          <p:nvPr>
+            <p:ph type="body" idx="1"/>
+          </p:nvPr>
+        </p:nvSpPr>
+        <p:spPr/>
+        <p:txBody>
+          <a:bodyPr/>
+          <a:lstStyle/>
+          <a:p>
+            <a:r>
+              <a:rPr lang="en-US" dirty="0"/>
+              <a:t>Trésorerie 30/09 = comptes de l'entité dans la position CI. SCO AO : fournisseurs projet payés depuis les comptes « Dédié paiement Projet SCO » (BACI-Projet 22,6 et BACI-AGORA 0,2) ; le reste (salaires 24,3, cotisations 16,6, fournisseurs 21,7, protocole Thulium 15,0, impôts 9,5, moins 3,6 d'encaissement client) depuis BACI courant 5,4, BOA 0,9 et Ecobank 0,1. FIRST : la redevance Diaby a exactement le montant du compte STANBIC-FIRST_LL (42,5) ; à confirmer avant de l'y imputer. Village Notre Père, autres : foncier 3,8 et autres dépenses 13,1. Riviera Park, autres : autres dépenses 37,5 et foncier 26,6.</a:t>
+            </a:r>
+            <a:endParaRPr lang="en-US" dirty="0"/>
+          </a:p>
+        </p:txBody>
+      </p:sp>
+      <p:sp>
+        <p:nvSpPr>
+          <p:cNvPr id="4" name="Slide Number Placeholder 3"/>
+          <p:cNvSpPr>
+            <a:spLocks noGrp="1"/>
+          </p:cNvSpPr>
+          <p:nvPr>
+            <p:ph type="sldNum" sz="quarter" idx="10"/>
+          </p:nvPr>
+        </p:nvSpPr>
+        <p:spPr/>
+        <p:txBody>
+          <a:bodyPr/>
+          <a:lstStyle/>
+          <a:p>
+            <a:fld id="{F7021451-1387-4CA6-816F-3879F97B5CBC}" type="slidenum">
+              <a:rPr lang="en-US"/>
+              <a:t>4</a:t>
+            </a:fld>
+            <a:endParaRPr lang="en-US"/>
+          </a:p>
+        </p:txBody>
+      </p:sp>
+    </p:spTree>
+    <p:extLst>
+      <p:ext uri="{BB962C8B-B14F-4D97-AF65-F5344CB8AC3E}">
+        <p14:creationId xmlns:p14="http://schemas.microsoft.com/office/powerpoint/2010/main" val="1024086991"/>
+      </p:ext>
+    </p:extLst>
+  </p:cSld>
+  <p:clrMapOvr>
+    <a:masterClrMapping/>
+  </p:clrMapOvr>
+</p:notes>
+</file>
+
+<file path=ppt/notesSlides/notesSlide5.xml><?xml version="1.0" encoding="utf-8"?>
+<p:notes xmlns:a="http://schemas.openxmlformats.org/drawingml/2006/main" xmlns:r="http://schemas.openxmlformats.org/officeDocument/2006/relationships" xmlns:p="http://schemas.openxmlformats.org/presentationml/2006/main">
+  <p:cSld>
+    <p:spTree>
+      <p:nvGrpSpPr>
+        <p:cNvPr id="1" name=""/>
+        <p:cNvGrpSpPr/>
+        <p:nvPr/>
+      </p:nvGrpSpPr>
+      <p:grpSpPr>
+        <a:xfrm>
+          <a:off x="0" y="0"/>
+          <a:ext cx="0" cy="0"/>
+          <a:chOff x="0" y="0"/>
+          <a:chExt cx="0" cy="0"/>
+        </a:xfrm>
+      </p:grpSpPr>
+      <p:sp>
+        <p:nvSpPr>
+          <p:cNvPr id="2" name="Slide Image Placeholder 1"/>
+          <p:cNvSpPr>
+            <a:spLocks noGrp="1" noRot="1" noChangeAspect="1"/>
+          </p:cNvSpPr>
+          <p:nvPr>
+            <p:ph type="sldImg"/>
+          </p:nvPr>
+        </p:nvSpPr>
+        <p:spPr/>
+      </p:sp>
+      <p:sp>
+        <p:nvSpPr>
+          <p:cNvPr id="3" name="Notes Placeholder 2"/>
+          <p:cNvSpPr>
+            <a:spLocks noGrp="1"/>
+          </p:cNvSpPr>
+          <p:nvPr>
+            <p:ph type="body" idx="1"/>
+          </p:nvPr>
+        </p:nvSpPr>
+        <p:spPr/>
+        <p:txBody>
+          <a:bodyPr/>
+          <a:lstStyle/>
+          <a:p>
+            <a:r>
+              <a:rPr lang="en-US" dirty="0"/>
               <a:t>BNI-RIVIERA courant (1 772,0 M) : 10,9 M pour le fonctionnement Riviera, 601,4 M pour le fonds projet RP, 1 157,4 M avancés à TERASSON ; reste 2,3 M. La position CI le marque « Affectation placement ? Ou besoin de fonctionnement ». SG-PICI porte la destination « Dédié besoin de fonctionnement et Netting autres compagnies CIV » : compte naturel des avances intragroupe, à alimenter d'abord depuis ECOBANK-PICI (368,2 M). L'encaissement PICI de 656,0 M n'est compté dans aucune option.</a:t>
             </a:r>
             <a:endParaRPr lang="en-US" dirty="0"/>
@@ -703,7 +881,7 @@
           <a:p>
             <a:fld id="{F7021451-1387-4CA6-816F-3879F97B5CBC}" type="slidenum">
               <a:rPr lang="en-US"/>
-              <a:t>3</a:t>
+              <a:t>5</a:t>
             </a:fld>
             <a:endParaRPr lang="en-US"/>
           </a:p>
@@ -1035,6 +1213,218 @@
     <p:bg>
       <p:bgPr>
         <a:solidFill>
+          <a:srgbClr val="002C50"/>
+        </a:solidFill>
+      </p:bgPr>
+    </p:bg>
+    <p:spTree>
+      <p:nvGrpSpPr>
+        <p:cNvPr id="1" name=""/>
+        <p:cNvGrpSpPr/>
+        <p:nvPr/>
+      </p:nvGrpSpPr>
+      <p:grpSpPr>
+        <a:xfrm>
+          <a:off x="0" y="0"/>
+          <a:ext cx="0" cy="0"/>
+          <a:chOff x="0" y="0"/>
+          <a:chExt cx="0" cy="0"/>
+        </a:xfrm>
+      </p:grpSpPr>
+      <p:pic>
+        <p:nvPicPr>
+          <p:cNvPr id="2" name="Image 0" descr="preencoded.png">    </p:cNvPr>
+          <p:cNvPicPr>
+            <a:picLocks noChangeAspect="1"/>
+          </p:cNvPicPr>
+          <p:nvPr/>
+        </p:nvPicPr>
+        <p:blipFill>
+          <a:blip r:embed="rId1"/>
+          <a:stretch>
+            <a:fillRect/>
+          </a:stretch>
+        </p:blipFill>
+        <p:spPr>
+          <a:xfrm>
+            <a:off x="7315200" y="0"/>
+            <a:ext cx="4873752" cy="6858000"/>
+          </a:xfrm>
+          <a:prstGeom prst="rect">
+            <a:avLst/>
+          </a:prstGeom>
+        </p:spPr>
+      </p:pic>
+      <p:sp>
+        <p:nvSpPr>
+          <p:cNvPr id="3" name="Text 0"/>
+          <p:cNvSpPr txBox="1"/>
+          <p:nvPr/>
+        </p:nvSpPr>
+        <p:spPr>
+          <a:xfrm>
+            <a:off x="731520" y="1371600"/>
+            <a:ext cx="6309360" cy="365760"/>
+          </a:xfrm>
+          <a:prstGeom prst="rect">
+            <a:avLst/>
+          </a:prstGeom>
+          <a:noFill/>
+          <a:ln/>
+        </p:spPr>
+        <p:txBody>
+          <a:bodyPr wrap="square" lIns="0" tIns="0" rIns="0" bIns="0" rtlCol="0" anchor="ctr"/>
+          <a:lstStyle/>
+          <a:p>
+            <a:pPr indent="0" marL="0">
+              <a:buNone/>
+            </a:pPr>
+            <a:r>
+              <a:rPr lang="en-US" sz="1400" b="1" spc="200" kern="0" dirty="0">
+                <a:solidFill>
+                  <a:srgbClr val="D4B483"/>
+                </a:solidFill>
+                <a:latin typeface="Calibri" pitchFamily="34" charset="0"/>
+                <a:ea typeface="Calibri" pitchFamily="34" charset="-122"/>
+                <a:cs typeface="Calibri" pitchFamily="34" charset="-120"/>
+              </a:rPr>
+              <a:t>SOCIÉTÉS RCI – TRÉSORERIE</a:t>
+            </a:r>
+            <a:endParaRPr lang="en-US" sz="1400" dirty="0"/>
+          </a:p>
+        </p:txBody>
+      </p:sp>
+      <p:sp>
+        <p:nvSpPr>
+          <p:cNvPr id="4" name="Text 1"/>
+          <p:cNvSpPr txBox="1"/>
+          <p:nvPr/>
+        </p:nvSpPr>
+        <p:spPr>
+          <a:xfrm>
+            <a:off x="731520" y="1828800"/>
+            <a:ext cx="6309360" cy="1828800"/>
+          </a:xfrm>
+          <a:prstGeom prst="rect">
+            <a:avLst/>
+          </a:prstGeom>
+          <a:noFill/>
+          <a:ln/>
+        </p:spPr>
+        <p:txBody>
+          <a:bodyPr wrap="square" lIns="0" tIns="0" rIns="0" bIns="0" rtlCol="0" anchor="t"/>
+          <a:lstStyle/>
+          <a:p>
+            <a:pPr indent="0" marL="0">
+              <a:buNone/>
+            </a:pPr>
+            <a:r>
+              <a:rPr lang="en-US" sz="3400" b="1" dirty="0">
+                <a:solidFill>
+                  <a:srgbClr val="FFFFFF"/>
+                </a:solidFill>
+                <a:latin typeface="Calibri" pitchFamily="34" charset="0"/>
+                <a:ea typeface="Calibri" pitchFamily="34" charset="-122"/>
+                <a:cs typeface="Calibri" pitchFamily="34" charset="-120"/>
+              </a:rPr>
+              <a:t>Besoins de trésorerie et comptes de paiement</a:t>
+            </a:r>
+            <a:endParaRPr lang="en-US" sz="3400" dirty="0"/>
+          </a:p>
+        </p:txBody>
+      </p:sp>
+      <p:sp>
+        <p:nvSpPr>
+          <p:cNvPr id="5" name="Text 2"/>
+          <p:cNvSpPr txBox="1"/>
+          <p:nvPr/>
+        </p:nvSpPr>
+        <p:spPr>
+          <a:xfrm>
+            <a:off x="731520" y="3840480"/>
+            <a:ext cx="6309360" cy="457200"/>
+          </a:xfrm>
+          <a:prstGeom prst="rect">
+            <a:avLst/>
+          </a:prstGeom>
+          <a:noFill/>
+          <a:ln/>
+        </p:spPr>
+        <p:txBody>
+          <a:bodyPr wrap="square" lIns="0" tIns="0" rIns="0" bIns="0" rtlCol="0" anchor="ctr"/>
+          <a:lstStyle/>
+          <a:p>
+            <a:pPr indent="0" marL="0">
+              <a:buNone/>
+            </a:pPr>
+            <a:r>
+              <a:rPr lang="en-US" sz="1500" dirty="0">
+                <a:solidFill>
+                  <a:srgbClr val="D4B483"/>
+                </a:solidFill>
+                <a:latin typeface="Calibri" pitchFamily="34" charset="0"/>
+                <a:ea typeface="Calibri" pitchFamily="34" charset="-122"/>
+                <a:cs typeface="Calibri" pitchFamily="34" charset="-120"/>
+              </a:rPr>
+              <a:t>Situation au 30/09/2026 – échéancier S1 à S5 (05/10 → 08/11/2026)</a:t>
+            </a:r>
+            <a:endParaRPr lang="en-US" sz="1500" dirty="0"/>
+          </a:p>
+        </p:txBody>
+      </p:sp>
+      <p:sp>
+        <p:nvSpPr>
+          <p:cNvPr id="6" name="Text 3"/>
+          <p:cNvSpPr txBox="1"/>
+          <p:nvPr/>
+        </p:nvSpPr>
+        <p:spPr>
+          <a:xfrm>
+            <a:off x="731520" y="5943600"/>
+            <a:ext cx="6309360" cy="365760"/>
+          </a:xfrm>
+          <a:prstGeom prst="rect">
+            <a:avLst/>
+          </a:prstGeom>
+          <a:noFill/>
+          <a:ln/>
+        </p:spPr>
+        <p:txBody>
+          <a:bodyPr wrap="square" lIns="0" tIns="0" rIns="0" bIns="0" rtlCol="0" anchor="ctr"/>
+          <a:lstStyle/>
+          <a:p>
+            <a:pPr indent="0" marL="0">
+              <a:buNone/>
+            </a:pPr>
+            <a:r>
+              <a:rPr lang="en-US" sz="1100" dirty="0">
+                <a:solidFill>
+                  <a:srgbClr val="FFFFFF"/>
+                </a:solidFill>
+                <a:latin typeface="Calibri" pitchFamily="34" charset="0"/>
+                <a:ea typeface="Calibri" pitchFamily="34" charset="-122"/>
+                <a:cs typeface="Calibri" pitchFamily="34" charset="-120"/>
+              </a:rPr>
+              <a:t>Direction Trésorerie &amp; Financement – Groupe Duval Afrique  |  Octobre 2026</a:t>
+            </a:r>
+            <a:endParaRPr lang="en-US" sz="1100" dirty="0"/>
+          </a:p>
+        </p:txBody>
+      </p:sp>
+    </p:spTree>
+  </p:cSld>
+  <p:clrMapOvr>
+    <a:masterClrMapping/>
+  </p:clrMapOvr>
+</p:sld>
+</file>
+
+<file path=ppt/slides/slide2.xml><?xml version="1.0" encoding="utf-8"?>
+<p:sld xmlns:a="http://schemas.openxmlformats.org/drawingml/2006/main" xmlns:r="http://schemas.openxmlformats.org/officeDocument/2006/relationships" xmlns:p="http://schemas.openxmlformats.org/presentationml/2006/main">
+  <p:cSld name="Slide 2">
+    <p:bg>
+      <p:bgPr>
+        <a:solidFill>
           <a:srgbClr val="FFFFFF"/>
         </a:solidFill>
       </p:bgPr>
@@ -1086,7 +1476,855 @@
                 <a:ea typeface="Calibri" pitchFamily="34" charset="-122"/>
                 <a:cs typeface="Calibri" pitchFamily="34" charset="-120"/>
               </a:rPr>
-              <a:t>Besoin de trésorerie – 1. Besoin par semaine</a:t>
+              <a:t>Sommaire</a:t>
+            </a:r>
+            <a:endParaRPr lang="en-US" sz="2600" dirty="0"/>
+          </a:p>
+        </p:txBody>
+      </p:sp>
+      <p:sp>
+        <p:nvSpPr>
+          <p:cNvPr id="3" name="Text 1"/>
+          <p:cNvSpPr txBox="1"/>
+          <p:nvPr/>
+        </p:nvSpPr>
+        <p:spPr>
+          <a:xfrm>
+            <a:off x="457200" y="822960"/>
+            <a:ext cx="11247120" cy="320040"/>
+          </a:xfrm>
+          <a:prstGeom prst="rect">
+            <a:avLst/>
+          </a:prstGeom>
+          <a:noFill/>
+          <a:ln/>
+        </p:spPr>
+        <p:txBody>
+          <a:bodyPr wrap="square" lIns="0" tIns="0" rIns="0" bIns="0" rtlCol="0" anchor="ctr"/>
+          <a:lstStyle/>
+          <a:p>
+            <a:pPr indent="0" marL="0">
+              <a:buNone/>
+            </a:pPr>
+            <a:r>
+              <a:rPr lang="en-US" sz="1300" dirty="0">
+                <a:solidFill>
+                  <a:srgbClr val="9D8C74"/>
+                </a:solidFill>
+                <a:latin typeface="Calibri" pitchFamily="34" charset="0"/>
+                <a:ea typeface="Calibri" pitchFamily="34" charset="-122"/>
+                <a:cs typeface="Calibri" pitchFamily="34" charset="-120"/>
+              </a:rPr>
+              <a:t>Position de trésorerie au 30/09/2026 – échéancier S1 à S5 (05/10 → 08/11/2026), antériorités en S1 – montants en MFCFA</a:t>
+            </a:r>
+            <a:endParaRPr lang="en-US" sz="1300" dirty="0"/>
+          </a:p>
+        </p:txBody>
+      </p:sp>
+      <p:sp>
+        <p:nvSpPr>
+          <p:cNvPr id="4" name="Shape 2"/>
+          <p:cNvSpPr/>
+          <p:nvPr/>
+        </p:nvSpPr>
+        <p:spPr>
+          <a:xfrm>
+            <a:off x="457200" y="1463040"/>
+            <a:ext cx="5468112" cy="4480560"/>
+          </a:xfrm>
+          <a:prstGeom prst="roundRect">
+            <a:avLst>
+              <a:gd name="adj" fmla="val 2041"/>
+            </a:avLst>
+          </a:prstGeom>
+          <a:solidFill>
+            <a:srgbClr val="EEF2F6"/>
+          </a:solidFill>
+          <a:ln w="12700">
+            <a:solidFill>
+              <a:srgbClr val="EEF2F6"/>
+            </a:solidFill>
+            <a:prstDash val="solid"/>
+          </a:ln>
+        </p:spPr>
+      </p:sp>
+      <p:sp>
+        <p:nvSpPr>
+          <p:cNvPr id="5" name="Text 3"/>
+          <p:cNvSpPr txBox="1"/>
+          <p:nvPr/>
+        </p:nvSpPr>
+        <p:spPr>
+          <a:xfrm>
+            <a:off x="777240" y="1691640"/>
+            <a:ext cx="4846320" cy="457200"/>
+          </a:xfrm>
+          <a:prstGeom prst="rect">
+            <a:avLst/>
+          </a:prstGeom>
+          <a:noFill/>
+          <a:ln/>
+        </p:spPr>
+        <p:txBody>
+          <a:bodyPr wrap="square" lIns="0" tIns="0" rIns="0" bIns="0" rtlCol="0" anchor="ctr"/>
+          <a:lstStyle/>
+          <a:p>
+            <a:pPr indent="0" marL="0">
+              <a:buNone/>
+            </a:pPr>
+            <a:r>
+              <a:rPr lang="en-US" sz="2200" b="1" dirty="0">
+                <a:solidFill>
+                  <a:srgbClr val="002C50"/>
+                </a:solidFill>
+                <a:latin typeface="Calibri" pitchFamily="34" charset="0"/>
+                <a:ea typeface="Calibri" pitchFamily="34" charset="-122"/>
+                <a:cs typeface="Calibri" pitchFamily="34" charset="-120"/>
+              </a:rPr>
+              <a:t>A. Besoin de trésorerie</a:t>
+            </a:r>
+            <a:endParaRPr lang="en-US" sz="2200" dirty="0"/>
+          </a:p>
+        </p:txBody>
+      </p:sp>
+      <p:sp>
+        <p:nvSpPr>
+          <p:cNvPr id="6" name="Text 4"/>
+          <p:cNvSpPr txBox="1"/>
+          <p:nvPr/>
+        </p:nvSpPr>
+        <p:spPr>
+          <a:xfrm>
+            <a:off x="777240" y="2176272"/>
+            <a:ext cx="4846320" cy="320040"/>
+          </a:xfrm>
+          <a:prstGeom prst="rect">
+            <a:avLst/>
+          </a:prstGeom>
+          <a:noFill/>
+          <a:ln/>
+        </p:spPr>
+        <p:txBody>
+          <a:bodyPr wrap="square" lIns="0" tIns="0" rIns="0" bIns="0" rtlCol="0" anchor="ctr"/>
+          <a:lstStyle/>
+          <a:p>
+            <a:pPr indent="0" marL="0">
+              <a:buNone/>
+            </a:pPr>
+            <a:r>
+              <a:rPr lang="en-US" sz="1250" dirty="0">
+                <a:solidFill>
+                  <a:srgbClr val="9D8C74"/>
+                </a:solidFill>
+                <a:latin typeface="Calibri" pitchFamily="34" charset="0"/>
+                <a:ea typeface="Calibri" pitchFamily="34" charset="-122"/>
+                <a:cs typeface="Calibri" pitchFamily="34" charset="-120"/>
+              </a:rPr>
+              <a:t>Fonctionnement, projets et dette, par semaine</a:t>
+            </a:r>
+            <a:endParaRPr lang="en-US" sz="1250" dirty="0"/>
+          </a:p>
+        </p:txBody>
+      </p:sp>
+      <p:sp>
+        <p:nvSpPr>
+          <p:cNvPr id="7" name="Shape 5"/>
+          <p:cNvSpPr/>
+          <p:nvPr/>
+        </p:nvSpPr>
+        <p:spPr>
+          <a:xfrm>
+            <a:off x="777240" y="2788920"/>
+            <a:ext cx="420624" cy="420624"/>
+          </a:xfrm>
+          <a:prstGeom prst="ellipse">
+            <a:avLst/>
+          </a:prstGeom>
+          <a:solidFill>
+            <a:srgbClr val="002C50"/>
+          </a:solidFill>
+          <a:ln w="12700">
+            <a:solidFill>
+              <a:srgbClr val="002C50"/>
+            </a:solidFill>
+            <a:prstDash val="solid"/>
+          </a:ln>
+        </p:spPr>
+      </p:sp>
+      <p:sp>
+        <p:nvSpPr>
+          <p:cNvPr id="8" name="Text 6"/>
+          <p:cNvSpPr txBox="1"/>
+          <p:nvPr/>
+        </p:nvSpPr>
+        <p:spPr>
+          <a:xfrm>
+            <a:off x="777240" y="2788920"/>
+            <a:ext cx="420624" cy="420624"/>
+          </a:xfrm>
+          <a:prstGeom prst="rect">
+            <a:avLst/>
+          </a:prstGeom>
+          <a:noFill/>
+          <a:ln/>
+        </p:spPr>
+        <p:txBody>
+          <a:bodyPr wrap="square" lIns="0" tIns="0" rIns="0" bIns="0" rtlCol="0" anchor="ctr"/>
+          <a:lstStyle/>
+          <a:p>
+            <a:pPr algn="ctr" indent="0" marL="0">
+              <a:buNone/>
+            </a:pPr>
+            <a:r>
+              <a:rPr lang="en-US" sz="1300" b="1" dirty="0">
+                <a:solidFill>
+                  <a:srgbClr val="FFFFFF"/>
+                </a:solidFill>
+                <a:latin typeface="Calibri" pitchFamily="34" charset="0"/>
+                <a:ea typeface="Calibri" pitchFamily="34" charset="-122"/>
+                <a:cs typeface="Calibri" pitchFamily="34" charset="-120"/>
+              </a:rPr>
+              <a:t>3</a:t>
+            </a:r>
+            <a:endParaRPr lang="en-US" sz="1300" dirty="0"/>
+          </a:p>
+        </p:txBody>
+      </p:sp>
+      <p:sp>
+        <p:nvSpPr>
+          <p:cNvPr id="9" name="Text 7"/>
+          <p:cNvSpPr txBox="1"/>
+          <p:nvPr/>
+        </p:nvSpPr>
+        <p:spPr>
+          <a:xfrm>
+            <a:off x="1371600" y="2788920"/>
+            <a:ext cx="4297680" cy="420624"/>
+          </a:xfrm>
+          <a:prstGeom prst="rect">
+            <a:avLst/>
+          </a:prstGeom>
+          <a:noFill/>
+          <a:ln/>
+        </p:spPr>
+        <p:txBody>
+          <a:bodyPr wrap="square" lIns="0" tIns="0" rIns="0" bIns="0" rtlCol="0" anchor="ctr"/>
+          <a:lstStyle/>
+          <a:p>
+            <a:pPr indent="0" marL="0">
+              <a:buNone/>
+            </a:pPr>
+            <a:r>
+              <a:rPr lang="en-US" sz="1500" dirty="0">
+                <a:solidFill>
+                  <a:srgbClr val="1F2933"/>
+                </a:solidFill>
+                <a:latin typeface="Calibri" pitchFamily="34" charset="0"/>
+                <a:ea typeface="Calibri" pitchFamily="34" charset="-122"/>
+                <a:cs typeface="Calibri" pitchFamily="34" charset="-120"/>
+              </a:rPr>
+              <a:t>Besoin par semaine et déficits à couvrir</a:t>
+            </a:r>
+            <a:endParaRPr lang="en-US" sz="1500" dirty="0"/>
+          </a:p>
+        </p:txBody>
+      </p:sp>
+      <p:sp>
+        <p:nvSpPr>
+          <p:cNvPr id="10" name="Text 8"/>
+          <p:cNvSpPr txBox="1"/>
+          <p:nvPr/>
+        </p:nvSpPr>
+        <p:spPr>
+          <a:xfrm>
+            <a:off x="777240" y="4206240"/>
+            <a:ext cx="4846320" cy="731520"/>
+          </a:xfrm>
+          <a:prstGeom prst="rect">
+            <a:avLst/>
+          </a:prstGeom>
+          <a:noFill/>
+          <a:ln/>
+        </p:spPr>
+        <p:txBody>
+          <a:bodyPr wrap="square" lIns="0" tIns="0" rIns="0" bIns="0" rtlCol="0" anchor="t"/>
+          <a:lstStyle/>
+          <a:p>
+            <a:pPr indent="0" marL="0">
+              <a:buNone/>
+            </a:pPr>
+            <a:r>
+              <a:rPr lang="en-US" sz="1400" b="1" dirty="0">
+                <a:solidFill>
+                  <a:srgbClr val="002C50"/>
+                </a:solidFill>
+                <a:latin typeface="Calibri" pitchFamily="34" charset="0"/>
+                <a:ea typeface="Calibri" pitchFamily="34" charset="-122"/>
+                <a:cs typeface="Calibri" pitchFamily="34" charset="-120"/>
+              </a:rPr>
+              <a:t>6 665,6 M à payer de S1 à S5, dont 4 895,0 M dès S1 ; 1 937,3 M de déficits</a:t>
+            </a:r>
+            <a:endParaRPr lang="en-US" sz="1400" dirty="0"/>
+          </a:p>
+        </p:txBody>
+      </p:sp>
+      <p:sp>
+        <p:nvSpPr>
+          <p:cNvPr id="11" name="Text 9"/>
+          <p:cNvSpPr txBox="1"/>
+          <p:nvPr/>
+        </p:nvSpPr>
+        <p:spPr>
+          <a:xfrm>
+            <a:off x="777240" y="5349240"/>
+            <a:ext cx="4846320" cy="457200"/>
+          </a:xfrm>
+          <a:prstGeom prst="rect">
+            <a:avLst/>
+          </a:prstGeom>
+          <a:noFill/>
+          <a:ln/>
+        </p:spPr>
+        <p:txBody>
+          <a:bodyPr wrap="square" lIns="0" tIns="0" rIns="0" bIns="0" rtlCol="0" anchor="t"/>
+          <a:lstStyle/>
+          <a:p>
+            <a:pPr indent="0" marL="0">
+              <a:buNone/>
+            </a:pPr>
+            <a:r>
+              <a:rPr lang="en-US" sz="1050" dirty="0">
+                <a:solidFill>
+                  <a:srgbClr val="6B7280"/>
+                </a:solidFill>
+                <a:latin typeface="Calibri" pitchFamily="34" charset="0"/>
+                <a:ea typeface="Calibri" pitchFamily="34" charset="-122"/>
+                <a:cs typeface="Calibri" pitchFamily="34" charset="-120"/>
+              </a:rPr>
+              <a:t>Fournisseurs, impôts, cotisations et salaires des sociétés ; cash plans de Village Notre Père et Riviera Park ; échéance Stanbic de FIRST</a:t>
+            </a:r>
+            <a:endParaRPr lang="en-US" sz="1050" dirty="0"/>
+          </a:p>
+        </p:txBody>
+      </p:sp>
+      <p:sp>
+        <p:nvSpPr>
+          <p:cNvPr id="12" name="Shape 10"/>
+          <p:cNvSpPr/>
+          <p:nvPr/>
+        </p:nvSpPr>
+        <p:spPr>
+          <a:xfrm>
+            <a:off x="6263640" y="1463040"/>
+            <a:ext cx="5468112" cy="4480560"/>
+          </a:xfrm>
+          <a:prstGeom prst="roundRect">
+            <a:avLst>
+              <a:gd name="adj" fmla="val 2041"/>
+            </a:avLst>
+          </a:prstGeom>
+          <a:solidFill>
+            <a:srgbClr val="EEF2F6"/>
+          </a:solidFill>
+          <a:ln w="12700">
+            <a:solidFill>
+              <a:srgbClr val="EEF2F6"/>
+            </a:solidFill>
+            <a:prstDash val="solid"/>
+          </a:ln>
+        </p:spPr>
+      </p:sp>
+      <p:sp>
+        <p:nvSpPr>
+          <p:cNvPr id="13" name="Text 11"/>
+          <p:cNvSpPr txBox="1"/>
+          <p:nvPr/>
+        </p:nvSpPr>
+        <p:spPr>
+          <a:xfrm>
+            <a:off x="6583680" y="1691640"/>
+            <a:ext cx="4846320" cy="457200"/>
+          </a:xfrm>
+          <a:prstGeom prst="rect">
+            <a:avLst/>
+          </a:prstGeom>
+          <a:noFill/>
+          <a:ln/>
+        </p:spPr>
+        <p:txBody>
+          <a:bodyPr wrap="square" lIns="0" tIns="0" rIns="0" bIns="0" rtlCol="0" anchor="ctr"/>
+          <a:lstStyle/>
+          <a:p>
+            <a:pPr indent="0" marL="0">
+              <a:buNone/>
+            </a:pPr>
+            <a:r>
+              <a:rPr lang="en-US" sz="2200" b="1" dirty="0">
+                <a:solidFill>
+                  <a:srgbClr val="002C50"/>
+                </a:solidFill>
+                <a:latin typeface="Calibri" pitchFamily="34" charset="0"/>
+                <a:ea typeface="Calibri" pitchFamily="34" charset="-122"/>
+                <a:cs typeface="Calibri" pitchFamily="34" charset="-120"/>
+              </a:rPr>
+              <a:t>B. Paiement</a:t>
+            </a:r>
+            <a:endParaRPr lang="en-US" sz="2200" dirty="0"/>
+          </a:p>
+        </p:txBody>
+      </p:sp>
+      <p:sp>
+        <p:nvSpPr>
+          <p:cNvPr id="14" name="Text 12"/>
+          <p:cNvSpPr txBox="1"/>
+          <p:nvPr/>
+        </p:nvSpPr>
+        <p:spPr>
+          <a:xfrm>
+            <a:off x="6583680" y="2176272"/>
+            <a:ext cx="4846320" cy="320040"/>
+          </a:xfrm>
+          <a:prstGeom prst="rect">
+            <a:avLst/>
+          </a:prstGeom>
+          <a:noFill/>
+          <a:ln/>
+        </p:spPr>
+        <p:txBody>
+          <a:bodyPr wrap="square" lIns="0" tIns="0" rIns="0" bIns="0" rtlCol="0" anchor="ctr"/>
+          <a:lstStyle/>
+          <a:p>
+            <a:pPr indent="0" marL="0">
+              <a:buNone/>
+            </a:pPr>
+            <a:r>
+              <a:rPr lang="en-US" sz="1250" dirty="0">
+                <a:solidFill>
+                  <a:srgbClr val="9D8C74"/>
+                </a:solidFill>
+                <a:latin typeface="Calibri" pitchFamily="34" charset="0"/>
+                <a:ea typeface="Calibri" pitchFamily="34" charset="-122"/>
+                <a:cs typeface="Calibri" pitchFamily="34" charset="-120"/>
+              </a:rPr>
+              <a:t>Comptes bancaires mobilisables au 30/09/2026</a:t>
+            </a:r>
+            <a:endParaRPr lang="en-US" sz="1250" dirty="0"/>
+          </a:p>
+        </p:txBody>
+      </p:sp>
+      <p:sp>
+        <p:nvSpPr>
+          <p:cNvPr id="15" name="Shape 13"/>
+          <p:cNvSpPr/>
+          <p:nvPr/>
+        </p:nvSpPr>
+        <p:spPr>
+          <a:xfrm>
+            <a:off x="6583680" y="2788920"/>
+            <a:ext cx="420624" cy="420624"/>
+          </a:xfrm>
+          <a:prstGeom prst="ellipse">
+            <a:avLst/>
+          </a:prstGeom>
+          <a:solidFill>
+            <a:srgbClr val="002C50"/>
+          </a:solidFill>
+          <a:ln w="12700">
+            <a:solidFill>
+              <a:srgbClr val="002C50"/>
+            </a:solidFill>
+            <a:prstDash val="solid"/>
+          </a:ln>
+        </p:spPr>
+      </p:sp>
+      <p:sp>
+        <p:nvSpPr>
+          <p:cNvPr id="16" name="Text 14"/>
+          <p:cNvSpPr txBox="1"/>
+          <p:nvPr/>
+        </p:nvSpPr>
+        <p:spPr>
+          <a:xfrm>
+            <a:off x="6583680" y="2788920"/>
+            <a:ext cx="420624" cy="420624"/>
+          </a:xfrm>
+          <a:prstGeom prst="rect">
+            <a:avLst/>
+          </a:prstGeom>
+          <a:noFill/>
+          <a:ln/>
+        </p:spPr>
+        <p:txBody>
+          <a:bodyPr wrap="square" lIns="0" tIns="0" rIns="0" bIns="0" rtlCol="0" anchor="ctr"/>
+          <a:lstStyle/>
+          <a:p>
+            <a:pPr algn="ctr" indent="0" marL="0">
+              <a:buNone/>
+            </a:pPr>
+            <a:r>
+              <a:rPr lang="en-US" sz="1300" b="1" dirty="0">
+                <a:solidFill>
+                  <a:srgbClr val="FFFFFF"/>
+                </a:solidFill>
+                <a:latin typeface="Calibri" pitchFamily="34" charset="0"/>
+                <a:ea typeface="Calibri" pitchFamily="34" charset="-122"/>
+                <a:cs typeface="Calibri" pitchFamily="34" charset="-120"/>
+              </a:rPr>
+              <a:t>4</a:t>
+            </a:r>
+            <a:endParaRPr lang="en-US" sz="1300" dirty="0"/>
+          </a:p>
+        </p:txBody>
+      </p:sp>
+      <p:sp>
+        <p:nvSpPr>
+          <p:cNvPr id="17" name="Text 15"/>
+          <p:cNvSpPr txBox="1"/>
+          <p:nvPr/>
+        </p:nvSpPr>
+        <p:spPr>
+          <a:xfrm>
+            <a:off x="7178040" y="2788920"/>
+            <a:ext cx="4297680" cy="420624"/>
+          </a:xfrm>
+          <a:prstGeom prst="rect">
+            <a:avLst/>
+          </a:prstGeom>
+          <a:noFill/>
+          <a:ln/>
+        </p:spPr>
+        <p:txBody>
+          <a:bodyPr wrap="square" lIns="0" tIns="0" rIns="0" bIns="0" rtlCol="0" anchor="ctr"/>
+          <a:lstStyle/>
+          <a:p>
+            <a:pPr indent="0" marL="0">
+              <a:buNone/>
+            </a:pPr>
+            <a:r>
+              <a:rPr lang="en-US" sz="1500" dirty="0">
+                <a:solidFill>
+                  <a:srgbClr val="1F2933"/>
+                </a:solidFill>
+                <a:latin typeface="Calibri" pitchFamily="34" charset="0"/>
+                <a:ea typeface="Calibri" pitchFamily="34" charset="-122"/>
+                <a:cs typeface="Calibri" pitchFamily="34" charset="-120"/>
+              </a:rPr>
+              <a:t>Comptes de paiement par entité et nature</a:t>
+            </a:r>
+            <a:endParaRPr lang="en-US" sz="1500" dirty="0"/>
+          </a:p>
+        </p:txBody>
+      </p:sp>
+      <p:sp>
+        <p:nvSpPr>
+          <p:cNvPr id="18" name="Shape 16"/>
+          <p:cNvSpPr/>
+          <p:nvPr/>
+        </p:nvSpPr>
+        <p:spPr>
+          <a:xfrm>
+            <a:off x="6583680" y="3410712"/>
+            <a:ext cx="420624" cy="420624"/>
+          </a:xfrm>
+          <a:prstGeom prst="ellipse">
+            <a:avLst/>
+          </a:prstGeom>
+          <a:solidFill>
+            <a:srgbClr val="002C50"/>
+          </a:solidFill>
+          <a:ln w="12700">
+            <a:solidFill>
+              <a:srgbClr val="002C50"/>
+            </a:solidFill>
+            <a:prstDash val="solid"/>
+          </a:ln>
+        </p:spPr>
+      </p:sp>
+      <p:sp>
+        <p:nvSpPr>
+          <p:cNvPr id="19" name="Text 17"/>
+          <p:cNvSpPr txBox="1"/>
+          <p:nvPr/>
+        </p:nvSpPr>
+        <p:spPr>
+          <a:xfrm>
+            <a:off x="6583680" y="3410712"/>
+            <a:ext cx="420624" cy="420624"/>
+          </a:xfrm>
+          <a:prstGeom prst="rect">
+            <a:avLst/>
+          </a:prstGeom>
+          <a:noFill/>
+          <a:ln/>
+        </p:spPr>
+        <p:txBody>
+          <a:bodyPr wrap="square" lIns="0" tIns="0" rIns="0" bIns="0" rtlCol="0" anchor="ctr"/>
+          <a:lstStyle/>
+          <a:p>
+            <a:pPr algn="ctr" indent="0" marL="0">
+              <a:buNone/>
+            </a:pPr>
+            <a:r>
+              <a:rPr lang="en-US" sz="1300" b="1" dirty="0">
+                <a:solidFill>
+                  <a:srgbClr val="FFFFFF"/>
+                </a:solidFill>
+                <a:latin typeface="Calibri" pitchFamily="34" charset="0"/>
+                <a:ea typeface="Calibri" pitchFamily="34" charset="-122"/>
+                <a:cs typeface="Calibri" pitchFamily="34" charset="-120"/>
+              </a:rPr>
+              <a:t>5</a:t>
+            </a:r>
+            <a:endParaRPr lang="en-US" sz="1300" dirty="0"/>
+          </a:p>
+        </p:txBody>
+      </p:sp>
+      <p:sp>
+        <p:nvSpPr>
+          <p:cNvPr id="20" name="Text 18"/>
+          <p:cNvSpPr txBox="1"/>
+          <p:nvPr/>
+        </p:nvSpPr>
+        <p:spPr>
+          <a:xfrm>
+            <a:off x="7178040" y="3410712"/>
+            <a:ext cx="4297680" cy="420624"/>
+          </a:xfrm>
+          <a:prstGeom prst="rect">
+            <a:avLst/>
+          </a:prstGeom>
+          <a:noFill/>
+          <a:ln/>
+        </p:spPr>
+        <p:txBody>
+          <a:bodyPr wrap="square" lIns="0" tIns="0" rIns="0" bIns="0" rtlCol="0" anchor="ctr"/>
+          <a:lstStyle/>
+          <a:p>
+            <a:pPr indent="0" marL="0">
+              <a:buNone/>
+            </a:pPr>
+            <a:r>
+              <a:rPr lang="en-US" sz="1500" dirty="0">
+                <a:solidFill>
+                  <a:srgbClr val="1F2933"/>
+                </a:solidFill>
+                <a:latin typeface="Calibri" pitchFamily="34" charset="0"/>
+                <a:ea typeface="Calibri" pitchFamily="34" charset="-122"/>
+                <a:cs typeface="Calibri" pitchFamily="34" charset="-120"/>
+              </a:rPr>
+              <a:t>Options de couverture et décisions</a:t>
+            </a:r>
+            <a:endParaRPr lang="en-US" sz="1500" dirty="0"/>
+          </a:p>
+        </p:txBody>
+      </p:sp>
+      <p:sp>
+        <p:nvSpPr>
+          <p:cNvPr id="21" name="Text 19"/>
+          <p:cNvSpPr txBox="1"/>
+          <p:nvPr/>
+        </p:nvSpPr>
+        <p:spPr>
+          <a:xfrm>
+            <a:off x="6583680" y="4206240"/>
+            <a:ext cx="4846320" cy="731520"/>
+          </a:xfrm>
+          <a:prstGeom prst="rect">
+            <a:avLst/>
+          </a:prstGeom>
+          <a:noFill/>
+          <a:ln/>
+        </p:spPr>
+        <p:txBody>
+          <a:bodyPr wrap="square" lIns="0" tIns="0" rIns="0" bIns="0" rtlCol="0" anchor="t"/>
+          <a:lstStyle/>
+          <a:p>
+            <a:pPr indent="0" marL="0">
+              <a:buNone/>
+            </a:pPr>
+            <a:r>
+              <a:rPr lang="en-US" sz="1400" b="1" dirty="0">
+                <a:solidFill>
+                  <a:srgbClr val="002C50"/>
+                </a:solidFill>
+                <a:latin typeface="Calibri" pitchFamily="34" charset="0"/>
+                <a:ea typeface="Calibri" pitchFamily="34" charset="-122"/>
+                <a:cs typeface="Calibri" pitchFamily="34" charset="-120"/>
+              </a:rPr>
+              <a:t>Trois avances intragroupe couvrent les déficits, sous réserve de l'affectation de BNI-RIVIERA courant</a:t>
+            </a:r>
+            <a:endParaRPr lang="en-US" sz="1400" dirty="0"/>
+          </a:p>
+        </p:txBody>
+      </p:sp>
+      <p:sp>
+        <p:nvSpPr>
+          <p:cNvPr id="22" name="Text 20"/>
+          <p:cNvSpPr txBox="1"/>
+          <p:nvPr/>
+        </p:nvSpPr>
+        <p:spPr>
+          <a:xfrm>
+            <a:off x="6583680" y="5349240"/>
+            <a:ext cx="4846320" cy="457200"/>
+          </a:xfrm>
+          <a:prstGeom prst="rect">
+            <a:avLst/>
+          </a:prstGeom>
+          <a:noFill/>
+          <a:ln/>
+        </p:spPr>
+        <p:txBody>
+          <a:bodyPr wrap="square" lIns="0" tIns="0" rIns="0" bIns="0" rtlCol="0" anchor="t"/>
+          <a:lstStyle/>
+          <a:p>
+            <a:pPr indent="0" marL="0">
+              <a:buNone/>
+            </a:pPr>
+            <a:r>
+              <a:rPr lang="en-US" sz="1050" dirty="0">
+                <a:solidFill>
+                  <a:srgbClr val="6B7280"/>
+                </a:solidFill>
+                <a:latin typeface="Calibri" pitchFamily="34" charset="0"/>
+                <a:ea typeface="Calibri" pitchFamily="34" charset="-122"/>
+                <a:cs typeface="Calibri" pitchFamily="34" charset="-120"/>
+              </a:rPr>
+              <a:t>Comptes « Dédié besoin de fonctionnement » des sociétés, comptes « Dédié paiement CPI » des projets, avances intragroupe</a:t>
+            </a:r>
+            <a:endParaRPr lang="en-US" sz="1050" dirty="0"/>
+          </a:p>
+        </p:txBody>
+      </p:sp>
+      <p:pic>
+        <p:nvPicPr>
+          <p:cNvPr id="23" name="Image 0" descr="preencoded.png">    </p:cNvPr>
+          <p:cNvPicPr>
+            <a:picLocks noChangeAspect="1"/>
+          </p:cNvPicPr>
+          <p:nvPr/>
+        </p:nvPicPr>
+        <p:blipFill>
+          <a:blip r:embed="rId1"/>
+          <a:stretch>
+            <a:fillRect/>
+          </a:stretch>
+        </p:blipFill>
+        <p:spPr>
+          <a:xfrm>
+            <a:off x="11018520" y="6382512"/>
+            <a:ext cx="530352" cy="329184"/>
+          </a:xfrm>
+          <a:prstGeom prst="rect">
+            <a:avLst/>
+          </a:prstGeom>
+        </p:spPr>
+      </p:pic>
+      <p:sp>
+        <p:nvSpPr>
+          <p:cNvPr id="24" name="Text 21"/>
+          <p:cNvSpPr txBox="1"/>
+          <p:nvPr/>
+        </p:nvSpPr>
+        <p:spPr>
+          <a:xfrm>
+            <a:off x="11612880" y="6400800"/>
+            <a:ext cx="365760" cy="274320"/>
+          </a:xfrm>
+          <a:prstGeom prst="rect">
+            <a:avLst/>
+          </a:prstGeom>
+          <a:noFill/>
+          <a:ln/>
+        </p:spPr>
+        <p:txBody>
+          <a:bodyPr wrap="square" lIns="0" tIns="0" rIns="0" bIns="0" rtlCol="0" anchor="ctr"/>
+          <a:lstStyle/>
+          <a:p>
+            <a:pPr indent="0" marL="0">
+              <a:buNone/>
+            </a:pPr>
+            <a:r>
+              <a:rPr lang="en-US" sz="900" dirty="0">
+                <a:solidFill>
+                  <a:srgbClr val="6B7280"/>
+                </a:solidFill>
+                <a:latin typeface="Calibri" pitchFamily="34" charset="0"/>
+                <a:ea typeface="Calibri" pitchFamily="34" charset="-122"/>
+                <a:cs typeface="Calibri" pitchFamily="34" charset="-120"/>
+              </a:rPr>
+              <a:t>2</a:t>
+            </a:r>
+            <a:endParaRPr lang="en-US" sz="900" dirty="0"/>
+          </a:p>
+        </p:txBody>
+      </p:sp>
+    </p:spTree>
+  </p:cSld>
+  <p:clrMapOvr>
+    <a:masterClrMapping/>
+  </p:clrMapOvr>
+</p:sld>
+</file>
+
+<file path=ppt/slides/slide3.xml><?xml version="1.0" encoding="utf-8"?>
+<p:sld xmlns:a="http://schemas.openxmlformats.org/drawingml/2006/main" xmlns:r="http://schemas.openxmlformats.org/officeDocument/2006/relationships" xmlns:p="http://schemas.openxmlformats.org/presentationml/2006/main">
+  <p:cSld name="Slide 3">
+    <p:bg>
+      <p:bgPr>
+        <a:solidFill>
+          <a:srgbClr val="FFFFFF"/>
+        </a:solidFill>
+      </p:bgPr>
+    </p:bg>
+    <p:spTree>
+      <p:nvGrpSpPr>
+        <p:cNvPr id="1" name=""/>
+        <p:cNvGrpSpPr/>
+        <p:nvPr/>
+      </p:nvGrpSpPr>
+      <p:grpSpPr>
+        <a:xfrm>
+          <a:off x="0" y="0"/>
+          <a:ext cx="0" cy="0"/>
+          <a:chOff x="0" y="0"/>
+          <a:chExt cx="0" cy="0"/>
+        </a:xfrm>
+      </p:grpSpPr>
+      <p:sp>
+        <p:nvSpPr>
+          <p:cNvPr id="2" name="Text 0"/>
+          <p:cNvSpPr txBox="1"/>
+          <p:nvPr/>
+        </p:nvSpPr>
+        <p:spPr>
+          <a:xfrm>
+            <a:off x="457200" y="274320"/>
+            <a:ext cx="11247120" cy="548640"/>
+          </a:xfrm>
+          <a:prstGeom prst="rect">
+            <a:avLst/>
+          </a:prstGeom>
+          <a:noFill/>
+          <a:ln/>
+        </p:spPr>
+        <p:txBody>
+          <a:bodyPr wrap="square" lIns="0" tIns="0" rIns="0" bIns="0" rtlCol="0" anchor="ctr"/>
+          <a:lstStyle/>
+          <a:p>
+            <a:pPr indent="0" marL="0">
+              <a:buNone/>
+            </a:pPr>
+            <a:r>
+              <a:rPr lang="en-US" sz="2600" b="1" dirty="0">
+                <a:solidFill>
+                  <a:srgbClr val="002C50"/>
+                </a:solidFill>
+                <a:latin typeface="Calibri" pitchFamily="34" charset="0"/>
+                <a:ea typeface="Calibri" pitchFamily="34" charset="-122"/>
+                <a:cs typeface="Calibri" pitchFamily="34" charset="-120"/>
+              </a:rPr>
+              <a:t>A. Besoin de trésorerie – Besoin par semaine</a:t>
             </a:r>
             <a:endParaRPr lang="en-US" sz="2600" dirty="0"/>
           </a:p>
@@ -1553,7 +2791,7 @@
       </p:sp>
       <p:graphicFrame>
         <p:nvGraphicFramePr>
-          <p:cNvPr id="2" name="Table 0"/>
+          <p:cNvPr id="4" name="Table 0"/>
           <p:cNvGraphicFramePr>
             <a:graphicFrameLocks noGrp="1"/>
           </p:cNvGraphicFramePr>
@@ -5973,7 +7211,7 @@
                 <a:ea typeface="Calibri" pitchFamily="34" charset="-122"/>
                 <a:cs typeface="Calibri" pitchFamily="34" charset="-120"/>
               </a:rPr>
-              <a:t>1</a:t>
+              <a:t>3</a:t>
             </a:r>
             <a:endParaRPr lang="en-US" sz="900" dirty="0"/>
           </a:p>
@@ -5987,9 +7225,9 @@
 </p:sld>
 </file>
 
-<file path=ppt/slides/slide2.xml><?xml version="1.0" encoding="utf-8"?>
+<file path=ppt/slides/slide4.xml><?xml version="1.0" encoding="utf-8"?>
 <p:sld xmlns:a="http://schemas.openxmlformats.org/drawingml/2006/main" xmlns:r="http://schemas.openxmlformats.org/officeDocument/2006/relationships" xmlns:p="http://schemas.openxmlformats.org/presentationml/2006/main">
-  <p:cSld name="Slide 2">
+  <p:cSld name="Slide 4">
     <p:bg>
       <p:bgPr>
         <a:solidFill>
@@ -6044,7 +7282,7 @@
                 <a:ea typeface="Calibri" pitchFamily="34" charset="-122"/>
                 <a:cs typeface="Calibri" pitchFamily="34" charset="-120"/>
               </a:rPr>
-              <a:t>Besoin de trésorerie – 2. Comptes de paiement</a:t>
+              <a:t>B. Paiement – 1. Comptes de paiement</a:t>
             </a:r>
             <a:endParaRPr lang="en-US" sz="2600" dirty="0"/>
           </a:p>
@@ -6091,7 +7329,7 @@
       </p:sp>
       <p:graphicFrame>
         <p:nvGraphicFramePr>
-          <p:cNvPr id="3" name="Table 0"/>
+          <p:cNvPr id="5" name="Table 0"/>
           <p:cNvGraphicFramePr>
             <a:graphicFrameLocks noGrp="1"/>
           </p:cNvGraphicFramePr>
@@ -12432,7 +13670,7 @@
                 <a:ea typeface="Calibri" pitchFamily="34" charset="-122"/>
                 <a:cs typeface="Calibri" pitchFamily="34" charset="-120"/>
               </a:rPr>
-              <a:t>2</a:t>
+              <a:t>4</a:t>
             </a:r>
             <a:endParaRPr lang="en-US" sz="900" dirty="0"/>
           </a:p>
@@ -12446,9 +13684,9 @@
 </p:sld>
 </file>
 
-<file path=ppt/slides/slide3.xml><?xml version="1.0" encoding="utf-8"?>
+<file path=ppt/slides/slide5.xml><?xml version="1.0" encoding="utf-8"?>
 <p:sld xmlns:a="http://schemas.openxmlformats.org/drawingml/2006/main" xmlns:r="http://schemas.openxmlformats.org/officeDocument/2006/relationships" xmlns:p="http://schemas.openxmlformats.org/presentationml/2006/main">
-  <p:cSld name="Slide 3">
+  <p:cSld name="Slide 5">
     <p:bg>
       <p:bgPr>
         <a:solidFill>
@@ -12503,7 +13741,7 @@
                 <a:ea typeface="Calibri" pitchFamily="34" charset="-122"/>
                 <a:cs typeface="Calibri" pitchFamily="34" charset="-120"/>
               </a:rPr>
-              <a:t>Besoin de trésorerie – 3. Options de couverture</a:t>
+              <a:t>B. Paiement – 2. Options de couverture</a:t>
             </a:r>
             <a:endParaRPr lang="en-US" sz="2600" dirty="0"/>
           </a:p>
@@ -12550,7 +13788,7 @@
       </p:sp>
       <p:graphicFrame>
         <p:nvGraphicFramePr>
-          <p:cNvPr id="4" name="Table 0"/>
+          <p:cNvPr id="6" name="Table 0"/>
           <p:cNvGraphicFramePr>
             <a:graphicFrameLocks noGrp="1"/>
           </p:cNvGraphicFramePr>
@@ -15616,7 +16854,7 @@
                 <a:ea typeface="Calibri" pitchFamily="34" charset="-122"/>
                 <a:cs typeface="Calibri" pitchFamily="34" charset="-120"/>
               </a:rPr>
-              <a:t>3</a:t>
+              <a:t>5</a:t>
             </a:r>
             <a:endParaRPr lang="en-US" sz="900" dirty="0"/>
           </a:p>

</xml_diff>

<commit_message>
HTML et présentation : besoin ou surplus de trésorerie nets avec détail dont
Tableau et indicateurs du générateur, slide 3 de la présentation : comptes
de sociétés (dont PICI, FIRST) et comptes dédiés (dont RIVIERA, TERASSON).

Co-Authored-By: Claude Opus 5.5 <noreply@anthropic.com>
Claude-Session: https://claude.ai/code/session_01NEhkcxCB327Mdpf33KqYQU
</commit_message>
<xml_diff>
--- a/RCI_Besoins_Tresorerie_Comptes_Paiement_30-09-2026.pptx
+++ b/RCI_Besoins_Tresorerie_Comptes_Paiement_30-09-2026.pptx
@@ -2936,7 +2936,7 @@
                 <a:ea typeface="Calibri" pitchFamily="34" charset="-122"/>
                 <a:cs typeface="Calibri" pitchFamily="34" charset="-120"/>
               </a:rPr>
-              <a:t>2 776,8 M</a:t>
+              <a:t>-866,8 M</a:t>
             </a:r>
             <a:endParaRPr lang="en-US" sz="2200" dirty="0"/>
           </a:p>
@@ -2975,7 +2975,7 @@
                 <a:ea typeface="Calibri" pitchFamily="34" charset="-122"/>
                 <a:cs typeface="Calibri" pitchFamily="34" charset="-120"/>
               </a:rPr>
-              <a:t>Déficits à couvrir : 2 projet(s) et 9 société(s)</a:t>
+              <a:t>Besoin fin S5 – comptes de sociétés ; comptes dédiés +41,0 M</a:t>
             </a:r>
             <a:endParaRPr lang="en-US" sz="1050" dirty="0"/>
           </a:p>
@@ -2996,7 +2996,7 @@
           </p:nvPr>
         </p:nvGraphicFramePr>
         <p:xfrm>
-          <a:off x="457200" y="2286000"/>
+          <a:off x="457200" y="2240280"/>
           <a:ext cx="11274552" cy="914400"/>
         </p:xfrm>
         <a:graphic>
@@ -3014,7 +3014,7 @@
                 <a:gridCol w="1737360"/>
                 <a:gridCol w="1280160"/>
               </a:tblGrid>
-              <a:tr h="274320">
+              <a:tr h="224028">
                 <a:tc>
                   <a:txBody>
                     <a:bodyPr/>
@@ -3024,7 +3024,7 @@
                         <a:buNone/>
                       </a:pPr>
                       <a:r>
-                        <a:rPr lang="en-US" sz="950" b="1" dirty="0">
+                        <a:rPr lang="en-US" sz="900" b="1" dirty="0">
                           <a:solidFill>
                             <a:srgbClr val="FFFFFF"/>
                           </a:solidFill>
@@ -3034,7 +3034,7 @@
                         </a:rPr>
                         <a:t>Décaissements</a:t>
                       </a:r>
-                      <a:endParaRPr lang="en-US" sz="950" dirty="0">
+                      <a:endParaRPr lang="en-US" sz="900" dirty="0">
                         <a:latin typeface="Calibri" charset="0"/>
                         <a:ea typeface="Calibri" charset="0"/>
                         <a:cs typeface="Calibri" charset="0"/>
@@ -3092,7 +3092,7 @@
                         <a:buNone/>
                       </a:pPr>
                       <a:r>
-                        <a:rPr lang="en-US" sz="950" b="1" dirty="0">
+                        <a:rPr lang="en-US" sz="900" b="1" dirty="0">
                           <a:solidFill>
                             <a:srgbClr val="FFFFFF"/>
                           </a:solidFill>
@@ -3102,7 +3102,7 @@
                         </a:rPr>
                         <a:t>S1 05/10</a:t>
                       </a:r>
-                      <a:endParaRPr lang="en-US" sz="950" dirty="0">
+                      <a:endParaRPr lang="en-US" sz="900" dirty="0">
                         <a:latin typeface="Calibri" charset="0"/>
                         <a:ea typeface="Calibri" charset="0"/>
                         <a:cs typeface="Calibri" charset="0"/>
@@ -3160,7 +3160,7 @@
                         <a:buNone/>
                       </a:pPr>
                       <a:r>
-                        <a:rPr lang="en-US" sz="950" b="1" dirty="0">
+                        <a:rPr lang="en-US" sz="900" b="1" dirty="0">
                           <a:solidFill>
                             <a:srgbClr val="FFFFFF"/>
                           </a:solidFill>
@@ -3170,7 +3170,7 @@
                         </a:rPr>
                         <a:t>S2 12/10</a:t>
                       </a:r>
-                      <a:endParaRPr lang="en-US" sz="950" dirty="0">
+                      <a:endParaRPr lang="en-US" sz="900" dirty="0">
                         <a:latin typeface="Calibri" charset="0"/>
                         <a:ea typeface="Calibri" charset="0"/>
                         <a:cs typeface="Calibri" charset="0"/>
@@ -3228,7 +3228,7 @@
                         <a:buNone/>
                       </a:pPr>
                       <a:r>
-                        <a:rPr lang="en-US" sz="950" b="1" dirty="0">
+                        <a:rPr lang="en-US" sz="900" b="1" dirty="0">
                           <a:solidFill>
                             <a:srgbClr val="FFFFFF"/>
                           </a:solidFill>
@@ -3238,7 +3238,7 @@
                         </a:rPr>
                         <a:t>S3 19/10</a:t>
                       </a:r>
-                      <a:endParaRPr lang="en-US" sz="950" dirty="0">
+                      <a:endParaRPr lang="en-US" sz="900" dirty="0">
                         <a:latin typeface="Calibri" charset="0"/>
                         <a:ea typeface="Calibri" charset="0"/>
                         <a:cs typeface="Calibri" charset="0"/>
@@ -3296,7 +3296,7 @@
                         <a:buNone/>
                       </a:pPr>
                       <a:r>
-                        <a:rPr lang="en-US" sz="950" b="1" dirty="0">
+                        <a:rPr lang="en-US" sz="900" b="1" dirty="0">
                           <a:solidFill>
                             <a:srgbClr val="FFFFFF"/>
                           </a:solidFill>
@@ -3306,7 +3306,7 @@
                         </a:rPr>
                         <a:t>S4 26/10</a:t>
                       </a:r>
-                      <a:endParaRPr lang="en-US" sz="950" dirty="0">
+                      <a:endParaRPr lang="en-US" sz="900" dirty="0">
                         <a:latin typeface="Calibri" charset="0"/>
                         <a:ea typeface="Calibri" charset="0"/>
                         <a:cs typeface="Calibri" charset="0"/>
@@ -3364,7 +3364,7 @@
                         <a:buNone/>
                       </a:pPr>
                       <a:r>
-                        <a:rPr lang="en-US" sz="950" b="1" dirty="0">
+                        <a:rPr lang="en-US" sz="900" b="1" dirty="0">
                           <a:solidFill>
                             <a:srgbClr val="FFFFFF"/>
                           </a:solidFill>
@@ -3374,7 +3374,7 @@
                         </a:rPr>
                         <a:t>S5 02/11</a:t>
                       </a:r>
-                      <a:endParaRPr lang="en-US" sz="950" dirty="0">
+                      <a:endParaRPr lang="en-US" sz="900" dirty="0">
                         <a:latin typeface="Calibri" charset="0"/>
                         <a:ea typeface="Calibri" charset="0"/>
                         <a:cs typeface="Calibri" charset="0"/>
@@ -3432,7 +3432,7 @@
                         <a:buNone/>
                       </a:pPr>
                       <a:r>
-                        <a:rPr lang="en-US" sz="950" b="1" dirty="0">
+                        <a:rPr lang="en-US" sz="900" b="1" dirty="0">
                           <a:solidFill>
                             <a:srgbClr val="FFFFFF"/>
                           </a:solidFill>
@@ -3442,7 +3442,7 @@
                         </a:rPr>
                         <a:t>Total S1 à S5</a:t>
                       </a:r>
-                      <a:endParaRPr lang="en-US" sz="950" dirty="0">
+                      <a:endParaRPr lang="en-US" sz="900" dirty="0">
                         <a:latin typeface="Calibri" charset="0"/>
                         <a:ea typeface="Calibri" charset="0"/>
                         <a:cs typeface="Calibri" charset="0"/>
@@ -3500,7 +3500,7 @@
                         <a:buNone/>
                       </a:pPr>
                       <a:r>
-                        <a:rPr lang="en-US" sz="950" b="1" dirty="0">
+                        <a:rPr lang="en-US" sz="900" b="1" dirty="0">
                           <a:solidFill>
                             <a:srgbClr val="FFFFFF"/>
                           </a:solidFill>
@@ -3510,7 +3510,7 @@
                         </a:rPr>
                         <a:t>Comptes payeurs au 30/09</a:t>
                       </a:r>
-                      <a:endParaRPr lang="en-US" sz="950" dirty="0">
+                      <a:endParaRPr lang="en-US" sz="900" dirty="0">
                         <a:latin typeface="Calibri" charset="0"/>
                         <a:ea typeface="Calibri" charset="0"/>
                         <a:cs typeface="Calibri" charset="0"/>
@@ -3568,7 +3568,7 @@
                         <a:buNone/>
                       </a:pPr>
                       <a:r>
-                        <a:rPr lang="en-US" sz="950" b="1" dirty="0">
+                        <a:rPr lang="en-US" sz="900" b="1" dirty="0">
                           <a:solidFill>
                             <a:srgbClr val="FFFFFF"/>
                           </a:solidFill>
@@ -3578,7 +3578,7 @@
                         </a:rPr>
                         <a:t>Déficit fin S5</a:t>
                       </a:r>
-                      <a:endParaRPr lang="en-US" sz="950" dirty="0">
+                      <a:endParaRPr lang="en-US" sz="900" dirty="0">
                         <a:latin typeface="Calibri" charset="0"/>
                         <a:ea typeface="Calibri" charset="0"/>
                         <a:cs typeface="Calibri" charset="0"/>
@@ -3628,7 +3628,7 @@
                   </a:tcPr>
                 </a:tc>
               </a:tr>
-              <a:tr h="274320">
+              <a:tr h="224028">
                 <a:tc>
                   <a:txBody>
                     <a:bodyPr/>
@@ -3638,7 +3638,7 @@
                         <a:buNone/>
                       </a:pPr>
                       <a:r>
-                        <a:rPr lang="en-US" sz="950" b="1" dirty="0">
+                        <a:rPr lang="en-US" sz="900" b="1" dirty="0">
                           <a:solidFill>
                             <a:srgbClr val="1F2933"/>
                           </a:solidFill>
@@ -3648,7 +3648,7 @@
                         </a:rPr>
                         <a:t>Fonctionnement des sociétés</a:t>
                       </a:r>
-                      <a:endParaRPr lang="en-US" sz="950" dirty="0">
+                      <a:endParaRPr lang="en-US" sz="900" dirty="0">
                         <a:latin typeface="Calibri" charset="0"/>
                         <a:ea typeface="Calibri" charset="0"/>
                         <a:cs typeface="Calibri" charset="0"/>
@@ -3703,7 +3703,7 @@
                         <a:buNone/>
                       </a:pPr>
                       <a:r>
-                        <a:rPr lang="en-US" sz="950" dirty="0">
+                        <a:rPr lang="en-US" sz="900" dirty="0">
                           <a:solidFill>
                             <a:srgbClr val="1F2933"/>
                           </a:solidFill>
@@ -3713,7 +3713,7 @@
                         </a:rPr>
                         <a:t>1 481,9</a:t>
                       </a:r>
-                      <a:endParaRPr lang="en-US" sz="950" dirty="0">
+                      <a:endParaRPr lang="en-US" sz="900" dirty="0">
                         <a:latin typeface="Calibri" charset="0"/>
                         <a:ea typeface="Calibri" charset="0"/>
                         <a:cs typeface="Calibri" charset="0"/>
@@ -3768,7 +3768,7 @@
                         <a:buNone/>
                       </a:pPr>
                       <a:r>
-                        <a:rPr lang="en-US" sz="950" dirty="0">
+                        <a:rPr lang="en-US" sz="900" dirty="0">
                           <a:solidFill>
                             <a:srgbClr val="1F2933"/>
                           </a:solidFill>
@@ -3778,7 +3778,7 @@
                         </a:rPr>
                         <a:t>69,6</a:t>
                       </a:r>
-                      <a:endParaRPr lang="en-US" sz="950" dirty="0">
+                      <a:endParaRPr lang="en-US" sz="900" dirty="0">
                         <a:latin typeface="Calibri" charset="0"/>
                         <a:ea typeface="Calibri" charset="0"/>
                         <a:cs typeface="Calibri" charset="0"/>
@@ -3833,7 +3833,7 @@
                         <a:buNone/>
                       </a:pPr>
                       <a:r>
-                        <a:rPr lang="en-US" sz="950" dirty="0">
+                        <a:rPr lang="en-US" sz="900" dirty="0">
                           <a:solidFill>
                             <a:srgbClr val="1F2933"/>
                           </a:solidFill>
@@ -3843,7 +3843,7 @@
                         </a:rPr>
                         <a:t>225,7</a:t>
                       </a:r>
-                      <a:endParaRPr lang="en-US" sz="950" dirty="0">
+                      <a:endParaRPr lang="en-US" sz="900" dirty="0">
                         <a:latin typeface="Calibri" charset="0"/>
                         <a:ea typeface="Calibri" charset="0"/>
                         <a:cs typeface="Calibri" charset="0"/>
@@ -3898,7 +3898,7 @@
                         <a:buNone/>
                       </a:pPr>
                       <a:r>
-                        <a:rPr lang="en-US" sz="950" dirty="0">
+                        <a:rPr lang="en-US" sz="900" dirty="0">
                           <a:solidFill>
                             <a:srgbClr val="1F2933"/>
                           </a:solidFill>
@@ -3908,7 +3908,7 @@
                         </a:rPr>
                         <a:t>–</a:t>
                       </a:r>
-                      <a:endParaRPr lang="en-US" sz="950" dirty="0">
+                      <a:endParaRPr lang="en-US" sz="900" dirty="0">
                         <a:latin typeface="Calibri" charset="0"/>
                         <a:ea typeface="Calibri" charset="0"/>
                         <a:cs typeface="Calibri" charset="0"/>
@@ -3963,7 +3963,7 @@
                         <a:buNone/>
                       </a:pPr>
                       <a:r>
-                        <a:rPr lang="en-US" sz="950" dirty="0">
+                        <a:rPr lang="en-US" sz="900" dirty="0">
                           <a:solidFill>
                             <a:srgbClr val="1F2933"/>
                           </a:solidFill>
@@ -3973,7 +3973,7 @@
                         </a:rPr>
                         <a:t>–</a:t>
                       </a:r>
-                      <a:endParaRPr lang="en-US" sz="950" dirty="0">
+                      <a:endParaRPr lang="en-US" sz="900" dirty="0">
                         <a:latin typeface="Calibri" charset="0"/>
                         <a:ea typeface="Calibri" charset="0"/>
                         <a:cs typeface="Calibri" charset="0"/>
@@ -4028,7 +4028,7 @@
                         <a:buNone/>
                       </a:pPr>
                       <a:r>
-                        <a:rPr lang="en-US" sz="950" b="1" dirty="0">
+                        <a:rPr lang="en-US" sz="900" b="1" dirty="0">
                           <a:solidFill>
                             <a:srgbClr val="1F2933"/>
                           </a:solidFill>
@@ -4038,7 +4038,7 @@
                         </a:rPr>
                         <a:t>1 777,1</a:t>
                       </a:r>
-                      <a:endParaRPr lang="en-US" sz="950" dirty="0">
+                      <a:endParaRPr lang="en-US" sz="900" dirty="0">
                         <a:latin typeface="Calibri" charset="0"/>
                         <a:ea typeface="Calibri" charset="0"/>
                         <a:cs typeface="Calibri" charset="0"/>
@@ -4096,7 +4096,7 @@
                         <a:buNone/>
                       </a:pPr>
                       <a:r>
-                        <a:rPr lang="en-US" sz="950" dirty="0">
+                        <a:rPr lang="en-US" sz="900" dirty="0">
                           <a:solidFill>
                             <a:srgbClr val="1F2933"/>
                           </a:solidFill>
@@ -4106,7 +4106,7 @@
                         </a:rPr>
                         <a:t>777,2</a:t>
                       </a:r>
-                      <a:endParaRPr lang="en-US" sz="950" dirty="0">
+                      <a:endParaRPr lang="en-US" sz="900" dirty="0">
                         <a:latin typeface="Calibri" charset="0"/>
                         <a:ea typeface="Calibri" charset="0"/>
                         <a:cs typeface="Calibri" charset="0"/>
@@ -4161,7 +4161,7 @@
                         <a:buNone/>
                       </a:pPr>
                       <a:r>
-                        <a:rPr lang="en-US" sz="950" b="1" dirty="0">
+                        <a:rPr lang="en-US" sz="900" b="1" dirty="0">
                           <a:solidFill>
                             <a:srgbClr val="B3261E"/>
                           </a:solidFill>
@@ -4171,7 +4171,7 @@
                         </a:rPr>
                         <a:t>969,5</a:t>
                       </a:r>
-                      <a:endParaRPr lang="en-US" sz="950" dirty="0">
+                      <a:endParaRPr lang="en-US" sz="900" dirty="0">
                         <a:latin typeface="Calibri" charset="0"/>
                         <a:ea typeface="Calibri" charset="0"/>
                         <a:cs typeface="Calibri" charset="0"/>
@@ -4221,7 +4221,7 @@
                   </a:tcPr>
                 </a:tc>
               </a:tr>
-              <a:tr h="274320">
+              <a:tr h="224028">
                 <a:tc>
                   <a:txBody>
                     <a:bodyPr/>
@@ -4231,7 +4231,7 @@
                         <a:buNone/>
                       </a:pPr>
                       <a:r>
-                        <a:rPr lang="en-US" sz="950" b="1" dirty="0">
+                        <a:rPr lang="en-US" sz="900" b="1" dirty="0">
                           <a:solidFill>
                             <a:srgbClr val="1F2933"/>
                           </a:solidFill>
@@ -4241,7 +4241,7 @@
                         </a:rPr>
                         <a:t>Projet RIVIERA (cash plan)</a:t>
                       </a:r>
-                      <a:endParaRPr lang="en-US" sz="950" dirty="0">
+                      <a:endParaRPr lang="en-US" sz="900" dirty="0">
                         <a:latin typeface="Calibri" charset="0"/>
                         <a:ea typeface="Calibri" charset="0"/>
                         <a:cs typeface="Calibri" charset="0"/>
@@ -4296,7 +4296,7 @@
                         <a:buNone/>
                       </a:pPr>
                       <a:r>
-                        <a:rPr lang="en-US" sz="950" dirty="0">
+                        <a:rPr lang="en-US" sz="900" dirty="0">
                           <a:solidFill>
                             <a:srgbClr val="1F2933"/>
                           </a:solidFill>
@@ -4306,7 +4306,7 @@
                         </a:rPr>
                         <a:t>1 988,4</a:t>
                       </a:r>
-                      <a:endParaRPr lang="en-US" sz="950" dirty="0">
+                      <a:endParaRPr lang="en-US" sz="900" dirty="0">
                         <a:latin typeface="Calibri" charset="0"/>
                         <a:ea typeface="Calibri" charset="0"/>
                         <a:cs typeface="Calibri" charset="0"/>
@@ -4361,7 +4361,7 @@
                         <a:buNone/>
                       </a:pPr>
                       <a:r>
-                        <a:rPr lang="en-US" sz="950" dirty="0">
+                        <a:rPr lang="en-US" sz="900" dirty="0">
                           <a:solidFill>
                             <a:srgbClr val="1F2933"/>
                           </a:solidFill>
@@ -4371,7 +4371,7 @@
                         </a:rPr>
                         <a:t>1 242,5</a:t>
                       </a:r>
-                      <a:endParaRPr lang="en-US" sz="950" dirty="0">
+                      <a:endParaRPr lang="en-US" sz="900" dirty="0">
                         <a:latin typeface="Calibri" charset="0"/>
                         <a:ea typeface="Calibri" charset="0"/>
                         <a:cs typeface="Calibri" charset="0"/>
@@ -4426,7 +4426,7 @@
                         <a:buNone/>
                       </a:pPr>
                       <a:r>
-                        <a:rPr lang="en-US" sz="950" dirty="0">
+                        <a:rPr lang="en-US" sz="900" dirty="0">
                           <a:solidFill>
                             <a:srgbClr val="1F2933"/>
                           </a:solidFill>
@@ -4436,7 +4436,7 @@
                         </a:rPr>
                         <a:t>–</a:t>
                       </a:r>
-                      <a:endParaRPr lang="en-US" sz="950" dirty="0">
+                      <a:endParaRPr lang="en-US" sz="900" dirty="0">
                         <a:latin typeface="Calibri" charset="0"/>
                         <a:ea typeface="Calibri" charset="0"/>
                         <a:cs typeface="Calibri" charset="0"/>
@@ -4491,7 +4491,7 @@
                         <a:buNone/>
                       </a:pPr>
                       <a:r>
-                        <a:rPr lang="en-US" sz="950" dirty="0">
+                        <a:rPr lang="en-US" sz="900" dirty="0">
                           <a:solidFill>
                             <a:srgbClr val="1F2933"/>
                           </a:solidFill>
@@ -4501,7 +4501,7 @@
                         </a:rPr>
                         <a:t>13,6</a:t>
                       </a:r>
-                      <a:endParaRPr lang="en-US" sz="950" dirty="0">
+                      <a:endParaRPr lang="en-US" sz="900" dirty="0">
                         <a:latin typeface="Calibri" charset="0"/>
                         <a:ea typeface="Calibri" charset="0"/>
                         <a:cs typeface="Calibri" charset="0"/>
@@ -4556,7 +4556,7 @@
                         <a:buNone/>
                       </a:pPr>
                       <a:r>
-                        <a:rPr lang="en-US" sz="950" dirty="0">
+                        <a:rPr lang="en-US" sz="900" dirty="0">
                           <a:solidFill>
                             <a:srgbClr val="1F2933"/>
                           </a:solidFill>
@@ -4566,7 +4566,7 @@
                         </a:rPr>
                         <a:t>–</a:t>
                       </a:r>
-                      <a:endParaRPr lang="en-US" sz="950" dirty="0">
+                      <a:endParaRPr lang="en-US" sz="900" dirty="0">
                         <a:latin typeface="Calibri" charset="0"/>
                         <a:ea typeface="Calibri" charset="0"/>
                         <a:cs typeface="Calibri" charset="0"/>
@@ -4621,7 +4621,7 @@
                         <a:buNone/>
                       </a:pPr>
                       <a:r>
-                        <a:rPr lang="en-US" sz="950" b="1" dirty="0">
+                        <a:rPr lang="en-US" sz="900" b="1" dirty="0">
                           <a:solidFill>
                             <a:srgbClr val="1F2933"/>
                           </a:solidFill>
@@ -4631,7 +4631,7 @@
                         </a:rPr>
                         <a:t>3 244,5</a:t>
                       </a:r>
-                      <a:endParaRPr lang="en-US" sz="950" dirty="0">
+                      <a:endParaRPr lang="en-US" sz="900" dirty="0">
                         <a:latin typeface="Calibri" charset="0"/>
                         <a:ea typeface="Calibri" charset="0"/>
                         <a:cs typeface="Calibri" charset="0"/>
@@ -4689,7 +4689,7 @@
                         <a:buNone/>
                       </a:pPr>
                       <a:r>
-                        <a:rPr lang="en-US" sz="950" dirty="0">
+                        <a:rPr lang="en-US" sz="900" dirty="0">
                           <a:solidFill>
                             <a:srgbClr val="1F2933"/>
                           </a:solidFill>
@@ -4699,7 +4699,7 @@
                         </a:rPr>
                         <a:t>2 643,1</a:t>
                       </a:r>
-                      <a:endParaRPr lang="en-US" sz="950" dirty="0">
+                      <a:endParaRPr lang="en-US" sz="900" dirty="0">
                         <a:latin typeface="Calibri" charset="0"/>
                         <a:ea typeface="Calibri" charset="0"/>
                         <a:cs typeface="Calibri" charset="0"/>
@@ -4754,7 +4754,7 @@
                         <a:buNone/>
                       </a:pPr>
                       <a:r>
-                        <a:rPr lang="en-US" sz="950" b="1" dirty="0">
+                        <a:rPr lang="en-US" sz="900" b="1" dirty="0">
                           <a:solidFill>
                             <a:srgbClr val="B3261E"/>
                           </a:solidFill>
@@ -4764,7 +4764,7 @@
                         </a:rPr>
                         <a:t>601,4</a:t>
                       </a:r>
-                      <a:endParaRPr lang="en-US" sz="950" dirty="0">
+                      <a:endParaRPr lang="en-US" sz="900" dirty="0">
                         <a:latin typeface="Calibri" charset="0"/>
                         <a:ea typeface="Calibri" charset="0"/>
                         <a:cs typeface="Calibri" charset="0"/>
@@ -4814,7 +4814,7 @@
                   </a:tcPr>
                 </a:tc>
               </a:tr>
-              <a:tr h="274320">
+              <a:tr h="224028">
                 <a:tc>
                   <a:txBody>
                     <a:bodyPr/>
@@ -4824,7 +4824,7 @@
                         <a:buNone/>
                       </a:pPr>
                       <a:r>
-                        <a:rPr lang="en-US" sz="950" b="1" dirty="0">
+                        <a:rPr lang="en-US" sz="900" b="1" dirty="0">
                           <a:solidFill>
                             <a:srgbClr val="1F2933"/>
                           </a:solidFill>
@@ -4834,7 +4834,7 @@
                         </a:rPr>
                         <a:t>Projet TERASSON (cash plan)</a:t>
                       </a:r>
-                      <a:endParaRPr lang="en-US" sz="950" dirty="0">
+                      <a:endParaRPr lang="en-US" sz="900" dirty="0">
                         <a:latin typeface="Calibri" charset="0"/>
                         <a:ea typeface="Calibri" charset="0"/>
                         <a:cs typeface="Calibri" charset="0"/>
@@ -4889,7 +4889,7 @@
                         <a:buNone/>
                       </a:pPr>
                       <a:r>
-                        <a:rPr lang="en-US" sz="950" dirty="0">
+                        <a:rPr lang="en-US" sz="900" dirty="0">
                           <a:solidFill>
                             <a:srgbClr val="1F2933"/>
                           </a:solidFill>
@@ -4899,7 +4899,7 @@
                         </a:rPr>
                         <a:t>2 202,1</a:t>
                       </a:r>
-                      <a:endParaRPr lang="en-US" sz="950" dirty="0">
+                      <a:endParaRPr lang="en-US" sz="900" dirty="0">
                         <a:latin typeface="Calibri" charset="0"/>
                         <a:ea typeface="Calibri" charset="0"/>
                         <a:cs typeface="Calibri" charset="0"/>
@@ -4954,7 +4954,7 @@
                         <a:buNone/>
                       </a:pPr>
                       <a:r>
-                        <a:rPr lang="en-US" sz="950" dirty="0">
+                        <a:rPr lang="en-US" sz="900" dirty="0">
                           <a:solidFill>
                             <a:srgbClr val="1F2933"/>
                           </a:solidFill>
@@ -4964,7 +4964,7 @@
                         </a:rPr>
                         <a:t>472,2</a:t>
                       </a:r>
-                      <a:endParaRPr lang="en-US" sz="950" dirty="0">
+                      <a:endParaRPr lang="en-US" sz="900" dirty="0">
                         <a:latin typeface="Calibri" charset="0"/>
                         <a:ea typeface="Calibri" charset="0"/>
                         <a:cs typeface="Calibri" charset="0"/>
@@ -5019,7 +5019,7 @@
                         <a:buNone/>
                       </a:pPr>
                       <a:r>
-                        <a:rPr lang="en-US" sz="950" dirty="0">
+                        <a:rPr lang="en-US" sz="900" dirty="0">
                           <a:solidFill>
                             <a:srgbClr val="1F2933"/>
                           </a:solidFill>
@@ -5029,7 +5029,7 @@
                         </a:rPr>
                         <a:t>–</a:t>
                       </a:r>
-                      <a:endParaRPr lang="en-US" sz="950" dirty="0">
+                      <a:endParaRPr lang="en-US" sz="900" dirty="0">
                         <a:latin typeface="Calibri" charset="0"/>
                         <a:ea typeface="Calibri" charset="0"/>
                         <a:cs typeface="Calibri" charset="0"/>
@@ -5084,7 +5084,7 @@
                         <a:buNone/>
                       </a:pPr>
                       <a:r>
-                        <a:rPr lang="en-US" sz="950" dirty="0">
+                        <a:rPr lang="en-US" sz="900" dirty="0">
                           <a:solidFill>
                             <a:srgbClr val="1F2933"/>
                           </a:solidFill>
@@ -5094,7 +5094,7 @@
                         </a:rPr>
                         <a:t>13,5</a:t>
                       </a:r>
-                      <a:endParaRPr lang="en-US" sz="950" dirty="0">
+                      <a:endParaRPr lang="en-US" sz="900" dirty="0">
                         <a:latin typeface="Calibri" charset="0"/>
                         <a:ea typeface="Calibri" charset="0"/>
                         <a:cs typeface="Calibri" charset="0"/>
@@ -5149,7 +5149,7 @@
                         <a:buNone/>
                       </a:pPr>
                       <a:r>
-                        <a:rPr lang="en-US" sz="950" dirty="0">
+                        <a:rPr lang="en-US" sz="900" dirty="0">
                           <a:solidFill>
                             <a:srgbClr val="1F2933"/>
                           </a:solidFill>
@@ -5159,7 +5159,7 @@
                         </a:rPr>
                         <a:t>–</a:t>
                       </a:r>
-                      <a:endParaRPr lang="en-US" sz="950" dirty="0">
+                      <a:endParaRPr lang="en-US" sz="900" dirty="0">
                         <a:latin typeface="Calibri" charset="0"/>
                         <a:ea typeface="Calibri" charset="0"/>
                         <a:cs typeface="Calibri" charset="0"/>
@@ -5214,7 +5214,7 @@
                         <a:buNone/>
                       </a:pPr>
                       <a:r>
-                        <a:rPr lang="en-US" sz="950" b="1" dirty="0">
+                        <a:rPr lang="en-US" sz="900" b="1" dirty="0">
                           <a:solidFill>
                             <a:srgbClr val="1F2933"/>
                           </a:solidFill>
@@ -5224,7 +5224,7 @@
                         </a:rPr>
                         <a:t>2 687,8</a:t>
                       </a:r>
-                      <a:endParaRPr lang="en-US" sz="950" dirty="0">
+                      <a:endParaRPr lang="en-US" sz="900" dirty="0">
                         <a:latin typeface="Calibri" charset="0"/>
                         <a:ea typeface="Calibri" charset="0"/>
                         <a:cs typeface="Calibri" charset="0"/>
@@ -5282,7 +5282,7 @@
                         <a:buNone/>
                       </a:pPr>
                       <a:r>
-                        <a:rPr lang="en-US" sz="950" dirty="0">
+                        <a:rPr lang="en-US" sz="900" dirty="0">
                           <a:solidFill>
                             <a:srgbClr val="1F2933"/>
                           </a:solidFill>
@@ -5292,7 +5292,7 @@
                         </a:rPr>
                         <a:t>1 481,9</a:t>
                       </a:r>
-                      <a:endParaRPr lang="en-US" sz="950" dirty="0">
+                      <a:endParaRPr lang="en-US" sz="900" dirty="0">
                         <a:latin typeface="Calibri" charset="0"/>
                         <a:ea typeface="Calibri" charset="0"/>
                         <a:cs typeface="Calibri" charset="0"/>
@@ -5347,7 +5347,7 @@
                         <a:buNone/>
                       </a:pPr>
                       <a:r>
-                        <a:rPr lang="en-US" sz="950" b="1" dirty="0">
+                        <a:rPr lang="en-US" sz="900" b="1" dirty="0">
                           <a:solidFill>
                             <a:srgbClr val="B3261E"/>
                           </a:solidFill>
@@ -5357,7 +5357,7 @@
                         </a:rPr>
                         <a:t>1 205,9</a:t>
                       </a:r>
-                      <a:endParaRPr lang="en-US" sz="950" dirty="0">
+                      <a:endParaRPr lang="en-US" sz="900" dirty="0">
                         <a:latin typeface="Calibri" charset="0"/>
                         <a:ea typeface="Calibri" charset="0"/>
                         <a:cs typeface="Calibri" charset="0"/>
@@ -5407,7 +5407,7 @@
                   </a:tcPr>
                 </a:tc>
               </a:tr>
-              <a:tr h="274320">
+              <a:tr h="224028">
                 <a:tc>
                   <a:txBody>
                     <a:bodyPr/>
@@ -5417,7 +5417,7 @@
                         <a:buNone/>
                       </a:pPr>
                       <a:r>
-                        <a:rPr lang="en-US" sz="950" b="1" dirty="0">
+                        <a:rPr lang="en-US" sz="900" b="1" dirty="0">
                           <a:solidFill>
                             <a:srgbClr val="FFFFFF"/>
                           </a:solidFill>
@@ -5427,7 +5427,7 @@
                         </a:rPr>
                         <a:t>Total des décaissements</a:t>
                       </a:r>
-                      <a:endParaRPr lang="en-US" sz="950" dirty="0">
+                      <a:endParaRPr lang="en-US" sz="900" dirty="0">
                         <a:latin typeface="Calibri" charset="0"/>
                         <a:ea typeface="Calibri" charset="0"/>
                         <a:cs typeface="Calibri" charset="0"/>
@@ -5485,7 +5485,7 @@
                         <a:buNone/>
                       </a:pPr>
                       <a:r>
-                        <a:rPr lang="en-US" sz="950" b="1" dirty="0">
+                        <a:rPr lang="en-US" sz="900" b="1" dirty="0">
                           <a:solidFill>
                             <a:srgbClr val="FFFFFF"/>
                           </a:solidFill>
@@ -5495,7 +5495,7 @@
                         </a:rPr>
                         <a:t>5 672,4</a:t>
                       </a:r>
-                      <a:endParaRPr lang="en-US" sz="950" dirty="0">
+                      <a:endParaRPr lang="en-US" sz="900" dirty="0">
                         <a:latin typeface="Calibri" charset="0"/>
                         <a:ea typeface="Calibri" charset="0"/>
                         <a:cs typeface="Calibri" charset="0"/>
@@ -5553,7 +5553,7 @@
                         <a:buNone/>
                       </a:pPr>
                       <a:r>
-                        <a:rPr lang="en-US" sz="950" b="1" dirty="0">
+                        <a:rPr lang="en-US" sz="900" b="1" dirty="0">
                           <a:solidFill>
                             <a:srgbClr val="FFFFFF"/>
                           </a:solidFill>
@@ -5563,7 +5563,7 @@
                         </a:rPr>
                         <a:t>1 784,3</a:t>
                       </a:r>
-                      <a:endParaRPr lang="en-US" sz="950" dirty="0">
+                      <a:endParaRPr lang="en-US" sz="900" dirty="0">
                         <a:latin typeface="Calibri" charset="0"/>
                         <a:ea typeface="Calibri" charset="0"/>
                         <a:cs typeface="Calibri" charset="0"/>
@@ -5621,7 +5621,7 @@
                         <a:buNone/>
                       </a:pPr>
                       <a:r>
-                        <a:rPr lang="en-US" sz="950" b="1" dirty="0">
+                        <a:rPr lang="en-US" sz="900" b="1" dirty="0">
                           <a:solidFill>
                             <a:srgbClr val="FFFFFF"/>
                           </a:solidFill>
@@ -5631,7 +5631,7 @@
                         </a:rPr>
                         <a:t>225,7</a:t>
                       </a:r>
-                      <a:endParaRPr lang="en-US" sz="950" dirty="0">
+                      <a:endParaRPr lang="en-US" sz="900" dirty="0">
                         <a:latin typeface="Calibri" charset="0"/>
                         <a:ea typeface="Calibri" charset="0"/>
                         <a:cs typeface="Calibri" charset="0"/>
@@ -5689,7 +5689,7 @@
                         <a:buNone/>
                       </a:pPr>
                       <a:r>
-                        <a:rPr lang="en-US" sz="950" b="1" dirty="0">
+                        <a:rPr lang="en-US" sz="900" b="1" dirty="0">
                           <a:solidFill>
                             <a:srgbClr val="FFFFFF"/>
                           </a:solidFill>
@@ -5699,7 +5699,7 @@
                         </a:rPr>
                         <a:t>27,1</a:t>
                       </a:r>
-                      <a:endParaRPr lang="en-US" sz="950" dirty="0">
+                      <a:endParaRPr lang="en-US" sz="900" dirty="0">
                         <a:latin typeface="Calibri" charset="0"/>
                         <a:ea typeface="Calibri" charset="0"/>
                         <a:cs typeface="Calibri" charset="0"/>
@@ -5757,7 +5757,7 @@
                         <a:buNone/>
                       </a:pPr>
                       <a:r>
-                        <a:rPr lang="en-US" sz="950" b="1" dirty="0">
+                        <a:rPr lang="en-US" sz="900" b="1" dirty="0">
                           <a:solidFill>
                             <a:srgbClr val="FFFFFF"/>
                           </a:solidFill>
@@ -5767,7 +5767,7 @@
                         </a:rPr>
                         <a:t>–</a:t>
                       </a:r>
-                      <a:endParaRPr lang="en-US" sz="950" dirty="0">
+                      <a:endParaRPr lang="en-US" sz="900" dirty="0">
                         <a:latin typeface="Calibri" charset="0"/>
                         <a:ea typeface="Calibri" charset="0"/>
                         <a:cs typeface="Calibri" charset="0"/>
@@ -5825,7 +5825,7 @@
                         <a:buNone/>
                       </a:pPr>
                       <a:r>
-                        <a:rPr lang="en-US" sz="950" b="1" dirty="0">
+                        <a:rPr lang="en-US" sz="900" b="1" dirty="0">
                           <a:solidFill>
                             <a:srgbClr val="FFFFFF"/>
                           </a:solidFill>
@@ -5835,7 +5835,7 @@
                         </a:rPr>
                         <a:t>7 709,5</a:t>
                       </a:r>
-                      <a:endParaRPr lang="en-US" sz="950" dirty="0">
+                      <a:endParaRPr lang="en-US" sz="900" dirty="0">
                         <a:latin typeface="Calibri" charset="0"/>
                         <a:ea typeface="Calibri" charset="0"/>
                         <a:cs typeface="Calibri" charset="0"/>
@@ -5893,7 +5893,7 @@
                         <a:buNone/>
                       </a:pPr>
                       <a:r>
-                        <a:rPr lang="en-US" sz="950" b="1" dirty="0">
+                        <a:rPr lang="en-US" sz="900" b="1" dirty="0">
                           <a:solidFill>
                             <a:srgbClr val="FFFFFF"/>
                           </a:solidFill>
@@ -5903,7 +5903,7 @@
                         </a:rPr>
                         <a:t>4 902,2</a:t>
                       </a:r>
-                      <a:endParaRPr lang="en-US" sz="950" dirty="0">
+                      <a:endParaRPr lang="en-US" sz="900" dirty="0">
                         <a:latin typeface="Calibri" charset="0"/>
                         <a:ea typeface="Calibri" charset="0"/>
                         <a:cs typeface="Calibri" charset="0"/>
@@ -5961,7 +5961,7 @@
                         <a:buNone/>
                       </a:pPr>
                       <a:r>
-                        <a:rPr lang="en-US" sz="950" b="1" dirty="0">
+                        <a:rPr lang="en-US" sz="900" b="1" dirty="0">
                           <a:solidFill>
                             <a:srgbClr val="FFFFFF"/>
                           </a:solidFill>
@@ -5971,7 +5971,7 @@
                         </a:rPr>
                         <a:t>2 776,8</a:t>
                       </a:r>
-                      <a:endParaRPr lang="en-US" sz="950" dirty="0">
+                      <a:endParaRPr lang="en-US" sz="900" dirty="0">
                         <a:latin typeface="Calibri" charset="0"/>
                         <a:ea typeface="Calibri" charset="0"/>
                         <a:cs typeface="Calibri" charset="0"/>
@@ -6021,7 +6021,7 @@
                   </a:tcPr>
                 </a:tc>
               </a:tr>
-              <a:tr h="274320">
+              <a:tr h="224028">
                 <a:tc>
                   <a:txBody>
                     <a:bodyPr/>
@@ -6031,7 +6031,7 @@
                         <a:buNone/>
                       </a:pPr>
                       <a:r>
-                        <a:rPr lang="en-US" sz="950" i="1" dirty="0">
+                        <a:rPr lang="en-US" sz="900" i="1" dirty="0">
                           <a:solidFill>
                             <a:srgbClr val="6B7280"/>
                           </a:solidFill>
@@ -6041,7 +6041,7 @@
                         </a:rPr>
                         <a:t>Encaissements prévus</a:t>
                       </a:r>
-                      <a:endParaRPr lang="en-US" sz="950" dirty="0">
+                      <a:endParaRPr lang="en-US" sz="900" dirty="0">
                         <a:latin typeface="Calibri" charset="0"/>
                         <a:ea typeface="Calibri" charset="0"/>
                         <a:cs typeface="Calibri" charset="0"/>
@@ -6096,7 +6096,7 @@
                         <a:buNone/>
                       </a:pPr>
                       <a:r>
-                        <a:rPr lang="en-US" sz="950" i="1" dirty="0">
+                        <a:rPr lang="en-US" sz="900" i="1" dirty="0">
                           <a:solidFill>
                             <a:srgbClr val="6B7280"/>
                           </a:solidFill>
@@ -6106,7 +6106,7 @@
                         </a:rPr>
                         <a:t>3,6</a:t>
                       </a:r>
-                      <a:endParaRPr lang="en-US" sz="950" dirty="0">
+                      <a:endParaRPr lang="en-US" sz="900" dirty="0">
                         <a:latin typeface="Calibri" charset="0"/>
                         <a:ea typeface="Calibri" charset="0"/>
                         <a:cs typeface="Calibri" charset="0"/>
@@ -6161,7 +6161,7 @@
                         <a:buNone/>
                       </a:pPr>
                       <a:r>
-                        <a:rPr lang="en-US" sz="950" i="1" dirty="0">
+                        <a:rPr lang="en-US" sz="900" i="1" dirty="0">
                           <a:solidFill>
                             <a:srgbClr val="6B7280"/>
                           </a:solidFill>
@@ -6171,7 +6171,7 @@
                         </a:rPr>
                         <a:t>129,6</a:t>
                       </a:r>
-                      <a:endParaRPr lang="en-US" sz="950" dirty="0">
+                      <a:endParaRPr lang="en-US" sz="900" dirty="0">
                         <a:latin typeface="Calibri" charset="0"/>
                         <a:ea typeface="Calibri" charset="0"/>
                         <a:cs typeface="Calibri" charset="0"/>
@@ -6226,7 +6226,7 @@
                         <a:buNone/>
                       </a:pPr>
                       <a:r>
-                        <a:rPr lang="en-US" sz="950" i="1" dirty="0">
+                        <a:rPr lang="en-US" sz="900" i="1" dirty="0">
                           <a:solidFill>
                             <a:srgbClr val="6B7280"/>
                           </a:solidFill>
@@ -6236,7 +6236,7 @@
                         </a:rPr>
                         <a:t>–</a:t>
                       </a:r>
-                      <a:endParaRPr lang="en-US" sz="950" dirty="0">
+                      <a:endParaRPr lang="en-US" sz="900" dirty="0">
                         <a:latin typeface="Calibri" charset="0"/>
                         <a:ea typeface="Calibri" charset="0"/>
                         <a:cs typeface="Calibri" charset="0"/>
@@ -6291,7 +6291,7 @@
                         <a:buNone/>
                       </a:pPr>
                       <a:r>
-                        <a:rPr lang="en-US" sz="950" i="1" dirty="0">
+                        <a:rPr lang="en-US" sz="900" i="1" dirty="0">
                           <a:solidFill>
                             <a:srgbClr val="6B7280"/>
                           </a:solidFill>
@@ -6301,7 +6301,7 @@
                         </a:rPr>
                         <a:t>–</a:t>
                       </a:r>
-                      <a:endParaRPr lang="en-US" sz="950" dirty="0">
+                      <a:endParaRPr lang="en-US" sz="900" dirty="0">
                         <a:latin typeface="Calibri" charset="0"/>
                         <a:ea typeface="Calibri" charset="0"/>
                         <a:cs typeface="Calibri" charset="0"/>
@@ -6356,7 +6356,7 @@
                         <a:buNone/>
                       </a:pPr>
                       <a:r>
-                        <a:rPr lang="en-US" sz="950" i="1" dirty="0">
+                        <a:rPr lang="en-US" sz="900" i="1" dirty="0">
                           <a:solidFill>
                             <a:srgbClr val="6B7280"/>
                           </a:solidFill>
@@ -6366,7 +6366,7 @@
                         </a:rPr>
                         <a:t>–</a:t>
                       </a:r>
-                      <a:endParaRPr lang="en-US" sz="950" dirty="0">
+                      <a:endParaRPr lang="en-US" sz="900" dirty="0">
                         <a:latin typeface="Calibri" charset="0"/>
                         <a:ea typeface="Calibri" charset="0"/>
                         <a:cs typeface="Calibri" charset="0"/>
@@ -6421,7 +6421,7 @@
                         <a:buNone/>
                       </a:pPr>
                       <a:r>
-                        <a:rPr lang="en-US" sz="950" i="1" dirty="0">
+                        <a:rPr lang="en-US" sz="900" i="1" dirty="0">
                           <a:solidFill>
                             <a:srgbClr val="6B7280"/>
                           </a:solidFill>
@@ -6431,7 +6431,7 @@
                         </a:rPr>
                         <a:t>133,2</a:t>
                       </a:r>
-                      <a:endParaRPr lang="en-US" sz="950" dirty="0">
+                      <a:endParaRPr lang="en-US" sz="900" dirty="0">
                         <a:latin typeface="Calibri" charset="0"/>
                         <a:ea typeface="Calibri" charset="0"/>
                         <a:cs typeface="Calibri" charset="0"/>
@@ -6485,7 +6485,7 @@
                       <a:pPr algn="r" indent="0" marL="0">
                         <a:buNone/>
                       </a:pPr>
-                      <a:endParaRPr lang="en-US" sz="950" dirty="0">
+                      <a:endParaRPr lang="en-US" sz="900" dirty="0">
                         <a:latin typeface="Calibri" charset="0"/>
                         <a:ea typeface="Calibri" charset="0"/>
                         <a:cs typeface="Calibri" charset="0"/>
@@ -6539,7 +6539,3479 @@
                       <a:pPr algn="r" indent="0" marL="0">
                         <a:buNone/>
                       </a:pPr>
-                      <a:endParaRPr lang="en-US" sz="950" dirty="0">
+                      <a:endParaRPr lang="en-US" sz="900" dirty="0">
+                        <a:latin typeface="Calibri" charset="0"/>
+                        <a:ea typeface="Calibri" charset="0"/>
+                        <a:cs typeface="Calibri" charset="0"/>
+                      </a:endParaRPr>
+                    </a:p>
+                  </a:txBody>
+                  <a:tcPr marL="64008" marR="64008" marT="0" marB="0" anchor="ctr">
+                    <a:lnL w="6350" cap="flat" cmpd="sng" algn="ctr">
+                      <a:solidFill>
+                        <a:srgbClr val="D5DBE3"/>
+                      </a:solidFill>
+                      <a:prstDash val="solid"/>
+                      <a:round/>
+                      <a:headEnd type="none" w="med" len="med"/>
+                      <a:tailEnd type="none" w="med" len="med"/>
+                    </a:lnL>
+                    <a:lnR w="6350" cap="flat" cmpd="sng" algn="ctr">
+                      <a:solidFill>
+                        <a:srgbClr val="D5DBE3"/>
+                      </a:solidFill>
+                      <a:prstDash val="solid"/>
+                      <a:round/>
+                      <a:headEnd type="none" w="med" len="med"/>
+                      <a:tailEnd type="none" w="med" len="med"/>
+                    </a:lnR>
+                    <a:lnT w="6350" cap="flat" cmpd="sng" algn="ctr">
+                      <a:solidFill>
+                        <a:srgbClr val="D5DBE3"/>
+                      </a:solidFill>
+                      <a:prstDash val="solid"/>
+                      <a:round/>
+                      <a:headEnd type="none" w="med" len="med"/>
+                      <a:tailEnd type="none" w="med" len="med"/>
+                    </a:lnT>
+                    <a:lnB w="6350" cap="flat" cmpd="sng" algn="ctr">
+                      <a:solidFill>
+                        <a:srgbClr val="D5DBE3"/>
+                      </a:solidFill>
+                      <a:prstDash val="solid"/>
+                      <a:round/>
+                      <a:headEnd type="none" w="med" len="med"/>
+                      <a:tailEnd type="none" w="med" len="med"/>
+                    </a:lnB>
+                  </a:tcPr>
+                </a:tc>
+              </a:tr>
+              <a:tr h="224028">
+                <a:tc gridSpan="9">
+                  <a:txBody>
+                    <a:bodyPr/>
+                    <a:lstStyle/>
+                    <a:p>
+                      <a:pPr algn="l" indent="0" marL="0">
+                        <a:buNone/>
+                      </a:pPr>
+                      <a:r>
+                        <a:rPr lang="en-US" sz="900" b="1" dirty="0">
+                          <a:solidFill>
+                            <a:srgbClr val="FFFFFF"/>
+                          </a:solidFill>
+                          <a:latin typeface="Calibri" pitchFamily="34" charset="0"/>
+                          <a:ea typeface="Calibri" pitchFamily="34" charset="-122"/>
+                          <a:cs typeface="Calibri" pitchFamily="34" charset="-120"/>
+                        </a:rPr>
+                        <a:t>Besoin (–) ou surplus (+) de trésorerie – soldes théoriques</a:t>
+                      </a:r>
+                      <a:endParaRPr lang="en-US" sz="900" dirty="0">
+                        <a:latin typeface="Calibri" charset="0"/>
+                        <a:ea typeface="Calibri" charset="0"/>
+                        <a:cs typeface="Calibri" charset="0"/>
+                      </a:endParaRPr>
+                    </a:p>
+                  </a:txBody>
+                  <a:tcPr marL="64008" marR="64008" marT="0" marB="0" anchor="ctr">
+                    <a:lnL w="6350" cap="flat" cmpd="sng" algn="ctr">
+                      <a:solidFill>
+                        <a:srgbClr val="D5DBE3"/>
+                      </a:solidFill>
+                      <a:prstDash val="solid"/>
+                      <a:round/>
+                      <a:headEnd type="none" w="med" len="med"/>
+                      <a:tailEnd type="none" w="med" len="med"/>
+                    </a:lnL>
+                    <a:lnR w="6350" cap="flat" cmpd="sng" algn="ctr">
+                      <a:solidFill>
+                        <a:srgbClr val="D5DBE3"/>
+                      </a:solidFill>
+                      <a:prstDash val="solid"/>
+                      <a:round/>
+                      <a:headEnd type="none" w="med" len="med"/>
+                      <a:tailEnd type="none" w="med" len="med"/>
+                    </a:lnR>
+                    <a:lnT w="6350" cap="flat" cmpd="sng" algn="ctr">
+                      <a:solidFill>
+                        <a:srgbClr val="D5DBE3"/>
+                      </a:solidFill>
+                      <a:prstDash val="solid"/>
+                      <a:round/>
+                      <a:headEnd type="none" w="med" len="med"/>
+                      <a:tailEnd type="none" w="med" len="med"/>
+                    </a:lnT>
+                    <a:lnB w="6350" cap="flat" cmpd="sng" algn="ctr">
+                      <a:solidFill>
+                        <a:srgbClr val="D5DBE3"/>
+                      </a:solidFill>
+                      <a:prstDash val="solid"/>
+                      <a:round/>
+                      <a:headEnd type="none" w="med" len="med"/>
+                      <a:tailEnd type="none" w="med" len="med"/>
+                    </a:lnB>
+                    <a:solidFill>
+                      <a:srgbClr val="002C50"/>
+                    </a:solidFill>
+                  </a:tcPr>
+                </a:tc>
+                <a:tc hMerge="1">
+                  <a:tcPr/>
+                </a:tc>
+                <a:tc hMerge="1">
+                  <a:tcPr/>
+                </a:tc>
+                <a:tc hMerge="1">
+                  <a:tcPr/>
+                </a:tc>
+                <a:tc hMerge="1">
+                  <a:tcPr/>
+                </a:tc>
+                <a:tc hMerge="1">
+                  <a:tcPr/>
+                </a:tc>
+                <a:tc hMerge="1">
+                  <a:tcPr/>
+                </a:tc>
+                <a:tc hMerge="1">
+                  <a:tcPr/>
+                </a:tc>
+                <a:tc hMerge="1">
+                  <a:tcPr/>
+                </a:tc>
+              </a:tr>
+              <a:tr h="224028">
+                <a:tc>
+                  <a:txBody>
+                    <a:bodyPr/>
+                    <a:lstStyle/>
+                    <a:p>
+                      <a:pPr algn="l" indent="0" marL="0">
+                        <a:buNone/>
+                      </a:pPr>
+                      <a:r>
+                        <a:rPr lang="en-US" sz="900" b="1" dirty="0">
+                          <a:solidFill>
+                            <a:srgbClr val="1F2933"/>
+                          </a:solidFill>
+                          <a:latin typeface="Calibri" pitchFamily="34" charset="0"/>
+                          <a:ea typeface="Calibri" pitchFamily="34" charset="-122"/>
+                          <a:cs typeface="Calibri" pitchFamily="34" charset="-120"/>
+                        </a:rPr>
+                        <a:t>Comptes de sociétés</a:t>
+                      </a:r>
+                      <a:endParaRPr lang="en-US" sz="900" dirty="0">
+                        <a:latin typeface="Calibri" charset="0"/>
+                        <a:ea typeface="Calibri" charset="0"/>
+                        <a:cs typeface="Calibri" charset="0"/>
+                      </a:endParaRPr>
+                    </a:p>
+                  </a:txBody>
+                  <a:tcPr marL="64008" marR="64008" marT="0" marB="0" anchor="ctr">
+                    <a:lnL w="6350" cap="flat" cmpd="sng" algn="ctr">
+                      <a:solidFill>
+                        <a:srgbClr val="D5DBE3"/>
+                      </a:solidFill>
+                      <a:prstDash val="solid"/>
+                      <a:round/>
+                      <a:headEnd type="none" w="med" len="med"/>
+                      <a:tailEnd type="none" w="med" len="med"/>
+                    </a:lnL>
+                    <a:lnR w="6350" cap="flat" cmpd="sng" algn="ctr">
+                      <a:solidFill>
+                        <a:srgbClr val="D5DBE3"/>
+                      </a:solidFill>
+                      <a:prstDash val="solid"/>
+                      <a:round/>
+                      <a:headEnd type="none" w="med" len="med"/>
+                      <a:tailEnd type="none" w="med" len="med"/>
+                    </a:lnR>
+                    <a:lnT w="6350" cap="flat" cmpd="sng" algn="ctr">
+                      <a:solidFill>
+                        <a:srgbClr val="D5DBE3"/>
+                      </a:solidFill>
+                      <a:prstDash val="solid"/>
+                      <a:round/>
+                      <a:headEnd type="none" w="med" len="med"/>
+                      <a:tailEnd type="none" w="med" len="med"/>
+                    </a:lnT>
+                    <a:lnB w="6350" cap="flat" cmpd="sng" algn="ctr">
+                      <a:solidFill>
+                        <a:srgbClr val="D5DBE3"/>
+                      </a:solidFill>
+                      <a:prstDash val="solid"/>
+                      <a:round/>
+                      <a:headEnd type="none" w="med" len="med"/>
+                      <a:tailEnd type="none" w="med" len="med"/>
+                    </a:lnB>
+                    <a:solidFill>
+                      <a:srgbClr val="EEF2F6"/>
+                    </a:solidFill>
+                  </a:tcPr>
+                </a:tc>
+                <a:tc>
+                  <a:txBody>
+                    <a:bodyPr/>
+                    <a:lstStyle/>
+                    <a:p>
+                      <a:pPr algn="r" indent="0" marL="0">
+                        <a:buNone/>
+                      </a:pPr>
+                      <a:r>
+                        <a:rPr lang="en-US" sz="900" b="1" dirty="0">
+                          <a:solidFill>
+                            <a:srgbClr val="B3261E"/>
+                          </a:solidFill>
+                          <a:latin typeface="Calibri" pitchFamily="34" charset="0"/>
+                          <a:ea typeface="Calibri" pitchFamily="34" charset="-122"/>
+                          <a:cs typeface="Calibri" pitchFamily="34" charset="-120"/>
+                        </a:rPr>
+                        <a:t>-701,1</a:t>
+                      </a:r>
+                      <a:endParaRPr lang="en-US" sz="900" dirty="0">
+                        <a:latin typeface="Calibri" charset="0"/>
+                        <a:ea typeface="Calibri" charset="0"/>
+                        <a:cs typeface="Calibri" charset="0"/>
+                      </a:endParaRPr>
+                    </a:p>
+                  </a:txBody>
+                  <a:tcPr marL="64008" marR="64008" marT="0" marB="0" anchor="ctr">
+                    <a:lnL w="6350" cap="flat" cmpd="sng" algn="ctr">
+                      <a:solidFill>
+                        <a:srgbClr val="D5DBE3"/>
+                      </a:solidFill>
+                      <a:prstDash val="solid"/>
+                      <a:round/>
+                      <a:headEnd type="none" w="med" len="med"/>
+                      <a:tailEnd type="none" w="med" len="med"/>
+                    </a:lnL>
+                    <a:lnR w="6350" cap="flat" cmpd="sng" algn="ctr">
+                      <a:solidFill>
+                        <a:srgbClr val="D5DBE3"/>
+                      </a:solidFill>
+                      <a:prstDash val="solid"/>
+                      <a:round/>
+                      <a:headEnd type="none" w="med" len="med"/>
+                      <a:tailEnd type="none" w="med" len="med"/>
+                    </a:lnR>
+                    <a:lnT w="6350" cap="flat" cmpd="sng" algn="ctr">
+                      <a:solidFill>
+                        <a:srgbClr val="D5DBE3"/>
+                      </a:solidFill>
+                      <a:prstDash val="solid"/>
+                      <a:round/>
+                      <a:headEnd type="none" w="med" len="med"/>
+                      <a:tailEnd type="none" w="med" len="med"/>
+                    </a:lnT>
+                    <a:lnB w="6350" cap="flat" cmpd="sng" algn="ctr">
+                      <a:solidFill>
+                        <a:srgbClr val="D5DBE3"/>
+                      </a:solidFill>
+                      <a:prstDash val="solid"/>
+                      <a:round/>
+                      <a:headEnd type="none" w="med" len="med"/>
+                      <a:tailEnd type="none" w="med" len="med"/>
+                    </a:lnB>
+                    <a:solidFill>
+                      <a:srgbClr val="EEF2F6"/>
+                    </a:solidFill>
+                  </a:tcPr>
+                </a:tc>
+                <a:tc>
+                  <a:txBody>
+                    <a:bodyPr/>
+                    <a:lstStyle/>
+                    <a:p>
+                      <a:pPr algn="r" indent="0" marL="0">
+                        <a:buNone/>
+                      </a:pPr>
+                      <a:r>
+                        <a:rPr lang="en-US" sz="900" b="1" dirty="0">
+                          <a:solidFill>
+                            <a:srgbClr val="B3261E"/>
+                          </a:solidFill>
+                          <a:latin typeface="Calibri" pitchFamily="34" charset="0"/>
+                          <a:ea typeface="Calibri" pitchFamily="34" charset="-122"/>
+                          <a:cs typeface="Calibri" pitchFamily="34" charset="-120"/>
+                        </a:rPr>
+                        <a:t>-641,1</a:t>
+                      </a:r>
+                      <a:endParaRPr lang="en-US" sz="900" dirty="0">
+                        <a:latin typeface="Calibri" charset="0"/>
+                        <a:ea typeface="Calibri" charset="0"/>
+                        <a:cs typeface="Calibri" charset="0"/>
+                      </a:endParaRPr>
+                    </a:p>
+                  </a:txBody>
+                  <a:tcPr marL="64008" marR="64008" marT="0" marB="0" anchor="ctr">
+                    <a:lnL w="6350" cap="flat" cmpd="sng" algn="ctr">
+                      <a:solidFill>
+                        <a:srgbClr val="D5DBE3"/>
+                      </a:solidFill>
+                      <a:prstDash val="solid"/>
+                      <a:round/>
+                      <a:headEnd type="none" w="med" len="med"/>
+                      <a:tailEnd type="none" w="med" len="med"/>
+                    </a:lnL>
+                    <a:lnR w="6350" cap="flat" cmpd="sng" algn="ctr">
+                      <a:solidFill>
+                        <a:srgbClr val="D5DBE3"/>
+                      </a:solidFill>
+                      <a:prstDash val="solid"/>
+                      <a:round/>
+                      <a:headEnd type="none" w="med" len="med"/>
+                      <a:tailEnd type="none" w="med" len="med"/>
+                    </a:lnR>
+                    <a:lnT w="6350" cap="flat" cmpd="sng" algn="ctr">
+                      <a:solidFill>
+                        <a:srgbClr val="D5DBE3"/>
+                      </a:solidFill>
+                      <a:prstDash val="solid"/>
+                      <a:round/>
+                      <a:headEnd type="none" w="med" len="med"/>
+                      <a:tailEnd type="none" w="med" len="med"/>
+                    </a:lnT>
+                    <a:lnB w="6350" cap="flat" cmpd="sng" algn="ctr">
+                      <a:solidFill>
+                        <a:srgbClr val="D5DBE3"/>
+                      </a:solidFill>
+                      <a:prstDash val="solid"/>
+                      <a:round/>
+                      <a:headEnd type="none" w="med" len="med"/>
+                      <a:tailEnd type="none" w="med" len="med"/>
+                    </a:lnB>
+                    <a:solidFill>
+                      <a:srgbClr val="EEF2F6"/>
+                    </a:solidFill>
+                  </a:tcPr>
+                </a:tc>
+                <a:tc>
+                  <a:txBody>
+                    <a:bodyPr/>
+                    <a:lstStyle/>
+                    <a:p>
+                      <a:pPr algn="r" indent="0" marL="0">
+                        <a:buNone/>
+                      </a:pPr>
+                      <a:r>
+                        <a:rPr lang="en-US" sz="900" b="1" dirty="0">
+                          <a:solidFill>
+                            <a:srgbClr val="B3261E"/>
+                          </a:solidFill>
+                          <a:latin typeface="Calibri" pitchFamily="34" charset="0"/>
+                          <a:ea typeface="Calibri" pitchFamily="34" charset="-122"/>
+                          <a:cs typeface="Calibri" pitchFamily="34" charset="-120"/>
+                        </a:rPr>
+                        <a:t>-866,8</a:t>
+                      </a:r>
+                      <a:endParaRPr lang="en-US" sz="900" dirty="0">
+                        <a:latin typeface="Calibri" charset="0"/>
+                        <a:ea typeface="Calibri" charset="0"/>
+                        <a:cs typeface="Calibri" charset="0"/>
+                      </a:endParaRPr>
+                    </a:p>
+                  </a:txBody>
+                  <a:tcPr marL="64008" marR="64008" marT="0" marB="0" anchor="ctr">
+                    <a:lnL w="6350" cap="flat" cmpd="sng" algn="ctr">
+                      <a:solidFill>
+                        <a:srgbClr val="D5DBE3"/>
+                      </a:solidFill>
+                      <a:prstDash val="solid"/>
+                      <a:round/>
+                      <a:headEnd type="none" w="med" len="med"/>
+                      <a:tailEnd type="none" w="med" len="med"/>
+                    </a:lnL>
+                    <a:lnR w="6350" cap="flat" cmpd="sng" algn="ctr">
+                      <a:solidFill>
+                        <a:srgbClr val="D5DBE3"/>
+                      </a:solidFill>
+                      <a:prstDash val="solid"/>
+                      <a:round/>
+                      <a:headEnd type="none" w="med" len="med"/>
+                      <a:tailEnd type="none" w="med" len="med"/>
+                    </a:lnR>
+                    <a:lnT w="6350" cap="flat" cmpd="sng" algn="ctr">
+                      <a:solidFill>
+                        <a:srgbClr val="D5DBE3"/>
+                      </a:solidFill>
+                      <a:prstDash val="solid"/>
+                      <a:round/>
+                      <a:headEnd type="none" w="med" len="med"/>
+                      <a:tailEnd type="none" w="med" len="med"/>
+                    </a:lnT>
+                    <a:lnB w="6350" cap="flat" cmpd="sng" algn="ctr">
+                      <a:solidFill>
+                        <a:srgbClr val="D5DBE3"/>
+                      </a:solidFill>
+                      <a:prstDash val="solid"/>
+                      <a:round/>
+                      <a:headEnd type="none" w="med" len="med"/>
+                      <a:tailEnd type="none" w="med" len="med"/>
+                    </a:lnB>
+                    <a:solidFill>
+                      <a:srgbClr val="EEF2F6"/>
+                    </a:solidFill>
+                  </a:tcPr>
+                </a:tc>
+                <a:tc>
+                  <a:txBody>
+                    <a:bodyPr/>
+                    <a:lstStyle/>
+                    <a:p>
+                      <a:pPr algn="r" indent="0" marL="0">
+                        <a:buNone/>
+                      </a:pPr>
+                      <a:r>
+                        <a:rPr lang="en-US" sz="900" b="1" dirty="0">
+                          <a:solidFill>
+                            <a:srgbClr val="B3261E"/>
+                          </a:solidFill>
+                          <a:latin typeface="Calibri" pitchFamily="34" charset="0"/>
+                          <a:ea typeface="Calibri" pitchFamily="34" charset="-122"/>
+                          <a:cs typeface="Calibri" pitchFamily="34" charset="-120"/>
+                        </a:rPr>
+                        <a:t>-866,8</a:t>
+                      </a:r>
+                      <a:endParaRPr lang="en-US" sz="900" dirty="0">
+                        <a:latin typeface="Calibri" charset="0"/>
+                        <a:ea typeface="Calibri" charset="0"/>
+                        <a:cs typeface="Calibri" charset="0"/>
+                      </a:endParaRPr>
+                    </a:p>
+                  </a:txBody>
+                  <a:tcPr marL="64008" marR="64008" marT="0" marB="0" anchor="ctr">
+                    <a:lnL w="6350" cap="flat" cmpd="sng" algn="ctr">
+                      <a:solidFill>
+                        <a:srgbClr val="D5DBE3"/>
+                      </a:solidFill>
+                      <a:prstDash val="solid"/>
+                      <a:round/>
+                      <a:headEnd type="none" w="med" len="med"/>
+                      <a:tailEnd type="none" w="med" len="med"/>
+                    </a:lnL>
+                    <a:lnR w="6350" cap="flat" cmpd="sng" algn="ctr">
+                      <a:solidFill>
+                        <a:srgbClr val="D5DBE3"/>
+                      </a:solidFill>
+                      <a:prstDash val="solid"/>
+                      <a:round/>
+                      <a:headEnd type="none" w="med" len="med"/>
+                      <a:tailEnd type="none" w="med" len="med"/>
+                    </a:lnR>
+                    <a:lnT w="6350" cap="flat" cmpd="sng" algn="ctr">
+                      <a:solidFill>
+                        <a:srgbClr val="D5DBE3"/>
+                      </a:solidFill>
+                      <a:prstDash val="solid"/>
+                      <a:round/>
+                      <a:headEnd type="none" w="med" len="med"/>
+                      <a:tailEnd type="none" w="med" len="med"/>
+                    </a:lnT>
+                    <a:lnB w="6350" cap="flat" cmpd="sng" algn="ctr">
+                      <a:solidFill>
+                        <a:srgbClr val="D5DBE3"/>
+                      </a:solidFill>
+                      <a:prstDash val="solid"/>
+                      <a:round/>
+                      <a:headEnd type="none" w="med" len="med"/>
+                      <a:tailEnd type="none" w="med" len="med"/>
+                    </a:lnB>
+                    <a:solidFill>
+                      <a:srgbClr val="EEF2F6"/>
+                    </a:solidFill>
+                  </a:tcPr>
+                </a:tc>
+                <a:tc>
+                  <a:txBody>
+                    <a:bodyPr/>
+                    <a:lstStyle/>
+                    <a:p>
+                      <a:pPr algn="r" indent="0" marL="0">
+                        <a:buNone/>
+                      </a:pPr>
+                      <a:r>
+                        <a:rPr lang="en-US" sz="900" b="1" dirty="0">
+                          <a:solidFill>
+                            <a:srgbClr val="B3261E"/>
+                          </a:solidFill>
+                          <a:latin typeface="Calibri" pitchFamily="34" charset="0"/>
+                          <a:ea typeface="Calibri" pitchFamily="34" charset="-122"/>
+                          <a:cs typeface="Calibri" pitchFamily="34" charset="-120"/>
+                        </a:rPr>
+                        <a:t>-866,8</a:t>
+                      </a:r>
+                      <a:endParaRPr lang="en-US" sz="900" dirty="0">
+                        <a:latin typeface="Calibri" charset="0"/>
+                        <a:ea typeface="Calibri" charset="0"/>
+                        <a:cs typeface="Calibri" charset="0"/>
+                      </a:endParaRPr>
+                    </a:p>
+                  </a:txBody>
+                  <a:tcPr marL="64008" marR="64008" marT="0" marB="0" anchor="ctr">
+                    <a:lnL w="6350" cap="flat" cmpd="sng" algn="ctr">
+                      <a:solidFill>
+                        <a:srgbClr val="D5DBE3"/>
+                      </a:solidFill>
+                      <a:prstDash val="solid"/>
+                      <a:round/>
+                      <a:headEnd type="none" w="med" len="med"/>
+                      <a:tailEnd type="none" w="med" len="med"/>
+                    </a:lnL>
+                    <a:lnR w="6350" cap="flat" cmpd="sng" algn="ctr">
+                      <a:solidFill>
+                        <a:srgbClr val="D5DBE3"/>
+                      </a:solidFill>
+                      <a:prstDash val="solid"/>
+                      <a:round/>
+                      <a:headEnd type="none" w="med" len="med"/>
+                      <a:tailEnd type="none" w="med" len="med"/>
+                    </a:lnR>
+                    <a:lnT w="6350" cap="flat" cmpd="sng" algn="ctr">
+                      <a:solidFill>
+                        <a:srgbClr val="D5DBE3"/>
+                      </a:solidFill>
+                      <a:prstDash val="solid"/>
+                      <a:round/>
+                      <a:headEnd type="none" w="med" len="med"/>
+                      <a:tailEnd type="none" w="med" len="med"/>
+                    </a:lnT>
+                    <a:lnB w="6350" cap="flat" cmpd="sng" algn="ctr">
+                      <a:solidFill>
+                        <a:srgbClr val="D5DBE3"/>
+                      </a:solidFill>
+                      <a:prstDash val="solid"/>
+                      <a:round/>
+                      <a:headEnd type="none" w="med" len="med"/>
+                      <a:tailEnd type="none" w="med" len="med"/>
+                    </a:lnB>
+                    <a:solidFill>
+                      <a:srgbClr val="EEF2F6"/>
+                    </a:solidFill>
+                  </a:tcPr>
+                </a:tc>
+                <a:tc>
+                  <a:txBody>
+                    <a:bodyPr/>
+                    <a:lstStyle/>
+                    <a:p>
+                      <a:pPr algn="r" indent="0" marL="0">
+                        <a:buNone/>
+                      </a:pPr>
+                      <a:endParaRPr lang="en-US" sz="900" dirty="0">
+                        <a:latin typeface="Calibri" charset="0"/>
+                        <a:ea typeface="Calibri" charset="0"/>
+                        <a:cs typeface="Calibri" charset="0"/>
+                      </a:endParaRPr>
+                    </a:p>
+                  </a:txBody>
+                  <a:tcPr marL="64008" marR="64008" marT="0" marB="0" anchor="ctr">
+                    <a:lnL w="6350" cap="flat" cmpd="sng" algn="ctr">
+                      <a:solidFill>
+                        <a:srgbClr val="D5DBE3"/>
+                      </a:solidFill>
+                      <a:prstDash val="solid"/>
+                      <a:round/>
+                      <a:headEnd type="none" w="med" len="med"/>
+                      <a:tailEnd type="none" w="med" len="med"/>
+                    </a:lnL>
+                    <a:lnR w="6350" cap="flat" cmpd="sng" algn="ctr">
+                      <a:solidFill>
+                        <a:srgbClr val="D5DBE3"/>
+                      </a:solidFill>
+                      <a:prstDash val="solid"/>
+                      <a:round/>
+                      <a:headEnd type="none" w="med" len="med"/>
+                      <a:tailEnd type="none" w="med" len="med"/>
+                    </a:lnR>
+                    <a:lnT w="6350" cap="flat" cmpd="sng" algn="ctr">
+                      <a:solidFill>
+                        <a:srgbClr val="D5DBE3"/>
+                      </a:solidFill>
+                      <a:prstDash val="solid"/>
+                      <a:round/>
+                      <a:headEnd type="none" w="med" len="med"/>
+                      <a:tailEnd type="none" w="med" len="med"/>
+                    </a:lnT>
+                    <a:lnB w="6350" cap="flat" cmpd="sng" algn="ctr">
+                      <a:solidFill>
+                        <a:srgbClr val="D5DBE3"/>
+                      </a:solidFill>
+                      <a:prstDash val="solid"/>
+                      <a:round/>
+                      <a:headEnd type="none" w="med" len="med"/>
+                      <a:tailEnd type="none" w="med" len="med"/>
+                    </a:lnB>
+                    <a:solidFill>
+                      <a:srgbClr val="EEF2F6"/>
+                    </a:solidFill>
+                  </a:tcPr>
+                </a:tc>
+                <a:tc>
+                  <a:txBody>
+                    <a:bodyPr/>
+                    <a:lstStyle/>
+                    <a:p>
+                      <a:pPr algn="r" indent="0" marL="0">
+                        <a:buNone/>
+                      </a:pPr>
+                      <a:endParaRPr lang="en-US" sz="900" dirty="0">
+                        <a:latin typeface="Calibri" charset="0"/>
+                        <a:ea typeface="Calibri" charset="0"/>
+                        <a:cs typeface="Calibri" charset="0"/>
+                      </a:endParaRPr>
+                    </a:p>
+                  </a:txBody>
+                  <a:tcPr marL="64008" marR="64008" marT="0" marB="0" anchor="ctr">
+                    <a:lnL w="6350" cap="flat" cmpd="sng" algn="ctr">
+                      <a:solidFill>
+                        <a:srgbClr val="D5DBE3"/>
+                      </a:solidFill>
+                      <a:prstDash val="solid"/>
+                      <a:round/>
+                      <a:headEnd type="none" w="med" len="med"/>
+                      <a:tailEnd type="none" w="med" len="med"/>
+                    </a:lnL>
+                    <a:lnR w="6350" cap="flat" cmpd="sng" algn="ctr">
+                      <a:solidFill>
+                        <a:srgbClr val="D5DBE3"/>
+                      </a:solidFill>
+                      <a:prstDash val="solid"/>
+                      <a:round/>
+                      <a:headEnd type="none" w="med" len="med"/>
+                      <a:tailEnd type="none" w="med" len="med"/>
+                    </a:lnR>
+                    <a:lnT w="6350" cap="flat" cmpd="sng" algn="ctr">
+                      <a:solidFill>
+                        <a:srgbClr val="D5DBE3"/>
+                      </a:solidFill>
+                      <a:prstDash val="solid"/>
+                      <a:round/>
+                      <a:headEnd type="none" w="med" len="med"/>
+                      <a:tailEnd type="none" w="med" len="med"/>
+                    </a:lnT>
+                    <a:lnB w="6350" cap="flat" cmpd="sng" algn="ctr">
+                      <a:solidFill>
+                        <a:srgbClr val="D5DBE3"/>
+                      </a:solidFill>
+                      <a:prstDash val="solid"/>
+                      <a:round/>
+                      <a:headEnd type="none" w="med" len="med"/>
+                      <a:tailEnd type="none" w="med" len="med"/>
+                    </a:lnB>
+                    <a:solidFill>
+                      <a:srgbClr val="EEF2F6"/>
+                    </a:solidFill>
+                  </a:tcPr>
+                </a:tc>
+                <a:tc>
+                  <a:txBody>
+                    <a:bodyPr/>
+                    <a:lstStyle/>
+                    <a:p>
+                      <a:pPr algn="r" indent="0" marL="0">
+                        <a:buNone/>
+                      </a:pPr>
+                      <a:endParaRPr lang="en-US" sz="900" dirty="0">
+                        <a:latin typeface="Calibri" charset="0"/>
+                        <a:ea typeface="Calibri" charset="0"/>
+                        <a:cs typeface="Calibri" charset="0"/>
+                      </a:endParaRPr>
+                    </a:p>
+                  </a:txBody>
+                  <a:tcPr marL="64008" marR="64008" marT="0" marB="0" anchor="ctr">
+                    <a:lnL w="6350" cap="flat" cmpd="sng" algn="ctr">
+                      <a:solidFill>
+                        <a:srgbClr val="D5DBE3"/>
+                      </a:solidFill>
+                      <a:prstDash val="solid"/>
+                      <a:round/>
+                      <a:headEnd type="none" w="med" len="med"/>
+                      <a:tailEnd type="none" w="med" len="med"/>
+                    </a:lnL>
+                    <a:lnR w="6350" cap="flat" cmpd="sng" algn="ctr">
+                      <a:solidFill>
+                        <a:srgbClr val="D5DBE3"/>
+                      </a:solidFill>
+                      <a:prstDash val="solid"/>
+                      <a:round/>
+                      <a:headEnd type="none" w="med" len="med"/>
+                      <a:tailEnd type="none" w="med" len="med"/>
+                    </a:lnR>
+                    <a:lnT w="6350" cap="flat" cmpd="sng" algn="ctr">
+                      <a:solidFill>
+                        <a:srgbClr val="D5DBE3"/>
+                      </a:solidFill>
+                      <a:prstDash val="solid"/>
+                      <a:round/>
+                      <a:headEnd type="none" w="med" len="med"/>
+                      <a:tailEnd type="none" w="med" len="med"/>
+                    </a:lnT>
+                    <a:lnB w="6350" cap="flat" cmpd="sng" algn="ctr">
+                      <a:solidFill>
+                        <a:srgbClr val="D5DBE3"/>
+                      </a:solidFill>
+                      <a:prstDash val="solid"/>
+                      <a:round/>
+                      <a:headEnd type="none" w="med" len="med"/>
+                      <a:tailEnd type="none" w="med" len="med"/>
+                    </a:lnB>
+                    <a:solidFill>
+                      <a:srgbClr val="EEF2F6"/>
+                    </a:solidFill>
+                  </a:tcPr>
+                </a:tc>
+              </a:tr>
+              <a:tr h="224028">
+                <a:tc>
+                  <a:txBody>
+                    <a:bodyPr/>
+                    <a:lstStyle/>
+                    <a:p>
+                      <a:pPr algn="l" indent="0" marL="0">
+                        <a:buNone/>
+                      </a:pPr>
+                      <a:r>
+                        <a:rPr lang="en-US" sz="900" i="1" dirty="0">
+                          <a:solidFill>
+                            <a:srgbClr val="1F2933"/>
+                          </a:solidFill>
+                          <a:latin typeface="Calibri" pitchFamily="34" charset="0"/>
+                          <a:ea typeface="Calibri" pitchFamily="34" charset="-122"/>
+                          <a:cs typeface="Calibri" pitchFamily="34" charset="-120"/>
+                        </a:rPr>
+                        <a:t>   dont PICI</a:t>
+                      </a:r>
+                      <a:endParaRPr lang="en-US" sz="900" dirty="0">
+                        <a:latin typeface="Calibri" charset="0"/>
+                        <a:ea typeface="Calibri" charset="0"/>
+                        <a:cs typeface="Calibri" charset="0"/>
+                      </a:endParaRPr>
+                    </a:p>
+                  </a:txBody>
+                  <a:tcPr marL="64008" marR="64008" marT="0" marB="0" anchor="ctr">
+                    <a:lnL w="6350" cap="flat" cmpd="sng" algn="ctr">
+                      <a:solidFill>
+                        <a:srgbClr val="D5DBE3"/>
+                      </a:solidFill>
+                      <a:prstDash val="solid"/>
+                      <a:round/>
+                      <a:headEnd type="none" w="med" len="med"/>
+                      <a:tailEnd type="none" w="med" len="med"/>
+                    </a:lnL>
+                    <a:lnR w="6350" cap="flat" cmpd="sng" algn="ctr">
+                      <a:solidFill>
+                        <a:srgbClr val="D5DBE3"/>
+                      </a:solidFill>
+                      <a:prstDash val="solid"/>
+                      <a:round/>
+                      <a:headEnd type="none" w="med" len="med"/>
+                      <a:tailEnd type="none" w="med" len="med"/>
+                    </a:lnR>
+                    <a:lnT w="6350" cap="flat" cmpd="sng" algn="ctr">
+                      <a:solidFill>
+                        <a:srgbClr val="D5DBE3"/>
+                      </a:solidFill>
+                      <a:prstDash val="solid"/>
+                      <a:round/>
+                      <a:headEnd type="none" w="med" len="med"/>
+                      <a:tailEnd type="none" w="med" len="med"/>
+                    </a:lnT>
+                    <a:lnB w="6350" cap="flat" cmpd="sng" algn="ctr">
+                      <a:solidFill>
+                        <a:srgbClr val="D5DBE3"/>
+                      </a:solidFill>
+                      <a:prstDash val="solid"/>
+                      <a:round/>
+                      <a:headEnd type="none" w="med" len="med"/>
+                      <a:tailEnd type="none" w="med" len="med"/>
+                    </a:lnB>
+                  </a:tcPr>
+                </a:tc>
+                <a:tc>
+                  <a:txBody>
+                    <a:bodyPr/>
+                    <a:lstStyle/>
+                    <a:p>
+                      <a:pPr algn="r" indent="0" marL="0">
+                        <a:buNone/>
+                      </a:pPr>
+                      <a:r>
+                        <a:rPr lang="en-US" sz="900" dirty="0">
+                          <a:solidFill>
+                            <a:srgbClr val="5E9B7E"/>
+                          </a:solidFill>
+                          <a:latin typeface="Calibri" pitchFamily="34" charset="0"/>
+                          <a:ea typeface="Calibri" pitchFamily="34" charset="-122"/>
+                          <a:cs typeface="Calibri" pitchFamily="34" charset="-120"/>
+                        </a:rPr>
+                        <a:t>+133,7</a:t>
+                      </a:r>
+                      <a:endParaRPr lang="en-US" sz="900" dirty="0">
+                        <a:latin typeface="Calibri" charset="0"/>
+                        <a:ea typeface="Calibri" charset="0"/>
+                        <a:cs typeface="Calibri" charset="0"/>
+                      </a:endParaRPr>
+                    </a:p>
+                  </a:txBody>
+                  <a:tcPr marL="64008" marR="64008" marT="0" marB="0" anchor="ctr">
+                    <a:lnL w="6350" cap="flat" cmpd="sng" algn="ctr">
+                      <a:solidFill>
+                        <a:srgbClr val="D5DBE3"/>
+                      </a:solidFill>
+                      <a:prstDash val="solid"/>
+                      <a:round/>
+                      <a:headEnd type="none" w="med" len="med"/>
+                      <a:tailEnd type="none" w="med" len="med"/>
+                    </a:lnL>
+                    <a:lnR w="6350" cap="flat" cmpd="sng" algn="ctr">
+                      <a:solidFill>
+                        <a:srgbClr val="D5DBE3"/>
+                      </a:solidFill>
+                      <a:prstDash val="solid"/>
+                      <a:round/>
+                      <a:headEnd type="none" w="med" len="med"/>
+                      <a:tailEnd type="none" w="med" len="med"/>
+                    </a:lnR>
+                    <a:lnT w="6350" cap="flat" cmpd="sng" algn="ctr">
+                      <a:solidFill>
+                        <a:srgbClr val="D5DBE3"/>
+                      </a:solidFill>
+                      <a:prstDash val="solid"/>
+                      <a:round/>
+                      <a:headEnd type="none" w="med" len="med"/>
+                      <a:tailEnd type="none" w="med" len="med"/>
+                    </a:lnT>
+                    <a:lnB w="6350" cap="flat" cmpd="sng" algn="ctr">
+                      <a:solidFill>
+                        <a:srgbClr val="D5DBE3"/>
+                      </a:solidFill>
+                      <a:prstDash val="solid"/>
+                      <a:round/>
+                      <a:headEnd type="none" w="med" len="med"/>
+                      <a:tailEnd type="none" w="med" len="med"/>
+                    </a:lnB>
+                  </a:tcPr>
+                </a:tc>
+                <a:tc>
+                  <a:txBody>
+                    <a:bodyPr/>
+                    <a:lstStyle/>
+                    <a:p>
+                      <a:pPr algn="r" indent="0" marL="0">
+                        <a:buNone/>
+                      </a:pPr>
+                      <a:r>
+                        <a:rPr lang="en-US" sz="900" dirty="0">
+                          <a:solidFill>
+                            <a:srgbClr val="5E9B7E"/>
+                          </a:solidFill>
+                          <a:latin typeface="Calibri" pitchFamily="34" charset="0"/>
+                          <a:ea typeface="Calibri" pitchFamily="34" charset="-122"/>
+                          <a:cs typeface="Calibri" pitchFamily="34" charset="-120"/>
+                        </a:rPr>
+                        <a:t>+124,3</a:t>
+                      </a:r>
+                      <a:endParaRPr lang="en-US" sz="900" dirty="0">
+                        <a:latin typeface="Calibri" charset="0"/>
+                        <a:ea typeface="Calibri" charset="0"/>
+                        <a:cs typeface="Calibri" charset="0"/>
+                      </a:endParaRPr>
+                    </a:p>
+                  </a:txBody>
+                  <a:tcPr marL="64008" marR="64008" marT="0" marB="0" anchor="ctr">
+                    <a:lnL w="6350" cap="flat" cmpd="sng" algn="ctr">
+                      <a:solidFill>
+                        <a:srgbClr val="D5DBE3"/>
+                      </a:solidFill>
+                      <a:prstDash val="solid"/>
+                      <a:round/>
+                      <a:headEnd type="none" w="med" len="med"/>
+                      <a:tailEnd type="none" w="med" len="med"/>
+                    </a:lnL>
+                    <a:lnR w="6350" cap="flat" cmpd="sng" algn="ctr">
+                      <a:solidFill>
+                        <a:srgbClr val="D5DBE3"/>
+                      </a:solidFill>
+                      <a:prstDash val="solid"/>
+                      <a:round/>
+                      <a:headEnd type="none" w="med" len="med"/>
+                      <a:tailEnd type="none" w="med" len="med"/>
+                    </a:lnR>
+                    <a:lnT w="6350" cap="flat" cmpd="sng" algn="ctr">
+                      <a:solidFill>
+                        <a:srgbClr val="D5DBE3"/>
+                      </a:solidFill>
+                      <a:prstDash val="solid"/>
+                      <a:round/>
+                      <a:headEnd type="none" w="med" len="med"/>
+                      <a:tailEnd type="none" w="med" len="med"/>
+                    </a:lnT>
+                    <a:lnB w="6350" cap="flat" cmpd="sng" algn="ctr">
+                      <a:solidFill>
+                        <a:srgbClr val="D5DBE3"/>
+                      </a:solidFill>
+                      <a:prstDash val="solid"/>
+                      <a:round/>
+                      <a:headEnd type="none" w="med" len="med"/>
+                      <a:tailEnd type="none" w="med" len="med"/>
+                    </a:lnB>
+                  </a:tcPr>
+                </a:tc>
+                <a:tc>
+                  <a:txBody>
+                    <a:bodyPr/>
+                    <a:lstStyle/>
+                    <a:p>
+                      <a:pPr algn="r" indent="0" marL="0">
+                        <a:buNone/>
+                      </a:pPr>
+                      <a:r>
+                        <a:rPr lang="en-US" sz="900" dirty="0">
+                          <a:solidFill>
+                            <a:srgbClr val="5E9B7E"/>
+                          </a:solidFill>
+                          <a:latin typeface="Calibri" pitchFamily="34" charset="0"/>
+                          <a:ea typeface="Calibri" pitchFamily="34" charset="-122"/>
+                          <a:cs typeface="Calibri" pitchFamily="34" charset="-120"/>
+                        </a:rPr>
+                        <a:t>+100,0</a:t>
+                      </a:r>
+                      <a:endParaRPr lang="en-US" sz="900" dirty="0">
+                        <a:latin typeface="Calibri" charset="0"/>
+                        <a:ea typeface="Calibri" charset="0"/>
+                        <a:cs typeface="Calibri" charset="0"/>
+                      </a:endParaRPr>
+                    </a:p>
+                  </a:txBody>
+                  <a:tcPr marL="64008" marR="64008" marT="0" marB="0" anchor="ctr">
+                    <a:lnL w="6350" cap="flat" cmpd="sng" algn="ctr">
+                      <a:solidFill>
+                        <a:srgbClr val="D5DBE3"/>
+                      </a:solidFill>
+                      <a:prstDash val="solid"/>
+                      <a:round/>
+                      <a:headEnd type="none" w="med" len="med"/>
+                      <a:tailEnd type="none" w="med" len="med"/>
+                    </a:lnL>
+                    <a:lnR w="6350" cap="flat" cmpd="sng" algn="ctr">
+                      <a:solidFill>
+                        <a:srgbClr val="D5DBE3"/>
+                      </a:solidFill>
+                      <a:prstDash val="solid"/>
+                      <a:round/>
+                      <a:headEnd type="none" w="med" len="med"/>
+                      <a:tailEnd type="none" w="med" len="med"/>
+                    </a:lnR>
+                    <a:lnT w="6350" cap="flat" cmpd="sng" algn="ctr">
+                      <a:solidFill>
+                        <a:srgbClr val="D5DBE3"/>
+                      </a:solidFill>
+                      <a:prstDash val="solid"/>
+                      <a:round/>
+                      <a:headEnd type="none" w="med" len="med"/>
+                      <a:tailEnd type="none" w="med" len="med"/>
+                    </a:lnT>
+                    <a:lnB w="6350" cap="flat" cmpd="sng" algn="ctr">
+                      <a:solidFill>
+                        <a:srgbClr val="D5DBE3"/>
+                      </a:solidFill>
+                      <a:prstDash val="solid"/>
+                      <a:round/>
+                      <a:headEnd type="none" w="med" len="med"/>
+                      <a:tailEnd type="none" w="med" len="med"/>
+                    </a:lnB>
+                  </a:tcPr>
+                </a:tc>
+                <a:tc>
+                  <a:txBody>
+                    <a:bodyPr/>
+                    <a:lstStyle/>
+                    <a:p>
+                      <a:pPr algn="r" indent="0" marL="0">
+                        <a:buNone/>
+                      </a:pPr>
+                      <a:r>
+                        <a:rPr lang="en-US" sz="900" dirty="0">
+                          <a:solidFill>
+                            <a:srgbClr val="5E9B7E"/>
+                          </a:solidFill>
+                          <a:latin typeface="Calibri" pitchFamily="34" charset="0"/>
+                          <a:ea typeface="Calibri" pitchFamily="34" charset="-122"/>
+                          <a:cs typeface="Calibri" pitchFamily="34" charset="-120"/>
+                        </a:rPr>
+                        <a:t>+100,0</a:t>
+                      </a:r>
+                      <a:endParaRPr lang="en-US" sz="900" dirty="0">
+                        <a:latin typeface="Calibri" charset="0"/>
+                        <a:ea typeface="Calibri" charset="0"/>
+                        <a:cs typeface="Calibri" charset="0"/>
+                      </a:endParaRPr>
+                    </a:p>
+                  </a:txBody>
+                  <a:tcPr marL="64008" marR="64008" marT="0" marB="0" anchor="ctr">
+                    <a:lnL w="6350" cap="flat" cmpd="sng" algn="ctr">
+                      <a:solidFill>
+                        <a:srgbClr val="D5DBE3"/>
+                      </a:solidFill>
+                      <a:prstDash val="solid"/>
+                      <a:round/>
+                      <a:headEnd type="none" w="med" len="med"/>
+                      <a:tailEnd type="none" w="med" len="med"/>
+                    </a:lnL>
+                    <a:lnR w="6350" cap="flat" cmpd="sng" algn="ctr">
+                      <a:solidFill>
+                        <a:srgbClr val="D5DBE3"/>
+                      </a:solidFill>
+                      <a:prstDash val="solid"/>
+                      <a:round/>
+                      <a:headEnd type="none" w="med" len="med"/>
+                      <a:tailEnd type="none" w="med" len="med"/>
+                    </a:lnR>
+                    <a:lnT w="6350" cap="flat" cmpd="sng" algn="ctr">
+                      <a:solidFill>
+                        <a:srgbClr val="D5DBE3"/>
+                      </a:solidFill>
+                      <a:prstDash val="solid"/>
+                      <a:round/>
+                      <a:headEnd type="none" w="med" len="med"/>
+                      <a:tailEnd type="none" w="med" len="med"/>
+                    </a:lnT>
+                    <a:lnB w="6350" cap="flat" cmpd="sng" algn="ctr">
+                      <a:solidFill>
+                        <a:srgbClr val="D5DBE3"/>
+                      </a:solidFill>
+                      <a:prstDash val="solid"/>
+                      <a:round/>
+                      <a:headEnd type="none" w="med" len="med"/>
+                      <a:tailEnd type="none" w="med" len="med"/>
+                    </a:lnB>
+                  </a:tcPr>
+                </a:tc>
+                <a:tc>
+                  <a:txBody>
+                    <a:bodyPr/>
+                    <a:lstStyle/>
+                    <a:p>
+                      <a:pPr algn="r" indent="0" marL="0">
+                        <a:buNone/>
+                      </a:pPr>
+                      <a:r>
+                        <a:rPr lang="en-US" sz="900" dirty="0">
+                          <a:solidFill>
+                            <a:srgbClr val="5E9B7E"/>
+                          </a:solidFill>
+                          <a:latin typeface="Calibri" pitchFamily="34" charset="0"/>
+                          <a:ea typeface="Calibri" pitchFamily="34" charset="-122"/>
+                          <a:cs typeface="Calibri" pitchFamily="34" charset="-120"/>
+                        </a:rPr>
+                        <a:t>+100,0</a:t>
+                      </a:r>
+                      <a:endParaRPr lang="en-US" sz="900" dirty="0">
+                        <a:latin typeface="Calibri" charset="0"/>
+                        <a:ea typeface="Calibri" charset="0"/>
+                        <a:cs typeface="Calibri" charset="0"/>
+                      </a:endParaRPr>
+                    </a:p>
+                  </a:txBody>
+                  <a:tcPr marL="64008" marR="64008" marT="0" marB="0" anchor="ctr">
+                    <a:lnL w="6350" cap="flat" cmpd="sng" algn="ctr">
+                      <a:solidFill>
+                        <a:srgbClr val="D5DBE3"/>
+                      </a:solidFill>
+                      <a:prstDash val="solid"/>
+                      <a:round/>
+                      <a:headEnd type="none" w="med" len="med"/>
+                      <a:tailEnd type="none" w="med" len="med"/>
+                    </a:lnL>
+                    <a:lnR w="6350" cap="flat" cmpd="sng" algn="ctr">
+                      <a:solidFill>
+                        <a:srgbClr val="D5DBE3"/>
+                      </a:solidFill>
+                      <a:prstDash val="solid"/>
+                      <a:round/>
+                      <a:headEnd type="none" w="med" len="med"/>
+                      <a:tailEnd type="none" w="med" len="med"/>
+                    </a:lnR>
+                    <a:lnT w="6350" cap="flat" cmpd="sng" algn="ctr">
+                      <a:solidFill>
+                        <a:srgbClr val="D5DBE3"/>
+                      </a:solidFill>
+                      <a:prstDash val="solid"/>
+                      <a:round/>
+                      <a:headEnd type="none" w="med" len="med"/>
+                      <a:tailEnd type="none" w="med" len="med"/>
+                    </a:lnT>
+                    <a:lnB w="6350" cap="flat" cmpd="sng" algn="ctr">
+                      <a:solidFill>
+                        <a:srgbClr val="D5DBE3"/>
+                      </a:solidFill>
+                      <a:prstDash val="solid"/>
+                      <a:round/>
+                      <a:headEnd type="none" w="med" len="med"/>
+                      <a:tailEnd type="none" w="med" len="med"/>
+                    </a:lnB>
+                  </a:tcPr>
+                </a:tc>
+                <a:tc>
+                  <a:txBody>
+                    <a:bodyPr/>
+                    <a:lstStyle/>
+                    <a:p>
+                      <a:pPr algn="r" indent="0" marL="0">
+                        <a:buNone/>
+                      </a:pPr>
+                      <a:endParaRPr lang="en-US" sz="900" dirty="0">
+                        <a:latin typeface="Calibri" charset="0"/>
+                        <a:ea typeface="Calibri" charset="0"/>
+                        <a:cs typeface="Calibri" charset="0"/>
+                      </a:endParaRPr>
+                    </a:p>
+                  </a:txBody>
+                  <a:tcPr marL="64008" marR="64008" marT="0" marB="0" anchor="ctr">
+                    <a:lnL w="6350" cap="flat" cmpd="sng" algn="ctr">
+                      <a:solidFill>
+                        <a:srgbClr val="D5DBE3"/>
+                      </a:solidFill>
+                      <a:prstDash val="solid"/>
+                      <a:round/>
+                      <a:headEnd type="none" w="med" len="med"/>
+                      <a:tailEnd type="none" w="med" len="med"/>
+                    </a:lnL>
+                    <a:lnR w="6350" cap="flat" cmpd="sng" algn="ctr">
+                      <a:solidFill>
+                        <a:srgbClr val="D5DBE3"/>
+                      </a:solidFill>
+                      <a:prstDash val="solid"/>
+                      <a:round/>
+                      <a:headEnd type="none" w="med" len="med"/>
+                      <a:tailEnd type="none" w="med" len="med"/>
+                    </a:lnR>
+                    <a:lnT w="6350" cap="flat" cmpd="sng" algn="ctr">
+                      <a:solidFill>
+                        <a:srgbClr val="D5DBE3"/>
+                      </a:solidFill>
+                      <a:prstDash val="solid"/>
+                      <a:round/>
+                      <a:headEnd type="none" w="med" len="med"/>
+                      <a:tailEnd type="none" w="med" len="med"/>
+                    </a:lnT>
+                    <a:lnB w="6350" cap="flat" cmpd="sng" algn="ctr">
+                      <a:solidFill>
+                        <a:srgbClr val="D5DBE3"/>
+                      </a:solidFill>
+                      <a:prstDash val="solid"/>
+                      <a:round/>
+                      <a:headEnd type="none" w="med" len="med"/>
+                      <a:tailEnd type="none" w="med" len="med"/>
+                    </a:lnB>
+                  </a:tcPr>
+                </a:tc>
+                <a:tc>
+                  <a:txBody>
+                    <a:bodyPr/>
+                    <a:lstStyle/>
+                    <a:p>
+                      <a:pPr algn="r" indent="0" marL="0">
+                        <a:buNone/>
+                      </a:pPr>
+                      <a:endParaRPr lang="en-US" sz="900" dirty="0">
+                        <a:latin typeface="Calibri" charset="0"/>
+                        <a:ea typeface="Calibri" charset="0"/>
+                        <a:cs typeface="Calibri" charset="0"/>
+                      </a:endParaRPr>
+                    </a:p>
+                  </a:txBody>
+                  <a:tcPr marL="64008" marR="64008" marT="0" marB="0" anchor="ctr">
+                    <a:lnL w="6350" cap="flat" cmpd="sng" algn="ctr">
+                      <a:solidFill>
+                        <a:srgbClr val="D5DBE3"/>
+                      </a:solidFill>
+                      <a:prstDash val="solid"/>
+                      <a:round/>
+                      <a:headEnd type="none" w="med" len="med"/>
+                      <a:tailEnd type="none" w="med" len="med"/>
+                    </a:lnL>
+                    <a:lnR w="6350" cap="flat" cmpd="sng" algn="ctr">
+                      <a:solidFill>
+                        <a:srgbClr val="D5DBE3"/>
+                      </a:solidFill>
+                      <a:prstDash val="solid"/>
+                      <a:round/>
+                      <a:headEnd type="none" w="med" len="med"/>
+                      <a:tailEnd type="none" w="med" len="med"/>
+                    </a:lnR>
+                    <a:lnT w="6350" cap="flat" cmpd="sng" algn="ctr">
+                      <a:solidFill>
+                        <a:srgbClr val="D5DBE3"/>
+                      </a:solidFill>
+                      <a:prstDash val="solid"/>
+                      <a:round/>
+                      <a:headEnd type="none" w="med" len="med"/>
+                      <a:tailEnd type="none" w="med" len="med"/>
+                    </a:lnT>
+                    <a:lnB w="6350" cap="flat" cmpd="sng" algn="ctr">
+                      <a:solidFill>
+                        <a:srgbClr val="D5DBE3"/>
+                      </a:solidFill>
+                      <a:prstDash val="solid"/>
+                      <a:round/>
+                      <a:headEnd type="none" w="med" len="med"/>
+                      <a:tailEnd type="none" w="med" len="med"/>
+                    </a:lnB>
+                  </a:tcPr>
+                </a:tc>
+                <a:tc>
+                  <a:txBody>
+                    <a:bodyPr/>
+                    <a:lstStyle/>
+                    <a:p>
+                      <a:pPr algn="r" indent="0" marL="0">
+                        <a:buNone/>
+                      </a:pPr>
+                      <a:endParaRPr lang="en-US" sz="900" dirty="0">
+                        <a:latin typeface="Calibri" charset="0"/>
+                        <a:ea typeface="Calibri" charset="0"/>
+                        <a:cs typeface="Calibri" charset="0"/>
+                      </a:endParaRPr>
+                    </a:p>
+                  </a:txBody>
+                  <a:tcPr marL="64008" marR="64008" marT="0" marB="0" anchor="ctr">
+                    <a:lnL w="6350" cap="flat" cmpd="sng" algn="ctr">
+                      <a:solidFill>
+                        <a:srgbClr val="D5DBE3"/>
+                      </a:solidFill>
+                      <a:prstDash val="solid"/>
+                      <a:round/>
+                      <a:headEnd type="none" w="med" len="med"/>
+                      <a:tailEnd type="none" w="med" len="med"/>
+                    </a:lnL>
+                    <a:lnR w="6350" cap="flat" cmpd="sng" algn="ctr">
+                      <a:solidFill>
+                        <a:srgbClr val="D5DBE3"/>
+                      </a:solidFill>
+                      <a:prstDash val="solid"/>
+                      <a:round/>
+                      <a:headEnd type="none" w="med" len="med"/>
+                      <a:tailEnd type="none" w="med" len="med"/>
+                    </a:lnR>
+                    <a:lnT w="6350" cap="flat" cmpd="sng" algn="ctr">
+                      <a:solidFill>
+                        <a:srgbClr val="D5DBE3"/>
+                      </a:solidFill>
+                      <a:prstDash val="solid"/>
+                      <a:round/>
+                      <a:headEnd type="none" w="med" len="med"/>
+                      <a:tailEnd type="none" w="med" len="med"/>
+                    </a:lnT>
+                    <a:lnB w="6350" cap="flat" cmpd="sng" algn="ctr">
+                      <a:solidFill>
+                        <a:srgbClr val="D5DBE3"/>
+                      </a:solidFill>
+                      <a:prstDash val="solid"/>
+                      <a:round/>
+                      <a:headEnd type="none" w="med" len="med"/>
+                      <a:tailEnd type="none" w="med" len="med"/>
+                    </a:lnB>
+                  </a:tcPr>
+                </a:tc>
+              </a:tr>
+              <a:tr h="224028">
+                <a:tc>
+                  <a:txBody>
+                    <a:bodyPr/>
+                    <a:lstStyle/>
+                    <a:p>
+                      <a:pPr algn="l" indent="0" marL="0">
+                        <a:buNone/>
+                      </a:pPr>
+                      <a:r>
+                        <a:rPr lang="en-US" sz="900" i="1" dirty="0">
+                          <a:solidFill>
+                            <a:srgbClr val="1F2933"/>
+                          </a:solidFill>
+                          <a:latin typeface="Calibri" pitchFamily="34" charset="0"/>
+                          <a:ea typeface="Calibri" pitchFamily="34" charset="-122"/>
+                          <a:cs typeface="Calibri" pitchFamily="34" charset="-120"/>
+                        </a:rPr>
+                        <a:t>   dont FIRST</a:t>
+                      </a:r>
+                      <a:endParaRPr lang="en-US" sz="900" dirty="0">
+                        <a:latin typeface="Calibri" charset="0"/>
+                        <a:ea typeface="Calibri" charset="0"/>
+                        <a:cs typeface="Calibri" charset="0"/>
+                      </a:endParaRPr>
+                    </a:p>
+                  </a:txBody>
+                  <a:tcPr marL="64008" marR="64008" marT="0" marB="0" anchor="ctr">
+                    <a:lnL w="6350" cap="flat" cmpd="sng" algn="ctr">
+                      <a:solidFill>
+                        <a:srgbClr val="D5DBE3"/>
+                      </a:solidFill>
+                      <a:prstDash val="solid"/>
+                      <a:round/>
+                      <a:headEnd type="none" w="med" len="med"/>
+                      <a:tailEnd type="none" w="med" len="med"/>
+                    </a:lnL>
+                    <a:lnR w="6350" cap="flat" cmpd="sng" algn="ctr">
+                      <a:solidFill>
+                        <a:srgbClr val="D5DBE3"/>
+                      </a:solidFill>
+                      <a:prstDash val="solid"/>
+                      <a:round/>
+                      <a:headEnd type="none" w="med" len="med"/>
+                      <a:tailEnd type="none" w="med" len="med"/>
+                    </a:lnR>
+                    <a:lnT w="6350" cap="flat" cmpd="sng" algn="ctr">
+                      <a:solidFill>
+                        <a:srgbClr val="D5DBE3"/>
+                      </a:solidFill>
+                      <a:prstDash val="solid"/>
+                      <a:round/>
+                      <a:headEnd type="none" w="med" len="med"/>
+                      <a:tailEnd type="none" w="med" len="med"/>
+                    </a:lnT>
+                    <a:lnB w="6350" cap="flat" cmpd="sng" algn="ctr">
+                      <a:solidFill>
+                        <a:srgbClr val="D5DBE3"/>
+                      </a:solidFill>
+                      <a:prstDash val="solid"/>
+                      <a:round/>
+                      <a:headEnd type="none" w="med" len="med"/>
+                      <a:tailEnd type="none" w="med" len="med"/>
+                    </a:lnB>
+                  </a:tcPr>
+                </a:tc>
+                <a:tc>
+                  <a:txBody>
+                    <a:bodyPr/>
+                    <a:lstStyle/>
+                    <a:p>
+                      <a:pPr algn="r" indent="0" marL="0">
+                        <a:buNone/>
+                      </a:pPr>
+                      <a:r>
+                        <a:rPr lang="en-US" sz="900" dirty="0">
+                          <a:solidFill>
+                            <a:srgbClr val="B3261E"/>
+                          </a:solidFill>
+                          <a:latin typeface="Calibri" pitchFamily="34" charset="0"/>
+                          <a:ea typeface="Calibri" pitchFamily="34" charset="-122"/>
+                          <a:cs typeface="Calibri" pitchFamily="34" charset="-120"/>
+                        </a:rPr>
+                        <a:t>-171,8</a:t>
+                      </a:r>
+                      <a:endParaRPr lang="en-US" sz="900" dirty="0">
+                        <a:latin typeface="Calibri" charset="0"/>
+                        <a:ea typeface="Calibri" charset="0"/>
+                        <a:cs typeface="Calibri" charset="0"/>
+                      </a:endParaRPr>
+                    </a:p>
+                  </a:txBody>
+                  <a:tcPr marL="64008" marR="64008" marT="0" marB="0" anchor="ctr">
+                    <a:lnL w="6350" cap="flat" cmpd="sng" algn="ctr">
+                      <a:solidFill>
+                        <a:srgbClr val="D5DBE3"/>
+                      </a:solidFill>
+                      <a:prstDash val="solid"/>
+                      <a:round/>
+                      <a:headEnd type="none" w="med" len="med"/>
+                      <a:tailEnd type="none" w="med" len="med"/>
+                    </a:lnL>
+                    <a:lnR w="6350" cap="flat" cmpd="sng" algn="ctr">
+                      <a:solidFill>
+                        <a:srgbClr val="D5DBE3"/>
+                      </a:solidFill>
+                      <a:prstDash val="solid"/>
+                      <a:round/>
+                      <a:headEnd type="none" w="med" len="med"/>
+                      <a:tailEnd type="none" w="med" len="med"/>
+                    </a:lnR>
+                    <a:lnT w="6350" cap="flat" cmpd="sng" algn="ctr">
+                      <a:solidFill>
+                        <a:srgbClr val="D5DBE3"/>
+                      </a:solidFill>
+                      <a:prstDash val="solid"/>
+                      <a:round/>
+                      <a:headEnd type="none" w="med" len="med"/>
+                      <a:tailEnd type="none" w="med" len="med"/>
+                    </a:lnT>
+                    <a:lnB w="6350" cap="flat" cmpd="sng" algn="ctr">
+                      <a:solidFill>
+                        <a:srgbClr val="D5DBE3"/>
+                      </a:solidFill>
+                      <a:prstDash val="solid"/>
+                      <a:round/>
+                      <a:headEnd type="none" w="med" len="med"/>
+                      <a:tailEnd type="none" w="med" len="med"/>
+                    </a:lnB>
+                  </a:tcPr>
+                </a:tc>
+                <a:tc>
+                  <a:txBody>
+                    <a:bodyPr/>
+                    <a:lstStyle/>
+                    <a:p>
+                      <a:pPr algn="r" indent="0" marL="0">
+                        <a:buNone/>
+                      </a:pPr>
+                      <a:r>
+                        <a:rPr lang="en-US" sz="900" dirty="0">
+                          <a:solidFill>
+                            <a:srgbClr val="B3261E"/>
+                          </a:solidFill>
+                          <a:latin typeface="Calibri" pitchFamily="34" charset="0"/>
+                          <a:ea typeface="Calibri" pitchFamily="34" charset="-122"/>
+                          <a:cs typeface="Calibri" pitchFamily="34" charset="-120"/>
+                        </a:rPr>
+                        <a:t>-71,1</a:t>
+                      </a:r>
+                      <a:endParaRPr lang="en-US" sz="900" dirty="0">
+                        <a:latin typeface="Calibri" charset="0"/>
+                        <a:ea typeface="Calibri" charset="0"/>
+                        <a:cs typeface="Calibri" charset="0"/>
+                      </a:endParaRPr>
+                    </a:p>
+                  </a:txBody>
+                  <a:tcPr marL="64008" marR="64008" marT="0" marB="0" anchor="ctr">
+                    <a:lnL w="6350" cap="flat" cmpd="sng" algn="ctr">
+                      <a:solidFill>
+                        <a:srgbClr val="D5DBE3"/>
+                      </a:solidFill>
+                      <a:prstDash val="solid"/>
+                      <a:round/>
+                      <a:headEnd type="none" w="med" len="med"/>
+                      <a:tailEnd type="none" w="med" len="med"/>
+                    </a:lnL>
+                    <a:lnR w="6350" cap="flat" cmpd="sng" algn="ctr">
+                      <a:solidFill>
+                        <a:srgbClr val="D5DBE3"/>
+                      </a:solidFill>
+                      <a:prstDash val="solid"/>
+                      <a:round/>
+                      <a:headEnd type="none" w="med" len="med"/>
+                      <a:tailEnd type="none" w="med" len="med"/>
+                    </a:lnR>
+                    <a:lnT w="6350" cap="flat" cmpd="sng" algn="ctr">
+                      <a:solidFill>
+                        <a:srgbClr val="D5DBE3"/>
+                      </a:solidFill>
+                      <a:prstDash val="solid"/>
+                      <a:round/>
+                      <a:headEnd type="none" w="med" len="med"/>
+                      <a:tailEnd type="none" w="med" len="med"/>
+                    </a:lnT>
+                    <a:lnB w="6350" cap="flat" cmpd="sng" algn="ctr">
+                      <a:solidFill>
+                        <a:srgbClr val="D5DBE3"/>
+                      </a:solidFill>
+                      <a:prstDash val="solid"/>
+                      <a:round/>
+                      <a:headEnd type="none" w="med" len="med"/>
+                      <a:tailEnd type="none" w="med" len="med"/>
+                    </a:lnB>
+                  </a:tcPr>
+                </a:tc>
+                <a:tc>
+                  <a:txBody>
+                    <a:bodyPr/>
+                    <a:lstStyle/>
+                    <a:p>
+                      <a:pPr algn="r" indent="0" marL="0">
+                        <a:buNone/>
+                      </a:pPr>
+                      <a:r>
+                        <a:rPr lang="en-US" sz="900" dirty="0">
+                          <a:solidFill>
+                            <a:srgbClr val="B3261E"/>
+                          </a:solidFill>
+                          <a:latin typeface="Calibri" pitchFamily="34" charset="0"/>
+                          <a:ea typeface="Calibri" pitchFamily="34" charset="-122"/>
+                          <a:cs typeface="Calibri" pitchFamily="34" charset="-120"/>
+                        </a:rPr>
+                        <a:t>-175,3</a:t>
+                      </a:r>
+                      <a:endParaRPr lang="en-US" sz="900" dirty="0">
+                        <a:latin typeface="Calibri" charset="0"/>
+                        <a:ea typeface="Calibri" charset="0"/>
+                        <a:cs typeface="Calibri" charset="0"/>
+                      </a:endParaRPr>
+                    </a:p>
+                  </a:txBody>
+                  <a:tcPr marL="64008" marR="64008" marT="0" marB="0" anchor="ctr">
+                    <a:lnL w="6350" cap="flat" cmpd="sng" algn="ctr">
+                      <a:solidFill>
+                        <a:srgbClr val="D5DBE3"/>
+                      </a:solidFill>
+                      <a:prstDash val="solid"/>
+                      <a:round/>
+                      <a:headEnd type="none" w="med" len="med"/>
+                      <a:tailEnd type="none" w="med" len="med"/>
+                    </a:lnL>
+                    <a:lnR w="6350" cap="flat" cmpd="sng" algn="ctr">
+                      <a:solidFill>
+                        <a:srgbClr val="D5DBE3"/>
+                      </a:solidFill>
+                      <a:prstDash val="solid"/>
+                      <a:round/>
+                      <a:headEnd type="none" w="med" len="med"/>
+                      <a:tailEnd type="none" w="med" len="med"/>
+                    </a:lnR>
+                    <a:lnT w="6350" cap="flat" cmpd="sng" algn="ctr">
+                      <a:solidFill>
+                        <a:srgbClr val="D5DBE3"/>
+                      </a:solidFill>
+                      <a:prstDash val="solid"/>
+                      <a:round/>
+                      <a:headEnd type="none" w="med" len="med"/>
+                      <a:tailEnd type="none" w="med" len="med"/>
+                    </a:lnT>
+                    <a:lnB w="6350" cap="flat" cmpd="sng" algn="ctr">
+                      <a:solidFill>
+                        <a:srgbClr val="D5DBE3"/>
+                      </a:solidFill>
+                      <a:prstDash val="solid"/>
+                      <a:round/>
+                      <a:headEnd type="none" w="med" len="med"/>
+                      <a:tailEnd type="none" w="med" len="med"/>
+                    </a:lnB>
+                  </a:tcPr>
+                </a:tc>
+                <a:tc>
+                  <a:txBody>
+                    <a:bodyPr/>
+                    <a:lstStyle/>
+                    <a:p>
+                      <a:pPr algn="r" indent="0" marL="0">
+                        <a:buNone/>
+                      </a:pPr>
+                      <a:r>
+                        <a:rPr lang="en-US" sz="900" dirty="0">
+                          <a:solidFill>
+                            <a:srgbClr val="B3261E"/>
+                          </a:solidFill>
+                          <a:latin typeface="Calibri" pitchFamily="34" charset="0"/>
+                          <a:ea typeface="Calibri" pitchFamily="34" charset="-122"/>
+                          <a:cs typeface="Calibri" pitchFamily="34" charset="-120"/>
+                        </a:rPr>
+                        <a:t>-175,3</a:t>
+                      </a:r>
+                      <a:endParaRPr lang="en-US" sz="900" dirty="0">
+                        <a:latin typeface="Calibri" charset="0"/>
+                        <a:ea typeface="Calibri" charset="0"/>
+                        <a:cs typeface="Calibri" charset="0"/>
+                      </a:endParaRPr>
+                    </a:p>
+                  </a:txBody>
+                  <a:tcPr marL="64008" marR="64008" marT="0" marB="0" anchor="ctr">
+                    <a:lnL w="6350" cap="flat" cmpd="sng" algn="ctr">
+                      <a:solidFill>
+                        <a:srgbClr val="D5DBE3"/>
+                      </a:solidFill>
+                      <a:prstDash val="solid"/>
+                      <a:round/>
+                      <a:headEnd type="none" w="med" len="med"/>
+                      <a:tailEnd type="none" w="med" len="med"/>
+                    </a:lnL>
+                    <a:lnR w="6350" cap="flat" cmpd="sng" algn="ctr">
+                      <a:solidFill>
+                        <a:srgbClr val="D5DBE3"/>
+                      </a:solidFill>
+                      <a:prstDash val="solid"/>
+                      <a:round/>
+                      <a:headEnd type="none" w="med" len="med"/>
+                      <a:tailEnd type="none" w="med" len="med"/>
+                    </a:lnR>
+                    <a:lnT w="6350" cap="flat" cmpd="sng" algn="ctr">
+                      <a:solidFill>
+                        <a:srgbClr val="D5DBE3"/>
+                      </a:solidFill>
+                      <a:prstDash val="solid"/>
+                      <a:round/>
+                      <a:headEnd type="none" w="med" len="med"/>
+                      <a:tailEnd type="none" w="med" len="med"/>
+                    </a:lnT>
+                    <a:lnB w="6350" cap="flat" cmpd="sng" algn="ctr">
+                      <a:solidFill>
+                        <a:srgbClr val="D5DBE3"/>
+                      </a:solidFill>
+                      <a:prstDash val="solid"/>
+                      <a:round/>
+                      <a:headEnd type="none" w="med" len="med"/>
+                      <a:tailEnd type="none" w="med" len="med"/>
+                    </a:lnB>
+                  </a:tcPr>
+                </a:tc>
+                <a:tc>
+                  <a:txBody>
+                    <a:bodyPr/>
+                    <a:lstStyle/>
+                    <a:p>
+                      <a:pPr algn="r" indent="0" marL="0">
+                        <a:buNone/>
+                      </a:pPr>
+                      <a:r>
+                        <a:rPr lang="en-US" sz="900" dirty="0">
+                          <a:solidFill>
+                            <a:srgbClr val="B3261E"/>
+                          </a:solidFill>
+                          <a:latin typeface="Calibri" pitchFamily="34" charset="0"/>
+                          <a:ea typeface="Calibri" pitchFamily="34" charset="-122"/>
+                          <a:cs typeface="Calibri" pitchFamily="34" charset="-120"/>
+                        </a:rPr>
+                        <a:t>-175,3</a:t>
+                      </a:r>
+                      <a:endParaRPr lang="en-US" sz="900" dirty="0">
+                        <a:latin typeface="Calibri" charset="0"/>
+                        <a:ea typeface="Calibri" charset="0"/>
+                        <a:cs typeface="Calibri" charset="0"/>
+                      </a:endParaRPr>
+                    </a:p>
+                  </a:txBody>
+                  <a:tcPr marL="64008" marR="64008" marT="0" marB="0" anchor="ctr">
+                    <a:lnL w="6350" cap="flat" cmpd="sng" algn="ctr">
+                      <a:solidFill>
+                        <a:srgbClr val="D5DBE3"/>
+                      </a:solidFill>
+                      <a:prstDash val="solid"/>
+                      <a:round/>
+                      <a:headEnd type="none" w="med" len="med"/>
+                      <a:tailEnd type="none" w="med" len="med"/>
+                    </a:lnL>
+                    <a:lnR w="6350" cap="flat" cmpd="sng" algn="ctr">
+                      <a:solidFill>
+                        <a:srgbClr val="D5DBE3"/>
+                      </a:solidFill>
+                      <a:prstDash val="solid"/>
+                      <a:round/>
+                      <a:headEnd type="none" w="med" len="med"/>
+                      <a:tailEnd type="none" w="med" len="med"/>
+                    </a:lnR>
+                    <a:lnT w="6350" cap="flat" cmpd="sng" algn="ctr">
+                      <a:solidFill>
+                        <a:srgbClr val="D5DBE3"/>
+                      </a:solidFill>
+                      <a:prstDash val="solid"/>
+                      <a:round/>
+                      <a:headEnd type="none" w="med" len="med"/>
+                      <a:tailEnd type="none" w="med" len="med"/>
+                    </a:lnT>
+                    <a:lnB w="6350" cap="flat" cmpd="sng" algn="ctr">
+                      <a:solidFill>
+                        <a:srgbClr val="D5DBE3"/>
+                      </a:solidFill>
+                      <a:prstDash val="solid"/>
+                      <a:round/>
+                      <a:headEnd type="none" w="med" len="med"/>
+                      <a:tailEnd type="none" w="med" len="med"/>
+                    </a:lnB>
+                  </a:tcPr>
+                </a:tc>
+                <a:tc>
+                  <a:txBody>
+                    <a:bodyPr/>
+                    <a:lstStyle/>
+                    <a:p>
+                      <a:pPr algn="r" indent="0" marL="0">
+                        <a:buNone/>
+                      </a:pPr>
+                      <a:endParaRPr lang="en-US" sz="900" dirty="0">
+                        <a:latin typeface="Calibri" charset="0"/>
+                        <a:ea typeface="Calibri" charset="0"/>
+                        <a:cs typeface="Calibri" charset="0"/>
+                      </a:endParaRPr>
+                    </a:p>
+                  </a:txBody>
+                  <a:tcPr marL="64008" marR="64008" marT="0" marB="0" anchor="ctr">
+                    <a:lnL w="6350" cap="flat" cmpd="sng" algn="ctr">
+                      <a:solidFill>
+                        <a:srgbClr val="D5DBE3"/>
+                      </a:solidFill>
+                      <a:prstDash val="solid"/>
+                      <a:round/>
+                      <a:headEnd type="none" w="med" len="med"/>
+                      <a:tailEnd type="none" w="med" len="med"/>
+                    </a:lnL>
+                    <a:lnR w="6350" cap="flat" cmpd="sng" algn="ctr">
+                      <a:solidFill>
+                        <a:srgbClr val="D5DBE3"/>
+                      </a:solidFill>
+                      <a:prstDash val="solid"/>
+                      <a:round/>
+                      <a:headEnd type="none" w="med" len="med"/>
+                      <a:tailEnd type="none" w="med" len="med"/>
+                    </a:lnR>
+                    <a:lnT w="6350" cap="flat" cmpd="sng" algn="ctr">
+                      <a:solidFill>
+                        <a:srgbClr val="D5DBE3"/>
+                      </a:solidFill>
+                      <a:prstDash val="solid"/>
+                      <a:round/>
+                      <a:headEnd type="none" w="med" len="med"/>
+                      <a:tailEnd type="none" w="med" len="med"/>
+                    </a:lnT>
+                    <a:lnB w="6350" cap="flat" cmpd="sng" algn="ctr">
+                      <a:solidFill>
+                        <a:srgbClr val="D5DBE3"/>
+                      </a:solidFill>
+                      <a:prstDash val="solid"/>
+                      <a:round/>
+                      <a:headEnd type="none" w="med" len="med"/>
+                      <a:tailEnd type="none" w="med" len="med"/>
+                    </a:lnB>
+                  </a:tcPr>
+                </a:tc>
+                <a:tc>
+                  <a:txBody>
+                    <a:bodyPr/>
+                    <a:lstStyle/>
+                    <a:p>
+                      <a:pPr algn="r" indent="0" marL="0">
+                        <a:buNone/>
+                      </a:pPr>
+                      <a:endParaRPr lang="en-US" sz="900" dirty="0">
+                        <a:latin typeface="Calibri" charset="0"/>
+                        <a:ea typeface="Calibri" charset="0"/>
+                        <a:cs typeface="Calibri" charset="0"/>
+                      </a:endParaRPr>
+                    </a:p>
+                  </a:txBody>
+                  <a:tcPr marL="64008" marR="64008" marT="0" marB="0" anchor="ctr">
+                    <a:lnL w="6350" cap="flat" cmpd="sng" algn="ctr">
+                      <a:solidFill>
+                        <a:srgbClr val="D5DBE3"/>
+                      </a:solidFill>
+                      <a:prstDash val="solid"/>
+                      <a:round/>
+                      <a:headEnd type="none" w="med" len="med"/>
+                      <a:tailEnd type="none" w="med" len="med"/>
+                    </a:lnL>
+                    <a:lnR w="6350" cap="flat" cmpd="sng" algn="ctr">
+                      <a:solidFill>
+                        <a:srgbClr val="D5DBE3"/>
+                      </a:solidFill>
+                      <a:prstDash val="solid"/>
+                      <a:round/>
+                      <a:headEnd type="none" w="med" len="med"/>
+                      <a:tailEnd type="none" w="med" len="med"/>
+                    </a:lnR>
+                    <a:lnT w="6350" cap="flat" cmpd="sng" algn="ctr">
+                      <a:solidFill>
+                        <a:srgbClr val="D5DBE3"/>
+                      </a:solidFill>
+                      <a:prstDash val="solid"/>
+                      <a:round/>
+                      <a:headEnd type="none" w="med" len="med"/>
+                      <a:tailEnd type="none" w="med" len="med"/>
+                    </a:lnT>
+                    <a:lnB w="6350" cap="flat" cmpd="sng" algn="ctr">
+                      <a:solidFill>
+                        <a:srgbClr val="D5DBE3"/>
+                      </a:solidFill>
+                      <a:prstDash val="solid"/>
+                      <a:round/>
+                      <a:headEnd type="none" w="med" len="med"/>
+                      <a:tailEnd type="none" w="med" len="med"/>
+                    </a:lnB>
+                  </a:tcPr>
+                </a:tc>
+                <a:tc>
+                  <a:txBody>
+                    <a:bodyPr/>
+                    <a:lstStyle/>
+                    <a:p>
+                      <a:pPr algn="r" indent="0" marL="0">
+                        <a:buNone/>
+                      </a:pPr>
+                      <a:endParaRPr lang="en-US" sz="900" dirty="0">
+                        <a:latin typeface="Calibri" charset="0"/>
+                        <a:ea typeface="Calibri" charset="0"/>
+                        <a:cs typeface="Calibri" charset="0"/>
+                      </a:endParaRPr>
+                    </a:p>
+                  </a:txBody>
+                  <a:tcPr marL="64008" marR="64008" marT="0" marB="0" anchor="ctr">
+                    <a:lnL w="6350" cap="flat" cmpd="sng" algn="ctr">
+                      <a:solidFill>
+                        <a:srgbClr val="D5DBE3"/>
+                      </a:solidFill>
+                      <a:prstDash val="solid"/>
+                      <a:round/>
+                      <a:headEnd type="none" w="med" len="med"/>
+                      <a:tailEnd type="none" w="med" len="med"/>
+                    </a:lnL>
+                    <a:lnR w="6350" cap="flat" cmpd="sng" algn="ctr">
+                      <a:solidFill>
+                        <a:srgbClr val="D5DBE3"/>
+                      </a:solidFill>
+                      <a:prstDash val="solid"/>
+                      <a:round/>
+                      <a:headEnd type="none" w="med" len="med"/>
+                      <a:tailEnd type="none" w="med" len="med"/>
+                    </a:lnR>
+                    <a:lnT w="6350" cap="flat" cmpd="sng" algn="ctr">
+                      <a:solidFill>
+                        <a:srgbClr val="D5DBE3"/>
+                      </a:solidFill>
+                      <a:prstDash val="solid"/>
+                      <a:round/>
+                      <a:headEnd type="none" w="med" len="med"/>
+                      <a:tailEnd type="none" w="med" len="med"/>
+                    </a:lnT>
+                    <a:lnB w="6350" cap="flat" cmpd="sng" algn="ctr">
+                      <a:solidFill>
+                        <a:srgbClr val="D5DBE3"/>
+                      </a:solidFill>
+                      <a:prstDash val="solid"/>
+                      <a:round/>
+                      <a:headEnd type="none" w="med" len="med"/>
+                      <a:tailEnd type="none" w="med" len="med"/>
+                    </a:lnB>
+                  </a:tcPr>
+                </a:tc>
+              </a:tr>
+              <a:tr h="224028">
+                <a:tc>
+                  <a:txBody>
+                    <a:bodyPr/>
+                    <a:lstStyle/>
+                    <a:p>
+                      <a:pPr algn="l" indent="0" marL="0">
+                        <a:buNone/>
+                      </a:pPr>
+                      <a:r>
+                        <a:rPr lang="en-US" sz="900" b="1" dirty="0">
+                          <a:solidFill>
+                            <a:srgbClr val="1F2933"/>
+                          </a:solidFill>
+                          <a:latin typeface="Calibri" pitchFamily="34" charset="0"/>
+                          <a:ea typeface="Calibri" pitchFamily="34" charset="-122"/>
+                          <a:cs typeface="Calibri" pitchFamily="34" charset="-120"/>
+                        </a:rPr>
+                        <a:t>Comptes dédiés</a:t>
+                      </a:r>
+                      <a:endParaRPr lang="en-US" sz="900" dirty="0">
+                        <a:latin typeface="Calibri" charset="0"/>
+                        <a:ea typeface="Calibri" charset="0"/>
+                        <a:cs typeface="Calibri" charset="0"/>
+                      </a:endParaRPr>
+                    </a:p>
+                  </a:txBody>
+                  <a:tcPr marL="64008" marR="64008" marT="0" marB="0" anchor="ctr">
+                    <a:lnL w="6350" cap="flat" cmpd="sng" algn="ctr">
+                      <a:solidFill>
+                        <a:srgbClr val="D5DBE3"/>
+                      </a:solidFill>
+                      <a:prstDash val="solid"/>
+                      <a:round/>
+                      <a:headEnd type="none" w="med" len="med"/>
+                      <a:tailEnd type="none" w="med" len="med"/>
+                    </a:lnL>
+                    <a:lnR w="6350" cap="flat" cmpd="sng" algn="ctr">
+                      <a:solidFill>
+                        <a:srgbClr val="D5DBE3"/>
+                      </a:solidFill>
+                      <a:prstDash val="solid"/>
+                      <a:round/>
+                      <a:headEnd type="none" w="med" len="med"/>
+                      <a:tailEnd type="none" w="med" len="med"/>
+                    </a:lnR>
+                    <a:lnT w="6350" cap="flat" cmpd="sng" algn="ctr">
+                      <a:solidFill>
+                        <a:srgbClr val="D5DBE3"/>
+                      </a:solidFill>
+                      <a:prstDash val="solid"/>
+                      <a:round/>
+                      <a:headEnd type="none" w="med" len="med"/>
+                      <a:tailEnd type="none" w="med" len="med"/>
+                    </a:lnT>
+                    <a:lnB w="6350" cap="flat" cmpd="sng" algn="ctr">
+                      <a:solidFill>
+                        <a:srgbClr val="D5DBE3"/>
+                      </a:solidFill>
+                      <a:prstDash val="solid"/>
+                      <a:round/>
+                      <a:headEnd type="none" w="med" len="med"/>
+                      <a:tailEnd type="none" w="med" len="med"/>
+                    </a:lnB>
+                    <a:solidFill>
+                      <a:srgbClr val="EEF2F6"/>
+                    </a:solidFill>
+                  </a:tcPr>
+                </a:tc>
+                <a:tc>
+                  <a:txBody>
+                    <a:bodyPr/>
+                    <a:lstStyle/>
+                    <a:p>
+                      <a:pPr algn="r" indent="0" marL="0">
+                        <a:buNone/>
+                      </a:pPr>
+                      <a:r>
+                        <a:rPr lang="en-US" sz="900" b="1" dirty="0">
+                          <a:solidFill>
+                            <a:srgbClr val="5E9B7E"/>
+                          </a:solidFill>
+                          <a:latin typeface="Calibri" pitchFamily="34" charset="0"/>
+                          <a:ea typeface="Calibri" pitchFamily="34" charset="-122"/>
+                          <a:cs typeface="Calibri" pitchFamily="34" charset="-120"/>
+                        </a:rPr>
+                        <a:t>+1 782,8</a:t>
+                      </a:r>
+                      <a:endParaRPr lang="en-US" sz="900" dirty="0">
+                        <a:latin typeface="Calibri" charset="0"/>
+                        <a:ea typeface="Calibri" charset="0"/>
+                        <a:cs typeface="Calibri" charset="0"/>
+                      </a:endParaRPr>
+                    </a:p>
+                  </a:txBody>
+                  <a:tcPr marL="64008" marR="64008" marT="0" marB="0" anchor="ctr">
+                    <a:lnL w="6350" cap="flat" cmpd="sng" algn="ctr">
+                      <a:solidFill>
+                        <a:srgbClr val="D5DBE3"/>
+                      </a:solidFill>
+                      <a:prstDash val="solid"/>
+                      <a:round/>
+                      <a:headEnd type="none" w="med" len="med"/>
+                      <a:tailEnd type="none" w="med" len="med"/>
+                    </a:lnL>
+                    <a:lnR w="6350" cap="flat" cmpd="sng" algn="ctr">
+                      <a:solidFill>
+                        <a:srgbClr val="D5DBE3"/>
+                      </a:solidFill>
+                      <a:prstDash val="solid"/>
+                      <a:round/>
+                      <a:headEnd type="none" w="med" len="med"/>
+                      <a:tailEnd type="none" w="med" len="med"/>
+                    </a:lnR>
+                    <a:lnT w="6350" cap="flat" cmpd="sng" algn="ctr">
+                      <a:solidFill>
+                        <a:srgbClr val="D5DBE3"/>
+                      </a:solidFill>
+                      <a:prstDash val="solid"/>
+                      <a:round/>
+                      <a:headEnd type="none" w="med" len="med"/>
+                      <a:tailEnd type="none" w="med" len="med"/>
+                    </a:lnT>
+                    <a:lnB w="6350" cap="flat" cmpd="sng" algn="ctr">
+                      <a:solidFill>
+                        <a:srgbClr val="D5DBE3"/>
+                      </a:solidFill>
+                      <a:prstDash val="solid"/>
+                      <a:round/>
+                      <a:headEnd type="none" w="med" len="med"/>
+                      <a:tailEnd type="none" w="med" len="med"/>
+                    </a:lnB>
+                    <a:solidFill>
+                      <a:srgbClr val="EEF2F6"/>
+                    </a:solidFill>
+                  </a:tcPr>
+                </a:tc>
+                <a:tc>
+                  <a:txBody>
+                    <a:bodyPr/>
+                    <a:lstStyle/>
+                    <a:p>
+                      <a:pPr algn="r" indent="0" marL="0">
+                        <a:buNone/>
+                      </a:pPr>
+                      <a:r>
+                        <a:rPr lang="en-US" sz="900" b="1" dirty="0">
+                          <a:solidFill>
+                            <a:srgbClr val="5E9B7E"/>
+                          </a:solidFill>
+                          <a:latin typeface="Calibri" pitchFamily="34" charset="0"/>
+                          <a:ea typeface="Calibri" pitchFamily="34" charset="-122"/>
+                          <a:cs typeface="Calibri" pitchFamily="34" charset="-120"/>
+                        </a:rPr>
+                        <a:t>+68,1</a:t>
+                      </a:r>
+                      <a:endParaRPr lang="en-US" sz="900" dirty="0">
+                        <a:latin typeface="Calibri" charset="0"/>
+                        <a:ea typeface="Calibri" charset="0"/>
+                        <a:cs typeface="Calibri" charset="0"/>
+                      </a:endParaRPr>
+                    </a:p>
+                  </a:txBody>
+                  <a:tcPr marL="64008" marR="64008" marT="0" marB="0" anchor="ctr">
+                    <a:lnL w="6350" cap="flat" cmpd="sng" algn="ctr">
+                      <a:solidFill>
+                        <a:srgbClr val="D5DBE3"/>
+                      </a:solidFill>
+                      <a:prstDash val="solid"/>
+                      <a:round/>
+                      <a:headEnd type="none" w="med" len="med"/>
+                      <a:tailEnd type="none" w="med" len="med"/>
+                    </a:lnL>
+                    <a:lnR w="6350" cap="flat" cmpd="sng" algn="ctr">
+                      <a:solidFill>
+                        <a:srgbClr val="D5DBE3"/>
+                      </a:solidFill>
+                      <a:prstDash val="solid"/>
+                      <a:round/>
+                      <a:headEnd type="none" w="med" len="med"/>
+                      <a:tailEnd type="none" w="med" len="med"/>
+                    </a:lnR>
+                    <a:lnT w="6350" cap="flat" cmpd="sng" algn="ctr">
+                      <a:solidFill>
+                        <a:srgbClr val="D5DBE3"/>
+                      </a:solidFill>
+                      <a:prstDash val="solid"/>
+                      <a:round/>
+                      <a:headEnd type="none" w="med" len="med"/>
+                      <a:tailEnd type="none" w="med" len="med"/>
+                    </a:lnT>
+                    <a:lnB w="6350" cap="flat" cmpd="sng" algn="ctr">
+                      <a:solidFill>
+                        <a:srgbClr val="D5DBE3"/>
+                      </a:solidFill>
+                      <a:prstDash val="solid"/>
+                      <a:round/>
+                      <a:headEnd type="none" w="med" len="med"/>
+                      <a:tailEnd type="none" w="med" len="med"/>
+                    </a:lnB>
+                    <a:solidFill>
+                      <a:srgbClr val="EEF2F6"/>
+                    </a:solidFill>
+                  </a:tcPr>
+                </a:tc>
+                <a:tc>
+                  <a:txBody>
+                    <a:bodyPr/>
+                    <a:lstStyle/>
+                    <a:p>
+                      <a:pPr algn="r" indent="0" marL="0">
+                        <a:buNone/>
+                      </a:pPr>
+                      <a:r>
+                        <a:rPr lang="en-US" sz="900" b="1" dirty="0">
+                          <a:solidFill>
+                            <a:srgbClr val="5E9B7E"/>
+                          </a:solidFill>
+                          <a:latin typeface="Calibri" pitchFamily="34" charset="0"/>
+                          <a:ea typeface="Calibri" pitchFamily="34" charset="-122"/>
+                          <a:cs typeface="Calibri" pitchFamily="34" charset="-120"/>
+                        </a:rPr>
+                        <a:t>+68,1</a:t>
+                      </a:r>
+                      <a:endParaRPr lang="en-US" sz="900" dirty="0">
+                        <a:latin typeface="Calibri" charset="0"/>
+                        <a:ea typeface="Calibri" charset="0"/>
+                        <a:cs typeface="Calibri" charset="0"/>
+                      </a:endParaRPr>
+                    </a:p>
+                  </a:txBody>
+                  <a:tcPr marL="64008" marR="64008" marT="0" marB="0" anchor="ctr">
+                    <a:lnL w="6350" cap="flat" cmpd="sng" algn="ctr">
+                      <a:solidFill>
+                        <a:srgbClr val="D5DBE3"/>
+                      </a:solidFill>
+                      <a:prstDash val="solid"/>
+                      <a:round/>
+                      <a:headEnd type="none" w="med" len="med"/>
+                      <a:tailEnd type="none" w="med" len="med"/>
+                    </a:lnL>
+                    <a:lnR w="6350" cap="flat" cmpd="sng" algn="ctr">
+                      <a:solidFill>
+                        <a:srgbClr val="D5DBE3"/>
+                      </a:solidFill>
+                      <a:prstDash val="solid"/>
+                      <a:round/>
+                      <a:headEnd type="none" w="med" len="med"/>
+                      <a:tailEnd type="none" w="med" len="med"/>
+                    </a:lnR>
+                    <a:lnT w="6350" cap="flat" cmpd="sng" algn="ctr">
+                      <a:solidFill>
+                        <a:srgbClr val="D5DBE3"/>
+                      </a:solidFill>
+                      <a:prstDash val="solid"/>
+                      <a:round/>
+                      <a:headEnd type="none" w="med" len="med"/>
+                      <a:tailEnd type="none" w="med" len="med"/>
+                    </a:lnT>
+                    <a:lnB w="6350" cap="flat" cmpd="sng" algn="ctr">
+                      <a:solidFill>
+                        <a:srgbClr val="D5DBE3"/>
+                      </a:solidFill>
+                      <a:prstDash val="solid"/>
+                      <a:round/>
+                      <a:headEnd type="none" w="med" len="med"/>
+                      <a:tailEnd type="none" w="med" len="med"/>
+                    </a:lnB>
+                    <a:solidFill>
+                      <a:srgbClr val="EEF2F6"/>
+                    </a:solidFill>
+                  </a:tcPr>
+                </a:tc>
+                <a:tc>
+                  <a:txBody>
+                    <a:bodyPr/>
+                    <a:lstStyle/>
+                    <a:p>
+                      <a:pPr algn="r" indent="0" marL="0">
+                        <a:buNone/>
+                      </a:pPr>
+                      <a:r>
+                        <a:rPr lang="en-US" sz="900" b="1" dirty="0">
+                          <a:solidFill>
+                            <a:srgbClr val="5E9B7E"/>
+                          </a:solidFill>
+                          <a:latin typeface="Calibri" pitchFamily="34" charset="0"/>
+                          <a:ea typeface="Calibri" pitchFamily="34" charset="-122"/>
+                          <a:cs typeface="Calibri" pitchFamily="34" charset="-120"/>
+                        </a:rPr>
+                        <a:t>+41,0</a:t>
+                      </a:r>
+                      <a:endParaRPr lang="en-US" sz="900" dirty="0">
+                        <a:latin typeface="Calibri" charset="0"/>
+                        <a:ea typeface="Calibri" charset="0"/>
+                        <a:cs typeface="Calibri" charset="0"/>
+                      </a:endParaRPr>
+                    </a:p>
+                  </a:txBody>
+                  <a:tcPr marL="64008" marR="64008" marT="0" marB="0" anchor="ctr">
+                    <a:lnL w="6350" cap="flat" cmpd="sng" algn="ctr">
+                      <a:solidFill>
+                        <a:srgbClr val="D5DBE3"/>
+                      </a:solidFill>
+                      <a:prstDash val="solid"/>
+                      <a:round/>
+                      <a:headEnd type="none" w="med" len="med"/>
+                      <a:tailEnd type="none" w="med" len="med"/>
+                    </a:lnL>
+                    <a:lnR w="6350" cap="flat" cmpd="sng" algn="ctr">
+                      <a:solidFill>
+                        <a:srgbClr val="D5DBE3"/>
+                      </a:solidFill>
+                      <a:prstDash val="solid"/>
+                      <a:round/>
+                      <a:headEnd type="none" w="med" len="med"/>
+                      <a:tailEnd type="none" w="med" len="med"/>
+                    </a:lnR>
+                    <a:lnT w="6350" cap="flat" cmpd="sng" algn="ctr">
+                      <a:solidFill>
+                        <a:srgbClr val="D5DBE3"/>
+                      </a:solidFill>
+                      <a:prstDash val="solid"/>
+                      <a:round/>
+                      <a:headEnd type="none" w="med" len="med"/>
+                      <a:tailEnd type="none" w="med" len="med"/>
+                    </a:lnT>
+                    <a:lnB w="6350" cap="flat" cmpd="sng" algn="ctr">
+                      <a:solidFill>
+                        <a:srgbClr val="D5DBE3"/>
+                      </a:solidFill>
+                      <a:prstDash val="solid"/>
+                      <a:round/>
+                      <a:headEnd type="none" w="med" len="med"/>
+                      <a:tailEnd type="none" w="med" len="med"/>
+                    </a:lnB>
+                    <a:solidFill>
+                      <a:srgbClr val="EEF2F6"/>
+                    </a:solidFill>
+                  </a:tcPr>
+                </a:tc>
+                <a:tc>
+                  <a:txBody>
+                    <a:bodyPr/>
+                    <a:lstStyle/>
+                    <a:p>
+                      <a:pPr algn="r" indent="0" marL="0">
+                        <a:buNone/>
+                      </a:pPr>
+                      <a:r>
+                        <a:rPr lang="en-US" sz="900" b="1" dirty="0">
+                          <a:solidFill>
+                            <a:srgbClr val="5E9B7E"/>
+                          </a:solidFill>
+                          <a:latin typeface="Calibri" pitchFamily="34" charset="0"/>
+                          <a:ea typeface="Calibri" pitchFamily="34" charset="-122"/>
+                          <a:cs typeface="Calibri" pitchFamily="34" charset="-120"/>
+                        </a:rPr>
+                        <a:t>+41,0</a:t>
+                      </a:r>
+                      <a:endParaRPr lang="en-US" sz="900" dirty="0">
+                        <a:latin typeface="Calibri" charset="0"/>
+                        <a:ea typeface="Calibri" charset="0"/>
+                        <a:cs typeface="Calibri" charset="0"/>
+                      </a:endParaRPr>
+                    </a:p>
+                  </a:txBody>
+                  <a:tcPr marL="64008" marR="64008" marT="0" marB="0" anchor="ctr">
+                    <a:lnL w="6350" cap="flat" cmpd="sng" algn="ctr">
+                      <a:solidFill>
+                        <a:srgbClr val="D5DBE3"/>
+                      </a:solidFill>
+                      <a:prstDash val="solid"/>
+                      <a:round/>
+                      <a:headEnd type="none" w="med" len="med"/>
+                      <a:tailEnd type="none" w="med" len="med"/>
+                    </a:lnL>
+                    <a:lnR w="6350" cap="flat" cmpd="sng" algn="ctr">
+                      <a:solidFill>
+                        <a:srgbClr val="D5DBE3"/>
+                      </a:solidFill>
+                      <a:prstDash val="solid"/>
+                      <a:round/>
+                      <a:headEnd type="none" w="med" len="med"/>
+                      <a:tailEnd type="none" w="med" len="med"/>
+                    </a:lnR>
+                    <a:lnT w="6350" cap="flat" cmpd="sng" algn="ctr">
+                      <a:solidFill>
+                        <a:srgbClr val="D5DBE3"/>
+                      </a:solidFill>
+                      <a:prstDash val="solid"/>
+                      <a:round/>
+                      <a:headEnd type="none" w="med" len="med"/>
+                      <a:tailEnd type="none" w="med" len="med"/>
+                    </a:lnT>
+                    <a:lnB w="6350" cap="flat" cmpd="sng" algn="ctr">
+                      <a:solidFill>
+                        <a:srgbClr val="D5DBE3"/>
+                      </a:solidFill>
+                      <a:prstDash val="solid"/>
+                      <a:round/>
+                      <a:headEnd type="none" w="med" len="med"/>
+                      <a:tailEnd type="none" w="med" len="med"/>
+                    </a:lnB>
+                    <a:solidFill>
+                      <a:srgbClr val="EEF2F6"/>
+                    </a:solidFill>
+                  </a:tcPr>
+                </a:tc>
+                <a:tc>
+                  <a:txBody>
+                    <a:bodyPr/>
+                    <a:lstStyle/>
+                    <a:p>
+                      <a:pPr algn="r" indent="0" marL="0">
+                        <a:buNone/>
+                      </a:pPr>
+                      <a:endParaRPr lang="en-US" sz="900" dirty="0">
+                        <a:latin typeface="Calibri" charset="0"/>
+                        <a:ea typeface="Calibri" charset="0"/>
+                        <a:cs typeface="Calibri" charset="0"/>
+                      </a:endParaRPr>
+                    </a:p>
+                  </a:txBody>
+                  <a:tcPr marL="64008" marR="64008" marT="0" marB="0" anchor="ctr">
+                    <a:lnL w="6350" cap="flat" cmpd="sng" algn="ctr">
+                      <a:solidFill>
+                        <a:srgbClr val="D5DBE3"/>
+                      </a:solidFill>
+                      <a:prstDash val="solid"/>
+                      <a:round/>
+                      <a:headEnd type="none" w="med" len="med"/>
+                      <a:tailEnd type="none" w="med" len="med"/>
+                    </a:lnL>
+                    <a:lnR w="6350" cap="flat" cmpd="sng" algn="ctr">
+                      <a:solidFill>
+                        <a:srgbClr val="D5DBE3"/>
+                      </a:solidFill>
+                      <a:prstDash val="solid"/>
+                      <a:round/>
+                      <a:headEnd type="none" w="med" len="med"/>
+                      <a:tailEnd type="none" w="med" len="med"/>
+                    </a:lnR>
+                    <a:lnT w="6350" cap="flat" cmpd="sng" algn="ctr">
+                      <a:solidFill>
+                        <a:srgbClr val="D5DBE3"/>
+                      </a:solidFill>
+                      <a:prstDash val="solid"/>
+                      <a:round/>
+                      <a:headEnd type="none" w="med" len="med"/>
+                      <a:tailEnd type="none" w="med" len="med"/>
+                    </a:lnT>
+                    <a:lnB w="6350" cap="flat" cmpd="sng" algn="ctr">
+                      <a:solidFill>
+                        <a:srgbClr val="D5DBE3"/>
+                      </a:solidFill>
+                      <a:prstDash val="solid"/>
+                      <a:round/>
+                      <a:headEnd type="none" w="med" len="med"/>
+                      <a:tailEnd type="none" w="med" len="med"/>
+                    </a:lnB>
+                    <a:solidFill>
+                      <a:srgbClr val="EEF2F6"/>
+                    </a:solidFill>
+                  </a:tcPr>
+                </a:tc>
+                <a:tc>
+                  <a:txBody>
+                    <a:bodyPr/>
+                    <a:lstStyle/>
+                    <a:p>
+                      <a:pPr algn="r" indent="0" marL="0">
+                        <a:buNone/>
+                      </a:pPr>
+                      <a:endParaRPr lang="en-US" sz="900" dirty="0">
+                        <a:latin typeface="Calibri" charset="0"/>
+                        <a:ea typeface="Calibri" charset="0"/>
+                        <a:cs typeface="Calibri" charset="0"/>
+                      </a:endParaRPr>
+                    </a:p>
+                  </a:txBody>
+                  <a:tcPr marL="64008" marR="64008" marT="0" marB="0" anchor="ctr">
+                    <a:lnL w="6350" cap="flat" cmpd="sng" algn="ctr">
+                      <a:solidFill>
+                        <a:srgbClr val="D5DBE3"/>
+                      </a:solidFill>
+                      <a:prstDash val="solid"/>
+                      <a:round/>
+                      <a:headEnd type="none" w="med" len="med"/>
+                      <a:tailEnd type="none" w="med" len="med"/>
+                    </a:lnL>
+                    <a:lnR w="6350" cap="flat" cmpd="sng" algn="ctr">
+                      <a:solidFill>
+                        <a:srgbClr val="D5DBE3"/>
+                      </a:solidFill>
+                      <a:prstDash val="solid"/>
+                      <a:round/>
+                      <a:headEnd type="none" w="med" len="med"/>
+                      <a:tailEnd type="none" w="med" len="med"/>
+                    </a:lnR>
+                    <a:lnT w="6350" cap="flat" cmpd="sng" algn="ctr">
+                      <a:solidFill>
+                        <a:srgbClr val="D5DBE3"/>
+                      </a:solidFill>
+                      <a:prstDash val="solid"/>
+                      <a:round/>
+                      <a:headEnd type="none" w="med" len="med"/>
+                      <a:tailEnd type="none" w="med" len="med"/>
+                    </a:lnT>
+                    <a:lnB w="6350" cap="flat" cmpd="sng" algn="ctr">
+                      <a:solidFill>
+                        <a:srgbClr val="D5DBE3"/>
+                      </a:solidFill>
+                      <a:prstDash val="solid"/>
+                      <a:round/>
+                      <a:headEnd type="none" w="med" len="med"/>
+                      <a:tailEnd type="none" w="med" len="med"/>
+                    </a:lnB>
+                    <a:solidFill>
+                      <a:srgbClr val="EEF2F6"/>
+                    </a:solidFill>
+                  </a:tcPr>
+                </a:tc>
+                <a:tc>
+                  <a:txBody>
+                    <a:bodyPr/>
+                    <a:lstStyle/>
+                    <a:p>
+                      <a:pPr algn="r" indent="0" marL="0">
+                        <a:buNone/>
+                      </a:pPr>
+                      <a:endParaRPr lang="en-US" sz="900" dirty="0">
+                        <a:latin typeface="Calibri" charset="0"/>
+                        <a:ea typeface="Calibri" charset="0"/>
+                        <a:cs typeface="Calibri" charset="0"/>
+                      </a:endParaRPr>
+                    </a:p>
+                  </a:txBody>
+                  <a:tcPr marL="64008" marR="64008" marT="0" marB="0" anchor="ctr">
+                    <a:lnL w="6350" cap="flat" cmpd="sng" algn="ctr">
+                      <a:solidFill>
+                        <a:srgbClr val="D5DBE3"/>
+                      </a:solidFill>
+                      <a:prstDash val="solid"/>
+                      <a:round/>
+                      <a:headEnd type="none" w="med" len="med"/>
+                      <a:tailEnd type="none" w="med" len="med"/>
+                    </a:lnL>
+                    <a:lnR w="6350" cap="flat" cmpd="sng" algn="ctr">
+                      <a:solidFill>
+                        <a:srgbClr val="D5DBE3"/>
+                      </a:solidFill>
+                      <a:prstDash val="solid"/>
+                      <a:round/>
+                      <a:headEnd type="none" w="med" len="med"/>
+                      <a:tailEnd type="none" w="med" len="med"/>
+                    </a:lnR>
+                    <a:lnT w="6350" cap="flat" cmpd="sng" algn="ctr">
+                      <a:solidFill>
+                        <a:srgbClr val="D5DBE3"/>
+                      </a:solidFill>
+                      <a:prstDash val="solid"/>
+                      <a:round/>
+                      <a:headEnd type="none" w="med" len="med"/>
+                      <a:tailEnd type="none" w="med" len="med"/>
+                    </a:lnT>
+                    <a:lnB w="6350" cap="flat" cmpd="sng" algn="ctr">
+                      <a:solidFill>
+                        <a:srgbClr val="D5DBE3"/>
+                      </a:solidFill>
+                      <a:prstDash val="solid"/>
+                      <a:round/>
+                      <a:headEnd type="none" w="med" len="med"/>
+                      <a:tailEnd type="none" w="med" len="med"/>
+                    </a:lnB>
+                    <a:solidFill>
+                      <a:srgbClr val="EEF2F6"/>
+                    </a:solidFill>
+                  </a:tcPr>
+                </a:tc>
+              </a:tr>
+              <a:tr h="224028">
+                <a:tc>
+                  <a:txBody>
+                    <a:bodyPr/>
+                    <a:lstStyle/>
+                    <a:p>
+                      <a:pPr algn="l" indent="0" marL="0">
+                        <a:buNone/>
+                      </a:pPr>
+                      <a:r>
+                        <a:rPr lang="en-US" sz="900" i="1" dirty="0">
+                          <a:solidFill>
+                            <a:srgbClr val="1F2933"/>
+                          </a:solidFill>
+                          <a:latin typeface="Calibri" pitchFamily="34" charset="0"/>
+                          <a:ea typeface="Calibri" pitchFamily="34" charset="-122"/>
+                          <a:cs typeface="Calibri" pitchFamily="34" charset="-120"/>
+                        </a:rPr>
+                        <a:t>   dont RIVIERA</a:t>
+                      </a:r>
+                      <a:endParaRPr lang="en-US" sz="900" dirty="0">
+                        <a:latin typeface="Calibri" charset="0"/>
+                        <a:ea typeface="Calibri" charset="0"/>
+                        <a:cs typeface="Calibri" charset="0"/>
+                      </a:endParaRPr>
+                    </a:p>
+                  </a:txBody>
+                  <a:tcPr marL="64008" marR="64008" marT="0" marB="0" anchor="ctr">
+                    <a:lnL w="6350" cap="flat" cmpd="sng" algn="ctr">
+                      <a:solidFill>
+                        <a:srgbClr val="D5DBE3"/>
+                      </a:solidFill>
+                      <a:prstDash val="solid"/>
+                      <a:round/>
+                      <a:headEnd type="none" w="med" len="med"/>
+                      <a:tailEnd type="none" w="med" len="med"/>
+                    </a:lnL>
+                    <a:lnR w="6350" cap="flat" cmpd="sng" algn="ctr">
+                      <a:solidFill>
+                        <a:srgbClr val="D5DBE3"/>
+                      </a:solidFill>
+                      <a:prstDash val="solid"/>
+                      <a:round/>
+                      <a:headEnd type="none" w="med" len="med"/>
+                      <a:tailEnd type="none" w="med" len="med"/>
+                    </a:lnR>
+                    <a:lnT w="6350" cap="flat" cmpd="sng" algn="ctr">
+                      <a:solidFill>
+                        <a:srgbClr val="D5DBE3"/>
+                      </a:solidFill>
+                      <a:prstDash val="solid"/>
+                      <a:round/>
+                      <a:headEnd type="none" w="med" len="med"/>
+                      <a:tailEnd type="none" w="med" len="med"/>
+                    </a:lnT>
+                    <a:lnB w="6350" cap="flat" cmpd="sng" algn="ctr">
+                      <a:solidFill>
+                        <a:srgbClr val="D5DBE3"/>
+                      </a:solidFill>
+                      <a:prstDash val="solid"/>
+                      <a:round/>
+                      <a:headEnd type="none" w="med" len="med"/>
+                      <a:tailEnd type="none" w="med" len="med"/>
+                    </a:lnB>
+                  </a:tcPr>
+                </a:tc>
+                <a:tc>
+                  <a:txBody>
+                    <a:bodyPr/>
+                    <a:lstStyle/>
+                    <a:p>
+                      <a:pPr algn="r" indent="0" marL="0">
+                        <a:buNone/>
+                      </a:pPr>
+                      <a:r>
+                        <a:rPr lang="en-US" sz="900" dirty="0">
+                          <a:solidFill>
+                            <a:srgbClr val="5E9B7E"/>
+                          </a:solidFill>
+                          <a:latin typeface="Calibri" pitchFamily="34" charset="0"/>
+                          <a:ea typeface="Calibri" pitchFamily="34" charset="-122"/>
+                          <a:cs typeface="Calibri" pitchFamily="34" charset="-120"/>
+                        </a:rPr>
+                        <a:t>+2 426,7</a:t>
+                      </a:r>
+                      <a:endParaRPr lang="en-US" sz="900" dirty="0">
+                        <a:latin typeface="Calibri" charset="0"/>
+                        <a:ea typeface="Calibri" charset="0"/>
+                        <a:cs typeface="Calibri" charset="0"/>
+                      </a:endParaRPr>
+                    </a:p>
+                  </a:txBody>
+                  <a:tcPr marL="64008" marR="64008" marT="0" marB="0" anchor="ctr">
+                    <a:lnL w="6350" cap="flat" cmpd="sng" algn="ctr">
+                      <a:solidFill>
+                        <a:srgbClr val="D5DBE3"/>
+                      </a:solidFill>
+                      <a:prstDash val="solid"/>
+                      <a:round/>
+                      <a:headEnd type="none" w="med" len="med"/>
+                      <a:tailEnd type="none" w="med" len="med"/>
+                    </a:lnL>
+                    <a:lnR w="6350" cap="flat" cmpd="sng" algn="ctr">
+                      <a:solidFill>
+                        <a:srgbClr val="D5DBE3"/>
+                      </a:solidFill>
+                      <a:prstDash val="solid"/>
+                      <a:round/>
+                      <a:headEnd type="none" w="med" len="med"/>
+                      <a:tailEnd type="none" w="med" len="med"/>
+                    </a:lnR>
+                    <a:lnT w="6350" cap="flat" cmpd="sng" algn="ctr">
+                      <a:solidFill>
+                        <a:srgbClr val="D5DBE3"/>
+                      </a:solidFill>
+                      <a:prstDash val="solid"/>
+                      <a:round/>
+                      <a:headEnd type="none" w="med" len="med"/>
+                      <a:tailEnd type="none" w="med" len="med"/>
+                    </a:lnT>
+                    <a:lnB w="6350" cap="flat" cmpd="sng" algn="ctr">
+                      <a:solidFill>
+                        <a:srgbClr val="D5DBE3"/>
+                      </a:solidFill>
+                      <a:prstDash val="solid"/>
+                      <a:round/>
+                      <a:headEnd type="none" w="med" len="med"/>
+                      <a:tailEnd type="none" w="med" len="med"/>
+                    </a:lnB>
+                  </a:tcPr>
+                </a:tc>
+                <a:tc>
+                  <a:txBody>
+                    <a:bodyPr/>
+                    <a:lstStyle/>
+                    <a:p>
+                      <a:pPr algn="r" indent="0" marL="0">
+                        <a:buNone/>
+                      </a:pPr>
+                      <a:r>
+                        <a:rPr lang="en-US" sz="900" dirty="0">
+                          <a:solidFill>
+                            <a:srgbClr val="5E9B7E"/>
+                          </a:solidFill>
+                          <a:latin typeface="Calibri" pitchFamily="34" charset="0"/>
+                          <a:ea typeface="Calibri" pitchFamily="34" charset="-122"/>
+                          <a:cs typeface="Calibri" pitchFamily="34" charset="-120"/>
+                        </a:rPr>
+                        <a:t>+1 184,2</a:t>
+                      </a:r>
+                      <a:endParaRPr lang="en-US" sz="900" dirty="0">
+                        <a:latin typeface="Calibri" charset="0"/>
+                        <a:ea typeface="Calibri" charset="0"/>
+                        <a:cs typeface="Calibri" charset="0"/>
+                      </a:endParaRPr>
+                    </a:p>
+                  </a:txBody>
+                  <a:tcPr marL="64008" marR="64008" marT="0" marB="0" anchor="ctr">
+                    <a:lnL w="6350" cap="flat" cmpd="sng" algn="ctr">
+                      <a:solidFill>
+                        <a:srgbClr val="D5DBE3"/>
+                      </a:solidFill>
+                      <a:prstDash val="solid"/>
+                      <a:round/>
+                      <a:headEnd type="none" w="med" len="med"/>
+                      <a:tailEnd type="none" w="med" len="med"/>
+                    </a:lnL>
+                    <a:lnR w="6350" cap="flat" cmpd="sng" algn="ctr">
+                      <a:solidFill>
+                        <a:srgbClr val="D5DBE3"/>
+                      </a:solidFill>
+                      <a:prstDash val="solid"/>
+                      <a:round/>
+                      <a:headEnd type="none" w="med" len="med"/>
+                      <a:tailEnd type="none" w="med" len="med"/>
+                    </a:lnR>
+                    <a:lnT w="6350" cap="flat" cmpd="sng" algn="ctr">
+                      <a:solidFill>
+                        <a:srgbClr val="D5DBE3"/>
+                      </a:solidFill>
+                      <a:prstDash val="solid"/>
+                      <a:round/>
+                      <a:headEnd type="none" w="med" len="med"/>
+                      <a:tailEnd type="none" w="med" len="med"/>
+                    </a:lnT>
+                    <a:lnB w="6350" cap="flat" cmpd="sng" algn="ctr">
+                      <a:solidFill>
+                        <a:srgbClr val="D5DBE3"/>
+                      </a:solidFill>
+                      <a:prstDash val="solid"/>
+                      <a:round/>
+                      <a:headEnd type="none" w="med" len="med"/>
+                      <a:tailEnd type="none" w="med" len="med"/>
+                    </a:lnB>
+                  </a:tcPr>
+                </a:tc>
+                <a:tc>
+                  <a:txBody>
+                    <a:bodyPr/>
+                    <a:lstStyle/>
+                    <a:p>
+                      <a:pPr algn="r" indent="0" marL="0">
+                        <a:buNone/>
+                      </a:pPr>
+                      <a:r>
+                        <a:rPr lang="en-US" sz="900" dirty="0">
+                          <a:solidFill>
+                            <a:srgbClr val="5E9B7E"/>
+                          </a:solidFill>
+                          <a:latin typeface="Calibri" pitchFamily="34" charset="0"/>
+                          <a:ea typeface="Calibri" pitchFamily="34" charset="-122"/>
+                          <a:cs typeface="Calibri" pitchFamily="34" charset="-120"/>
+                        </a:rPr>
+                        <a:t>+1 184,2</a:t>
+                      </a:r>
+                      <a:endParaRPr lang="en-US" sz="900" dirty="0">
+                        <a:latin typeface="Calibri" charset="0"/>
+                        <a:ea typeface="Calibri" charset="0"/>
+                        <a:cs typeface="Calibri" charset="0"/>
+                      </a:endParaRPr>
+                    </a:p>
+                  </a:txBody>
+                  <a:tcPr marL="64008" marR="64008" marT="0" marB="0" anchor="ctr">
+                    <a:lnL w="6350" cap="flat" cmpd="sng" algn="ctr">
+                      <a:solidFill>
+                        <a:srgbClr val="D5DBE3"/>
+                      </a:solidFill>
+                      <a:prstDash val="solid"/>
+                      <a:round/>
+                      <a:headEnd type="none" w="med" len="med"/>
+                      <a:tailEnd type="none" w="med" len="med"/>
+                    </a:lnL>
+                    <a:lnR w="6350" cap="flat" cmpd="sng" algn="ctr">
+                      <a:solidFill>
+                        <a:srgbClr val="D5DBE3"/>
+                      </a:solidFill>
+                      <a:prstDash val="solid"/>
+                      <a:round/>
+                      <a:headEnd type="none" w="med" len="med"/>
+                      <a:tailEnd type="none" w="med" len="med"/>
+                    </a:lnR>
+                    <a:lnT w="6350" cap="flat" cmpd="sng" algn="ctr">
+                      <a:solidFill>
+                        <a:srgbClr val="D5DBE3"/>
+                      </a:solidFill>
+                      <a:prstDash val="solid"/>
+                      <a:round/>
+                      <a:headEnd type="none" w="med" len="med"/>
+                      <a:tailEnd type="none" w="med" len="med"/>
+                    </a:lnT>
+                    <a:lnB w="6350" cap="flat" cmpd="sng" algn="ctr">
+                      <a:solidFill>
+                        <a:srgbClr val="D5DBE3"/>
+                      </a:solidFill>
+                      <a:prstDash val="solid"/>
+                      <a:round/>
+                      <a:headEnd type="none" w="med" len="med"/>
+                      <a:tailEnd type="none" w="med" len="med"/>
+                    </a:lnB>
+                  </a:tcPr>
+                </a:tc>
+                <a:tc>
+                  <a:txBody>
+                    <a:bodyPr/>
+                    <a:lstStyle/>
+                    <a:p>
+                      <a:pPr algn="r" indent="0" marL="0">
+                        <a:buNone/>
+                      </a:pPr>
+                      <a:r>
+                        <a:rPr lang="en-US" sz="900" dirty="0">
+                          <a:solidFill>
+                            <a:srgbClr val="5E9B7E"/>
+                          </a:solidFill>
+                          <a:latin typeface="Calibri" pitchFamily="34" charset="0"/>
+                          <a:ea typeface="Calibri" pitchFamily="34" charset="-122"/>
+                          <a:cs typeface="Calibri" pitchFamily="34" charset="-120"/>
+                        </a:rPr>
+                        <a:t>+1 170,6</a:t>
+                      </a:r>
+                      <a:endParaRPr lang="en-US" sz="900" dirty="0">
+                        <a:latin typeface="Calibri" charset="0"/>
+                        <a:ea typeface="Calibri" charset="0"/>
+                        <a:cs typeface="Calibri" charset="0"/>
+                      </a:endParaRPr>
+                    </a:p>
+                  </a:txBody>
+                  <a:tcPr marL="64008" marR="64008" marT="0" marB="0" anchor="ctr">
+                    <a:lnL w="6350" cap="flat" cmpd="sng" algn="ctr">
+                      <a:solidFill>
+                        <a:srgbClr val="D5DBE3"/>
+                      </a:solidFill>
+                      <a:prstDash val="solid"/>
+                      <a:round/>
+                      <a:headEnd type="none" w="med" len="med"/>
+                      <a:tailEnd type="none" w="med" len="med"/>
+                    </a:lnL>
+                    <a:lnR w="6350" cap="flat" cmpd="sng" algn="ctr">
+                      <a:solidFill>
+                        <a:srgbClr val="D5DBE3"/>
+                      </a:solidFill>
+                      <a:prstDash val="solid"/>
+                      <a:round/>
+                      <a:headEnd type="none" w="med" len="med"/>
+                      <a:tailEnd type="none" w="med" len="med"/>
+                    </a:lnR>
+                    <a:lnT w="6350" cap="flat" cmpd="sng" algn="ctr">
+                      <a:solidFill>
+                        <a:srgbClr val="D5DBE3"/>
+                      </a:solidFill>
+                      <a:prstDash val="solid"/>
+                      <a:round/>
+                      <a:headEnd type="none" w="med" len="med"/>
+                      <a:tailEnd type="none" w="med" len="med"/>
+                    </a:lnT>
+                    <a:lnB w="6350" cap="flat" cmpd="sng" algn="ctr">
+                      <a:solidFill>
+                        <a:srgbClr val="D5DBE3"/>
+                      </a:solidFill>
+                      <a:prstDash val="solid"/>
+                      <a:round/>
+                      <a:headEnd type="none" w="med" len="med"/>
+                      <a:tailEnd type="none" w="med" len="med"/>
+                    </a:lnB>
+                  </a:tcPr>
+                </a:tc>
+                <a:tc>
+                  <a:txBody>
+                    <a:bodyPr/>
+                    <a:lstStyle/>
+                    <a:p>
+                      <a:pPr algn="r" indent="0" marL="0">
+                        <a:buNone/>
+                      </a:pPr>
+                      <a:r>
+                        <a:rPr lang="en-US" sz="900" dirty="0">
+                          <a:solidFill>
+                            <a:srgbClr val="5E9B7E"/>
+                          </a:solidFill>
+                          <a:latin typeface="Calibri" pitchFamily="34" charset="0"/>
+                          <a:ea typeface="Calibri" pitchFamily="34" charset="-122"/>
+                          <a:cs typeface="Calibri" pitchFamily="34" charset="-120"/>
+                        </a:rPr>
+                        <a:t>+1 170,6</a:t>
+                      </a:r>
+                      <a:endParaRPr lang="en-US" sz="900" dirty="0">
+                        <a:latin typeface="Calibri" charset="0"/>
+                        <a:ea typeface="Calibri" charset="0"/>
+                        <a:cs typeface="Calibri" charset="0"/>
+                      </a:endParaRPr>
+                    </a:p>
+                  </a:txBody>
+                  <a:tcPr marL="64008" marR="64008" marT="0" marB="0" anchor="ctr">
+                    <a:lnL w="6350" cap="flat" cmpd="sng" algn="ctr">
+                      <a:solidFill>
+                        <a:srgbClr val="D5DBE3"/>
+                      </a:solidFill>
+                      <a:prstDash val="solid"/>
+                      <a:round/>
+                      <a:headEnd type="none" w="med" len="med"/>
+                      <a:tailEnd type="none" w="med" len="med"/>
+                    </a:lnL>
+                    <a:lnR w="6350" cap="flat" cmpd="sng" algn="ctr">
+                      <a:solidFill>
+                        <a:srgbClr val="D5DBE3"/>
+                      </a:solidFill>
+                      <a:prstDash val="solid"/>
+                      <a:round/>
+                      <a:headEnd type="none" w="med" len="med"/>
+                      <a:tailEnd type="none" w="med" len="med"/>
+                    </a:lnR>
+                    <a:lnT w="6350" cap="flat" cmpd="sng" algn="ctr">
+                      <a:solidFill>
+                        <a:srgbClr val="D5DBE3"/>
+                      </a:solidFill>
+                      <a:prstDash val="solid"/>
+                      <a:round/>
+                      <a:headEnd type="none" w="med" len="med"/>
+                      <a:tailEnd type="none" w="med" len="med"/>
+                    </a:lnT>
+                    <a:lnB w="6350" cap="flat" cmpd="sng" algn="ctr">
+                      <a:solidFill>
+                        <a:srgbClr val="D5DBE3"/>
+                      </a:solidFill>
+                      <a:prstDash val="solid"/>
+                      <a:round/>
+                      <a:headEnd type="none" w="med" len="med"/>
+                      <a:tailEnd type="none" w="med" len="med"/>
+                    </a:lnB>
+                  </a:tcPr>
+                </a:tc>
+                <a:tc>
+                  <a:txBody>
+                    <a:bodyPr/>
+                    <a:lstStyle/>
+                    <a:p>
+                      <a:pPr algn="r" indent="0" marL="0">
+                        <a:buNone/>
+                      </a:pPr>
+                      <a:endParaRPr lang="en-US" sz="900" dirty="0">
+                        <a:latin typeface="Calibri" charset="0"/>
+                        <a:ea typeface="Calibri" charset="0"/>
+                        <a:cs typeface="Calibri" charset="0"/>
+                      </a:endParaRPr>
+                    </a:p>
+                  </a:txBody>
+                  <a:tcPr marL="64008" marR="64008" marT="0" marB="0" anchor="ctr">
+                    <a:lnL w="6350" cap="flat" cmpd="sng" algn="ctr">
+                      <a:solidFill>
+                        <a:srgbClr val="D5DBE3"/>
+                      </a:solidFill>
+                      <a:prstDash val="solid"/>
+                      <a:round/>
+                      <a:headEnd type="none" w="med" len="med"/>
+                      <a:tailEnd type="none" w="med" len="med"/>
+                    </a:lnL>
+                    <a:lnR w="6350" cap="flat" cmpd="sng" algn="ctr">
+                      <a:solidFill>
+                        <a:srgbClr val="D5DBE3"/>
+                      </a:solidFill>
+                      <a:prstDash val="solid"/>
+                      <a:round/>
+                      <a:headEnd type="none" w="med" len="med"/>
+                      <a:tailEnd type="none" w="med" len="med"/>
+                    </a:lnR>
+                    <a:lnT w="6350" cap="flat" cmpd="sng" algn="ctr">
+                      <a:solidFill>
+                        <a:srgbClr val="D5DBE3"/>
+                      </a:solidFill>
+                      <a:prstDash val="solid"/>
+                      <a:round/>
+                      <a:headEnd type="none" w="med" len="med"/>
+                      <a:tailEnd type="none" w="med" len="med"/>
+                    </a:lnT>
+                    <a:lnB w="6350" cap="flat" cmpd="sng" algn="ctr">
+                      <a:solidFill>
+                        <a:srgbClr val="D5DBE3"/>
+                      </a:solidFill>
+                      <a:prstDash val="solid"/>
+                      <a:round/>
+                      <a:headEnd type="none" w="med" len="med"/>
+                      <a:tailEnd type="none" w="med" len="med"/>
+                    </a:lnB>
+                  </a:tcPr>
+                </a:tc>
+                <a:tc>
+                  <a:txBody>
+                    <a:bodyPr/>
+                    <a:lstStyle/>
+                    <a:p>
+                      <a:pPr algn="r" indent="0" marL="0">
+                        <a:buNone/>
+                      </a:pPr>
+                      <a:endParaRPr lang="en-US" sz="900" dirty="0">
+                        <a:latin typeface="Calibri" charset="0"/>
+                        <a:ea typeface="Calibri" charset="0"/>
+                        <a:cs typeface="Calibri" charset="0"/>
+                      </a:endParaRPr>
+                    </a:p>
+                  </a:txBody>
+                  <a:tcPr marL="64008" marR="64008" marT="0" marB="0" anchor="ctr">
+                    <a:lnL w="6350" cap="flat" cmpd="sng" algn="ctr">
+                      <a:solidFill>
+                        <a:srgbClr val="D5DBE3"/>
+                      </a:solidFill>
+                      <a:prstDash val="solid"/>
+                      <a:round/>
+                      <a:headEnd type="none" w="med" len="med"/>
+                      <a:tailEnd type="none" w="med" len="med"/>
+                    </a:lnL>
+                    <a:lnR w="6350" cap="flat" cmpd="sng" algn="ctr">
+                      <a:solidFill>
+                        <a:srgbClr val="D5DBE3"/>
+                      </a:solidFill>
+                      <a:prstDash val="solid"/>
+                      <a:round/>
+                      <a:headEnd type="none" w="med" len="med"/>
+                      <a:tailEnd type="none" w="med" len="med"/>
+                    </a:lnR>
+                    <a:lnT w="6350" cap="flat" cmpd="sng" algn="ctr">
+                      <a:solidFill>
+                        <a:srgbClr val="D5DBE3"/>
+                      </a:solidFill>
+                      <a:prstDash val="solid"/>
+                      <a:round/>
+                      <a:headEnd type="none" w="med" len="med"/>
+                      <a:tailEnd type="none" w="med" len="med"/>
+                    </a:lnT>
+                    <a:lnB w="6350" cap="flat" cmpd="sng" algn="ctr">
+                      <a:solidFill>
+                        <a:srgbClr val="D5DBE3"/>
+                      </a:solidFill>
+                      <a:prstDash val="solid"/>
+                      <a:round/>
+                      <a:headEnd type="none" w="med" len="med"/>
+                      <a:tailEnd type="none" w="med" len="med"/>
+                    </a:lnB>
+                  </a:tcPr>
+                </a:tc>
+                <a:tc>
+                  <a:txBody>
+                    <a:bodyPr/>
+                    <a:lstStyle/>
+                    <a:p>
+                      <a:pPr algn="r" indent="0" marL="0">
+                        <a:buNone/>
+                      </a:pPr>
+                      <a:endParaRPr lang="en-US" sz="900" dirty="0">
+                        <a:latin typeface="Calibri" charset="0"/>
+                        <a:ea typeface="Calibri" charset="0"/>
+                        <a:cs typeface="Calibri" charset="0"/>
+                      </a:endParaRPr>
+                    </a:p>
+                  </a:txBody>
+                  <a:tcPr marL="64008" marR="64008" marT="0" marB="0" anchor="ctr">
+                    <a:lnL w="6350" cap="flat" cmpd="sng" algn="ctr">
+                      <a:solidFill>
+                        <a:srgbClr val="D5DBE3"/>
+                      </a:solidFill>
+                      <a:prstDash val="solid"/>
+                      <a:round/>
+                      <a:headEnd type="none" w="med" len="med"/>
+                      <a:tailEnd type="none" w="med" len="med"/>
+                    </a:lnL>
+                    <a:lnR w="6350" cap="flat" cmpd="sng" algn="ctr">
+                      <a:solidFill>
+                        <a:srgbClr val="D5DBE3"/>
+                      </a:solidFill>
+                      <a:prstDash val="solid"/>
+                      <a:round/>
+                      <a:headEnd type="none" w="med" len="med"/>
+                      <a:tailEnd type="none" w="med" len="med"/>
+                    </a:lnR>
+                    <a:lnT w="6350" cap="flat" cmpd="sng" algn="ctr">
+                      <a:solidFill>
+                        <a:srgbClr val="D5DBE3"/>
+                      </a:solidFill>
+                      <a:prstDash val="solid"/>
+                      <a:round/>
+                      <a:headEnd type="none" w="med" len="med"/>
+                      <a:tailEnd type="none" w="med" len="med"/>
+                    </a:lnT>
+                    <a:lnB w="6350" cap="flat" cmpd="sng" algn="ctr">
+                      <a:solidFill>
+                        <a:srgbClr val="D5DBE3"/>
+                      </a:solidFill>
+                      <a:prstDash val="solid"/>
+                      <a:round/>
+                      <a:headEnd type="none" w="med" len="med"/>
+                      <a:tailEnd type="none" w="med" len="med"/>
+                    </a:lnB>
+                  </a:tcPr>
+                </a:tc>
+              </a:tr>
+              <a:tr h="224028">
+                <a:tc>
+                  <a:txBody>
+                    <a:bodyPr/>
+                    <a:lstStyle/>
+                    <a:p>
+                      <a:pPr algn="l" indent="0" marL="0">
+                        <a:buNone/>
+                      </a:pPr>
+                      <a:r>
+                        <a:rPr lang="en-US" sz="900" i="1" dirty="0">
+                          <a:solidFill>
+                            <a:srgbClr val="1F2933"/>
+                          </a:solidFill>
+                          <a:latin typeface="Calibri" pitchFamily="34" charset="0"/>
+                          <a:ea typeface="Calibri" pitchFamily="34" charset="-122"/>
+                          <a:cs typeface="Calibri" pitchFamily="34" charset="-120"/>
+                        </a:rPr>
+                        <a:t>   dont TERASSON</a:t>
+                      </a:r>
+                      <a:endParaRPr lang="en-US" sz="900" dirty="0">
+                        <a:latin typeface="Calibri" charset="0"/>
+                        <a:ea typeface="Calibri" charset="0"/>
+                        <a:cs typeface="Calibri" charset="0"/>
+                      </a:endParaRPr>
+                    </a:p>
+                  </a:txBody>
+                  <a:tcPr marL="64008" marR="64008" marT="0" marB="0" anchor="ctr">
+                    <a:lnL w="6350" cap="flat" cmpd="sng" algn="ctr">
+                      <a:solidFill>
+                        <a:srgbClr val="D5DBE3"/>
+                      </a:solidFill>
+                      <a:prstDash val="solid"/>
+                      <a:round/>
+                      <a:headEnd type="none" w="med" len="med"/>
+                      <a:tailEnd type="none" w="med" len="med"/>
+                    </a:lnL>
+                    <a:lnR w="6350" cap="flat" cmpd="sng" algn="ctr">
+                      <a:solidFill>
+                        <a:srgbClr val="D5DBE3"/>
+                      </a:solidFill>
+                      <a:prstDash val="solid"/>
+                      <a:round/>
+                      <a:headEnd type="none" w="med" len="med"/>
+                      <a:tailEnd type="none" w="med" len="med"/>
+                    </a:lnR>
+                    <a:lnT w="6350" cap="flat" cmpd="sng" algn="ctr">
+                      <a:solidFill>
+                        <a:srgbClr val="D5DBE3"/>
+                      </a:solidFill>
+                      <a:prstDash val="solid"/>
+                      <a:round/>
+                      <a:headEnd type="none" w="med" len="med"/>
+                      <a:tailEnd type="none" w="med" len="med"/>
+                    </a:lnT>
+                    <a:lnB w="6350" cap="flat" cmpd="sng" algn="ctr">
+                      <a:solidFill>
+                        <a:srgbClr val="D5DBE3"/>
+                      </a:solidFill>
+                      <a:prstDash val="solid"/>
+                      <a:round/>
+                      <a:headEnd type="none" w="med" len="med"/>
+                      <a:tailEnd type="none" w="med" len="med"/>
+                    </a:lnB>
+                  </a:tcPr>
+                </a:tc>
+                <a:tc>
+                  <a:txBody>
+                    <a:bodyPr/>
+                    <a:lstStyle/>
+                    <a:p>
+                      <a:pPr algn="r" indent="0" marL="0">
+                        <a:buNone/>
+                      </a:pPr>
+                      <a:r>
+                        <a:rPr lang="en-US" sz="900" dirty="0">
+                          <a:solidFill>
+                            <a:srgbClr val="B3261E"/>
+                          </a:solidFill>
+                          <a:latin typeface="Calibri" pitchFamily="34" charset="0"/>
+                          <a:ea typeface="Calibri" pitchFamily="34" charset="-122"/>
+                          <a:cs typeface="Calibri" pitchFamily="34" charset="-120"/>
+                        </a:rPr>
+                        <a:t>-720,2</a:t>
+                      </a:r>
+                      <a:endParaRPr lang="en-US" sz="900" dirty="0">
+                        <a:latin typeface="Calibri" charset="0"/>
+                        <a:ea typeface="Calibri" charset="0"/>
+                        <a:cs typeface="Calibri" charset="0"/>
+                      </a:endParaRPr>
+                    </a:p>
+                  </a:txBody>
+                  <a:tcPr marL="64008" marR="64008" marT="0" marB="0" anchor="ctr">
+                    <a:lnL w="6350" cap="flat" cmpd="sng" algn="ctr">
+                      <a:solidFill>
+                        <a:srgbClr val="D5DBE3"/>
+                      </a:solidFill>
+                      <a:prstDash val="solid"/>
+                      <a:round/>
+                      <a:headEnd type="none" w="med" len="med"/>
+                      <a:tailEnd type="none" w="med" len="med"/>
+                    </a:lnL>
+                    <a:lnR w="6350" cap="flat" cmpd="sng" algn="ctr">
+                      <a:solidFill>
+                        <a:srgbClr val="D5DBE3"/>
+                      </a:solidFill>
+                      <a:prstDash val="solid"/>
+                      <a:round/>
+                      <a:headEnd type="none" w="med" len="med"/>
+                      <a:tailEnd type="none" w="med" len="med"/>
+                    </a:lnR>
+                    <a:lnT w="6350" cap="flat" cmpd="sng" algn="ctr">
+                      <a:solidFill>
+                        <a:srgbClr val="D5DBE3"/>
+                      </a:solidFill>
+                      <a:prstDash val="solid"/>
+                      <a:round/>
+                      <a:headEnd type="none" w="med" len="med"/>
+                      <a:tailEnd type="none" w="med" len="med"/>
+                    </a:lnT>
+                    <a:lnB w="6350" cap="flat" cmpd="sng" algn="ctr">
+                      <a:solidFill>
+                        <a:srgbClr val="D5DBE3"/>
+                      </a:solidFill>
+                      <a:prstDash val="solid"/>
+                      <a:round/>
+                      <a:headEnd type="none" w="med" len="med"/>
+                      <a:tailEnd type="none" w="med" len="med"/>
+                    </a:lnB>
+                  </a:tcPr>
+                </a:tc>
+                <a:tc>
+                  <a:txBody>
+                    <a:bodyPr/>
+                    <a:lstStyle/>
+                    <a:p>
+                      <a:pPr algn="r" indent="0" marL="0">
+                        <a:buNone/>
+                      </a:pPr>
+                      <a:r>
+                        <a:rPr lang="en-US" sz="900" dirty="0">
+                          <a:solidFill>
+                            <a:srgbClr val="B3261E"/>
+                          </a:solidFill>
+                          <a:latin typeface="Calibri" pitchFamily="34" charset="0"/>
+                          <a:ea typeface="Calibri" pitchFamily="34" charset="-122"/>
+                          <a:cs typeface="Calibri" pitchFamily="34" charset="-120"/>
+                        </a:rPr>
+                        <a:t>-1 192,4</a:t>
+                      </a:r>
+                      <a:endParaRPr lang="en-US" sz="900" dirty="0">
+                        <a:latin typeface="Calibri" charset="0"/>
+                        <a:ea typeface="Calibri" charset="0"/>
+                        <a:cs typeface="Calibri" charset="0"/>
+                      </a:endParaRPr>
+                    </a:p>
+                  </a:txBody>
+                  <a:tcPr marL="64008" marR="64008" marT="0" marB="0" anchor="ctr">
+                    <a:lnL w="6350" cap="flat" cmpd="sng" algn="ctr">
+                      <a:solidFill>
+                        <a:srgbClr val="D5DBE3"/>
+                      </a:solidFill>
+                      <a:prstDash val="solid"/>
+                      <a:round/>
+                      <a:headEnd type="none" w="med" len="med"/>
+                      <a:tailEnd type="none" w="med" len="med"/>
+                    </a:lnL>
+                    <a:lnR w="6350" cap="flat" cmpd="sng" algn="ctr">
+                      <a:solidFill>
+                        <a:srgbClr val="D5DBE3"/>
+                      </a:solidFill>
+                      <a:prstDash val="solid"/>
+                      <a:round/>
+                      <a:headEnd type="none" w="med" len="med"/>
+                      <a:tailEnd type="none" w="med" len="med"/>
+                    </a:lnR>
+                    <a:lnT w="6350" cap="flat" cmpd="sng" algn="ctr">
+                      <a:solidFill>
+                        <a:srgbClr val="D5DBE3"/>
+                      </a:solidFill>
+                      <a:prstDash val="solid"/>
+                      <a:round/>
+                      <a:headEnd type="none" w="med" len="med"/>
+                      <a:tailEnd type="none" w="med" len="med"/>
+                    </a:lnT>
+                    <a:lnB w="6350" cap="flat" cmpd="sng" algn="ctr">
+                      <a:solidFill>
+                        <a:srgbClr val="D5DBE3"/>
+                      </a:solidFill>
+                      <a:prstDash val="solid"/>
+                      <a:round/>
+                      <a:headEnd type="none" w="med" len="med"/>
+                      <a:tailEnd type="none" w="med" len="med"/>
+                    </a:lnB>
+                  </a:tcPr>
+                </a:tc>
+                <a:tc>
+                  <a:txBody>
+                    <a:bodyPr/>
+                    <a:lstStyle/>
+                    <a:p>
+                      <a:pPr algn="r" indent="0" marL="0">
+                        <a:buNone/>
+                      </a:pPr>
+                      <a:r>
+                        <a:rPr lang="en-US" sz="900" dirty="0">
+                          <a:solidFill>
+                            <a:srgbClr val="B3261E"/>
+                          </a:solidFill>
+                          <a:latin typeface="Calibri" pitchFamily="34" charset="0"/>
+                          <a:ea typeface="Calibri" pitchFamily="34" charset="-122"/>
+                          <a:cs typeface="Calibri" pitchFamily="34" charset="-120"/>
+                        </a:rPr>
+                        <a:t>-1 192,4</a:t>
+                      </a:r>
+                      <a:endParaRPr lang="en-US" sz="900" dirty="0">
+                        <a:latin typeface="Calibri" charset="0"/>
+                        <a:ea typeface="Calibri" charset="0"/>
+                        <a:cs typeface="Calibri" charset="0"/>
+                      </a:endParaRPr>
+                    </a:p>
+                  </a:txBody>
+                  <a:tcPr marL="64008" marR="64008" marT="0" marB="0" anchor="ctr">
+                    <a:lnL w="6350" cap="flat" cmpd="sng" algn="ctr">
+                      <a:solidFill>
+                        <a:srgbClr val="D5DBE3"/>
+                      </a:solidFill>
+                      <a:prstDash val="solid"/>
+                      <a:round/>
+                      <a:headEnd type="none" w="med" len="med"/>
+                      <a:tailEnd type="none" w="med" len="med"/>
+                    </a:lnL>
+                    <a:lnR w="6350" cap="flat" cmpd="sng" algn="ctr">
+                      <a:solidFill>
+                        <a:srgbClr val="D5DBE3"/>
+                      </a:solidFill>
+                      <a:prstDash val="solid"/>
+                      <a:round/>
+                      <a:headEnd type="none" w="med" len="med"/>
+                      <a:tailEnd type="none" w="med" len="med"/>
+                    </a:lnR>
+                    <a:lnT w="6350" cap="flat" cmpd="sng" algn="ctr">
+                      <a:solidFill>
+                        <a:srgbClr val="D5DBE3"/>
+                      </a:solidFill>
+                      <a:prstDash val="solid"/>
+                      <a:round/>
+                      <a:headEnd type="none" w="med" len="med"/>
+                      <a:tailEnd type="none" w="med" len="med"/>
+                    </a:lnT>
+                    <a:lnB w="6350" cap="flat" cmpd="sng" algn="ctr">
+                      <a:solidFill>
+                        <a:srgbClr val="D5DBE3"/>
+                      </a:solidFill>
+                      <a:prstDash val="solid"/>
+                      <a:round/>
+                      <a:headEnd type="none" w="med" len="med"/>
+                      <a:tailEnd type="none" w="med" len="med"/>
+                    </a:lnB>
+                  </a:tcPr>
+                </a:tc>
+                <a:tc>
+                  <a:txBody>
+                    <a:bodyPr/>
+                    <a:lstStyle/>
+                    <a:p>
+                      <a:pPr algn="r" indent="0" marL="0">
+                        <a:buNone/>
+                      </a:pPr>
+                      <a:r>
+                        <a:rPr lang="en-US" sz="900" dirty="0">
+                          <a:solidFill>
+                            <a:srgbClr val="B3261E"/>
+                          </a:solidFill>
+                          <a:latin typeface="Calibri" pitchFamily="34" charset="0"/>
+                          <a:ea typeface="Calibri" pitchFamily="34" charset="-122"/>
+                          <a:cs typeface="Calibri" pitchFamily="34" charset="-120"/>
+                        </a:rPr>
+                        <a:t>-1 205,9</a:t>
+                      </a:r>
+                      <a:endParaRPr lang="en-US" sz="900" dirty="0">
+                        <a:latin typeface="Calibri" charset="0"/>
+                        <a:ea typeface="Calibri" charset="0"/>
+                        <a:cs typeface="Calibri" charset="0"/>
+                      </a:endParaRPr>
+                    </a:p>
+                  </a:txBody>
+                  <a:tcPr marL="64008" marR="64008" marT="0" marB="0" anchor="ctr">
+                    <a:lnL w="6350" cap="flat" cmpd="sng" algn="ctr">
+                      <a:solidFill>
+                        <a:srgbClr val="D5DBE3"/>
+                      </a:solidFill>
+                      <a:prstDash val="solid"/>
+                      <a:round/>
+                      <a:headEnd type="none" w="med" len="med"/>
+                      <a:tailEnd type="none" w="med" len="med"/>
+                    </a:lnL>
+                    <a:lnR w="6350" cap="flat" cmpd="sng" algn="ctr">
+                      <a:solidFill>
+                        <a:srgbClr val="D5DBE3"/>
+                      </a:solidFill>
+                      <a:prstDash val="solid"/>
+                      <a:round/>
+                      <a:headEnd type="none" w="med" len="med"/>
+                      <a:tailEnd type="none" w="med" len="med"/>
+                    </a:lnR>
+                    <a:lnT w="6350" cap="flat" cmpd="sng" algn="ctr">
+                      <a:solidFill>
+                        <a:srgbClr val="D5DBE3"/>
+                      </a:solidFill>
+                      <a:prstDash val="solid"/>
+                      <a:round/>
+                      <a:headEnd type="none" w="med" len="med"/>
+                      <a:tailEnd type="none" w="med" len="med"/>
+                    </a:lnT>
+                    <a:lnB w="6350" cap="flat" cmpd="sng" algn="ctr">
+                      <a:solidFill>
+                        <a:srgbClr val="D5DBE3"/>
+                      </a:solidFill>
+                      <a:prstDash val="solid"/>
+                      <a:round/>
+                      <a:headEnd type="none" w="med" len="med"/>
+                      <a:tailEnd type="none" w="med" len="med"/>
+                    </a:lnB>
+                  </a:tcPr>
+                </a:tc>
+                <a:tc>
+                  <a:txBody>
+                    <a:bodyPr/>
+                    <a:lstStyle/>
+                    <a:p>
+                      <a:pPr algn="r" indent="0" marL="0">
+                        <a:buNone/>
+                      </a:pPr>
+                      <a:r>
+                        <a:rPr lang="en-US" sz="900" dirty="0">
+                          <a:solidFill>
+                            <a:srgbClr val="B3261E"/>
+                          </a:solidFill>
+                          <a:latin typeface="Calibri" pitchFamily="34" charset="0"/>
+                          <a:ea typeface="Calibri" pitchFamily="34" charset="-122"/>
+                          <a:cs typeface="Calibri" pitchFamily="34" charset="-120"/>
+                        </a:rPr>
+                        <a:t>-1 205,9</a:t>
+                      </a:r>
+                      <a:endParaRPr lang="en-US" sz="900" dirty="0">
+                        <a:latin typeface="Calibri" charset="0"/>
+                        <a:ea typeface="Calibri" charset="0"/>
+                        <a:cs typeface="Calibri" charset="0"/>
+                      </a:endParaRPr>
+                    </a:p>
+                  </a:txBody>
+                  <a:tcPr marL="64008" marR="64008" marT="0" marB="0" anchor="ctr">
+                    <a:lnL w="6350" cap="flat" cmpd="sng" algn="ctr">
+                      <a:solidFill>
+                        <a:srgbClr val="D5DBE3"/>
+                      </a:solidFill>
+                      <a:prstDash val="solid"/>
+                      <a:round/>
+                      <a:headEnd type="none" w="med" len="med"/>
+                      <a:tailEnd type="none" w="med" len="med"/>
+                    </a:lnL>
+                    <a:lnR w="6350" cap="flat" cmpd="sng" algn="ctr">
+                      <a:solidFill>
+                        <a:srgbClr val="D5DBE3"/>
+                      </a:solidFill>
+                      <a:prstDash val="solid"/>
+                      <a:round/>
+                      <a:headEnd type="none" w="med" len="med"/>
+                      <a:tailEnd type="none" w="med" len="med"/>
+                    </a:lnR>
+                    <a:lnT w="6350" cap="flat" cmpd="sng" algn="ctr">
+                      <a:solidFill>
+                        <a:srgbClr val="D5DBE3"/>
+                      </a:solidFill>
+                      <a:prstDash val="solid"/>
+                      <a:round/>
+                      <a:headEnd type="none" w="med" len="med"/>
+                      <a:tailEnd type="none" w="med" len="med"/>
+                    </a:lnT>
+                    <a:lnB w="6350" cap="flat" cmpd="sng" algn="ctr">
+                      <a:solidFill>
+                        <a:srgbClr val="D5DBE3"/>
+                      </a:solidFill>
+                      <a:prstDash val="solid"/>
+                      <a:round/>
+                      <a:headEnd type="none" w="med" len="med"/>
+                      <a:tailEnd type="none" w="med" len="med"/>
+                    </a:lnB>
+                  </a:tcPr>
+                </a:tc>
+                <a:tc>
+                  <a:txBody>
+                    <a:bodyPr/>
+                    <a:lstStyle/>
+                    <a:p>
+                      <a:pPr algn="r" indent="0" marL="0">
+                        <a:buNone/>
+                      </a:pPr>
+                      <a:endParaRPr lang="en-US" sz="900" dirty="0">
+                        <a:latin typeface="Calibri" charset="0"/>
+                        <a:ea typeface="Calibri" charset="0"/>
+                        <a:cs typeface="Calibri" charset="0"/>
+                      </a:endParaRPr>
+                    </a:p>
+                  </a:txBody>
+                  <a:tcPr marL="64008" marR="64008" marT="0" marB="0" anchor="ctr">
+                    <a:lnL w="6350" cap="flat" cmpd="sng" algn="ctr">
+                      <a:solidFill>
+                        <a:srgbClr val="D5DBE3"/>
+                      </a:solidFill>
+                      <a:prstDash val="solid"/>
+                      <a:round/>
+                      <a:headEnd type="none" w="med" len="med"/>
+                      <a:tailEnd type="none" w="med" len="med"/>
+                    </a:lnL>
+                    <a:lnR w="6350" cap="flat" cmpd="sng" algn="ctr">
+                      <a:solidFill>
+                        <a:srgbClr val="D5DBE3"/>
+                      </a:solidFill>
+                      <a:prstDash val="solid"/>
+                      <a:round/>
+                      <a:headEnd type="none" w="med" len="med"/>
+                      <a:tailEnd type="none" w="med" len="med"/>
+                    </a:lnR>
+                    <a:lnT w="6350" cap="flat" cmpd="sng" algn="ctr">
+                      <a:solidFill>
+                        <a:srgbClr val="D5DBE3"/>
+                      </a:solidFill>
+                      <a:prstDash val="solid"/>
+                      <a:round/>
+                      <a:headEnd type="none" w="med" len="med"/>
+                      <a:tailEnd type="none" w="med" len="med"/>
+                    </a:lnT>
+                    <a:lnB w="6350" cap="flat" cmpd="sng" algn="ctr">
+                      <a:solidFill>
+                        <a:srgbClr val="D5DBE3"/>
+                      </a:solidFill>
+                      <a:prstDash val="solid"/>
+                      <a:round/>
+                      <a:headEnd type="none" w="med" len="med"/>
+                      <a:tailEnd type="none" w="med" len="med"/>
+                    </a:lnB>
+                  </a:tcPr>
+                </a:tc>
+                <a:tc>
+                  <a:txBody>
+                    <a:bodyPr/>
+                    <a:lstStyle/>
+                    <a:p>
+                      <a:pPr algn="r" indent="0" marL="0">
+                        <a:buNone/>
+                      </a:pPr>
+                      <a:endParaRPr lang="en-US" sz="900" dirty="0">
+                        <a:latin typeface="Calibri" charset="0"/>
+                        <a:ea typeface="Calibri" charset="0"/>
+                        <a:cs typeface="Calibri" charset="0"/>
+                      </a:endParaRPr>
+                    </a:p>
+                  </a:txBody>
+                  <a:tcPr marL="64008" marR="64008" marT="0" marB="0" anchor="ctr">
+                    <a:lnL w="6350" cap="flat" cmpd="sng" algn="ctr">
+                      <a:solidFill>
+                        <a:srgbClr val="D5DBE3"/>
+                      </a:solidFill>
+                      <a:prstDash val="solid"/>
+                      <a:round/>
+                      <a:headEnd type="none" w="med" len="med"/>
+                      <a:tailEnd type="none" w="med" len="med"/>
+                    </a:lnL>
+                    <a:lnR w="6350" cap="flat" cmpd="sng" algn="ctr">
+                      <a:solidFill>
+                        <a:srgbClr val="D5DBE3"/>
+                      </a:solidFill>
+                      <a:prstDash val="solid"/>
+                      <a:round/>
+                      <a:headEnd type="none" w="med" len="med"/>
+                      <a:tailEnd type="none" w="med" len="med"/>
+                    </a:lnR>
+                    <a:lnT w="6350" cap="flat" cmpd="sng" algn="ctr">
+                      <a:solidFill>
+                        <a:srgbClr val="D5DBE3"/>
+                      </a:solidFill>
+                      <a:prstDash val="solid"/>
+                      <a:round/>
+                      <a:headEnd type="none" w="med" len="med"/>
+                      <a:tailEnd type="none" w="med" len="med"/>
+                    </a:lnT>
+                    <a:lnB w="6350" cap="flat" cmpd="sng" algn="ctr">
+                      <a:solidFill>
+                        <a:srgbClr val="D5DBE3"/>
+                      </a:solidFill>
+                      <a:prstDash val="solid"/>
+                      <a:round/>
+                      <a:headEnd type="none" w="med" len="med"/>
+                      <a:tailEnd type="none" w="med" len="med"/>
+                    </a:lnB>
+                  </a:tcPr>
+                </a:tc>
+                <a:tc>
+                  <a:txBody>
+                    <a:bodyPr/>
+                    <a:lstStyle/>
+                    <a:p>
+                      <a:pPr algn="r" indent="0" marL="0">
+                        <a:buNone/>
+                      </a:pPr>
+                      <a:endParaRPr lang="en-US" sz="900" dirty="0">
                         <a:latin typeface="Calibri" charset="0"/>
                         <a:ea typeface="Calibri" charset="0"/>
                         <a:cs typeface="Calibri" charset="0"/>
@@ -6598,8 +10070,8 @@
         </p:nvSpPr>
         <p:spPr>
           <a:xfrm>
-            <a:off x="457200" y="4434840"/>
-            <a:ext cx="11247120" cy="1554480"/>
+            <a:off x="457200" y="5262372"/>
+            <a:ext cx="11247120" cy="845820"/>
           </a:xfrm>
           <a:prstGeom prst="rect">
             <a:avLst/>
@@ -6619,42 +10091,7 @@
               <a:buChar char="•"/>
             </a:pPr>
             <a:r>
-              <a:rPr lang="en-US" sz="1150" b="1" dirty="0">
-                <a:solidFill>
-                  <a:srgbClr val="002C50"/>
-                </a:solidFill>
-                <a:latin typeface="Calibri" pitchFamily="34" charset="0"/>
-                <a:ea typeface="Calibri" pitchFamily="34" charset="-122"/>
-                <a:cs typeface="Calibri" pitchFamily="34" charset="-120"/>
-              </a:rPr>
-              <a:t>S1 concentre 74 % du besoin : </a:t>
-            </a:r>
-            <a:pPr indent="0" marL="0">
-              <a:buNone/>
-            </a:pPr>
-            <a:r>
-              <a:rPr lang="en-US" sz="1150" dirty="0">
-                <a:solidFill>
-                  <a:srgbClr val="1F2933"/>
-                </a:solidFill>
-                <a:latin typeface="Calibri" pitchFamily="34" charset="0"/>
-                <a:ea typeface="Calibri" pitchFamily="34" charset="-122"/>
-                <a:cs typeface="Calibri" pitchFamily="34" charset="-120"/>
-              </a:rPr>
-              <a:t>factures échues et arriérés d'impôts et de cotisations de l'audit, semaine en cours, cash plans non réglés jusqu'au mois de la situation, échéance de la dette.</a:t>
-            </a:r>
-            <a:endParaRPr lang="en-US" sz="1150" dirty="0"/>
-          </a:p>
-          <a:p>
-            <a:pPr marL="177800" indent="-177800">
-              <a:spcAft>
-                <a:spcPts val="400"/>
-              </a:spcAft>
-              <a:buSzPct val="100000"/>
-              <a:buChar char="•"/>
-            </a:pPr>
-            <a:r>
-              <a:rPr lang="en-US" sz="1150" b="1" dirty="0">
+              <a:rPr lang="en-US" sz="1000" b="1" dirty="0">
                 <a:solidFill>
                   <a:srgbClr val="002C50"/>
                 </a:solidFill>
@@ -6668,7 +10105,7 @@
               <a:buNone/>
             </a:pPr>
             <a:r>
-              <a:rPr lang="en-US" sz="1150" dirty="0">
+              <a:rPr lang="en-US" sz="1000" dirty="0">
                 <a:solidFill>
                   <a:srgbClr val="1F2933"/>
                 </a:solidFill>
@@ -6678,7 +10115,7 @@
               </a:rPr>
               <a:t>5 932,3 M. RIVIERA en déficit de 601,4 M dès S2 ; TERASSON en déficit de 1 205,9 M dès S1.</a:t>
             </a:r>
-            <a:endParaRPr lang="en-US" sz="1150" dirty="0"/>
+            <a:endParaRPr lang="en-US" sz="1000" dirty="0"/>
           </a:p>
           <a:p>
             <a:pPr marL="177800" indent="-177800">
@@ -6689,7 +10126,7 @@
               <a:buChar char="•"/>
             </a:pPr>
             <a:r>
-              <a:rPr lang="en-US" sz="1150" b="1" dirty="0">
+              <a:rPr lang="en-US" sz="1000" b="1" dirty="0">
                 <a:solidFill>
                   <a:srgbClr val="002C50"/>
                 </a:solidFill>
@@ -6703,7 +10140,7 @@
               <a:buNone/>
             </a:pPr>
             <a:r>
-              <a:rPr lang="en-US" sz="1150" dirty="0">
+              <a:rPr lang="en-US" sz="1000" dirty="0">
                 <a:solidFill>
                   <a:srgbClr val="1F2933"/>
                 </a:solidFill>
@@ -6713,7 +10150,7 @@
               </a:rPr>
               <a:t>déficits TERASSON 206,4 M, FINAFRICA 198,7 M, SCO AO 176,0 M, FIRST 175,3 M, RIVIERA 87,3 M, IMMONEUF 66,0 M ; excédents PICI 100,0 M, INFI SOFT 2,8 M.</a:t>
             </a:r>
-            <a:endParaRPr lang="en-US" sz="1150" dirty="0"/>
+            <a:endParaRPr lang="en-US" sz="1000" dirty="0"/>
           </a:p>
         </p:txBody>
       </p:sp>

</xml_diff>

<commit_message>
SCO AO : prévision de trésorerie SCO prioritaire
Lecture du fichier « Mouvement TRESO PREVISION » (colonnes du jj/mm au jj/mm :
encaissements clients, frais généraux, projets) ; remplace les flux SCO du
reporting de Christophe et d'un reporting modifié réimporté.

Co-Authored-By: Claude Opus 5.5 <noreply@anthropic.com>
Claude-Session: https://claude.ai/code/session_01NEhkcxCB327Mdpf33KqYQU
</commit_message>
<xml_diff>
--- a/RCI_Besoins_Tresorerie_Comptes_Paiement_30-09-2026.pptx
+++ b/RCI_Besoins_Tresorerie_Comptes_Paiement_30-09-2026.pptx
@@ -1851,7 +1851,7 @@
                 <a:ea typeface="Calibri" pitchFamily="34" charset="-122"/>
                 <a:cs typeface="Calibri" pitchFamily="34" charset="-120"/>
               </a:rPr>
-              <a:t>7 004,8 M à payer de S1 à S5, dont 5 277,0 M dès S1 ; 2 676,8 M de déficits</a:t>
+              <a:t>6 974,1 M à payer de S1 à S5, dont 5 115,2 M dès S1 ; 2 530,3 M de déficits</a:t>
             </a:r>
             <a:endParaRPr lang="en-US" sz="1400" dirty="0"/>
           </a:p>
@@ -2621,7 +2621,7 @@
                 <a:ea typeface="Calibri" pitchFamily="34" charset="-122"/>
                 <a:cs typeface="Calibri" pitchFamily="34" charset="-120"/>
               </a:rPr>
-              <a:t>7 004,8 M</a:t>
+              <a:t>6 974,1 M</a:t>
             </a:r>
             <a:endParaRPr lang="en-US" sz="2200" dirty="0"/>
           </a:p>
@@ -2660,7 +2660,7 @@
                 <a:ea typeface="Calibri" pitchFamily="34" charset="-122"/>
                 <a:cs typeface="Calibri" pitchFamily="34" charset="-120"/>
               </a:rPr>
-              <a:t>Besoin S1 à S5 (10,7 M€) : fonctionnement, projets et dette</a:t>
+              <a:t>Besoin S1 à S5 (10,6 M€) : fonctionnement, projets et dette</a:t>
             </a:r>
             <a:endParaRPr lang="en-US" sz="1050" dirty="0"/>
           </a:p>
@@ -2726,7 +2726,7 @@
                 <a:ea typeface="Calibri" pitchFamily="34" charset="-122"/>
                 <a:cs typeface="Calibri" pitchFamily="34" charset="-120"/>
               </a:rPr>
-              <a:t>5 277,0 M</a:t>
+              <a:t>5 115,2 M</a:t>
             </a:r>
             <a:endParaRPr lang="en-US" sz="2200" dirty="0"/>
           </a:p>
@@ -2765,7 +2765,7 @@
                 <a:ea typeface="Calibri" pitchFamily="34" charset="-122"/>
                 <a:cs typeface="Calibri" pitchFamily="34" charset="-120"/>
               </a:rPr>
-              <a:t>À régler dès S1 (antériorités incluses), 75 % du besoin</a:t>
+              <a:t>À régler dès S1 (antériorités incluses), 73 % du besoin</a:t>
             </a:r>
             <a:endParaRPr lang="en-US" sz="1050" dirty="0"/>
           </a:p>
@@ -2936,7 +2936,7 @@
                 <a:ea typeface="Calibri" pitchFamily="34" charset="-122"/>
                 <a:cs typeface="Calibri" pitchFamily="34" charset="-120"/>
               </a:rPr>
-              <a:t>-1 571,4 M</a:t>
+              <a:t>-1 425,0 M</a:t>
             </a:r>
             <a:endParaRPr lang="en-US" sz="2200" dirty="0"/>
           </a:p>
@@ -3711,7 +3711,7 @@
                           <a:ea typeface="Calibri" pitchFamily="34" charset="-122"/>
                           <a:cs typeface="Calibri" pitchFamily="34" charset="-120"/>
                         </a:rPr>
-                        <a:t>1 481,9</a:t>
+                        <a:t>1 320,1</a:t>
                       </a:r>
                       <a:endParaRPr lang="en-US" sz="900" dirty="0">
                         <a:latin typeface="Calibri" charset="0"/>
@@ -3776,7 +3776,7 @@
                           <a:ea typeface="Calibri" pitchFamily="34" charset="-122"/>
                           <a:cs typeface="Calibri" pitchFamily="34" charset="-120"/>
                         </a:rPr>
-                        <a:t>69,6</a:t>
+                        <a:t>87,0</a:t>
                       </a:r>
                       <a:endParaRPr lang="en-US" sz="900" dirty="0">
                         <a:latin typeface="Calibri" charset="0"/>
@@ -3841,7 +3841,7 @@
                           <a:ea typeface="Calibri" pitchFamily="34" charset="-122"/>
                           <a:cs typeface="Calibri" pitchFamily="34" charset="-120"/>
                         </a:rPr>
-                        <a:t>225,7</a:t>
+                        <a:t>247,9</a:t>
                       </a:r>
                       <a:endParaRPr lang="en-US" sz="900" dirty="0">
                         <a:latin typeface="Calibri" charset="0"/>
@@ -3906,7 +3906,7 @@
                           <a:ea typeface="Calibri" pitchFamily="34" charset="-122"/>
                           <a:cs typeface="Calibri" pitchFamily="34" charset="-120"/>
                         </a:rPr>
-                        <a:t>–</a:t>
+                        <a:t>27,1</a:t>
                       </a:r>
                       <a:endParaRPr lang="en-US" sz="900" dirty="0">
                         <a:latin typeface="Calibri" charset="0"/>
@@ -3971,7 +3971,7 @@
                           <a:ea typeface="Calibri" pitchFamily="34" charset="-122"/>
                           <a:cs typeface="Calibri" pitchFamily="34" charset="-120"/>
                         </a:rPr>
-                        <a:t>–</a:t>
+                        <a:t>64,4</a:t>
                       </a:r>
                       <a:endParaRPr lang="en-US" sz="900" dirty="0">
                         <a:latin typeface="Calibri" charset="0"/>
@@ -4036,7 +4036,7 @@
                           <a:ea typeface="Calibri" pitchFamily="34" charset="-122"/>
                           <a:cs typeface="Calibri" pitchFamily="34" charset="-120"/>
                         </a:rPr>
-                        <a:t>1 777,1</a:t>
+                        <a:t>1 746,4</a:t>
                       </a:r>
                       <a:endParaRPr lang="en-US" sz="900" dirty="0">
                         <a:latin typeface="Calibri" charset="0"/>
@@ -4169,7 +4169,7 @@
                           <a:ea typeface="Calibri" pitchFamily="34" charset="-122"/>
                           <a:cs typeface="Calibri" pitchFamily="34" charset="-120"/>
                         </a:rPr>
-                        <a:t>1 574,2</a:t>
+                        <a:t>1 427,7</a:t>
                       </a:r>
                       <a:endParaRPr lang="en-US" sz="900" dirty="0">
                         <a:latin typeface="Calibri" charset="0"/>
@@ -5493,7 +5493,7 @@
                           <a:ea typeface="Calibri" pitchFamily="34" charset="-122"/>
                           <a:cs typeface="Calibri" pitchFamily="34" charset="-120"/>
                         </a:rPr>
-                        <a:t>5 277,0</a:t>
+                        <a:t>5 115,2</a:t>
                       </a:r>
                       <a:endParaRPr lang="en-US" sz="900" dirty="0">
                         <a:latin typeface="Calibri" charset="0"/>
@@ -5561,7 +5561,7 @@
                           <a:ea typeface="Calibri" pitchFamily="34" charset="-122"/>
                           <a:cs typeface="Calibri" pitchFamily="34" charset="-120"/>
                         </a:rPr>
-                        <a:t>1 475,0</a:t>
+                        <a:t>1 492,4</a:t>
                       </a:r>
                       <a:endParaRPr lang="en-US" sz="900" dirty="0">
                         <a:latin typeface="Calibri" charset="0"/>
@@ -5629,7 +5629,7 @@
                           <a:ea typeface="Calibri" pitchFamily="34" charset="-122"/>
                           <a:cs typeface="Calibri" pitchFamily="34" charset="-120"/>
                         </a:rPr>
-                        <a:t>225,7</a:t>
+                        <a:t>247,9</a:t>
                       </a:r>
                       <a:endParaRPr lang="en-US" sz="900" dirty="0">
                         <a:latin typeface="Calibri" charset="0"/>
@@ -5697,7 +5697,7 @@
                           <a:ea typeface="Calibri" pitchFamily="34" charset="-122"/>
                           <a:cs typeface="Calibri" pitchFamily="34" charset="-120"/>
                         </a:rPr>
-                        <a:t>27,1</a:t>
+                        <a:t>54,1</a:t>
                       </a:r>
                       <a:endParaRPr lang="en-US" sz="900" dirty="0">
                         <a:latin typeface="Calibri" charset="0"/>
@@ -5765,7 +5765,7 @@
                           <a:ea typeface="Calibri" pitchFamily="34" charset="-122"/>
                           <a:cs typeface="Calibri" pitchFamily="34" charset="-120"/>
                         </a:rPr>
-                        <a:t>–</a:t>
+                        <a:t>64,4</a:t>
                       </a:r>
                       <a:endParaRPr lang="en-US" sz="900" dirty="0">
                         <a:latin typeface="Calibri" charset="0"/>
@@ -5833,7 +5833,7 @@
                           <a:ea typeface="Calibri" pitchFamily="34" charset="-122"/>
                           <a:cs typeface="Calibri" pitchFamily="34" charset="-120"/>
                         </a:rPr>
-                        <a:t>7 004,8</a:t>
+                        <a:t>6 974,1</a:t>
                       </a:r>
                       <a:endParaRPr lang="en-US" sz="900" dirty="0">
                         <a:latin typeface="Calibri" charset="0"/>
@@ -5969,7 +5969,7 @@
                           <a:ea typeface="Calibri" pitchFamily="34" charset="-122"/>
                           <a:cs typeface="Calibri" pitchFamily="34" charset="-120"/>
                         </a:rPr>
-                        <a:t>2 676,8</a:t>
+                        <a:t>2 530,3</a:t>
                       </a:r>
                       <a:endParaRPr lang="en-US" sz="900" dirty="0">
                         <a:latin typeface="Calibri" charset="0"/>
@@ -6104,7 +6104,7 @@
                           <a:ea typeface="Calibri" pitchFamily="34" charset="-122"/>
                           <a:cs typeface="Calibri" pitchFamily="34" charset="-120"/>
                         </a:rPr>
-                        <a:t>3,6</a:t>
+                        <a:t>14,8</a:t>
                       </a:r>
                       <a:endParaRPr lang="en-US" sz="900" dirty="0">
                         <a:latin typeface="Calibri" charset="0"/>
@@ -6169,7 +6169,7 @@
                           <a:ea typeface="Calibri" pitchFamily="34" charset="-122"/>
                           <a:cs typeface="Calibri" pitchFamily="34" charset="-120"/>
                         </a:rPr>
-                        <a:t>129,6</a:t>
+                        <a:t>175,2</a:t>
                       </a:r>
                       <a:endParaRPr lang="en-US" sz="900" dirty="0">
                         <a:latin typeface="Calibri" charset="0"/>
@@ -6234,6 +6234,71 @@
                           <a:ea typeface="Calibri" pitchFamily="34" charset="-122"/>
                           <a:cs typeface="Calibri" pitchFamily="34" charset="-120"/>
                         </a:rPr>
+                        <a:t>59,0</a:t>
+                      </a:r>
+                      <a:endParaRPr lang="en-US" sz="900" dirty="0">
+                        <a:latin typeface="Calibri" charset="0"/>
+                        <a:ea typeface="Calibri" charset="0"/>
+                        <a:cs typeface="Calibri" charset="0"/>
+                      </a:endParaRPr>
+                    </a:p>
+                  </a:txBody>
+                  <a:tcPr marL="64008" marR="64008" marT="0" marB="0" anchor="ctr">
+                    <a:lnL w="6350" cap="flat" cmpd="sng" algn="ctr">
+                      <a:solidFill>
+                        <a:srgbClr val="D5DBE3"/>
+                      </a:solidFill>
+                      <a:prstDash val="solid"/>
+                      <a:round/>
+                      <a:headEnd type="none" w="med" len="med"/>
+                      <a:tailEnd type="none" w="med" len="med"/>
+                    </a:lnL>
+                    <a:lnR w="6350" cap="flat" cmpd="sng" algn="ctr">
+                      <a:solidFill>
+                        <a:srgbClr val="D5DBE3"/>
+                      </a:solidFill>
+                      <a:prstDash val="solid"/>
+                      <a:round/>
+                      <a:headEnd type="none" w="med" len="med"/>
+                      <a:tailEnd type="none" w="med" len="med"/>
+                    </a:lnR>
+                    <a:lnT w="6350" cap="flat" cmpd="sng" algn="ctr">
+                      <a:solidFill>
+                        <a:srgbClr val="D5DBE3"/>
+                      </a:solidFill>
+                      <a:prstDash val="solid"/>
+                      <a:round/>
+                      <a:headEnd type="none" w="med" len="med"/>
+                      <a:tailEnd type="none" w="med" len="med"/>
+                    </a:lnT>
+                    <a:lnB w="6350" cap="flat" cmpd="sng" algn="ctr">
+                      <a:solidFill>
+                        <a:srgbClr val="D5DBE3"/>
+                      </a:solidFill>
+                      <a:prstDash val="solid"/>
+                      <a:round/>
+                      <a:headEnd type="none" w="med" len="med"/>
+                      <a:tailEnd type="none" w="med" len="med"/>
+                    </a:lnB>
+                  </a:tcPr>
+                </a:tc>
+                <a:tc>
+                  <a:txBody>
+                    <a:bodyPr/>
+                    <a:lstStyle/>
+                    <a:p>
+                      <a:pPr algn="r" indent="0" marL="0">
+                        <a:buNone/>
+                      </a:pPr>
+                      <a:r>
+                        <a:rPr lang="en-US" sz="900" i="1" dirty="0">
+                          <a:solidFill>
+                            <a:srgbClr val="6B7280"/>
+                          </a:solidFill>
+                          <a:latin typeface="Calibri" pitchFamily="34" charset="0"/>
+                          <a:ea typeface="Calibri" pitchFamily="34" charset="-122"/>
+                          <a:cs typeface="Calibri" pitchFamily="34" charset="-120"/>
+                        </a:rPr>
                         <a:t>–</a:t>
                       </a:r>
                       <a:endParaRPr lang="en-US" sz="900" dirty="0">
@@ -6364,72 +6429,7 @@
                           <a:ea typeface="Calibri" pitchFamily="34" charset="-122"/>
                           <a:cs typeface="Calibri" pitchFamily="34" charset="-120"/>
                         </a:rPr>
-                        <a:t>–</a:t>
-                      </a:r>
-                      <a:endParaRPr lang="en-US" sz="900" dirty="0">
-                        <a:latin typeface="Calibri" charset="0"/>
-                        <a:ea typeface="Calibri" charset="0"/>
-                        <a:cs typeface="Calibri" charset="0"/>
-                      </a:endParaRPr>
-                    </a:p>
-                  </a:txBody>
-                  <a:tcPr marL="64008" marR="64008" marT="0" marB="0" anchor="ctr">
-                    <a:lnL w="6350" cap="flat" cmpd="sng" algn="ctr">
-                      <a:solidFill>
-                        <a:srgbClr val="D5DBE3"/>
-                      </a:solidFill>
-                      <a:prstDash val="solid"/>
-                      <a:round/>
-                      <a:headEnd type="none" w="med" len="med"/>
-                      <a:tailEnd type="none" w="med" len="med"/>
-                    </a:lnL>
-                    <a:lnR w="6350" cap="flat" cmpd="sng" algn="ctr">
-                      <a:solidFill>
-                        <a:srgbClr val="D5DBE3"/>
-                      </a:solidFill>
-                      <a:prstDash val="solid"/>
-                      <a:round/>
-                      <a:headEnd type="none" w="med" len="med"/>
-                      <a:tailEnd type="none" w="med" len="med"/>
-                    </a:lnR>
-                    <a:lnT w="6350" cap="flat" cmpd="sng" algn="ctr">
-                      <a:solidFill>
-                        <a:srgbClr val="D5DBE3"/>
-                      </a:solidFill>
-                      <a:prstDash val="solid"/>
-                      <a:round/>
-                      <a:headEnd type="none" w="med" len="med"/>
-                      <a:tailEnd type="none" w="med" len="med"/>
-                    </a:lnT>
-                    <a:lnB w="6350" cap="flat" cmpd="sng" algn="ctr">
-                      <a:solidFill>
-                        <a:srgbClr val="D5DBE3"/>
-                      </a:solidFill>
-                      <a:prstDash val="solid"/>
-                      <a:round/>
-                      <a:headEnd type="none" w="med" len="med"/>
-                      <a:tailEnd type="none" w="med" len="med"/>
-                    </a:lnB>
-                  </a:tcPr>
-                </a:tc>
-                <a:tc>
-                  <a:txBody>
-                    <a:bodyPr/>
-                    <a:lstStyle/>
-                    <a:p>
-                      <a:pPr algn="r" indent="0" marL="0">
-                        <a:buNone/>
-                      </a:pPr>
-                      <a:r>
-                        <a:rPr lang="en-US" sz="900" i="1" dirty="0">
-                          <a:solidFill>
-                            <a:srgbClr val="6B7280"/>
-                          </a:solidFill>
-                          <a:latin typeface="Calibri" pitchFamily="34" charset="0"/>
-                          <a:ea typeface="Calibri" pitchFamily="34" charset="-122"/>
-                          <a:cs typeface="Calibri" pitchFamily="34" charset="-120"/>
-                        </a:rPr>
-                        <a:t>133,2</a:t>
+                        <a:t>248,9</a:t>
                       </a:r>
                       <a:endParaRPr lang="en-US" sz="900" dirty="0">
                         <a:latin typeface="Calibri" charset="0"/>
@@ -6766,7 +6766,7 @@
                           <a:ea typeface="Calibri" pitchFamily="34" charset="-122"/>
                           <a:cs typeface="Calibri" pitchFamily="34" charset="-120"/>
                         </a:rPr>
-                        <a:t>-1 405,7</a:t>
+                        <a:t>-1 232,8</a:t>
                       </a:r>
                       <a:endParaRPr lang="en-US" sz="900" dirty="0">
                         <a:latin typeface="Calibri" charset="0"/>
@@ -6834,7 +6834,7 @@
                           <a:ea typeface="Calibri" pitchFamily="34" charset="-122"/>
                           <a:cs typeface="Calibri" pitchFamily="34" charset="-120"/>
                         </a:rPr>
-                        <a:t>-1 345,8</a:t>
+                        <a:t>-1 144,6</a:t>
                       </a:r>
                       <a:endParaRPr lang="en-US" sz="900" dirty="0">
                         <a:latin typeface="Calibri" charset="0"/>
@@ -6902,7 +6902,7 @@
                           <a:ea typeface="Calibri" pitchFamily="34" charset="-122"/>
                           <a:cs typeface="Calibri" pitchFamily="34" charset="-120"/>
                         </a:rPr>
-                        <a:t>-1 571,4</a:t>
+                        <a:t>-1 333,5</a:t>
                       </a:r>
                       <a:endParaRPr lang="en-US" sz="900" dirty="0">
                         <a:latin typeface="Calibri" charset="0"/>
@@ -6970,7 +6970,7 @@
                           <a:ea typeface="Calibri" pitchFamily="34" charset="-122"/>
                           <a:cs typeface="Calibri" pitchFamily="34" charset="-120"/>
                         </a:rPr>
-                        <a:t>-1 571,4</a:t>
+                        <a:t>-1 360,6</a:t>
                       </a:r>
                       <a:endParaRPr lang="en-US" sz="900" dirty="0">
                         <a:latin typeface="Calibri" charset="0"/>
@@ -7038,7 +7038,7 @@
                           <a:ea typeface="Calibri" pitchFamily="34" charset="-122"/>
                           <a:cs typeface="Calibri" pitchFamily="34" charset="-120"/>
                         </a:rPr>
-                        <a:t>-1 571,4</a:t>
+                        <a:t>-1 425,0</a:t>
                       </a:r>
                       <a:endParaRPr lang="en-US" sz="900" dirty="0">
                         <a:latin typeface="Calibri" charset="0"/>
@@ -10148,7 +10148,7 @@
                 <a:ea typeface="Calibri" pitchFamily="34" charset="-122"/>
                 <a:cs typeface="Calibri" pitchFamily="34" charset="-120"/>
               </a:rPr>
-              <a:t>déficits PICI 604,7 M, TERASSON 206,4 M, FINAFRICA 198,7 M, SCO AO 176,0 M, FIRST 175,3 M, RIVIERA 87,3 M ; excédents INFI SOFT 2,8 M.</a:t>
+              <a:t>déficits PICI 604,7 M, TERASSON 206,4 M, FINAFRICA 198,7 M, FIRST 175,3 M, RIVIERA 87,3 M, IMMONEUF 66,0 M ; excédents INFI SOFT 2,8 M.</a:t>
             </a:r>
             <a:endParaRPr lang="en-US" sz="1000" dirty="0"/>
           </a:p>
@@ -12018,7 +12018,7 @@
                           <a:ea typeface="Calibri" pitchFamily="34" charset="-122"/>
                           <a:cs typeface="Calibri" pitchFamily="34" charset="-120"/>
                         </a:rPr>
-                        <a:t>SCO AO</a:t>
+                        <a:t>FIRST</a:t>
                       </a:r>
                       <a:endParaRPr lang="en-US" sz="950" dirty="0">
                         <a:latin typeface="Calibri" charset="0"/>
@@ -12086,7 +12086,7 @@
                           <a:ea typeface="Calibri" pitchFamily="34" charset="-122"/>
                           <a:cs typeface="Calibri" pitchFamily="34" charset="-120"/>
                         </a:rPr>
-                        <a:t>Fournisseurs 131,2 · impôts 21,7 · cotisations 16,6 · salaires 24,3 · autres 15,0 · encaissements −3,6</a:t>
+                        <a:t>Fournisseurs 91,3 · impôts 1,6 · prêts 448,1 · encaissements −129,6</a:t>
                       </a:r>
                       <a:endParaRPr lang="en-US" sz="950" dirty="0">
                         <a:latin typeface="Calibri" charset="0"/>
@@ -12151,7 +12151,7 @@
                           <a:ea typeface="Calibri" pitchFamily="34" charset="-122"/>
                           <a:cs typeface="Calibri" pitchFamily="34" charset="-120"/>
                         </a:rPr>
-                        <a:t>208,7</a:t>
+                        <a:t>541,0</a:t>
                       </a:r>
                       <a:endParaRPr lang="en-US" sz="950" dirty="0">
                         <a:latin typeface="Calibri" charset="0"/>
@@ -12216,7 +12216,7 @@
                           <a:ea typeface="Calibri" pitchFamily="34" charset="-122"/>
                           <a:cs typeface="Calibri" pitchFamily="34" charset="-120"/>
                         </a:rPr>
-                        <a:t>BACI-Projet, puis BACI-CompteCourant</a:t>
+                        <a:t>STANBIC-FIRST, puis SOCIETE GENERALE-FIRST</a:t>
                       </a:r>
                       <a:endParaRPr lang="en-US" sz="950" dirty="0">
                         <a:latin typeface="Calibri" charset="0"/>
@@ -12281,7 +12281,7 @@
                           <a:ea typeface="Calibri" pitchFamily="34" charset="-122"/>
                           <a:cs typeface="Calibri" pitchFamily="34" charset="-120"/>
                         </a:rPr>
-                        <a:t>29,1</a:t>
+                        <a:t>236,1</a:t>
                       </a:r>
                       <a:endParaRPr lang="en-US" sz="950" dirty="0">
                         <a:latin typeface="Calibri" charset="0"/>
@@ -12346,7 +12346,7 @@
                           <a:ea typeface="Calibri" pitchFamily="34" charset="-122"/>
                           <a:cs typeface="Calibri" pitchFamily="34" charset="-120"/>
                         </a:rPr>
-                        <a:t>-176,0</a:t>
+                        <a:t>-175,3</a:t>
                       </a:r>
                       <a:endParaRPr lang="en-US" sz="950" dirty="0">
                         <a:latin typeface="Calibri" charset="0"/>
@@ -12416,7 +12416,7 @@
                           <a:ea typeface="Calibri" pitchFamily="34" charset="-122"/>
                           <a:cs typeface="Calibri" pitchFamily="34" charset="-120"/>
                         </a:rPr>
-                        <a:t>FIRST</a:t>
+                        <a:t>RIVIERA</a:t>
                       </a:r>
                       <a:endParaRPr lang="en-US" sz="950" dirty="0">
                         <a:latin typeface="Calibri" charset="0"/>
@@ -12484,7 +12484,7 @@
                           <a:ea typeface="Calibri" pitchFamily="34" charset="-122"/>
                           <a:cs typeface="Calibri" pitchFamily="34" charset="-120"/>
                         </a:rPr>
-                        <a:t>Fournisseurs 91,3 · impôts 1,6 · prêts 448,1 · encaissements −129,6</a:t>
+                        <a:t>Fournisseurs 17,6 · impôts 70,8 · cotisations 0,3</a:t>
                       </a:r>
                       <a:endParaRPr lang="en-US" sz="950" dirty="0">
                         <a:latin typeface="Calibri" charset="0"/>
@@ -12549,7 +12549,7 @@
                           <a:ea typeface="Calibri" pitchFamily="34" charset="-122"/>
                           <a:cs typeface="Calibri" pitchFamily="34" charset="-120"/>
                         </a:rPr>
-                        <a:t>541,0</a:t>
+                        <a:t>88,8</a:t>
                       </a:r>
                       <a:endParaRPr lang="en-US" sz="950" dirty="0">
                         <a:latin typeface="Calibri" charset="0"/>
@@ -12614,7 +12614,7 @@
                           <a:ea typeface="Calibri" pitchFamily="34" charset="-122"/>
                           <a:cs typeface="Calibri" pitchFamily="34" charset="-120"/>
                         </a:rPr>
-                        <a:t>STANBIC-FIRST, puis SOCIETE GENERALE-FIRST</a:t>
+                        <a:t>SOCIETE GENERALE-RIVIERA</a:t>
                       </a:r>
                       <a:endParaRPr lang="en-US" sz="950" dirty="0">
                         <a:latin typeface="Calibri" charset="0"/>
@@ -12679,7 +12679,7 @@
                           <a:ea typeface="Calibri" pitchFamily="34" charset="-122"/>
                           <a:cs typeface="Calibri" pitchFamily="34" charset="-120"/>
                         </a:rPr>
-                        <a:t>236,1</a:t>
+                        <a:t>1,5</a:t>
                       </a:r>
                       <a:endParaRPr lang="en-US" sz="950" dirty="0">
                         <a:latin typeface="Calibri" charset="0"/>
@@ -12744,7 +12744,7 @@
                           <a:ea typeface="Calibri" pitchFamily="34" charset="-122"/>
                           <a:cs typeface="Calibri" pitchFamily="34" charset="-120"/>
                         </a:rPr>
-                        <a:t>-175,3</a:t>
+                        <a:t>-87,3</a:t>
                       </a:r>
                       <a:endParaRPr lang="en-US" sz="950" dirty="0">
                         <a:latin typeface="Calibri" charset="0"/>
@@ -12814,7 +12814,7 @@
                           <a:ea typeface="Calibri" pitchFamily="34" charset="-122"/>
                           <a:cs typeface="Calibri" pitchFamily="34" charset="-120"/>
                         </a:rPr>
-                        <a:t>RIVIERA</a:t>
+                        <a:t>IMMONEUF</a:t>
                       </a:r>
                       <a:endParaRPr lang="en-US" sz="950" dirty="0">
                         <a:latin typeface="Calibri" charset="0"/>
@@ -12882,7 +12882,7 @@
                           <a:ea typeface="Calibri" pitchFamily="34" charset="-122"/>
                           <a:cs typeface="Calibri" pitchFamily="34" charset="-120"/>
                         </a:rPr>
-                        <a:t>Fournisseurs 17,6 · impôts 70,8 · cotisations 0,3</a:t>
+                        <a:t>Fournisseurs 6,2 · impôts 17,1 · cotisations 28,4 · salaires 26,0</a:t>
                       </a:r>
                       <a:endParaRPr lang="en-US" sz="950" dirty="0">
                         <a:latin typeface="Calibri" charset="0"/>
@@ -12947,7 +12947,7 @@
                           <a:ea typeface="Calibri" pitchFamily="34" charset="-122"/>
                           <a:cs typeface="Calibri" pitchFamily="34" charset="-120"/>
                         </a:rPr>
-                        <a:t>88,8</a:t>
+                        <a:t>77,8</a:t>
                       </a:r>
                       <a:endParaRPr lang="en-US" sz="950" dirty="0">
                         <a:latin typeface="Calibri" charset="0"/>
@@ -13012,7 +13012,7 @@
                           <a:ea typeface="Calibri" pitchFamily="34" charset="-122"/>
                           <a:cs typeface="Calibri" pitchFamily="34" charset="-120"/>
                         </a:rPr>
-                        <a:t>SOCIETE GENERALE-RIVIERA</a:t>
+                        <a:t>SOCIETE GENERALE-IMMONEUF, puis BACI - IMMONEUF</a:t>
                       </a:r>
                       <a:endParaRPr lang="en-US" sz="950" dirty="0">
                         <a:latin typeface="Calibri" charset="0"/>
@@ -13077,7 +13077,7 @@
                           <a:ea typeface="Calibri" pitchFamily="34" charset="-122"/>
                           <a:cs typeface="Calibri" pitchFamily="34" charset="-120"/>
                         </a:rPr>
-                        <a:t>1,5</a:t>
+                        <a:t>11,8</a:t>
                       </a:r>
                       <a:endParaRPr lang="en-US" sz="950" dirty="0">
                         <a:latin typeface="Calibri" charset="0"/>
@@ -13142,7 +13142,7 @@
                           <a:ea typeface="Calibri" pitchFamily="34" charset="-122"/>
                           <a:cs typeface="Calibri" pitchFamily="34" charset="-120"/>
                         </a:rPr>
-                        <a:t>-87,3</a:t>
+                        <a:t>-66,0</a:t>
                       </a:r>
                       <a:endParaRPr lang="en-US" sz="950" dirty="0">
                         <a:latin typeface="Calibri" charset="0"/>
@@ -13212,7 +13212,7 @@
                           <a:ea typeface="Calibri" pitchFamily="34" charset="-122"/>
                           <a:cs typeface="Calibri" pitchFamily="34" charset="-120"/>
                         </a:rPr>
-                        <a:t>IMMONEUF</a:t>
+                        <a:t>RHD CI</a:t>
                       </a:r>
                       <a:endParaRPr lang="en-US" sz="950" dirty="0">
                         <a:latin typeface="Calibri" charset="0"/>
@@ -13280,7 +13280,7 @@
                           <a:ea typeface="Calibri" pitchFamily="34" charset="-122"/>
                           <a:cs typeface="Calibri" pitchFamily="34" charset="-120"/>
                         </a:rPr>
-                        <a:t>Fournisseurs 6,2 · impôts 17,1 · cotisations 28,4 · salaires 26,0</a:t>
+                        <a:t>Impôts 38,9 · cotisations 11,1</a:t>
                       </a:r>
                       <a:endParaRPr lang="en-US" sz="950" dirty="0">
                         <a:latin typeface="Calibri" charset="0"/>
@@ -13345,7 +13345,7 @@
                           <a:ea typeface="Calibri" pitchFamily="34" charset="-122"/>
                           <a:cs typeface="Calibri" pitchFamily="34" charset="-120"/>
                         </a:rPr>
-                        <a:t>77,8</a:t>
+                        <a:t>50,0</a:t>
                       </a:r>
                       <a:endParaRPr lang="en-US" sz="950" dirty="0">
                         <a:latin typeface="Calibri" charset="0"/>
@@ -13410,7 +13410,7 @@
                           <a:ea typeface="Calibri" pitchFamily="34" charset="-122"/>
                           <a:cs typeface="Calibri" pitchFamily="34" charset="-120"/>
                         </a:rPr>
-                        <a:t>SOCIETE GENERALE-IMMONEUF, puis BACI - IMMONEUF</a:t>
+                        <a:t>Aucun compte : paiement pour son compte par une autre société</a:t>
                       </a:r>
                       <a:endParaRPr lang="en-US" sz="950" dirty="0">
                         <a:latin typeface="Calibri" charset="0"/>
@@ -13475,7 +13475,7 @@
                           <a:ea typeface="Calibri" pitchFamily="34" charset="-122"/>
                           <a:cs typeface="Calibri" pitchFamily="34" charset="-120"/>
                         </a:rPr>
-                        <a:t>11,8</a:t>
+                        <a:t>–</a:t>
                       </a:r>
                       <a:endParaRPr lang="en-US" sz="950" dirty="0">
                         <a:latin typeface="Calibri" charset="0"/>
@@ -13540,7 +13540,7 @@
                           <a:ea typeface="Calibri" pitchFamily="34" charset="-122"/>
                           <a:cs typeface="Calibri" pitchFamily="34" charset="-120"/>
                         </a:rPr>
-                        <a:t>-66,0</a:t>
+                        <a:t>-50,0</a:t>
                       </a:r>
                       <a:endParaRPr lang="en-US" sz="950" dirty="0">
                         <a:latin typeface="Calibri" charset="0"/>
@@ -13610,7 +13610,7 @@
                           <a:ea typeface="Calibri" pitchFamily="34" charset="-122"/>
                           <a:cs typeface="Calibri" pitchFamily="34" charset="-120"/>
                         </a:rPr>
-                        <a:t>RHD CI</a:t>
+                        <a:t>SCO AO</a:t>
                       </a:r>
                       <a:endParaRPr lang="en-US" sz="950" dirty="0">
                         <a:latin typeface="Calibri" charset="0"/>
@@ -13678,7 +13678,7 @@
                           <a:ea typeface="Calibri" pitchFamily="34" charset="-122"/>
                           <a:cs typeface="Calibri" pitchFamily="34" charset="-120"/>
                         </a:rPr>
-                        <a:t>Impôts 38,9 · cotisations 11,1</a:t>
+                        <a:t>Fournisseurs 145,7 · impôts 17,1 · cotisations 3,6 · salaires 11,6 · encaissements −119,4</a:t>
                       </a:r>
                       <a:endParaRPr lang="en-US" sz="950" dirty="0">
                         <a:latin typeface="Calibri" charset="0"/>
@@ -13743,7 +13743,7 @@
                           <a:ea typeface="Calibri" pitchFamily="34" charset="-122"/>
                           <a:cs typeface="Calibri" pitchFamily="34" charset="-120"/>
                         </a:rPr>
-                        <a:t>50,0</a:t>
+                        <a:t>178,0</a:t>
                       </a:r>
                       <a:endParaRPr lang="en-US" sz="950" dirty="0">
                         <a:latin typeface="Calibri" charset="0"/>
@@ -13808,7 +13808,7 @@
                           <a:ea typeface="Calibri" pitchFamily="34" charset="-122"/>
                           <a:cs typeface="Calibri" pitchFamily="34" charset="-120"/>
                         </a:rPr>
-                        <a:t>Aucun compte : paiement pour son compte par une autre société</a:t>
+                        <a:t>BACI-Projet, puis BACI-CompteCourant</a:t>
                       </a:r>
                       <a:endParaRPr lang="en-US" sz="950" dirty="0">
                         <a:latin typeface="Calibri" charset="0"/>
@@ -13873,7 +13873,7 @@
                           <a:ea typeface="Calibri" pitchFamily="34" charset="-122"/>
                           <a:cs typeface="Calibri" pitchFamily="34" charset="-120"/>
                         </a:rPr>
-                        <a:t>–</a:t>
+                        <a:t>29,1</a:t>
                       </a:r>
                       <a:endParaRPr lang="en-US" sz="950" dirty="0">
                         <a:latin typeface="Calibri" charset="0"/>
@@ -13938,7 +13938,7 @@
                           <a:ea typeface="Calibri" pitchFamily="34" charset="-122"/>
                           <a:cs typeface="Calibri" pitchFamily="34" charset="-120"/>
                         </a:rPr>
-                        <a:t>-50,0</a:t>
+                        <a:t>-29,5</a:t>
                       </a:r>
                       <a:endParaRPr lang="en-US" sz="950" dirty="0">
                         <a:latin typeface="Calibri" charset="0"/>
@@ -16041,7 +16041,7 @@
                 <a:ea typeface="Calibri" pitchFamily="34" charset="-122"/>
                 <a:cs typeface="Calibri" pitchFamily="34" charset="-120"/>
               </a:rPr>
-              <a:t>Déficits à couvrir d'ici S5 : 2 676,8 M – MFCFA</a:t>
+              <a:t>Déficits à couvrir d'ici S5 : 2 530,3 M – MFCFA</a:t>
             </a:r>
             <a:endParaRPr lang="en-US" sz="1300" dirty="0"/>
           </a:p>
@@ -17162,7 +17162,7 @@
                           <a:ea typeface="Calibri" pitchFamily="34" charset="-122"/>
                           <a:cs typeface="Calibri" pitchFamily="34" charset="-120"/>
                         </a:rPr>
-                        <a:t>SCO AO</a:t>
+                        <a:t>FIRST</a:t>
                       </a:r>
                       <a:endParaRPr lang="en-US" sz="950" dirty="0">
                         <a:latin typeface="Calibri" charset="0"/>
@@ -17227,7 +17227,7 @@
                           <a:ea typeface="Calibri" pitchFamily="34" charset="-122"/>
                           <a:cs typeface="Calibri" pitchFamily="34" charset="-120"/>
                         </a:rPr>
-                        <a:t>176,0</a:t>
+                        <a:t>175,3</a:t>
                       </a:r>
                       <a:endParaRPr lang="en-US" sz="950" dirty="0">
                         <a:latin typeface="Calibri" charset="0"/>
@@ -17427,7 +17427,7 @@
                           <a:ea typeface="Calibri" pitchFamily="34" charset="-122"/>
                           <a:cs typeface="Calibri" pitchFamily="34" charset="-120"/>
                         </a:rPr>
-                        <a:t>FIRST</a:t>
+                        <a:t>RIVIERA</a:t>
                       </a:r>
                       <a:endParaRPr lang="en-US" sz="950" dirty="0">
                         <a:latin typeface="Calibri" charset="0"/>
@@ -17492,7 +17492,7 @@
                           <a:ea typeface="Calibri" pitchFamily="34" charset="-122"/>
                           <a:cs typeface="Calibri" pitchFamily="34" charset="-120"/>
                         </a:rPr>
-                        <a:t>175,3</a:t>
+                        <a:t>87,3</a:t>
                       </a:r>
                       <a:endParaRPr lang="en-US" sz="950" dirty="0">
                         <a:latin typeface="Calibri" charset="0"/>
@@ -17692,7 +17692,7 @@
                           <a:ea typeface="Calibri" pitchFamily="34" charset="-122"/>
                           <a:cs typeface="Calibri" pitchFamily="34" charset="-120"/>
                         </a:rPr>
-                        <a:t>RIVIERA</a:t>
+                        <a:t>IMMONEUF</a:t>
                       </a:r>
                       <a:endParaRPr lang="en-US" sz="950" dirty="0">
                         <a:latin typeface="Calibri" charset="0"/>
@@ -17757,7 +17757,7 @@
                           <a:ea typeface="Calibri" pitchFamily="34" charset="-122"/>
                           <a:cs typeface="Calibri" pitchFamily="34" charset="-120"/>
                         </a:rPr>
-                        <a:t>87,3</a:t>
+                        <a:t>66,0</a:t>
                       </a:r>
                       <a:endParaRPr lang="en-US" sz="950" dirty="0">
                         <a:latin typeface="Calibri" charset="0"/>
@@ -17957,7 +17957,7 @@
                           <a:ea typeface="Calibri" pitchFamily="34" charset="-122"/>
                           <a:cs typeface="Calibri" pitchFamily="34" charset="-120"/>
                         </a:rPr>
-                        <a:t>IMMONEUF</a:t>
+                        <a:t>RHD CI</a:t>
                       </a:r>
                       <a:endParaRPr lang="en-US" sz="950" dirty="0">
                         <a:latin typeface="Calibri" charset="0"/>
@@ -18022,7 +18022,7 @@
                           <a:ea typeface="Calibri" pitchFamily="34" charset="-122"/>
                           <a:cs typeface="Calibri" pitchFamily="34" charset="-120"/>
                         </a:rPr>
-                        <a:t>66,0</a:t>
+                        <a:t>50,0</a:t>
                       </a:r>
                       <a:endParaRPr lang="en-US" sz="950" dirty="0">
                         <a:latin typeface="Calibri" charset="0"/>
@@ -18222,7 +18222,7 @@
                           <a:ea typeface="Calibri" pitchFamily="34" charset="-122"/>
                           <a:cs typeface="Calibri" pitchFamily="34" charset="-120"/>
                         </a:rPr>
-                        <a:t>RHD CI</a:t>
+                        <a:t>SCO AO</a:t>
                       </a:r>
                       <a:endParaRPr lang="en-US" sz="950" dirty="0">
                         <a:latin typeface="Calibri" charset="0"/>
@@ -18287,7 +18287,7 @@
                           <a:ea typeface="Calibri" pitchFamily="34" charset="-122"/>
                           <a:cs typeface="Calibri" pitchFamily="34" charset="-120"/>
                         </a:rPr>
-                        <a:t>50,0</a:t>
+                        <a:t>29,5</a:t>
                       </a:r>
                       <a:endParaRPr lang="en-US" sz="950" dirty="0">
                         <a:latin typeface="Calibri" charset="0"/>
@@ -18420,7 +18420,7 @@
                           <a:ea typeface="Calibri" pitchFamily="34" charset="-122"/>
                           <a:cs typeface="Calibri" pitchFamily="34" charset="-120"/>
                         </a:rPr>
-                        <a:t>S1</a:t>
+                        <a:t>S5</a:t>
                       </a:r>
                       <a:endParaRPr lang="en-US" sz="950" dirty="0">
                         <a:latin typeface="Calibri" charset="0"/>
@@ -19615,7 +19615,7 @@
                           <a:ea typeface="Calibri" pitchFamily="34" charset="-122"/>
                           <a:cs typeface="Calibri" pitchFamily="34" charset="-120"/>
                         </a:rPr>
-                        <a:t>2 676,8</a:t>
+                        <a:t>2 530,3</a:t>
                       </a:r>
                       <a:endParaRPr lang="en-US" sz="950" dirty="0">
                         <a:latin typeface="Calibri" charset="0"/>
@@ -19882,7 +19882,7 @@
                 <a:ea typeface="Calibri" pitchFamily="34" charset="-122"/>
                 <a:cs typeface="Calibri" pitchFamily="34" charset="-120"/>
               </a:rPr>
-              <a:t>1 574,2 M</a:t>
+              <a:t>1 427,7 M</a:t>
             </a:r>
             <a:endParaRPr lang="en-US" sz="1400" dirty="0"/>
           </a:p>
@@ -19921,7 +19921,7 @@
                 <a:ea typeface="Calibri" pitchFamily="34" charset="-122"/>
                 <a:cs typeface="Calibri" pitchFamily="34" charset="-120"/>
               </a:rPr>
-              <a:t>Un dossier par société en déficit (10), tiré par tranche : 1 408,5 M pour S1, le solde à l'échéance. Remboursement à la mise en place des financements.</a:t>
+              <a:t>Un dossier par société en déficit (10), tiré par tranche : 1 256,8 M pour S1, le solde à l'échéance. Remboursement à la mise en place des financements.</a:t>
             </a:r>
             <a:endParaRPr lang="en-US" sz="1100" dirty="0"/>
           </a:p>
@@ -20293,7 +20293,7 @@
                 <a:ea typeface="Calibri" pitchFamily="34" charset="-122"/>
                 <a:cs typeface="Calibri" pitchFamily="34" charset="-120"/>
               </a:rPr>
-              <a:t>Choisir la solution des sociétés en déficit (1 574,2 M) : crédit spot, avances intragroupe ou combinaison.</a:t>
+              <a:t>Choisir la solution des sociétés en déficit (1 427,7 M) : crédit spot, avances intragroupe ou combinaison.</a:t>
             </a:r>
             <a:endParaRPr lang="en-US" sz="1300" dirty="0"/>
           </a:p>
@@ -20335,7 +20335,7 @@
                 <a:ea typeface="Calibri" pitchFamily="34" charset="-122"/>
                 <a:cs typeface="Calibri" pitchFamily="34" charset="-120"/>
               </a:rPr>
-              <a:t>Confirmer les encaissements prévus (133,2 M), dont Loyer octobre 2026 – DC/BR.</a:t>
+              <a:t>Confirmer les encaissements prévus (248,9 M), dont SUD CONSTRUCTION – BCEAO (En attente … relance à effectuer).</a:t>
             </a:r>
             <a:endParaRPr lang="en-US" sz="1300" dirty="0"/>
           </a:p>
@@ -20616,7 +20616,7 @@
                 <a:ea typeface="Calibri" pitchFamily="34" charset="-122"/>
                 <a:cs typeface="Calibri" pitchFamily="34" charset="-120"/>
               </a:rPr>
-              <a:t>5 273,4 M</a:t>
+              <a:t>5 100,4 M</a:t>
             </a:r>
             <a:endParaRPr lang="en-US" sz="2200" dirty="0"/>
           </a:p>
@@ -20931,7 +20931,7 @@
                 <a:ea typeface="Calibri" pitchFamily="34" charset="-122"/>
                 <a:cs typeface="Calibri" pitchFamily="34" charset="-120"/>
               </a:rPr>
-              <a:t>1 659,6 M</a:t>
+              <a:t>1 509,2 M</a:t>
             </a:r>
             <a:endParaRPr lang="en-US" sz="2200" dirty="0"/>
           </a:p>
@@ -24332,7 +24332,7 @@
                           <a:ea typeface="Calibri" pitchFamily="34" charset="-122"/>
                           <a:cs typeface="Calibri" pitchFamily="34" charset="-120"/>
                         </a:rPr>
-                        <a:t>-180,9</a:t>
+                        <a:t>-7,9</a:t>
                       </a:r>
                       <a:endParaRPr lang="en-US" sz="850" dirty="0">
                         <a:latin typeface="Calibri" charset="0"/>
@@ -24456,13 +24456,78 @@
                       <a:r>
                         <a:rPr lang="en-US" sz="850" b="1" dirty="0">
                           <a:solidFill>
+                            <a:srgbClr val="5E9B7E"/>
+                          </a:solidFill>
+                          <a:latin typeface="Calibri" pitchFamily="34" charset="0"/>
+                          <a:ea typeface="Calibri" pitchFamily="34" charset="-122"/>
+                          <a:cs typeface="Calibri" pitchFamily="34" charset="-120"/>
+                        </a:rPr>
+                        <a:t>21,2</a:t>
+                      </a:r>
+                      <a:endParaRPr lang="en-US" sz="850" dirty="0">
+                        <a:latin typeface="Calibri" charset="0"/>
+                        <a:ea typeface="Calibri" charset="0"/>
+                        <a:cs typeface="Calibri" charset="0"/>
+                      </a:endParaRPr>
+                    </a:p>
+                  </a:txBody>
+                  <a:tcPr marL="64008" marR="64008" marT="0" marB="0" anchor="ctr">
+                    <a:lnL w="6350" cap="flat" cmpd="sng" algn="ctr">
+                      <a:solidFill>
+                        <a:srgbClr val="D5DBE3"/>
+                      </a:solidFill>
+                      <a:prstDash val="solid"/>
+                      <a:round/>
+                      <a:headEnd type="none" w="med" len="med"/>
+                      <a:tailEnd type="none" w="med" len="med"/>
+                    </a:lnL>
+                    <a:lnR w="6350" cap="flat" cmpd="sng" algn="ctr">
+                      <a:solidFill>
+                        <a:srgbClr val="D5DBE3"/>
+                      </a:solidFill>
+                      <a:prstDash val="solid"/>
+                      <a:round/>
+                      <a:headEnd type="none" w="med" len="med"/>
+                      <a:tailEnd type="none" w="med" len="med"/>
+                    </a:lnR>
+                    <a:lnT w="6350" cap="flat" cmpd="sng" algn="ctr">
+                      <a:solidFill>
+                        <a:srgbClr val="D5DBE3"/>
+                      </a:solidFill>
+                      <a:prstDash val="solid"/>
+                      <a:round/>
+                      <a:headEnd type="none" w="med" len="med"/>
+                      <a:tailEnd type="none" w="med" len="med"/>
+                    </a:lnT>
+                    <a:lnB w="6350" cap="flat" cmpd="sng" algn="ctr">
+                      <a:solidFill>
+                        <a:srgbClr val="D5DBE3"/>
+                      </a:solidFill>
+                      <a:prstDash val="solid"/>
+                      <a:round/>
+                      <a:headEnd type="none" w="med" len="med"/>
+                      <a:tailEnd type="none" w="med" len="med"/>
+                    </a:lnB>
+                  </a:tcPr>
+                </a:tc>
+                <a:tc>
+                  <a:txBody>
+                    <a:bodyPr/>
+                    <a:lstStyle/>
+                    <a:p>
+                      <a:pPr algn="r" indent="0" marL="0">
+                        <a:buNone/>
+                      </a:pPr>
+                      <a:r>
+                        <a:rPr lang="en-US" sz="850" b="1" dirty="0">
+                          <a:solidFill>
                             <a:srgbClr val="B3261E"/>
                           </a:solidFill>
                           <a:latin typeface="Calibri" pitchFamily="34" charset="0"/>
                           <a:ea typeface="Calibri" pitchFamily="34" charset="-122"/>
                           <a:cs typeface="Calibri" pitchFamily="34" charset="-120"/>
                         </a:rPr>
-                        <a:t>-151,7</a:t>
+                        <a:t>2,5</a:t>
                       </a:r>
                       <a:endParaRPr lang="en-US" sz="850" dirty="0">
                         <a:latin typeface="Calibri" charset="0"/>
@@ -24513,6 +24578,73 @@
                     </a:solidFill>
                   </a:tcPr>
                 </a:tc>
+              </a:tr>
+              <a:tr h="224028">
+                <a:tc>
+                  <a:txBody>
+                    <a:bodyPr/>
+                    <a:lstStyle/>
+                    <a:p>
+                      <a:pPr algn="l" indent="0" marL="0">
+                        <a:buNone/>
+                      </a:pPr>
+                      <a:r>
+                        <a:rPr lang="en-US" sz="850" b="1" dirty="0">
+                          <a:solidFill>
+                            <a:srgbClr val="1F2933"/>
+                          </a:solidFill>
+                          <a:latin typeface="Calibri" pitchFamily="34" charset="0"/>
+                          <a:ea typeface="Calibri" pitchFamily="34" charset="-122"/>
+                          <a:cs typeface="Calibri" pitchFamily="34" charset="-120"/>
+                        </a:rPr>
+                        <a:t>IMMONEUF</a:t>
+                      </a:r>
+                      <a:endParaRPr lang="en-US" sz="850" dirty="0">
+                        <a:latin typeface="Calibri" charset="0"/>
+                        <a:ea typeface="Calibri" charset="0"/>
+                        <a:cs typeface="Calibri" charset="0"/>
+                      </a:endParaRPr>
+                    </a:p>
+                  </a:txBody>
+                  <a:tcPr marL="64008" marR="64008" marT="0" marB="0" anchor="ctr">
+                    <a:lnL w="6350" cap="flat" cmpd="sng" algn="ctr">
+                      <a:solidFill>
+                        <a:srgbClr val="D5DBE3"/>
+                      </a:solidFill>
+                      <a:prstDash val="solid"/>
+                      <a:round/>
+                      <a:headEnd type="none" w="med" len="med"/>
+                      <a:tailEnd type="none" w="med" len="med"/>
+                    </a:lnL>
+                    <a:lnR w="6350" cap="flat" cmpd="sng" algn="ctr">
+                      <a:solidFill>
+                        <a:srgbClr val="D5DBE3"/>
+                      </a:solidFill>
+                      <a:prstDash val="solid"/>
+                      <a:round/>
+                      <a:headEnd type="none" w="med" len="med"/>
+                      <a:tailEnd type="none" w="med" len="med"/>
+                    </a:lnR>
+                    <a:lnT w="6350" cap="flat" cmpd="sng" algn="ctr">
+                      <a:solidFill>
+                        <a:srgbClr val="D5DBE3"/>
+                      </a:solidFill>
+                      <a:prstDash val="solid"/>
+                      <a:round/>
+                      <a:headEnd type="none" w="med" len="med"/>
+                      <a:tailEnd type="none" w="med" len="med"/>
+                    </a:lnT>
+                    <a:lnB w="6350" cap="flat" cmpd="sng" algn="ctr">
+                      <a:solidFill>
+                        <a:srgbClr val="D5DBE3"/>
+                      </a:solidFill>
+                      <a:prstDash val="solid"/>
+                      <a:round/>
+                      <a:headEnd type="none" w="med" len="med"/>
+                      <a:tailEnd type="none" w="med" len="med"/>
+                    </a:lnB>
+                  </a:tcPr>
+                </a:tc>
                 <a:tc>
                   <a:txBody>
                     <a:bodyPr/>
@@ -24522,6 +24654,201 @@
                         <a:buNone/>
                       </a:pPr>
                       <a:r>
+                        <a:rPr lang="en-US" sz="850" dirty="0">
+                          <a:solidFill>
+                            <a:srgbClr val="1F2933"/>
+                          </a:solidFill>
+                          <a:latin typeface="Calibri" pitchFamily="34" charset="0"/>
+                          <a:ea typeface="Calibri" pitchFamily="34" charset="-122"/>
+                          <a:cs typeface="Calibri" pitchFamily="34" charset="-120"/>
+                        </a:rPr>
+                        <a:t>11,8</a:t>
+                      </a:r>
+                      <a:endParaRPr lang="en-US" sz="850" dirty="0">
+                        <a:latin typeface="Calibri" charset="0"/>
+                        <a:ea typeface="Calibri" charset="0"/>
+                        <a:cs typeface="Calibri" charset="0"/>
+                      </a:endParaRPr>
+                    </a:p>
+                  </a:txBody>
+                  <a:tcPr marL="64008" marR="64008" marT="0" marB="0" anchor="ctr">
+                    <a:lnL w="6350" cap="flat" cmpd="sng" algn="ctr">
+                      <a:solidFill>
+                        <a:srgbClr val="D5DBE3"/>
+                      </a:solidFill>
+                      <a:prstDash val="solid"/>
+                      <a:round/>
+                      <a:headEnd type="none" w="med" len="med"/>
+                      <a:tailEnd type="none" w="med" len="med"/>
+                    </a:lnL>
+                    <a:lnR w="6350" cap="flat" cmpd="sng" algn="ctr">
+                      <a:solidFill>
+                        <a:srgbClr val="D5DBE3"/>
+                      </a:solidFill>
+                      <a:prstDash val="solid"/>
+                      <a:round/>
+                      <a:headEnd type="none" w="med" len="med"/>
+                      <a:tailEnd type="none" w="med" len="med"/>
+                    </a:lnR>
+                    <a:lnT w="6350" cap="flat" cmpd="sng" algn="ctr">
+                      <a:solidFill>
+                        <a:srgbClr val="D5DBE3"/>
+                      </a:solidFill>
+                      <a:prstDash val="solid"/>
+                      <a:round/>
+                      <a:headEnd type="none" w="med" len="med"/>
+                      <a:tailEnd type="none" w="med" len="med"/>
+                    </a:lnT>
+                    <a:lnB w="6350" cap="flat" cmpd="sng" algn="ctr">
+                      <a:solidFill>
+                        <a:srgbClr val="D5DBE3"/>
+                      </a:solidFill>
+                      <a:prstDash val="solid"/>
+                      <a:round/>
+                      <a:headEnd type="none" w="med" len="med"/>
+                      <a:tailEnd type="none" w="med" len="med"/>
+                    </a:lnB>
+                  </a:tcPr>
+                </a:tc>
+                <a:tc>
+                  <a:txBody>
+                    <a:bodyPr/>
+                    <a:lstStyle/>
+                    <a:p>
+                      <a:pPr algn="r" indent="0" marL="0">
+                        <a:buNone/>
+                      </a:pPr>
+                      <a:r>
+                        <a:rPr lang="en-US" sz="850" dirty="0">
+                          <a:solidFill>
+                            <a:srgbClr val="1F2933"/>
+                          </a:solidFill>
+                          <a:latin typeface="Calibri" pitchFamily="34" charset="0"/>
+                          <a:ea typeface="Calibri" pitchFamily="34" charset="-122"/>
+                          <a:cs typeface="Calibri" pitchFamily="34" charset="-120"/>
+                        </a:rPr>
+                        <a:t>-37,3</a:t>
+                      </a:r>
+                      <a:endParaRPr lang="en-US" sz="850" dirty="0">
+                        <a:latin typeface="Calibri" charset="0"/>
+                        <a:ea typeface="Calibri" charset="0"/>
+                        <a:cs typeface="Calibri" charset="0"/>
+                      </a:endParaRPr>
+                    </a:p>
+                  </a:txBody>
+                  <a:tcPr marL="64008" marR="64008" marT="0" marB="0" anchor="ctr">
+                    <a:lnL w="6350" cap="flat" cmpd="sng" algn="ctr">
+                      <a:solidFill>
+                        <a:srgbClr val="D5DBE3"/>
+                      </a:solidFill>
+                      <a:prstDash val="solid"/>
+                      <a:round/>
+                      <a:headEnd type="none" w="med" len="med"/>
+                      <a:tailEnd type="none" w="med" len="med"/>
+                    </a:lnL>
+                    <a:lnR w="6350" cap="flat" cmpd="sng" algn="ctr">
+                      <a:solidFill>
+                        <a:srgbClr val="D5DBE3"/>
+                      </a:solidFill>
+                      <a:prstDash val="solid"/>
+                      <a:round/>
+                      <a:headEnd type="none" w="med" len="med"/>
+                      <a:tailEnd type="none" w="med" len="med"/>
+                    </a:lnR>
+                    <a:lnT w="6350" cap="flat" cmpd="sng" algn="ctr">
+                      <a:solidFill>
+                        <a:srgbClr val="D5DBE3"/>
+                      </a:solidFill>
+                      <a:prstDash val="solid"/>
+                      <a:round/>
+                      <a:headEnd type="none" w="med" len="med"/>
+                      <a:tailEnd type="none" w="med" len="med"/>
+                    </a:lnT>
+                    <a:lnB w="6350" cap="flat" cmpd="sng" algn="ctr">
+                      <a:solidFill>
+                        <a:srgbClr val="D5DBE3"/>
+                      </a:solidFill>
+                      <a:prstDash val="solid"/>
+                      <a:round/>
+                      <a:headEnd type="none" w="med" len="med"/>
+                      <a:tailEnd type="none" w="med" len="med"/>
+                    </a:lnB>
+                  </a:tcPr>
+                </a:tc>
+                <a:tc>
+                  <a:txBody>
+                    <a:bodyPr/>
+                    <a:lstStyle/>
+                    <a:p>
+                      <a:pPr algn="r" indent="0" marL="0">
+                        <a:buNone/>
+                      </a:pPr>
+                      <a:r>
+                        <a:rPr lang="en-US" sz="850" dirty="0">
+                          <a:solidFill>
+                            <a:srgbClr val="1F2933"/>
+                          </a:solidFill>
+                          <a:latin typeface="Calibri" pitchFamily="34" charset="0"/>
+                          <a:ea typeface="Calibri" pitchFamily="34" charset="-122"/>
+                          <a:cs typeface="Calibri" pitchFamily="34" charset="-120"/>
+                        </a:rPr>
+                        <a:t>–</a:t>
+                      </a:r>
+                      <a:endParaRPr lang="en-US" sz="850" dirty="0">
+                        <a:latin typeface="Calibri" charset="0"/>
+                        <a:ea typeface="Calibri" charset="0"/>
+                        <a:cs typeface="Calibri" charset="0"/>
+                      </a:endParaRPr>
+                    </a:p>
+                  </a:txBody>
+                  <a:tcPr marL="64008" marR="64008" marT="0" marB="0" anchor="ctr">
+                    <a:lnL w="6350" cap="flat" cmpd="sng" algn="ctr">
+                      <a:solidFill>
+                        <a:srgbClr val="D5DBE3"/>
+                      </a:solidFill>
+                      <a:prstDash val="solid"/>
+                      <a:round/>
+                      <a:headEnd type="none" w="med" len="med"/>
+                      <a:tailEnd type="none" w="med" len="med"/>
+                    </a:lnL>
+                    <a:lnR w="6350" cap="flat" cmpd="sng" algn="ctr">
+                      <a:solidFill>
+                        <a:srgbClr val="D5DBE3"/>
+                      </a:solidFill>
+                      <a:prstDash val="solid"/>
+                      <a:round/>
+                      <a:headEnd type="none" w="med" len="med"/>
+                      <a:tailEnd type="none" w="med" len="med"/>
+                    </a:lnR>
+                    <a:lnT w="6350" cap="flat" cmpd="sng" algn="ctr">
+                      <a:solidFill>
+                        <a:srgbClr val="D5DBE3"/>
+                      </a:solidFill>
+                      <a:prstDash val="solid"/>
+                      <a:round/>
+                      <a:headEnd type="none" w="med" len="med"/>
+                      <a:tailEnd type="none" w="med" len="med"/>
+                    </a:lnT>
+                    <a:lnB w="6350" cap="flat" cmpd="sng" algn="ctr">
+                      <a:solidFill>
+                        <a:srgbClr val="D5DBE3"/>
+                      </a:solidFill>
+                      <a:prstDash val="solid"/>
+                      <a:round/>
+                      <a:headEnd type="none" w="med" len="med"/>
+                      <a:tailEnd type="none" w="med" len="med"/>
+                    </a:lnB>
+                  </a:tcPr>
+                </a:tc>
+                <a:tc>
+                  <a:txBody>
+                    <a:bodyPr/>
+                    <a:lstStyle/>
+                    <a:p>
+                      <a:pPr algn="r" indent="0" marL="0">
+                        <a:buNone/>
+                      </a:pPr>
+                      <a:r>
                         <a:rPr lang="en-US" sz="850" b="1" dirty="0">
                           <a:solidFill>
                             <a:srgbClr val="B3261E"/>
@@ -24530,7 +24857,7 @@
                           <a:ea typeface="Calibri" pitchFamily="34" charset="-122"/>
                           <a:cs typeface="Calibri" pitchFamily="34" charset="-120"/>
                         </a:rPr>
-                        <a:t>152,9</a:t>
+                        <a:t>-25,6</a:t>
                       </a:r>
                       <a:endParaRPr lang="en-US" sz="850" dirty="0">
                         <a:latin typeface="Calibri" charset="0"/>
@@ -24581,286 +24908,24 @@
                     </a:solidFill>
                   </a:tcPr>
                 </a:tc>
-              </a:tr>
-              <a:tr h="224028">
-                <a:tc>
-                  <a:txBody>
-                    <a:bodyPr/>
-                    <a:lstStyle/>
-                    <a:p>
-                      <a:pPr algn="l" indent="0" marL="0">
+                <a:tc>
+                  <a:txBody>
+                    <a:bodyPr/>
+                    <a:lstStyle/>
+                    <a:p>
+                      <a:pPr algn="r" indent="0" marL="0">
                         <a:buNone/>
                       </a:pPr>
                       <a:r>
                         <a:rPr lang="en-US" sz="850" b="1" dirty="0">
                           <a:solidFill>
-                            <a:srgbClr val="1F2933"/>
-                          </a:solidFill>
-                          <a:latin typeface="Calibri" pitchFamily="34" charset="0"/>
-                          <a:ea typeface="Calibri" pitchFamily="34" charset="-122"/>
-                          <a:cs typeface="Calibri" pitchFamily="34" charset="-120"/>
-                        </a:rPr>
-                        <a:t>IMMONEUF</a:t>
-                      </a:r>
-                      <a:endParaRPr lang="en-US" sz="850" dirty="0">
-                        <a:latin typeface="Calibri" charset="0"/>
-                        <a:ea typeface="Calibri" charset="0"/>
-                        <a:cs typeface="Calibri" charset="0"/>
-                      </a:endParaRPr>
-                    </a:p>
-                  </a:txBody>
-                  <a:tcPr marL="64008" marR="64008" marT="0" marB="0" anchor="ctr">
-                    <a:lnL w="6350" cap="flat" cmpd="sng" algn="ctr">
-                      <a:solidFill>
-                        <a:srgbClr val="D5DBE3"/>
-                      </a:solidFill>
-                      <a:prstDash val="solid"/>
-                      <a:round/>
-                      <a:headEnd type="none" w="med" len="med"/>
-                      <a:tailEnd type="none" w="med" len="med"/>
-                    </a:lnL>
-                    <a:lnR w="6350" cap="flat" cmpd="sng" algn="ctr">
-                      <a:solidFill>
-                        <a:srgbClr val="D5DBE3"/>
-                      </a:solidFill>
-                      <a:prstDash val="solid"/>
-                      <a:round/>
-                      <a:headEnd type="none" w="med" len="med"/>
-                      <a:tailEnd type="none" w="med" len="med"/>
-                    </a:lnR>
-                    <a:lnT w="6350" cap="flat" cmpd="sng" algn="ctr">
-                      <a:solidFill>
-                        <a:srgbClr val="D5DBE3"/>
-                      </a:solidFill>
-                      <a:prstDash val="solid"/>
-                      <a:round/>
-                      <a:headEnd type="none" w="med" len="med"/>
-                      <a:tailEnd type="none" w="med" len="med"/>
-                    </a:lnT>
-                    <a:lnB w="6350" cap="flat" cmpd="sng" algn="ctr">
-                      <a:solidFill>
-                        <a:srgbClr val="D5DBE3"/>
-                      </a:solidFill>
-                      <a:prstDash val="solid"/>
-                      <a:round/>
-                      <a:headEnd type="none" w="med" len="med"/>
-                      <a:tailEnd type="none" w="med" len="med"/>
-                    </a:lnB>
-                  </a:tcPr>
-                </a:tc>
-                <a:tc>
-                  <a:txBody>
-                    <a:bodyPr/>
-                    <a:lstStyle/>
-                    <a:p>
-                      <a:pPr algn="r" indent="0" marL="0">
-                        <a:buNone/>
-                      </a:pPr>
-                      <a:r>
-                        <a:rPr lang="en-US" sz="850" dirty="0">
-                          <a:solidFill>
-                            <a:srgbClr val="1F2933"/>
-                          </a:solidFill>
-                          <a:latin typeface="Calibri" pitchFamily="34" charset="0"/>
-                          <a:ea typeface="Calibri" pitchFamily="34" charset="-122"/>
-                          <a:cs typeface="Calibri" pitchFamily="34" charset="-120"/>
-                        </a:rPr>
-                        <a:t>11,8</a:t>
-                      </a:r>
-                      <a:endParaRPr lang="en-US" sz="850" dirty="0">
-                        <a:latin typeface="Calibri" charset="0"/>
-                        <a:ea typeface="Calibri" charset="0"/>
-                        <a:cs typeface="Calibri" charset="0"/>
-                      </a:endParaRPr>
-                    </a:p>
-                  </a:txBody>
-                  <a:tcPr marL="64008" marR="64008" marT="0" marB="0" anchor="ctr">
-                    <a:lnL w="6350" cap="flat" cmpd="sng" algn="ctr">
-                      <a:solidFill>
-                        <a:srgbClr val="D5DBE3"/>
-                      </a:solidFill>
-                      <a:prstDash val="solid"/>
-                      <a:round/>
-                      <a:headEnd type="none" w="med" len="med"/>
-                      <a:tailEnd type="none" w="med" len="med"/>
-                    </a:lnL>
-                    <a:lnR w="6350" cap="flat" cmpd="sng" algn="ctr">
-                      <a:solidFill>
-                        <a:srgbClr val="D5DBE3"/>
-                      </a:solidFill>
-                      <a:prstDash val="solid"/>
-                      <a:round/>
-                      <a:headEnd type="none" w="med" len="med"/>
-                      <a:tailEnd type="none" w="med" len="med"/>
-                    </a:lnR>
-                    <a:lnT w="6350" cap="flat" cmpd="sng" algn="ctr">
-                      <a:solidFill>
-                        <a:srgbClr val="D5DBE3"/>
-                      </a:solidFill>
-                      <a:prstDash val="solid"/>
-                      <a:round/>
-                      <a:headEnd type="none" w="med" len="med"/>
-                      <a:tailEnd type="none" w="med" len="med"/>
-                    </a:lnT>
-                    <a:lnB w="6350" cap="flat" cmpd="sng" algn="ctr">
-                      <a:solidFill>
-                        <a:srgbClr val="D5DBE3"/>
-                      </a:solidFill>
-                      <a:prstDash val="solid"/>
-                      <a:round/>
-                      <a:headEnd type="none" w="med" len="med"/>
-                      <a:tailEnd type="none" w="med" len="med"/>
-                    </a:lnB>
-                  </a:tcPr>
-                </a:tc>
-                <a:tc>
-                  <a:txBody>
-                    <a:bodyPr/>
-                    <a:lstStyle/>
-                    <a:p>
-                      <a:pPr algn="r" indent="0" marL="0">
-                        <a:buNone/>
-                      </a:pPr>
-                      <a:r>
-                        <a:rPr lang="en-US" sz="850" dirty="0">
-                          <a:solidFill>
-                            <a:srgbClr val="1F2933"/>
-                          </a:solidFill>
-                          <a:latin typeface="Calibri" pitchFamily="34" charset="0"/>
-                          <a:ea typeface="Calibri" pitchFamily="34" charset="-122"/>
-                          <a:cs typeface="Calibri" pitchFamily="34" charset="-120"/>
-                        </a:rPr>
-                        <a:t>-37,3</a:t>
-                      </a:r>
-                      <a:endParaRPr lang="en-US" sz="850" dirty="0">
-                        <a:latin typeface="Calibri" charset="0"/>
-                        <a:ea typeface="Calibri" charset="0"/>
-                        <a:cs typeface="Calibri" charset="0"/>
-                      </a:endParaRPr>
-                    </a:p>
-                  </a:txBody>
-                  <a:tcPr marL="64008" marR="64008" marT="0" marB="0" anchor="ctr">
-                    <a:lnL w="6350" cap="flat" cmpd="sng" algn="ctr">
-                      <a:solidFill>
-                        <a:srgbClr val="D5DBE3"/>
-                      </a:solidFill>
-                      <a:prstDash val="solid"/>
-                      <a:round/>
-                      <a:headEnd type="none" w="med" len="med"/>
-                      <a:tailEnd type="none" w="med" len="med"/>
-                    </a:lnL>
-                    <a:lnR w="6350" cap="flat" cmpd="sng" algn="ctr">
-                      <a:solidFill>
-                        <a:srgbClr val="D5DBE3"/>
-                      </a:solidFill>
-                      <a:prstDash val="solid"/>
-                      <a:round/>
-                      <a:headEnd type="none" w="med" len="med"/>
-                      <a:tailEnd type="none" w="med" len="med"/>
-                    </a:lnR>
-                    <a:lnT w="6350" cap="flat" cmpd="sng" algn="ctr">
-                      <a:solidFill>
-                        <a:srgbClr val="D5DBE3"/>
-                      </a:solidFill>
-                      <a:prstDash val="solid"/>
-                      <a:round/>
-                      <a:headEnd type="none" w="med" len="med"/>
-                      <a:tailEnd type="none" w="med" len="med"/>
-                    </a:lnT>
-                    <a:lnB w="6350" cap="flat" cmpd="sng" algn="ctr">
-                      <a:solidFill>
-                        <a:srgbClr val="D5DBE3"/>
-                      </a:solidFill>
-                      <a:prstDash val="solid"/>
-                      <a:round/>
-                      <a:headEnd type="none" w="med" len="med"/>
-                      <a:tailEnd type="none" w="med" len="med"/>
-                    </a:lnB>
-                  </a:tcPr>
-                </a:tc>
-                <a:tc>
-                  <a:txBody>
-                    <a:bodyPr/>
-                    <a:lstStyle/>
-                    <a:p>
-                      <a:pPr algn="r" indent="0" marL="0">
-                        <a:buNone/>
-                      </a:pPr>
-                      <a:r>
-                        <a:rPr lang="en-US" sz="850" dirty="0">
-                          <a:solidFill>
-                            <a:srgbClr val="1F2933"/>
-                          </a:solidFill>
-                          <a:latin typeface="Calibri" pitchFamily="34" charset="0"/>
-                          <a:ea typeface="Calibri" pitchFamily="34" charset="-122"/>
-                          <a:cs typeface="Calibri" pitchFamily="34" charset="-120"/>
-                        </a:rPr>
-                        <a:t>–</a:t>
-                      </a:r>
-                      <a:endParaRPr lang="en-US" sz="850" dirty="0">
-                        <a:latin typeface="Calibri" charset="0"/>
-                        <a:ea typeface="Calibri" charset="0"/>
-                        <a:cs typeface="Calibri" charset="0"/>
-                      </a:endParaRPr>
-                    </a:p>
-                  </a:txBody>
-                  <a:tcPr marL="64008" marR="64008" marT="0" marB="0" anchor="ctr">
-                    <a:lnL w="6350" cap="flat" cmpd="sng" algn="ctr">
-                      <a:solidFill>
-                        <a:srgbClr val="D5DBE3"/>
-                      </a:solidFill>
-                      <a:prstDash val="solid"/>
-                      <a:round/>
-                      <a:headEnd type="none" w="med" len="med"/>
-                      <a:tailEnd type="none" w="med" len="med"/>
-                    </a:lnL>
-                    <a:lnR w="6350" cap="flat" cmpd="sng" algn="ctr">
-                      <a:solidFill>
-                        <a:srgbClr val="D5DBE3"/>
-                      </a:solidFill>
-                      <a:prstDash val="solid"/>
-                      <a:round/>
-                      <a:headEnd type="none" w="med" len="med"/>
-                      <a:tailEnd type="none" w="med" len="med"/>
-                    </a:lnR>
-                    <a:lnT w="6350" cap="flat" cmpd="sng" algn="ctr">
-                      <a:solidFill>
-                        <a:srgbClr val="D5DBE3"/>
-                      </a:solidFill>
-                      <a:prstDash val="solid"/>
-                      <a:round/>
-                      <a:headEnd type="none" w="med" len="med"/>
-                      <a:tailEnd type="none" w="med" len="med"/>
-                    </a:lnT>
-                    <a:lnB w="6350" cap="flat" cmpd="sng" algn="ctr">
-                      <a:solidFill>
-                        <a:srgbClr val="D5DBE3"/>
-                      </a:solidFill>
-                      <a:prstDash val="solid"/>
-                      <a:round/>
-                      <a:headEnd type="none" w="med" len="med"/>
-                      <a:tailEnd type="none" w="med" len="med"/>
-                    </a:lnB>
-                  </a:tcPr>
-                </a:tc>
-                <a:tc>
-                  <a:txBody>
-                    <a:bodyPr/>
-                    <a:lstStyle/>
-                    <a:p>
-                      <a:pPr algn="r" indent="0" marL="0">
-                        <a:buNone/>
-                      </a:pPr>
-                      <a:r>
-                        <a:rPr lang="en-US" sz="850" b="1" dirty="0">
-                          <a:solidFill>
                             <a:srgbClr val="B3261E"/>
                           </a:solidFill>
                           <a:latin typeface="Calibri" pitchFamily="34" charset="0"/>
                           <a:ea typeface="Calibri" pitchFamily="34" charset="-122"/>
                           <a:cs typeface="Calibri" pitchFamily="34" charset="-120"/>
                         </a:rPr>
-                        <a:t>-25,6</a:t>
+                        <a:t>25,6</a:t>
                       </a:r>
                       <a:endParaRPr lang="en-US" sz="850" dirty="0">
                         <a:latin typeface="Calibri" charset="0"/>
@@ -24911,6 +24976,73 @@
                     </a:solidFill>
                   </a:tcPr>
                 </a:tc>
+              </a:tr>
+              <a:tr h="224028">
+                <a:tc>
+                  <a:txBody>
+                    <a:bodyPr/>
+                    <a:lstStyle/>
+                    <a:p>
+                      <a:pPr algn="l" indent="0" marL="0">
+                        <a:buNone/>
+                      </a:pPr>
+                      <a:r>
+                        <a:rPr lang="en-US" sz="850" b="1" dirty="0">
+                          <a:solidFill>
+                            <a:srgbClr val="1F2933"/>
+                          </a:solidFill>
+                          <a:latin typeface="Calibri" pitchFamily="34" charset="0"/>
+                          <a:ea typeface="Calibri" pitchFamily="34" charset="-122"/>
+                          <a:cs typeface="Calibri" pitchFamily="34" charset="-120"/>
+                        </a:rPr>
+                        <a:t>FINAFRICA</a:t>
+                      </a:r>
+                      <a:endParaRPr lang="en-US" sz="850" dirty="0">
+                        <a:latin typeface="Calibri" charset="0"/>
+                        <a:ea typeface="Calibri" charset="0"/>
+                        <a:cs typeface="Calibri" charset="0"/>
+                      </a:endParaRPr>
+                    </a:p>
+                  </a:txBody>
+                  <a:tcPr marL="64008" marR="64008" marT="0" marB="0" anchor="ctr">
+                    <a:lnL w="6350" cap="flat" cmpd="sng" algn="ctr">
+                      <a:solidFill>
+                        <a:srgbClr val="D5DBE3"/>
+                      </a:solidFill>
+                      <a:prstDash val="solid"/>
+                      <a:round/>
+                      <a:headEnd type="none" w="med" len="med"/>
+                      <a:tailEnd type="none" w="med" len="med"/>
+                    </a:lnL>
+                    <a:lnR w="6350" cap="flat" cmpd="sng" algn="ctr">
+                      <a:solidFill>
+                        <a:srgbClr val="D5DBE3"/>
+                      </a:solidFill>
+                      <a:prstDash val="solid"/>
+                      <a:round/>
+                      <a:headEnd type="none" w="med" len="med"/>
+                      <a:tailEnd type="none" w="med" len="med"/>
+                    </a:lnR>
+                    <a:lnT w="6350" cap="flat" cmpd="sng" algn="ctr">
+                      <a:solidFill>
+                        <a:srgbClr val="D5DBE3"/>
+                      </a:solidFill>
+                      <a:prstDash val="solid"/>
+                      <a:round/>
+                      <a:headEnd type="none" w="med" len="med"/>
+                      <a:tailEnd type="none" w="med" len="med"/>
+                    </a:lnT>
+                    <a:lnB w="6350" cap="flat" cmpd="sng" algn="ctr">
+                      <a:solidFill>
+                        <a:srgbClr val="D5DBE3"/>
+                      </a:solidFill>
+                      <a:prstDash val="solid"/>
+                      <a:round/>
+                      <a:headEnd type="none" w="med" len="med"/>
+                      <a:tailEnd type="none" w="med" len="med"/>
+                    </a:lnB>
+                  </a:tcPr>
+                </a:tc>
                 <a:tc>
                   <a:txBody>
                     <a:bodyPr/>
@@ -24920,6 +25052,201 @@
                         <a:buNone/>
                       </a:pPr>
                       <a:r>
+                        <a:rPr lang="en-US" sz="850" dirty="0">
+                          <a:solidFill>
+                            <a:srgbClr val="1F2933"/>
+                          </a:solidFill>
+                          <a:latin typeface="Calibri" pitchFamily="34" charset="0"/>
+                          <a:ea typeface="Calibri" pitchFamily="34" charset="-122"/>
+                          <a:cs typeface="Calibri" pitchFamily="34" charset="-120"/>
+                        </a:rPr>
+                        <a:t>35,1</a:t>
+                      </a:r>
+                      <a:endParaRPr lang="en-US" sz="850" dirty="0">
+                        <a:latin typeface="Calibri" charset="0"/>
+                        <a:ea typeface="Calibri" charset="0"/>
+                        <a:cs typeface="Calibri" charset="0"/>
+                      </a:endParaRPr>
+                    </a:p>
+                  </a:txBody>
+                  <a:tcPr marL="64008" marR="64008" marT="0" marB="0" anchor="ctr">
+                    <a:lnL w="6350" cap="flat" cmpd="sng" algn="ctr">
+                      <a:solidFill>
+                        <a:srgbClr val="D5DBE3"/>
+                      </a:solidFill>
+                      <a:prstDash val="solid"/>
+                      <a:round/>
+                      <a:headEnd type="none" w="med" len="med"/>
+                      <a:tailEnd type="none" w="med" len="med"/>
+                    </a:lnL>
+                    <a:lnR w="6350" cap="flat" cmpd="sng" algn="ctr">
+                      <a:solidFill>
+                        <a:srgbClr val="D5DBE3"/>
+                      </a:solidFill>
+                      <a:prstDash val="solid"/>
+                      <a:round/>
+                      <a:headEnd type="none" w="med" len="med"/>
+                      <a:tailEnd type="none" w="med" len="med"/>
+                    </a:lnR>
+                    <a:lnT w="6350" cap="flat" cmpd="sng" algn="ctr">
+                      <a:solidFill>
+                        <a:srgbClr val="D5DBE3"/>
+                      </a:solidFill>
+                      <a:prstDash val="solid"/>
+                      <a:round/>
+                      <a:headEnd type="none" w="med" len="med"/>
+                      <a:tailEnd type="none" w="med" len="med"/>
+                    </a:lnT>
+                    <a:lnB w="6350" cap="flat" cmpd="sng" algn="ctr">
+                      <a:solidFill>
+                        <a:srgbClr val="D5DBE3"/>
+                      </a:solidFill>
+                      <a:prstDash val="solid"/>
+                      <a:round/>
+                      <a:headEnd type="none" w="med" len="med"/>
+                      <a:tailEnd type="none" w="med" len="med"/>
+                    </a:lnB>
+                  </a:tcPr>
+                </a:tc>
+                <a:tc>
+                  <a:txBody>
+                    <a:bodyPr/>
+                    <a:lstStyle/>
+                    <a:p>
+                      <a:pPr algn="r" indent="0" marL="0">
+                        <a:buNone/>
+                      </a:pPr>
+                      <a:r>
+                        <a:rPr lang="en-US" sz="850" dirty="0">
+                          <a:solidFill>
+                            <a:srgbClr val="1F2933"/>
+                          </a:solidFill>
+                          <a:latin typeface="Calibri" pitchFamily="34" charset="0"/>
+                          <a:ea typeface="Calibri" pitchFamily="34" charset="-122"/>
+                          <a:cs typeface="Calibri" pitchFamily="34" charset="-120"/>
+                        </a:rPr>
+                        <a:t>-175,2</a:t>
+                      </a:r>
+                      <a:endParaRPr lang="en-US" sz="850" dirty="0">
+                        <a:latin typeface="Calibri" charset="0"/>
+                        <a:ea typeface="Calibri" charset="0"/>
+                        <a:cs typeface="Calibri" charset="0"/>
+                      </a:endParaRPr>
+                    </a:p>
+                  </a:txBody>
+                  <a:tcPr marL="64008" marR="64008" marT="0" marB="0" anchor="ctr">
+                    <a:lnL w="6350" cap="flat" cmpd="sng" algn="ctr">
+                      <a:solidFill>
+                        <a:srgbClr val="D5DBE3"/>
+                      </a:solidFill>
+                      <a:prstDash val="solid"/>
+                      <a:round/>
+                      <a:headEnd type="none" w="med" len="med"/>
+                      <a:tailEnd type="none" w="med" len="med"/>
+                    </a:lnL>
+                    <a:lnR w="6350" cap="flat" cmpd="sng" algn="ctr">
+                      <a:solidFill>
+                        <a:srgbClr val="D5DBE3"/>
+                      </a:solidFill>
+                      <a:prstDash val="solid"/>
+                      <a:round/>
+                      <a:headEnd type="none" w="med" len="med"/>
+                      <a:tailEnd type="none" w="med" len="med"/>
+                    </a:lnR>
+                    <a:lnT w="6350" cap="flat" cmpd="sng" algn="ctr">
+                      <a:solidFill>
+                        <a:srgbClr val="D5DBE3"/>
+                      </a:solidFill>
+                      <a:prstDash val="solid"/>
+                      <a:round/>
+                      <a:headEnd type="none" w="med" len="med"/>
+                      <a:tailEnd type="none" w="med" len="med"/>
+                    </a:lnT>
+                    <a:lnB w="6350" cap="flat" cmpd="sng" algn="ctr">
+                      <a:solidFill>
+                        <a:srgbClr val="D5DBE3"/>
+                      </a:solidFill>
+                      <a:prstDash val="solid"/>
+                      <a:round/>
+                      <a:headEnd type="none" w="med" len="med"/>
+                      <a:tailEnd type="none" w="med" len="med"/>
+                    </a:lnB>
+                  </a:tcPr>
+                </a:tc>
+                <a:tc>
+                  <a:txBody>
+                    <a:bodyPr/>
+                    <a:lstStyle/>
+                    <a:p>
+                      <a:pPr algn="r" indent="0" marL="0">
+                        <a:buNone/>
+                      </a:pPr>
+                      <a:r>
+                        <a:rPr lang="en-US" sz="850" dirty="0">
+                          <a:solidFill>
+                            <a:srgbClr val="1F2933"/>
+                          </a:solidFill>
+                          <a:latin typeface="Calibri" pitchFamily="34" charset="0"/>
+                          <a:ea typeface="Calibri" pitchFamily="34" charset="-122"/>
+                          <a:cs typeface="Calibri" pitchFamily="34" charset="-120"/>
+                        </a:rPr>
+                        <a:t>–</a:t>
+                      </a:r>
+                      <a:endParaRPr lang="en-US" sz="850" dirty="0">
+                        <a:latin typeface="Calibri" charset="0"/>
+                        <a:ea typeface="Calibri" charset="0"/>
+                        <a:cs typeface="Calibri" charset="0"/>
+                      </a:endParaRPr>
+                    </a:p>
+                  </a:txBody>
+                  <a:tcPr marL="64008" marR="64008" marT="0" marB="0" anchor="ctr">
+                    <a:lnL w="6350" cap="flat" cmpd="sng" algn="ctr">
+                      <a:solidFill>
+                        <a:srgbClr val="D5DBE3"/>
+                      </a:solidFill>
+                      <a:prstDash val="solid"/>
+                      <a:round/>
+                      <a:headEnd type="none" w="med" len="med"/>
+                      <a:tailEnd type="none" w="med" len="med"/>
+                    </a:lnL>
+                    <a:lnR w="6350" cap="flat" cmpd="sng" algn="ctr">
+                      <a:solidFill>
+                        <a:srgbClr val="D5DBE3"/>
+                      </a:solidFill>
+                      <a:prstDash val="solid"/>
+                      <a:round/>
+                      <a:headEnd type="none" w="med" len="med"/>
+                      <a:tailEnd type="none" w="med" len="med"/>
+                    </a:lnR>
+                    <a:lnT w="6350" cap="flat" cmpd="sng" algn="ctr">
+                      <a:solidFill>
+                        <a:srgbClr val="D5DBE3"/>
+                      </a:solidFill>
+                      <a:prstDash val="solid"/>
+                      <a:round/>
+                      <a:headEnd type="none" w="med" len="med"/>
+                      <a:tailEnd type="none" w="med" len="med"/>
+                    </a:lnT>
+                    <a:lnB w="6350" cap="flat" cmpd="sng" algn="ctr">
+                      <a:solidFill>
+                        <a:srgbClr val="D5DBE3"/>
+                      </a:solidFill>
+                      <a:prstDash val="solid"/>
+                      <a:round/>
+                      <a:headEnd type="none" w="med" len="med"/>
+                      <a:tailEnd type="none" w="med" len="med"/>
+                    </a:lnB>
+                  </a:tcPr>
+                </a:tc>
+                <a:tc>
+                  <a:txBody>
+                    <a:bodyPr/>
+                    <a:lstStyle/>
+                    <a:p>
+                      <a:pPr algn="r" indent="0" marL="0">
+                        <a:buNone/>
+                      </a:pPr>
+                      <a:r>
                         <a:rPr lang="en-US" sz="850" b="1" dirty="0">
                           <a:solidFill>
                             <a:srgbClr val="B3261E"/>
@@ -24928,7 +25255,7 @@
                           <a:ea typeface="Calibri" pitchFamily="34" charset="-122"/>
                           <a:cs typeface="Calibri" pitchFamily="34" charset="-120"/>
                         </a:rPr>
-                        <a:t>25,6</a:t>
+                        <a:t>-140,1</a:t>
                       </a:r>
                       <a:endParaRPr lang="en-US" sz="850" dirty="0">
                         <a:latin typeface="Calibri" charset="0"/>
@@ -24979,286 +25306,24 @@
                     </a:solidFill>
                   </a:tcPr>
                 </a:tc>
-              </a:tr>
-              <a:tr h="224028">
-                <a:tc>
-                  <a:txBody>
-                    <a:bodyPr/>
-                    <a:lstStyle/>
-                    <a:p>
-                      <a:pPr algn="l" indent="0" marL="0">
+                <a:tc>
+                  <a:txBody>
+                    <a:bodyPr/>
+                    <a:lstStyle/>
+                    <a:p>
+                      <a:pPr algn="r" indent="0" marL="0">
                         <a:buNone/>
                       </a:pPr>
                       <a:r>
                         <a:rPr lang="en-US" sz="850" b="1" dirty="0">
                           <a:solidFill>
-                            <a:srgbClr val="1F2933"/>
-                          </a:solidFill>
-                          <a:latin typeface="Calibri" pitchFamily="34" charset="0"/>
-                          <a:ea typeface="Calibri" pitchFamily="34" charset="-122"/>
-                          <a:cs typeface="Calibri" pitchFamily="34" charset="-120"/>
-                        </a:rPr>
-                        <a:t>FINAFRICA</a:t>
-                      </a:r>
-                      <a:endParaRPr lang="en-US" sz="850" dirty="0">
-                        <a:latin typeface="Calibri" charset="0"/>
-                        <a:ea typeface="Calibri" charset="0"/>
-                        <a:cs typeface="Calibri" charset="0"/>
-                      </a:endParaRPr>
-                    </a:p>
-                  </a:txBody>
-                  <a:tcPr marL="64008" marR="64008" marT="0" marB="0" anchor="ctr">
-                    <a:lnL w="6350" cap="flat" cmpd="sng" algn="ctr">
-                      <a:solidFill>
-                        <a:srgbClr val="D5DBE3"/>
-                      </a:solidFill>
-                      <a:prstDash val="solid"/>
-                      <a:round/>
-                      <a:headEnd type="none" w="med" len="med"/>
-                      <a:tailEnd type="none" w="med" len="med"/>
-                    </a:lnL>
-                    <a:lnR w="6350" cap="flat" cmpd="sng" algn="ctr">
-                      <a:solidFill>
-                        <a:srgbClr val="D5DBE3"/>
-                      </a:solidFill>
-                      <a:prstDash val="solid"/>
-                      <a:round/>
-                      <a:headEnd type="none" w="med" len="med"/>
-                      <a:tailEnd type="none" w="med" len="med"/>
-                    </a:lnR>
-                    <a:lnT w="6350" cap="flat" cmpd="sng" algn="ctr">
-                      <a:solidFill>
-                        <a:srgbClr val="D5DBE3"/>
-                      </a:solidFill>
-                      <a:prstDash val="solid"/>
-                      <a:round/>
-                      <a:headEnd type="none" w="med" len="med"/>
-                      <a:tailEnd type="none" w="med" len="med"/>
-                    </a:lnT>
-                    <a:lnB w="6350" cap="flat" cmpd="sng" algn="ctr">
-                      <a:solidFill>
-                        <a:srgbClr val="D5DBE3"/>
-                      </a:solidFill>
-                      <a:prstDash val="solid"/>
-                      <a:round/>
-                      <a:headEnd type="none" w="med" len="med"/>
-                      <a:tailEnd type="none" w="med" len="med"/>
-                    </a:lnB>
-                  </a:tcPr>
-                </a:tc>
-                <a:tc>
-                  <a:txBody>
-                    <a:bodyPr/>
-                    <a:lstStyle/>
-                    <a:p>
-                      <a:pPr algn="r" indent="0" marL="0">
-                        <a:buNone/>
-                      </a:pPr>
-                      <a:r>
-                        <a:rPr lang="en-US" sz="850" dirty="0">
-                          <a:solidFill>
-                            <a:srgbClr val="1F2933"/>
-                          </a:solidFill>
-                          <a:latin typeface="Calibri" pitchFamily="34" charset="0"/>
-                          <a:ea typeface="Calibri" pitchFamily="34" charset="-122"/>
-                          <a:cs typeface="Calibri" pitchFamily="34" charset="-120"/>
-                        </a:rPr>
-                        <a:t>35,1</a:t>
-                      </a:r>
-                      <a:endParaRPr lang="en-US" sz="850" dirty="0">
-                        <a:latin typeface="Calibri" charset="0"/>
-                        <a:ea typeface="Calibri" charset="0"/>
-                        <a:cs typeface="Calibri" charset="0"/>
-                      </a:endParaRPr>
-                    </a:p>
-                  </a:txBody>
-                  <a:tcPr marL="64008" marR="64008" marT="0" marB="0" anchor="ctr">
-                    <a:lnL w="6350" cap="flat" cmpd="sng" algn="ctr">
-                      <a:solidFill>
-                        <a:srgbClr val="D5DBE3"/>
-                      </a:solidFill>
-                      <a:prstDash val="solid"/>
-                      <a:round/>
-                      <a:headEnd type="none" w="med" len="med"/>
-                      <a:tailEnd type="none" w="med" len="med"/>
-                    </a:lnL>
-                    <a:lnR w="6350" cap="flat" cmpd="sng" algn="ctr">
-                      <a:solidFill>
-                        <a:srgbClr val="D5DBE3"/>
-                      </a:solidFill>
-                      <a:prstDash val="solid"/>
-                      <a:round/>
-                      <a:headEnd type="none" w="med" len="med"/>
-                      <a:tailEnd type="none" w="med" len="med"/>
-                    </a:lnR>
-                    <a:lnT w="6350" cap="flat" cmpd="sng" algn="ctr">
-                      <a:solidFill>
-                        <a:srgbClr val="D5DBE3"/>
-                      </a:solidFill>
-                      <a:prstDash val="solid"/>
-                      <a:round/>
-                      <a:headEnd type="none" w="med" len="med"/>
-                      <a:tailEnd type="none" w="med" len="med"/>
-                    </a:lnT>
-                    <a:lnB w="6350" cap="flat" cmpd="sng" algn="ctr">
-                      <a:solidFill>
-                        <a:srgbClr val="D5DBE3"/>
-                      </a:solidFill>
-                      <a:prstDash val="solid"/>
-                      <a:round/>
-                      <a:headEnd type="none" w="med" len="med"/>
-                      <a:tailEnd type="none" w="med" len="med"/>
-                    </a:lnB>
-                  </a:tcPr>
-                </a:tc>
-                <a:tc>
-                  <a:txBody>
-                    <a:bodyPr/>
-                    <a:lstStyle/>
-                    <a:p>
-                      <a:pPr algn="r" indent="0" marL="0">
-                        <a:buNone/>
-                      </a:pPr>
-                      <a:r>
-                        <a:rPr lang="en-US" sz="850" dirty="0">
-                          <a:solidFill>
-                            <a:srgbClr val="1F2933"/>
-                          </a:solidFill>
-                          <a:latin typeface="Calibri" pitchFamily="34" charset="0"/>
-                          <a:ea typeface="Calibri" pitchFamily="34" charset="-122"/>
-                          <a:cs typeface="Calibri" pitchFamily="34" charset="-120"/>
-                        </a:rPr>
-                        <a:t>-175,2</a:t>
-                      </a:r>
-                      <a:endParaRPr lang="en-US" sz="850" dirty="0">
-                        <a:latin typeface="Calibri" charset="0"/>
-                        <a:ea typeface="Calibri" charset="0"/>
-                        <a:cs typeface="Calibri" charset="0"/>
-                      </a:endParaRPr>
-                    </a:p>
-                  </a:txBody>
-                  <a:tcPr marL="64008" marR="64008" marT="0" marB="0" anchor="ctr">
-                    <a:lnL w="6350" cap="flat" cmpd="sng" algn="ctr">
-                      <a:solidFill>
-                        <a:srgbClr val="D5DBE3"/>
-                      </a:solidFill>
-                      <a:prstDash val="solid"/>
-                      <a:round/>
-                      <a:headEnd type="none" w="med" len="med"/>
-                      <a:tailEnd type="none" w="med" len="med"/>
-                    </a:lnL>
-                    <a:lnR w="6350" cap="flat" cmpd="sng" algn="ctr">
-                      <a:solidFill>
-                        <a:srgbClr val="D5DBE3"/>
-                      </a:solidFill>
-                      <a:prstDash val="solid"/>
-                      <a:round/>
-                      <a:headEnd type="none" w="med" len="med"/>
-                      <a:tailEnd type="none" w="med" len="med"/>
-                    </a:lnR>
-                    <a:lnT w="6350" cap="flat" cmpd="sng" algn="ctr">
-                      <a:solidFill>
-                        <a:srgbClr val="D5DBE3"/>
-                      </a:solidFill>
-                      <a:prstDash val="solid"/>
-                      <a:round/>
-                      <a:headEnd type="none" w="med" len="med"/>
-                      <a:tailEnd type="none" w="med" len="med"/>
-                    </a:lnT>
-                    <a:lnB w="6350" cap="flat" cmpd="sng" algn="ctr">
-                      <a:solidFill>
-                        <a:srgbClr val="D5DBE3"/>
-                      </a:solidFill>
-                      <a:prstDash val="solid"/>
-                      <a:round/>
-                      <a:headEnd type="none" w="med" len="med"/>
-                      <a:tailEnd type="none" w="med" len="med"/>
-                    </a:lnB>
-                  </a:tcPr>
-                </a:tc>
-                <a:tc>
-                  <a:txBody>
-                    <a:bodyPr/>
-                    <a:lstStyle/>
-                    <a:p>
-                      <a:pPr algn="r" indent="0" marL="0">
-                        <a:buNone/>
-                      </a:pPr>
-                      <a:r>
-                        <a:rPr lang="en-US" sz="850" dirty="0">
-                          <a:solidFill>
-                            <a:srgbClr val="1F2933"/>
-                          </a:solidFill>
-                          <a:latin typeface="Calibri" pitchFamily="34" charset="0"/>
-                          <a:ea typeface="Calibri" pitchFamily="34" charset="-122"/>
-                          <a:cs typeface="Calibri" pitchFamily="34" charset="-120"/>
-                        </a:rPr>
-                        <a:t>–</a:t>
-                      </a:r>
-                      <a:endParaRPr lang="en-US" sz="850" dirty="0">
-                        <a:latin typeface="Calibri" charset="0"/>
-                        <a:ea typeface="Calibri" charset="0"/>
-                        <a:cs typeface="Calibri" charset="0"/>
-                      </a:endParaRPr>
-                    </a:p>
-                  </a:txBody>
-                  <a:tcPr marL="64008" marR="64008" marT="0" marB="0" anchor="ctr">
-                    <a:lnL w="6350" cap="flat" cmpd="sng" algn="ctr">
-                      <a:solidFill>
-                        <a:srgbClr val="D5DBE3"/>
-                      </a:solidFill>
-                      <a:prstDash val="solid"/>
-                      <a:round/>
-                      <a:headEnd type="none" w="med" len="med"/>
-                      <a:tailEnd type="none" w="med" len="med"/>
-                    </a:lnL>
-                    <a:lnR w="6350" cap="flat" cmpd="sng" algn="ctr">
-                      <a:solidFill>
-                        <a:srgbClr val="D5DBE3"/>
-                      </a:solidFill>
-                      <a:prstDash val="solid"/>
-                      <a:round/>
-                      <a:headEnd type="none" w="med" len="med"/>
-                      <a:tailEnd type="none" w="med" len="med"/>
-                    </a:lnR>
-                    <a:lnT w="6350" cap="flat" cmpd="sng" algn="ctr">
-                      <a:solidFill>
-                        <a:srgbClr val="D5DBE3"/>
-                      </a:solidFill>
-                      <a:prstDash val="solid"/>
-                      <a:round/>
-                      <a:headEnd type="none" w="med" len="med"/>
-                      <a:tailEnd type="none" w="med" len="med"/>
-                    </a:lnT>
-                    <a:lnB w="6350" cap="flat" cmpd="sng" algn="ctr">
-                      <a:solidFill>
-                        <a:srgbClr val="D5DBE3"/>
-                      </a:solidFill>
-                      <a:prstDash val="solid"/>
-                      <a:round/>
-                      <a:headEnd type="none" w="med" len="med"/>
-                      <a:tailEnd type="none" w="med" len="med"/>
-                    </a:lnB>
-                  </a:tcPr>
-                </a:tc>
-                <a:tc>
-                  <a:txBody>
-                    <a:bodyPr/>
-                    <a:lstStyle/>
-                    <a:p>
-                      <a:pPr algn="r" indent="0" marL="0">
-                        <a:buNone/>
-                      </a:pPr>
-                      <a:r>
-                        <a:rPr lang="en-US" sz="850" b="1" dirty="0">
-                          <a:solidFill>
                             <a:srgbClr val="B3261E"/>
                           </a:solidFill>
                           <a:latin typeface="Calibri" pitchFamily="34" charset="0"/>
                           <a:ea typeface="Calibri" pitchFamily="34" charset="-122"/>
                           <a:cs typeface="Calibri" pitchFamily="34" charset="-120"/>
                         </a:rPr>
-                        <a:t>-140,1</a:t>
+                        <a:t>140,2</a:t>
                       </a:r>
                       <a:endParaRPr lang="en-US" sz="850" dirty="0">
                         <a:latin typeface="Calibri" charset="0"/>
@@ -25309,6 +25374,73 @@
                     </a:solidFill>
                   </a:tcPr>
                 </a:tc>
+              </a:tr>
+              <a:tr h="224028">
+                <a:tc>
+                  <a:txBody>
+                    <a:bodyPr/>
+                    <a:lstStyle/>
+                    <a:p>
+                      <a:pPr algn="l" indent="0" marL="0">
+                        <a:buNone/>
+                      </a:pPr>
+                      <a:r>
+                        <a:rPr lang="en-US" sz="850" b="1" dirty="0">
+                          <a:solidFill>
+                            <a:srgbClr val="1F2933"/>
+                          </a:solidFill>
+                          <a:latin typeface="Calibri" pitchFamily="34" charset="0"/>
+                          <a:ea typeface="Calibri" pitchFamily="34" charset="-122"/>
+                          <a:cs typeface="Calibri" pitchFamily="34" charset="-120"/>
+                        </a:rPr>
+                        <a:t>INFI</a:t>
+                      </a:r>
+                      <a:endParaRPr lang="en-US" sz="850" dirty="0">
+                        <a:latin typeface="Calibri" charset="0"/>
+                        <a:ea typeface="Calibri" charset="0"/>
+                        <a:cs typeface="Calibri" charset="0"/>
+                      </a:endParaRPr>
+                    </a:p>
+                  </a:txBody>
+                  <a:tcPr marL="64008" marR="64008" marT="0" marB="0" anchor="ctr">
+                    <a:lnL w="6350" cap="flat" cmpd="sng" algn="ctr">
+                      <a:solidFill>
+                        <a:srgbClr val="D5DBE3"/>
+                      </a:solidFill>
+                      <a:prstDash val="solid"/>
+                      <a:round/>
+                      <a:headEnd type="none" w="med" len="med"/>
+                      <a:tailEnd type="none" w="med" len="med"/>
+                    </a:lnL>
+                    <a:lnR w="6350" cap="flat" cmpd="sng" algn="ctr">
+                      <a:solidFill>
+                        <a:srgbClr val="D5DBE3"/>
+                      </a:solidFill>
+                      <a:prstDash val="solid"/>
+                      <a:round/>
+                      <a:headEnd type="none" w="med" len="med"/>
+                      <a:tailEnd type="none" w="med" len="med"/>
+                    </a:lnR>
+                    <a:lnT w="6350" cap="flat" cmpd="sng" algn="ctr">
+                      <a:solidFill>
+                        <a:srgbClr val="D5DBE3"/>
+                      </a:solidFill>
+                      <a:prstDash val="solid"/>
+                      <a:round/>
+                      <a:headEnd type="none" w="med" len="med"/>
+                      <a:tailEnd type="none" w="med" len="med"/>
+                    </a:lnT>
+                    <a:lnB w="6350" cap="flat" cmpd="sng" algn="ctr">
+                      <a:solidFill>
+                        <a:srgbClr val="D5DBE3"/>
+                      </a:solidFill>
+                      <a:prstDash val="solid"/>
+                      <a:round/>
+                      <a:headEnd type="none" w="med" len="med"/>
+                      <a:tailEnd type="none" w="med" len="med"/>
+                    </a:lnB>
+                  </a:tcPr>
+                </a:tc>
                 <a:tc>
                   <a:txBody>
                     <a:bodyPr/>
@@ -25318,15 +25450,602 @@
                         <a:buNone/>
                       </a:pPr>
                       <a:r>
+                        <a:rPr lang="en-US" sz="850" dirty="0">
+                          <a:solidFill>
+                            <a:srgbClr val="1F2933"/>
+                          </a:solidFill>
+                          <a:latin typeface="Calibri" pitchFamily="34" charset="0"/>
+                          <a:ea typeface="Calibri" pitchFamily="34" charset="-122"/>
+                          <a:cs typeface="Calibri" pitchFamily="34" charset="-120"/>
+                        </a:rPr>
+                        <a:t>2,8</a:t>
+                      </a:r>
+                      <a:endParaRPr lang="en-US" sz="850" dirty="0">
+                        <a:latin typeface="Calibri" charset="0"/>
+                        <a:ea typeface="Calibri" charset="0"/>
+                        <a:cs typeface="Calibri" charset="0"/>
+                      </a:endParaRPr>
+                    </a:p>
+                  </a:txBody>
+                  <a:tcPr marL="64008" marR="64008" marT="0" marB="0" anchor="ctr">
+                    <a:lnL w="6350" cap="flat" cmpd="sng" algn="ctr">
+                      <a:solidFill>
+                        <a:srgbClr val="D5DBE3"/>
+                      </a:solidFill>
+                      <a:prstDash val="solid"/>
+                      <a:round/>
+                      <a:headEnd type="none" w="med" len="med"/>
+                      <a:tailEnd type="none" w="med" len="med"/>
+                    </a:lnL>
+                    <a:lnR w="6350" cap="flat" cmpd="sng" algn="ctr">
+                      <a:solidFill>
+                        <a:srgbClr val="D5DBE3"/>
+                      </a:solidFill>
+                      <a:prstDash val="solid"/>
+                      <a:round/>
+                      <a:headEnd type="none" w="med" len="med"/>
+                      <a:tailEnd type="none" w="med" len="med"/>
+                    </a:lnR>
+                    <a:lnT w="6350" cap="flat" cmpd="sng" algn="ctr">
+                      <a:solidFill>
+                        <a:srgbClr val="D5DBE3"/>
+                      </a:solidFill>
+                      <a:prstDash val="solid"/>
+                      <a:round/>
+                      <a:headEnd type="none" w="med" len="med"/>
+                      <a:tailEnd type="none" w="med" len="med"/>
+                    </a:lnT>
+                    <a:lnB w="6350" cap="flat" cmpd="sng" algn="ctr">
+                      <a:solidFill>
+                        <a:srgbClr val="D5DBE3"/>
+                      </a:solidFill>
+                      <a:prstDash val="solid"/>
+                      <a:round/>
+                      <a:headEnd type="none" w="med" len="med"/>
+                      <a:tailEnd type="none" w="med" len="med"/>
+                    </a:lnB>
+                  </a:tcPr>
+                </a:tc>
+                <a:tc>
+                  <a:txBody>
+                    <a:bodyPr/>
+                    <a:lstStyle/>
+                    <a:p>
+                      <a:pPr algn="r" indent="0" marL="0">
+                        <a:buNone/>
+                      </a:pPr>
+                      <a:r>
+                        <a:rPr lang="en-US" sz="850" dirty="0">
+                          <a:solidFill>
+                            <a:srgbClr val="1F2933"/>
+                          </a:solidFill>
+                          <a:latin typeface="Calibri" pitchFamily="34" charset="0"/>
+                          <a:ea typeface="Calibri" pitchFamily="34" charset="-122"/>
+                          <a:cs typeface="Calibri" pitchFamily="34" charset="-120"/>
+                        </a:rPr>
+                        <a:t>–</a:t>
+                      </a:r>
+                      <a:endParaRPr lang="en-US" sz="850" dirty="0">
+                        <a:latin typeface="Calibri" charset="0"/>
+                        <a:ea typeface="Calibri" charset="0"/>
+                        <a:cs typeface="Calibri" charset="0"/>
+                      </a:endParaRPr>
+                    </a:p>
+                  </a:txBody>
+                  <a:tcPr marL="64008" marR="64008" marT="0" marB="0" anchor="ctr">
+                    <a:lnL w="6350" cap="flat" cmpd="sng" algn="ctr">
+                      <a:solidFill>
+                        <a:srgbClr val="D5DBE3"/>
+                      </a:solidFill>
+                      <a:prstDash val="solid"/>
+                      <a:round/>
+                      <a:headEnd type="none" w="med" len="med"/>
+                      <a:tailEnd type="none" w="med" len="med"/>
+                    </a:lnL>
+                    <a:lnR w="6350" cap="flat" cmpd="sng" algn="ctr">
+                      <a:solidFill>
+                        <a:srgbClr val="D5DBE3"/>
+                      </a:solidFill>
+                      <a:prstDash val="solid"/>
+                      <a:round/>
+                      <a:headEnd type="none" w="med" len="med"/>
+                      <a:tailEnd type="none" w="med" len="med"/>
+                    </a:lnR>
+                    <a:lnT w="6350" cap="flat" cmpd="sng" algn="ctr">
+                      <a:solidFill>
+                        <a:srgbClr val="D5DBE3"/>
+                      </a:solidFill>
+                      <a:prstDash val="solid"/>
+                      <a:round/>
+                      <a:headEnd type="none" w="med" len="med"/>
+                      <a:tailEnd type="none" w="med" len="med"/>
+                    </a:lnT>
+                    <a:lnB w="6350" cap="flat" cmpd="sng" algn="ctr">
+                      <a:solidFill>
+                        <a:srgbClr val="D5DBE3"/>
+                      </a:solidFill>
+                      <a:prstDash val="solid"/>
+                      <a:round/>
+                      <a:headEnd type="none" w="med" len="med"/>
+                      <a:tailEnd type="none" w="med" len="med"/>
+                    </a:lnB>
+                  </a:tcPr>
+                </a:tc>
+                <a:tc>
+                  <a:txBody>
+                    <a:bodyPr/>
+                    <a:lstStyle/>
+                    <a:p>
+                      <a:pPr algn="r" indent="0" marL="0">
+                        <a:buNone/>
+                      </a:pPr>
+                      <a:r>
+                        <a:rPr lang="en-US" sz="850" dirty="0">
+                          <a:solidFill>
+                            <a:srgbClr val="1F2933"/>
+                          </a:solidFill>
+                          <a:latin typeface="Calibri" pitchFamily="34" charset="0"/>
+                          <a:ea typeface="Calibri" pitchFamily="34" charset="-122"/>
+                          <a:cs typeface="Calibri" pitchFamily="34" charset="-120"/>
+                        </a:rPr>
+                        <a:t>–</a:t>
+                      </a:r>
+                      <a:endParaRPr lang="en-US" sz="850" dirty="0">
+                        <a:latin typeface="Calibri" charset="0"/>
+                        <a:ea typeface="Calibri" charset="0"/>
+                        <a:cs typeface="Calibri" charset="0"/>
+                      </a:endParaRPr>
+                    </a:p>
+                  </a:txBody>
+                  <a:tcPr marL="64008" marR="64008" marT="0" marB="0" anchor="ctr">
+                    <a:lnL w="6350" cap="flat" cmpd="sng" algn="ctr">
+                      <a:solidFill>
+                        <a:srgbClr val="D5DBE3"/>
+                      </a:solidFill>
+                      <a:prstDash val="solid"/>
+                      <a:round/>
+                      <a:headEnd type="none" w="med" len="med"/>
+                      <a:tailEnd type="none" w="med" len="med"/>
+                    </a:lnL>
+                    <a:lnR w="6350" cap="flat" cmpd="sng" algn="ctr">
+                      <a:solidFill>
+                        <a:srgbClr val="D5DBE3"/>
+                      </a:solidFill>
+                      <a:prstDash val="solid"/>
+                      <a:round/>
+                      <a:headEnd type="none" w="med" len="med"/>
+                      <a:tailEnd type="none" w="med" len="med"/>
+                    </a:lnR>
+                    <a:lnT w="6350" cap="flat" cmpd="sng" algn="ctr">
+                      <a:solidFill>
+                        <a:srgbClr val="D5DBE3"/>
+                      </a:solidFill>
+                      <a:prstDash val="solid"/>
+                      <a:round/>
+                      <a:headEnd type="none" w="med" len="med"/>
+                      <a:tailEnd type="none" w="med" len="med"/>
+                    </a:lnT>
+                    <a:lnB w="6350" cap="flat" cmpd="sng" algn="ctr">
+                      <a:solidFill>
+                        <a:srgbClr val="D5DBE3"/>
+                      </a:solidFill>
+                      <a:prstDash val="solid"/>
+                      <a:round/>
+                      <a:headEnd type="none" w="med" len="med"/>
+                      <a:tailEnd type="none" w="med" len="med"/>
+                    </a:lnB>
+                  </a:tcPr>
+                </a:tc>
+                <a:tc>
+                  <a:txBody>
+                    <a:bodyPr/>
+                    <a:lstStyle/>
+                    <a:p>
+                      <a:pPr algn="r" indent="0" marL="0">
+                        <a:buNone/>
+                      </a:pPr>
+                      <a:r>
                         <a:rPr lang="en-US" sz="850" b="1" dirty="0">
                           <a:solidFill>
+                            <a:srgbClr val="5E9B7E"/>
+                          </a:solidFill>
+                          <a:latin typeface="Calibri" pitchFamily="34" charset="0"/>
+                          <a:ea typeface="Calibri" pitchFamily="34" charset="-122"/>
+                          <a:cs typeface="Calibri" pitchFamily="34" charset="-120"/>
+                        </a:rPr>
+                        <a:t>2,8</a:t>
+                      </a:r>
+                      <a:endParaRPr lang="en-US" sz="850" dirty="0">
+                        <a:latin typeface="Calibri" charset="0"/>
+                        <a:ea typeface="Calibri" charset="0"/>
+                        <a:cs typeface="Calibri" charset="0"/>
+                      </a:endParaRPr>
+                    </a:p>
+                  </a:txBody>
+                  <a:tcPr marL="64008" marR="64008" marT="0" marB="0" anchor="ctr">
+                    <a:lnL w="6350" cap="flat" cmpd="sng" algn="ctr">
+                      <a:solidFill>
+                        <a:srgbClr val="D5DBE3"/>
+                      </a:solidFill>
+                      <a:prstDash val="solid"/>
+                      <a:round/>
+                      <a:headEnd type="none" w="med" len="med"/>
+                      <a:tailEnd type="none" w="med" len="med"/>
+                    </a:lnL>
+                    <a:lnR w="6350" cap="flat" cmpd="sng" algn="ctr">
+                      <a:solidFill>
+                        <a:srgbClr val="D5DBE3"/>
+                      </a:solidFill>
+                      <a:prstDash val="solid"/>
+                      <a:round/>
+                      <a:headEnd type="none" w="med" len="med"/>
+                      <a:tailEnd type="none" w="med" len="med"/>
+                    </a:lnR>
+                    <a:lnT w="6350" cap="flat" cmpd="sng" algn="ctr">
+                      <a:solidFill>
+                        <a:srgbClr val="D5DBE3"/>
+                      </a:solidFill>
+                      <a:prstDash val="solid"/>
+                      <a:round/>
+                      <a:headEnd type="none" w="med" len="med"/>
+                      <a:tailEnd type="none" w="med" len="med"/>
+                    </a:lnT>
+                    <a:lnB w="6350" cap="flat" cmpd="sng" algn="ctr">
+                      <a:solidFill>
+                        <a:srgbClr val="D5DBE3"/>
+                      </a:solidFill>
+                      <a:prstDash val="solid"/>
+                      <a:round/>
+                      <a:headEnd type="none" w="med" len="med"/>
+                      <a:tailEnd type="none" w="med" len="med"/>
+                    </a:lnB>
+                  </a:tcPr>
+                </a:tc>
+                <a:tc>
+                  <a:txBody>
+                    <a:bodyPr/>
+                    <a:lstStyle/>
+                    <a:p>
+                      <a:pPr algn="r" indent="0" marL="0">
+                        <a:buNone/>
+                      </a:pPr>
+                      <a:r>
+                        <a:rPr lang="en-US" sz="850" dirty="0">
+                          <a:solidFill>
+                            <a:srgbClr val="1F2933"/>
+                          </a:solidFill>
+                          <a:latin typeface="Calibri" pitchFamily="34" charset="0"/>
+                          <a:ea typeface="Calibri" pitchFamily="34" charset="-122"/>
+                          <a:cs typeface="Calibri" pitchFamily="34" charset="-120"/>
+                        </a:rPr>
+                        <a:t>–</a:t>
+                      </a:r>
+                      <a:endParaRPr lang="en-US" sz="850" dirty="0">
+                        <a:latin typeface="Calibri" charset="0"/>
+                        <a:ea typeface="Calibri" charset="0"/>
+                        <a:cs typeface="Calibri" charset="0"/>
+                      </a:endParaRPr>
+                    </a:p>
+                  </a:txBody>
+                  <a:tcPr marL="64008" marR="64008" marT="0" marB="0" anchor="ctr">
+                    <a:lnL w="6350" cap="flat" cmpd="sng" algn="ctr">
+                      <a:solidFill>
+                        <a:srgbClr val="D5DBE3"/>
+                      </a:solidFill>
+                      <a:prstDash val="solid"/>
+                      <a:round/>
+                      <a:headEnd type="none" w="med" len="med"/>
+                      <a:tailEnd type="none" w="med" len="med"/>
+                    </a:lnL>
+                    <a:lnR w="6350" cap="flat" cmpd="sng" algn="ctr">
+                      <a:solidFill>
+                        <a:srgbClr val="D5DBE3"/>
+                      </a:solidFill>
+                      <a:prstDash val="solid"/>
+                      <a:round/>
+                      <a:headEnd type="none" w="med" len="med"/>
+                      <a:tailEnd type="none" w="med" len="med"/>
+                    </a:lnR>
+                    <a:lnT w="6350" cap="flat" cmpd="sng" algn="ctr">
+                      <a:solidFill>
+                        <a:srgbClr val="D5DBE3"/>
+                      </a:solidFill>
+                      <a:prstDash val="solid"/>
+                      <a:round/>
+                      <a:headEnd type="none" w="med" len="med"/>
+                      <a:tailEnd type="none" w="med" len="med"/>
+                    </a:lnT>
+                    <a:lnB w="6350" cap="flat" cmpd="sng" algn="ctr">
+                      <a:solidFill>
+                        <a:srgbClr val="D5DBE3"/>
+                      </a:solidFill>
+                      <a:prstDash val="solid"/>
+                      <a:round/>
+                      <a:headEnd type="none" w="med" len="med"/>
+                      <a:tailEnd type="none" w="med" len="med"/>
+                    </a:lnB>
+                  </a:tcPr>
+                </a:tc>
+              </a:tr>
+              <a:tr h="224028">
+                <a:tc>
+                  <a:txBody>
+                    <a:bodyPr/>
+                    <a:lstStyle/>
+                    <a:p>
+                      <a:pPr algn="l" indent="0" marL="0">
+                        <a:buNone/>
+                      </a:pPr>
+                      <a:r>
+                        <a:rPr lang="en-US" sz="850" b="1" dirty="0">
+                          <a:solidFill>
+                            <a:srgbClr val="1F2933"/>
+                          </a:solidFill>
+                          <a:latin typeface="Calibri" pitchFamily="34" charset="0"/>
+                          <a:ea typeface="Calibri" pitchFamily="34" charset="-122"/>
+                          <a:cs typeface="Calibri" pitchFamily="34" charset="-120"/>
+                        </a:rPr>
+                        <a:t>ODALYS CI</a:t>
+                      </a:r>
+                      <a:endParaRPr lang="en-US" sz="850" dirty="0">
+                        <a:latin typeface="Calibri" charset="0"/>
+                        <a:ea typeface="Calibri" charset="0"/>
+                        <a:cs typeface="Calibri" charset="0"/>
+                      </a:endParaRPr>
+                    </a:p>
+                  </a:txBody>
+                  <a:tcPr marL="64008" marR="64008" marT="0" marB="0" anchor="ctr">
+                    <a:lnL w="6350" cap="flat" cmpd="sng" algn="ctr">
+                      <a:solidFill>
+                        <a:srgbClr val="D5DBE3"/>
+                      </a:solidFill>
+                      <a:prstDash val="solid"/>
+                      <a:round/>
+                      <a:headEnd type="none" w="med" len="med"/>
+                      <a:tailEnd type="none" w="med" len="med"/>
+                    </a:lnL>
+                    <a:lnR w="6350" cap="flat" cmpd="sng" algn="ctr">
+                      <a:solidFill>
+                        <a:srgbClr val="D5DBE3"/>
+                      </a:solidFill>
+                      <a:prstDash val="solid"/>
+                      <a:round/>
+                      <a:headEnd type="none" w="med" len="med"/>
+                      <a:tailEnd type="none" w="med" len="med"/>
+                    </a:lnR>
+                    <a:lnT w="6350" cap="flat" cmpd="sng" algn="ctr">
+                      <a:solidFill>
+                        <a:srgbClr val="D5DBE3"/>
+                      </a:solidFill>
+                      <a:prstDash val="solid"/>
+                      <a:round/>
+                      <a:headEnd type="none" w="med" len="med"/>
+                      <a:tailEnd type="none" w="med" len="med"/>
+                    </a:lnT>
+                    <a:lnB w="6350" cap="flat" cmpd="sng" algn="ctr">
+                      <a:solidFill>
+                        <a:srgbClr val="D5DBE3"/>
+                      </a:solidFill>
+                      <a:prstDash val="solid"/>
+                      <a:round/>
+                      <a:headEnd type="none" w="med" len="med"/>
+                      <a:tailEnd type="none" w="med" len="med"/>
+                    </a:lnB>
+                  </a:tcPr>
+                </a:tc>
+                <a:tc>
+                  <a:txBody>
+                    <a:bodyPr/>
+                    <a:lstStyle/>
+                    <a:p>
+                      <a:pPr algn="r" indent="0" marL="0">
+                        <a:buNone/>
+                      </a:pPr>
+                      <a:r>
+                        <a:rPr lang="en-US" sz="850" dirty="0">
+                          <a:solidFill>
+                            <a:srgbClr val="1F2933"/>
+                          </a:solidFill>
+                          <a:latin typeface="Calibri" pitchFamily="34" charset="0"/>
+                          <a:ea typeface="Calibri" pitchFamily="34" charset="-122"/>
+                          <a:cs typeface="Calibri" pitchFamily="34" charset="-120"/>
+                        </a:rPr>
+                        <a:t>6,1</a:t>
+                      </a:r>
+                      <a:endParaRPr lang="en-US" sz="850" dirty="0">
+                        <a:latin typeface="Calibri" charset="0"/>
+                        <a:ea typeface="Calibri" charset="0"/>
+                        <a:cs typeface="Calibri" charset="0"/>
+                      </a:endParaRPr>
+                    </a:p>
+                  </a:txBody>
+                  <a:tcPr marL="64008" marR="64008" marT="0" marB="0" anchor="ctr">
+                    <a:lnL w="6350" cap="flat" cmpd="sng" algn="ctr">
+                      <a:solidFill>
+                        <a:srgbClr val="D5DBE3"/>
+                      </a:solidFill>
+                      <a:prstDash val="solid"/>
+                      <a:round/>
+                      <a:headEnd type="none" w="med" len="med"/>
+                      <a:tailEnd type="none" w="med" len="med"/>
+                    </a:lnL>
+                    <a:lnR w="6350" cap="flat" cmpd="sng" algn="ctr">
+                      <a:solidFill>
+                        <a:srgbClr val="D5DBE3"/>
+                      </a:solidFill>
+                      <a:prstDash val="solid"/>
+                      <a:round/>
+                      <a:headEnd type="none" w="med" len="med"/>
+                      <a:tailEnd type="none" w="med" len="med"/>
+                    </a:lnR>
+                    <a:lnT w="6350" cap="flat" cmpd="sng" algn="ctr">
+                      <a:solidFill>
+                        <a:srgbClr val="D5DBE3"/>
+                      </a:solidFill>
+                      <a:prstDash val="solid"/>
+                      <a:round/>
+                      <a:headEnd type="none" w="med" len="med"/>
+                      <a:tailEnd type="none" w="med" len="med"/>
+                    </a:lnT>
+                    <a:lnB w="6350" cap="flat" cmpd="sng" algn="ctr">
+                      <a:solidFill>
+                        <a:srgbClr val="D5DBE3"/>
+                      </a:solidFill>
+                      <a:prstDash val="solid"/>
+                      <a:round/>
+                      <a:headEnd type="none" w="med" len="med"/>
+                      <a:tailEnd type="none" w="med" len="med"/>
+                    </a:lnB>
+                  </a:tcPr>
+                </a:tc>
+                <a:tc>
+                  <a:txBody>
+                    <a:bodyPr/>
+                    <a:lstStyle/>
+                    <a:p>
+                      <a:pPr algn="r" indent="0" marL="0">
+                        <a:buNone/>
+                      </a:pPr>
+                      <a:r>
+                        <a:rPr lang="en-US" sz="850" dirty="0">
+                          <a:solidFill>
+                            <a:srgbClr val="1F2933"/>
+                          </a:solidFill>
+                          <a:latin typeface="Calibri" pitchFamily="34" charset="0"/>
+                          <a:ea typeface="Calibri" pitchFamily="34" charset="-122"/>
+                          <a:cs typeface="Calibri" pitchFamily="34" charset="-120"/>
+                        </a:rPr>
+                        <a:t>-9,6</a:t>
+                      </a:r>
+                      <a:endParaRPr lang="en-US" sz="850" dirty="0">
+                        <a:latin typeface="Calibri" charset="0"/>
+                        <a:ea typeface="Calibri" charset="0"/>
+                        <a:cs typeface="Calibri" charset="0"/>
+                      </a:endParaRPr>
+                    </a:p>
+                  </a:txBody>
+                  <a:tcPr marL="64008" marR="64008" marT="0" marB="0" anchor="ctr">
+                    <a:lnL w="6350" cap="flat" cmpd="sng" algn="ctr">
+                      <a:solidFill>
+                        <a:srgbClr val="D5DBE3"/>
+                      </a:solidFill>
+                      <a:prstDash val="solid"/>
+                      <a:round/>
+                      <a:headEnd type="none" w="med" len="med"/>
+                      <a:tailEnd type="none" w="med" len="med"/>
+                    </a:lnL>
+                    <a:lnR w="6350" cap="flat" cmpd="sng" algn="ctr">
+                      <a:solidFill>
+                        <a:srgbClr val="D5DBE3"/>
+                      </a:solidFill>
+                      <a:prstDash val="solid"/>
+                      <a:round/>
+                      <a:headEnd type="none" w="med" len="med"/>
+                      <a:tailEnd type="none" w="med" len="med"/>
+                    </a:lnR>
+                    <a:lnT w="6350" cap="flat" cmpd="sng" algn="ctr">
+                      <a:solidFill>
+                        <a:srgbClr val="D5DBE3"/>
+                      </a:solidFill>
+                      <a:prstDash val="solid"/>
+                      <a:round/>
+                      <a:headEnd type="none" w="med" len="med"/>
+                      <a:tailEnd type="none" w="med" len="med"/>
+                    </a:lnT>
+                    <a:lnB w="6350" cap="flat" cmpd="sng" algn="ctr">
+                      <a:solidFill>
+                        <a:srgbClr val="D5DBE3"/>
+                      </a:solidFill>
+                      <a:prstDash val="solid"/>
+                      <a:round/>
+                      <a:headEnd type="none" w="med" len="med"/>
+                      <a:tailEnd type="none" w="med" len="med"/>
+                    </a:lnB>
+                  </a:tcPr>
+                </a:tc>
+                <a:tc>
+                  <a:txBody>
+                    <a:bodyPr/>
+                    <a:lstStyle/>
+                    <a:p>
+                      <a:pPr algn="r" indent="0" marL="0">
+                        <a:buNone/>
+                      </a:pPr>
+                      <a:r>
+                        <a:rPr lang="en-US" sz="850" dirty="0">
+                          <a:solidFill>
+                            <a:srgbClr val="1F2933"/>
+                          </a:solidFill>
+                          <a:latin typeface="Calibri" pitchFamily="34" charset="0"/>
+                          <a:ea typeface="Calibri" pitchFamily="34" charset="-122"/>
+                          <a:cs typeface="Calibri" pitchFamily="34" charset="-120"/>
+                        </a:rPr>
+                        <a:t>–</a:t>
+                      </a:r>
+                      <a:endParaRPr lang="en-US" sz="850" dirty="0">
+                        <a:latin typeface="Calibri" charset="0"/>
+                        <a:ea typeface="Calibri" charset="0"/>
+                        <a:cs typeface="Calibri" charset="0"/>
+                      </a:endParaRPr>
+                    </a:p>
+                  </a:txBody>
+                  <a:tcPr marL="64008" marR="64008" marT="0" marB="0" anchor="ctr">
+                    <a:lnL w="6350" cap="flat" cmpd="sng" algn="ctr">
+                      <a:solidFill>
+                        <a:srgbClr val="D5DBE3"/>
+                      </a:solidFill>
+                      <a:prstDash val="solid"/>
+                      <a:round/>
+                      <a:headEnd type="none" w="med" len="med"/>
+                      <a:tailEnd type="none" w="med" len="med"/>
+                    </a:lnL>
+                    <a:lnR w="6350" cap="flat" cmpd="sng" algn="ctr">
+                      <a:solidFill>
+                        <a:srgbClr val="D5DBE3"/>
+                      </a:solidFill>
+                      <a:prstDash val="solid"/>
+                      <a:round/>
+                      <a:headEnd type="none" w="med" len="med"/>
+                      <a:tailEnd type="none" w="med" len="med"/>
+                    </a:lnR>
+                    <a:lnT w="6350" cap="flat" cmpd="sng" algn="ctr">
+                      <a:solidFill>
+                        <a:srgbClr val="D5DBE3"/>
+                      </a:solidFill>
+                      <a:prstDash val="solid"/>
+                      <a:round/>
+                      <a:headEnd type="none" w="med" len="med"/>
+                      <a:tailEnd type="none" w="med" len="med"/>
+                    </a:lnT>
+                    <a:lnB w="6350" cap="flat" cmpd="sng" algn="ctr">
+                      <a:solidFill>
+                        <a:srgbClr val="D5DBE3"/>
+                      </a:solidFill>
+                      <a:prstDash val="solid"/>
+                      <a:round/>
+                      <a:headEnd type="none" w="med" len="med"/>
+                      <a:tailEnd type="none" w="med" len="med"/>
+                    </a:lnB>
+                  </a:tcPr>
+                </a:tc>
+                <a:tc>
+                  <a:txBody>
+                    <a:bodyPr/>
+                    <a:lstStyle/>
+                    <a:p>
+                      <a:pPr algn="r" indent="0" marL="0">
+                        <a:buNone/>
+                      </a:pPr>
+                      <a:r>
+                        <a:rPr lang="en-US" sz="850" b="1" dirty="0">
+                          <a:solidFill>
                             <a:srgbClr val="B3261E"/>
                           </a:solidFill>
                           <a:latin typeface="Calibri" pitchFamily="34" charset="0"/>
                           <a:ea typeface="Calibri" pitchFamily="34" charset="-122"/>
                           <a:cs typeface="Calibri" pitchFamily="34" charset="-120"/>
                         </a:rPr>
-                        <a:t>140,2</a:t>
+                        <a:t>-3,5</a:t>
                       </a:r>
                       <a:endParaRPr lang="en-US" sz="850" dirty="0">
                         <a:latin typeface="Calibri" charset="0"/>
@@ -25377,678 +26096,24 @@
                     </a:solidFill>
                   </a:tcPr>
                 </a:tc>
-              </a:tr>
-              <a:tr h="224028">
-                <a:tc>
-                  <a:txBody>
-                    <a:bodyPr/>
-                    <a:lstStyle/>
-                    <a:p>
-                      <a:pPr algn="l" indent="0" marL="0">
+                <a:tc>
+                  <a:txBody>
+                    <a:bodyPr/>
+                    <a:lstStyle/>
+                    <a:p>
+                      <a:pPr algn="r" indent="0" marL="0">
                         <a:buNone/>
                       </a:pPr>
                       <a:r>
                         <a:rPr lang="en-US" sz="850" b="1" dirty="0">
                           <a:solidFill>
-                            <a:srgbClr val="1F2933"/>
-                          </a:solidFill>
-                          <a:latin typeface="Calibri" pitchFamily="34" charset="0"/>
-                          <a:ea typeface="Calibri" pitchFamily="34" charset="-122"/>
-                          <a:cs typeface="Calibri" pitchFamily="34" charset="-120"/>
-                        </a:rPr>
-                        <a:t>INFI</a:t>
-                      </a:r>
-                      <a:endParaRPr lang="en-US" sz="850" dirty="0">
-                        <a:latin typeface="Calibri" charset="0"/>
-                        <a:ea typeface="Calibri" charset="0"/>
-                        <a:cs typeface="Calibri" charset="0"/>
-                      </a:endParaRPr>
-                    </a:p>
-                  </a:txBody>
-                  <a:tcPr marL="64008" marR="64008" marT="0" marB="0" anchor="ctr">
-                    <a:lnL w="6350" cap="flat" cmpd="sng" algn="ctr">
-                      <a:solidFill>
-                        <a:srgbClr val="D5DBE3"/>
-                      </a:solidFill>
-                      <a:prstDash val="solid"/>
-                      <a:round/>
-                      <a:headEnd type="none" w="med" len="med"/>
-                      <a:tailEnd type="none" w="med" len="med"/>
-                    </a:lnL>
-                    <a:lnR w="6350" cap="flat" cmpd="sng" algn="ctr">
-                      <a:solidFill>
-                        <a:srgbClr val="D5DBE3"/>
-                      </a:solidFill>
-                      <a:prstDash val="solid"/>
-                      <a:round/>
-                      <a:headEnd type="none" w="med" len="med"/>
-                      <a:tailEnd type="none" w="med" len="med"/>
-                    </a:lnR>
-                    <a:lnT w="6350" cap="flat" cmpd="sng" algn="ctr">
-                      <a:solidFill>
-                        <a:srgbClr val="D5DBE3"/>
-                      </a:solidFill>
-                      <a:prstDash val="solid"/>
-                      <a:round/>
-                      <a:headEnd type="none" w="med" len="med"/>
-                      <a:tailEnd type="none" w="med" len="med"/>
-                    </a:lnT>
-                    <a:lnB w="6350" cap="flat" cmpd="sng" algn="ctr">
-                      <a:solidFill>
-                        <a:srgbClr val="D5DBE3"/>
-                      </a:solidFill>
-                      <a:prstDash val="solid"/>
-                      <a:round/>
-                      <a:headEnd type="none" w="med" len="med"/>
-                      <a:tailEnd type="none" w="med" len="med"/>
-                    </a:lnB>
-                  </a:tcPr>
-                </a:tc>
-                <a:tc>
-                  <a:txBody>
-                    <a:bodyPr/>
-                    <a:lstStyle/>
-                    <a:p>
-                      <a:pPr algn="r" indent="0" marL="0">
-                        <a:buNone/>
-                      </a:pPr>
-                      <a:r>
-                        <a:rPr lang="en-US" sz="850" dirty="0">
-                          <a:solidFill>
-                            <a:srgbClr val="1F2933"/>
-                          </a:solidFill>
-                          <a:latin typeface="Calibri" pitchFamily="34" charset="0"/>
-                          <a:ea typeface="Calibri" pitchFamily="34" charset="-122"/>
-                          <a:cs typeface="Calibri" pitchFamily="34" charset="-120"/>
-                        </a:rPr>
-                        <a:t>2,8</a:t>
-                      </a:r>
-                      <a:endParaRPr lang="en-US" sz="850" dirty="0">
-                        <a:latin typeface="Calibri" charset="0"/>
-                        <a:ea typeface="Calibri" charset="0"/>
-                        <a:cs typeface="Calibri" charset="0"/>
-                      </a:endParaRPr>
-                    </a:p>
-                  </a:txBody>
-                  <a:tcPr marL="64008" marR="64008" marT="0" marB="0" anchor="ctr">
-                    <a:lnL w="6350" cap="flat" cmpd="sng" algn="ctr">
-                      <a:solidFill>
-                        <a:srgbClr val="D5DBE3"/>
-                      </a:solidFill>
-                      <a:prstDash val="solid"/>
-                      <a:round/>
-                      <a:headEnd type="none" w="med" len="med"/>
-                      <a:tailEnd type="none" w="med" len="med"/>
-                    </a:lnL>
-                    <a:lnR w="6350" cap="flat" cmpd="sng" algn="ctr">
-                      <a:solidFill>
-                        <a:srgbClr val="D5DBE3"/>
-                      </a:solidFill>
-                      <a:prstDash val="solid"/>
-                      <a:round/>
-                      <a:headEnd type="none" w="med" len="med"/>
-                      <a:tailEnd type="none" w="med" len="med"/>
-                    </a:lnR>
-                    <a:lnT w="6350" cap="flat" cmpd="sng" algn="ctr">
-                      <a:solidFill>
-                        <a:srgbClr val="D5DBE3"/>
-                      </a:solidFill>
-                      <a:prstDash val="solid"/>
-                      <a:round/>
-                      <a:headEnd type="none" w="med" len="med"/>
-                      <a:tailEnd type="none" w="med" len="med"/>
-                    </a:lnT>
-                    <a:lnB w="6350" cap="flat" cmpd="sng" algn="ctr">
-                      <a:solidFill>
-                        <a:srgbClr val="D5DBE3"/>
-                      </a:solidFill>
-                      <a:prstDash val="solid"/>
-                      <a:round/>
-                      <a:headEnd type="none" w="med" len="med"/>
-                      <a:tailEnd type="none" w="med" len="med"/>
-                    </a:lnB>
-                  </a:tcPr>
-                </a:tc>
-                <a:tc>
-                  <a:txBody>
-                    <a:bodyPr/>
-                    <a:lstStyle/>
-                    <a:p>
-                      <a:pPr algn="r" indent="0" marL="0">
-                        <a:buNone/>
-                      </a:pPr>
-                      <a:r>
-                        <a:rPr lang="en-US" sz="850" dirty="0">
-                          <a:solidFill>
-                            <a:srgbClr val="1F2933"/>
-                          </a:solidFill>
-                          <a:latin typeface="Calibri" pitchFamily="34" charset="0"/>
-                          <a:ea typeface="Calibri" pitchFamily="34" charset="-122"/>
-                          <a:cs typeface="Calibri" pitchFamily="34" charset="-120"/>
-                        </a:rPr>
-                        <a:t>–</a:t>
-                      </a:r>
-                      <a:endParaRPr lang="en-US" sz="850" dirty="0">
-                        <a:latin typeface="Calibri" charset="0"/>
-                        <a:ea typeface="Calibri" charset="0"/>
-                        <a:cs typeface="Calibri" charset="0"/>
-                      </a:endParaRPr>
-                    </a:p>
-                  </a:txBody>
-                  <a:tcPr marL="64008" marR="64008" marT="0" marB="0" anchor="ctr">
-                    <a:lnL w="6350" cap="flat" cmpd="sng" algn="ctr">
-                      <a:solidFill>
-                        <a:srgbClr val="D5DBE3"/>
-                      </a:solidFill>
-                      <a:prstDash val="solid"/>
-                      <a:round/>
-                      <a:headEnd type="none" w="med" len="med"/>
-                      <a:tailEnd type="none" w="med" len="med"/>
-                    </a:lnL>
-                    <a:lnR w="6350" cap="flat" cmpd="sng" algn="ctr">
-                      <a:solidFill>
-                        <a:srgbClr val="D5DBE3"/>
-                      </a:solidFill>
-                      <a:prstDash val="solid"/>
-                      <a:round/>
-                      <a:headEnd type="none" w="med" len="med"/>
-                      <a:tailEnd type="none" w="med" len="med"/>
-                    </a:lnR>
-                    <a:lnT w="6350" cap="flat" cmpd="sng" algn="ctr">
-                      <a:solidFill>
-                        <a:srgbClr val="D5DBE3"/>
-                      </a:solidFill>
-                      <a:prstDash val="solid"/>
-                      <a:round/>
-                      <a:headEnd type="none" w="med" len="med"/>
-                      <a:tailEnd type="none" w="med" len="med"/>
-                    </a:lnT>
-                    <a:lnB w="6350" cap="flat" cmpd="sng" algn="ctr">
-                      <a:solidFill>
-                        <a:srgbClr val="D5DBE3"/>
-                      </a:solidFill>
-                      <a:prstDash val="solid"/>
-                      <a:round/>
-                      <a:headEnd type="none" w="med" len="med"/>
-                      <a:tailEnd type="none" w="med" len="med"/>
-                    </a:lnB>
-                  </a:tcPr>
-                </a:tc>
-                <a:tc>
-                  <a:txBody>
-                    <a:bodyPr/>
-                    <a:lstStyle/>
-                    <a:p>
-                      <a:pPr algn="r" indent="0" marL="0">
-                        <a:buNone/>
-                      </a:pPr>
-                      <a:r>
-                        <a:rPr lang="en-US" sz="850" dirty="0">
-                          <a:solidFill>
-                            <a:srgbClr val="1F2933"/>
-                          </a:solidFill>
-                          <a:latin typeface="Calibri" pitchFamily="34" charset="0"/>
-                          <a:ea typeface="Calibri" pitchFamily="34" charset="-122"/>
-                          <a:cs typeface="Calibri" pitchFamily="34" charset="-120"/>
-                        </a:rPr>
-                        <a:t>–</a:t>
-                      </a:r>
-                      <a:endParaRPr lang="en-US" sz="850" dirty="0">
-                        <a:latin typeface="Calibri" charset="0"/>
-                        <a:ea typeface="Calibri" charset="0"/>
-                        <a:cs typeface="Calibri" charset="0"/>
-                      </a:endParaRPr>
-                    </a:p>
-                  </a:txBody>
-                  <a:tcPr marL="64008" marR="64008" marT="0" marB="0" anchor="ctr">
-                    <a:lnL w="6350" cap="flat" cmpd="sng" algn="ctr">
-                      <a:solidFill>
-                        <a:srgbClr val="D5DBE3"/>
-                      </a:solidFill>
-                      <a:prstDash val="solid"/>
-                      <a:round/>
-                      <a:headEnd type="none" w="med" len="med"/>
-                      <a:tailEnd type="none" w="med" len="med"/>
-                    </a:lnL>
-                    <a:lnR w="6350" cap="flat" cmpd="sng" algn="ctr">
-                      <a:solidFill>
-                        <a:srgbClr val="D5DBE3"/>
-                      </a:solidFill>
-                      <a:prstDash val="solid"/>
-                      <a:round/>
-                      <a:headEnd type="none" w="med" len="med"/>
-                      <a:tailEnd type="none" w="med" len="med"/>
-                    </a:lnR>
-                    <a:lnT w="6350" cap="flat" cmpd="sng" algn="ctr">
-                      <a:solidFill>
-                        <a:srgbClr val="D5DBE3"/>
-                      </a:solidFill>
-                      <a:prstDash val="solid"/>
-                      <a:round/>
-                      <a:headEnd type="none" w="med" len="med"/>
-                      <a:tailEnd type="none" w="med" len="med"/>
-                    </a:lnT>
-                    <a:lnB w="6350" cap="flat" cmpd="sng" algn="ctr">
-                      <a:solidFill>
-                        <a:srgbClr val="D5DBE3"/>
-                      </a:solidFill>
-                      <a:prstDash val="solid"/>
-                      <a:round/>
-                      <a:headEnd type="none" w="med" len="med"/>
-                      <a:tailEnd type="none" w="med" len="med"/>
-                    </a:lnB>
-                  </a:tcPr>
-                </a:tc>
-                <a:tc>
-                  <a:txBody>
-                    <a:bodyPr/>
-                    <a:lstStyle/>
-                    <a:p>
-                      <a:pPr algn="r" indent="0" marL="0">
-                        <a:buNone/>
-                      </a:pPr>
-                      <a:r>
-                        <a:rPr lang="en-US" sz="850" b="1" dirty="0">
-                          <a:solidFill>
-                            <a:srgbClr val="5E9B7E"/>
-                          </a:solidFill>
-                          <a:latin typeface="Calibri" pitchFamily="34" charset="0"/>
-                          <a:ea typeface="Calibri" pitchFamily="34" charset="-122"/>
-                          <a:cs typeface="Calibri" pitchFamily="34" charset="-120"/>
-                        </a:rPr>
-                        <a:t>2,8</a:t>
-                      </a:r>
-                      <a:endParaRPr lang="en-US" sz="850" dirty="0">
-                        <a:latin typeface="Calibri" charset="0"/>
-                        <a:ea typeface="Calibri" charset="0"/>
-                        <a:cs typeface="Calibri" charset="0"/>
-                      </a:endParaRPr>
-                    </a:p>
-                  </a:txBody>
-                  <a:tcPr marL="64008" marR="64008" marT="0" marB="0" anchor="ctr">
-                    <a:lnL w="6350" cap="flat" cmpd="sng" algn="ctr">
-                      <a:solidFill>
-                        <a:srgbClr val="D5DBE3"/>
-                      </a:solidFill>
-                      <a:prstDash val="solid"/>
-                      <a:round/>
-                      <a:headEnd type="none" w="med" len="med"/>
-                      <a:tailEnd type="none" w="med" len="med"/>
-                    </a:lnL>
-                    <a:lnR w="6350" cap="flat" cmpd="sng" algn="ctr">
-                      <a:solidFill>
-                        <a:srgbClr val="D5DBE3"/>
-                      </a:solidFill>
-                      <a:prstDash val="solid"/>
-                      <a:round/>
-                      <a:headEnd type="none" w="med" len="med"/>
-                      <a:tailEnd type="none" w="med" len="med"/>
-                    </a:lnR>
-                    <a:lnT w="6350" cap="flat" cmpd="sng" algn="ctr">
-                      <a:solidFill>
-                        <a:srgbClr val="D5DBE3"/>
-                      </a:solidFill>
-                      <a:prstDash val="solid"/>
-                      <a:round/>
-                      <a:headEnd type="none" w="med" len="med"/>
-                      <a:tailEnd type="none" w="med" len="med"/>
-                    </a:lnT>
-                    <a:lnB w="6350" cap="flat" cmpd="sng" algn="ctr">
-                      <a:solidFill>
-                        <a:srgbClr val="D5DBE3"/>
-                      </a:solidFill>
-                      <a:prstDash val="solid"/>
-                      <a:round/>
-                      <a:headEnd type="none" w="med" len="med"/>
-                      <a:tailEnd type="none" w="med" len="med"/>
-                    </a:lnB>
-                  </a:tcPr>
-                </a:tc>
-                <a:tc>
-                  <a:txBody>
-                    <a:bodyPr/>
-                    <a:lstStyle/>
-                    <a:p>
-                      <a:pPr algn="r" indent="0" marL="0">
-                        <a:buNone/>
-                      </a:pPr>
-                      <a:r>
-                        <a:rPr lang="en-US" sz="850" dirty="0">
-                          <a:solidFill>
-                            <a:srgbClr val="1F2933"/>
-                          </a:solidFill>
-                          <a:latin typeface="Calibri" pitchFamily="34" charset="0"/>
-                          <a:ea typeface="Calibri" pitchFamily="34" charset="-122"/>
-                          <a:cs typeface="Calibri" pitchFamily="34" charset="-120"/>
-                        </a:rPr>
-                        <a:t>–</a:t>
-                      </a:r>
-                      <a:endParaRPr lang="en-US" sz="850" dirty="0">
-                        <a:latin typeface="Calibri" charset="0"/>
-                        <a:ea typeface="Calibri" charset="0"/>
-                        <a:cs typeface="Calibri" charset="0"/>
-                      </a:endParaRPr>
-                    </a:p>
-                  </a:txBody>
-                  <a:tcPr marL="64008" marR="64008" marT="0" marB="0" anchor="ctr">
-                    <a:lnL w="6350" cap="flat" cmpd="sng" algn="ctr">
-                      <a:solidFill>
-                        <a:srgbClr val="D5DBE3"/>
-                      </a:solidFill>
-                      <a:prstDash val="solid"/>
-                      <a:round/>
-                      <a:headEnd type="none" w="med" len="med"/>
-                      <a:tailEnd type="none" w="med" len="med"/>
-                    </a:lnL>
-                    <a:lnR w="6350" cap="flat" cmpd="sng" algn="ctr">
-                      <a:solidFill>
-                        <a:srgbClr val="D5DBE3"/>
-                      </a:solidFill>
-                      <a:prstDash val="solid"/>
-                      <a:round/>
-                      <a:headEnd type="none" w="med" len="med"/>
-                      <a:tailEnd type="none" w="med" len="med"/>
-                    </a:lnR>
-                    <a:lnT w="6350" cap="flat" cmpd="sng" algn="ctr">
-                      <a:solidFill>
-                        <a:srgbClr val="D5DBE3"/>
-                      </a:solidFill>
-                      <a:prstDash val="solid"/>
-                      <a:round/>
-                      <a:headEnd type="none" w="med" len="med"/>
-                      <a:tailEnd type="none" w="med" len="med"/>
-                    </a:lnT>
-                    <a:lnB w="6350" cap="flat" cmpd="sng" algn="ctr">
-                      <a:solidFill>
-                        <a:srgbClr val="D5DBE3"/>
-                      </a:solidFill>
-                      <a:prstDash val="solid"/>
-                      <a:round/>
-                      <a:headEnd type="none" w="med" len="med"/>
-                      <a:tailEnd type="none" w="med" len="med"/>
-                    </a:lnB>
-                  </a:tcPr>
-                </a:tc>
-              </a:tr>
-              <a:tr h="224028">
-                <a:tc>
-                  <a:txBody>
-                    <a:bodyPr/>
-                    <a:lstStyle/>
-                    <a:p>
-                      <a:pPr algn="l" indent="0" marL="0">
-                        <a:buNone/>
-                      </a:pPr>
-                      <a:r>
-                        <a:rPr lang="en-US" sz="850" b="1" dirty="0">
-                          <a:solidFill>
-                            <a:srgbClr val="1F2933"/>
-                          </a:solidFill>
-                          <a:latin typeface="Calibri" pitchFamily="34" charset="0"/>
-                          <a:ea typeface="Calibri" pitchFamily="34" charset="-122"/>
-                          <a:cs typeface="Calibri" pitchFamily="34" charset="-120"/>
-                        </a:rPr>
-                        <a:t>ODALYS CI</a:t>
-                      </a:r>
-                      <a:endParaRPr lang="en-US" sz="850" dirty="0">
-                        <a:latin typeface="Calibri" charset="0"/>
-                        <a:ea typeface="Calibri" charset="0"/>
-                        <a:cs typeface="Calibri" charset="0"/>
-                      </a:endParaRPr>
-                    </a:p>
-                  </a:txBody>
-                  <a:tcPr marL="64008" marR="64008" marT="0" marB="0" anchor="ctr">
-                    <a:lnL w="6350" cap="flat" cmpd="sng" algn="ctr">
-                      <a:solidFill>
-                        <a:srgbClr val="D5DBE3"/>
-                      </a:solidFill>
-                      <a:prstDash val="solid"/>
-                      <a:round/>
-                      <a:headEnd type="none" w="med" len="med"/>
-                      <a:tailEnd type="none" w="med" len="med"/>
-                    </a:lnL>
-                    <a:lnR w="6350" cap="flat" cmpd="sng" algn="ctr">
-                      <a:solidFill>
-                        <a:srgbClr val="D5DBE3"/>
-                      </a:solidFill>
-                      <a:prstDash val="solid"/>
-                      <a:round/>
-                      <a:headEnd type="none" w="med" len="med"/>
-                      <a:tailEnd type="none" w="med" len="med"/>
-                    </a:lnR>
-                    <a:lnT w="6350" cap="flat" cmpd="sng" algn="ctr">
-                      <a:solidFill>
-                        <a:srgbClr val="D5DBE3"/>
-                      </a:solidFill>
-                      <a:prstDash val="solid"/>
-                      <a:round/>
-                      <a:headEnd type="none" w="med" len="med"/>
-                      <a:tailEnd type="none" w="med" len="med"/>
-                    </a:lnT>
-                    <a:lnB w="6350" cap="flat" cmpd="sng" algn="ctr">
-                      <a:solidFill>
-                        <a:srgbClr val="D5DBE3"/>
-                      </a:solidFill>
-                      <a:prstDash val="solid"/>
-                      <a:round/>
-                      <a:headEnd type="none" w="med" len="med"/>
-                      <a:tailEnd type="none" w="med" len="med"/>
-                    </a:lnB>
-                  </a:tcPr>
-                </a:tc>
-                <a:tc>
-                  <a:txBody>
-                    <a:bodyPr/>
-                    <a:lstStyle/>
-                    <a:p>
-                      <a:pPr algn="r" indent="0" marL="0">
-                        <a:buNone/>
-                      </a:pPr>
-                      <a:r>
-                        <a:rPr lang="en-US" sz="850" dirty="0">
-                          <a:solidFill>
-                            <a:srgbClr val="1F2933"/>
-                          </a:solidFill>
-                          <a:latin typeface="Calibri" pitchFamily="34" charset="0"/>
-                          <a:ea typeface="Calibri" pitchFamily="34" charset="-122"/>
-                          <a:cs typeface="Calibri" pitchFamily="34" charset="-120"/>
-                        </a:rPr>
-                        <a:t>6,1</a:t>
-                      </a:r>
-                      <a:endParaRPr lang="en-US" sz="850" dirty="0">
-                        <a:latin typeface="Calibri" charset="0"/>
-                        <a:ea typeface="Calibri" charset="0"/>
-                        <a:cs typeface="Calibri" charset="0"/>
-                      </a:endParaRPr>
-                    </a:p>
-                  </a:txBody>
-                  <a:tcPr marL="64008" marR="64008" marT="0" marB="0" anchor="ctr">
-                    <a:lnL w="6350" cap="flat" cmpd="sng" algn="ctr">
-                      <a:solidFill>
-                        <a:srgbClr val="D5DBE3"/>
-                      </a:solidFill>
-                      <a:prstDash val="solid"/>
-                      <a:round/>
-                      <a:headEnd type="none" w="med" len="med"/>
-                      <a:tailEnd type="none" w="med" len="med"/>
-                    </a:lnL>
-                    <a:lnR w="6350" cap="flat" cmpd="sng" algn="ctr">
-                      <a:solidFill>
-                        <a:srgbClr val="D5DBE3"/>
-                      </a:solidFill>
-                      <a:prstDash val="solid"/>
-                      <a:round/>
-                      <a:headEnd type="none" w="med" len="med"/>
-                      <a:tailEnd type="none" w="med" len="med"/>
-                    </a:lnR>
-                    <a:lnT w="6350" cap="flat" cmpd="sng" algn="ctr">
-                      <a:solidFill>
-                        <a:srgbClr val="D5DBE3"/>
-                      </a:solidFill>
-                      <a:prstDash val="solid"/>
-                      <a:round/>
-                      <a:headEnd type="none" w="med" len="med"/>
-                      <a:tailEnd type="none" w="med" len="med"/>
-                    </a:lnT>
-                    <a:lnB w="6350" cap="flat" cmpd="sng" algn="ctr">
-                      <a:solidFill>
-                        <a:srgbClr val="D5DBE3"/>
-                      </a:solidFill>
-                      <a:prstDash val="solid"/>
-                      <a:round/>
-                      <a:headEnd type="none" w="med" len="med"/>
-                      <a:tailEnd type="none" w="med" len="med"/>
-                    </a:lnB>
-                  </a:tcPr>
-                </a:tc>
-                <a:tc>
-                  <a:txBody>
-                    <a:bodyPr/>
-                    <a:lstStyle/>
-                    <a:p>
-                      <a:pPr algn="r" indent="0" marL="0">
-                        <a:buNone/>
-                      </a:pPr>
-                      <a:r>
-                        <a:rPr lang="en-US" sz="850" dirty="0">
-                          <a:solidFill>
-                            <a:srgbClr val="1F2933"/>
-                          </a:solidFill>
-                          <a:latin typeface="Calibri" pitchFamily="34" charset="0"/>
-                          <a:ea typeface="Calibri" pitchFamily="34" charset="-122"/>
-                          <a:cs typeface="Calibri" pitchFamily="34" charset="-120"/>
-                        </a:rPr>
-                        <a:t>-9,6</a:t>
-                      </a:r>
-                      <a:endParaRPr lang="en-US" sz="850" dirty="0">
-                        <a:latin typeface="Calibri" charset="0"/>
-                        <a:ea typeface="Calibri" charset="0"/>
-                        <a:cs typeface="Calibri" charset="0"/>
-                      </a:endParaRPr>
-                    </a:p>
-                  </a:txBody>
-                  <a:tcPr marL="64008" marR="64008" marT="0" marB="0" anchor="ctr">
-                    <a:lnL w="6350" cap="flat" cmpd="sng" algn="ctr">
-                      <a:solidFill>
-                        <a:srgbClr val="D5DBE3"/>
-                      </a:solidFill>
-                      <a:prstDash val="solid"/>
-                      <a:round/>
-                      <a:headEnd type="none" w="med" len="med"/>
-                      <a:tailEnd type="none" w="med" len="med"/>
-                    </a:lnL>
-                    <a:lnR w="6350" cap="flat" cmpd="sng" algn="ctr">
-                      <a:solidFill>
-                        <a:srgbClr val="D5DBE3"/>
-                      </a:solidFill>
-                      <a:prstDash val="solid"/>
-                      <a:round/>
-                      <a:headEnd type="none" w="med" len="med"/>
-                      <a:tailEnd type="none" w="med" len="med"/>
-                    </a:lnR>
-                    <a:lnT w="6350" cap="flat" cmpd="sng" algn="ctr">
-                      <a:solidFill>
-                        <a:srgbClr val="D5DBE3"/>
-                      </a:solidFill>
-                      <a:prstDash val="solid"/>
-                      <a:round/>
-                      <a:headEnd type="none" w="med" len="med"/>
-                      <a:tailEnd type="none" w="med" len="med"/>
-                    </a:lnT>
-                    <a:lnB w="6350" cap="flat" cmpd="sng" algn="ctr">
-                      <a:solidFill>
-                        <a:srgbClr val="D5DBE3"/>
-                      </a:solidFill>
-                      <a:prstDash val="solid"/>
-                      <a:round/>
-                      <a:headEnd type="none" w="med" len="med"/>
-                      <a:tailEnd type="none" w="med" len="med"/>
-                    </a:lnB>
-                  </a:tcPr>
-                </a:tc>
-                <a:tc>
-                  <a:txBody>
-                    <a:bodyPr/>
-                    <a:lstStyle/>
-                    <a:p>
-                      <a:pPr algn="r" indent="0" marL="0">
-                        <a:buNone/>
-                      </a:pPr>
-                      <a:r>
-                        <a:rPr lang="en-US" sz="850" dirty="0">
-                          <a:solidFill>
-                            <a:srgbClr val="1F2933"/>
-                          </a:solidFill>
-                          <a:latin typeface="Calibri" pitchFamily="34" charset="0"/>
-                          <a:ea typeface="Calibri" pitchFamily="34" charset="-122"/>
-                          <a:cs typeface="Calibri" pitchFamily="34" charset="-120"/>
-                        </a:rPr>
-                        <a:t>–</a:t>
-                      </a:r>
-                      <a:endParaRPr lang="en-US" sz="850" dirty="0">
-                        <a:latin typeface="Calibri" charset="0"/>
-                        <a:ea typeface="Calibri" charset="0"/>
-                        <a:cs typeface="Calibri" charset="0"/>
-                      </a:endParaRPr>
-                    </a:p>
-                  </a:txBody>
-                  <a:tcPr marL="64008" marR="64008" marT="0" marB="0" anchor="ctr">
-                    <a:lnL w="6350" cap="flat" cmpd="sng" algn="ctr">
-                      <a:solidFill>
-                        <a:srgbClr val="D5DBE3"/>
-                      </a:solidFill>
-                      <a:prstDash val="solid"/>
-                      <a:round/>
-                      <a:headEnd type="none" w="med" len="med"/>
-                      <a:tailEnd type="none" w="med" len="med"/>
-                    </a:lnL>
-                    <a:lnR w="6350" cap="flat" cmpd="sng" algn="ctr">
-                      <a:solidFill>
-                        <a:srgbClr val="D5DBE3"/>
-                      </a:solidFill>
-                      <a:prstDash val="solid"/>
-                      <a:round/>
-                      <a:headEnd type="none" w="med" len="med"/>
-                      <a:tailEnd type="none" w="med" len="med"/>
-                    </a:lnR>
-                    <a:lnT w="6350" cap="flat" cmpd="sng" algn="ctr">
-                      <a:solidFill>
-                        <a:srgbClr val="D5DBE3"/>
-                      </a:solidFill>
-                      <a:prstDash val="solid"/>
-                      <a:round/>
-                      <a:headEnd type="none" w="med" len="med"/>
-                      <a:tailEnd type="none" w="med" len="med"/>
-                    </a:lnT>
-                    <a:lnB w="6350" cap="flat" cmpd="sng" algn="ctr">
-                      <a:solidFill>
-                        <a:srgbClr val="D5DBE3"/>
-                      </a:solidFill>
-                      <a:prstDash val="solid"/>
-                      <a:round/>
-                      <a:headEnd type="none" w="med" len="med"/>
-                      <a:tailEnd type="none" w="med" len="med"/>
-                    </a:lnB>
-                  </a:tcPr>
-                </a:tc>
-                <a:tc>
-                  <a:txBody>
-                    <a:bodyPr/>
-                    <a:lstStyle/>
-                    <a:p>
-                      <a:pPr algn="r" indent="0" marL="0">
-                        <a:buNone/>
-                      </a:pPr>
-                      <a:r>
-                        <a:rPr lang="en-US" sz="850" b="1" dirty="0">
-                          <a:solidFill>
                             <a:srgbClr val="B3261E"/>
                           </a:solidFill>
                           <a:latin typeface="Calibri" pitchFamily="34" charset="0"/>
                           <a:ea typeface="Calibri" pitchFamily="34" charset="-122"/>
                           <a:cs typeface="Calibri" pitchFamily="34" charset="-120"/>
                         </a:rPr>
-                        <a:t>-3,5</a:t>
+                        <a:t>3,5</a:t>
                       </a:r>
                       <a:endParaRPr lang="en-US" sz="850" dirty="0">
                         <a:latin typeface="Calibri" charset="0"/>
@@ -26099,6 +26164,73 @@
                     </a:solidFill>
                   </a:tcPr>
                 </a:tc>
+              </a:tr>
+              <a:tr h="224028">
+                <a:tc>
+                  <a:txBody>
+                    <a:bodyPr/>
+                    <a:lstStyle/>
+                    <a:p>
+                      <a:pPr algn="l" indent="0" marL="0">
+                        <a:buNone/>
+                      </a:pPr>
+                      <a:r>
+                        <a:rPr lang="en-US" sz="850" b="1" dirty="0">
+                          <a:solidFill>
+                            <a:srgbClr val="1F2933"/>
+                          </a:solidFill>
+                          <a:latin typeface="Calibri" pitchFamily="34" charset="0"/>
+                          <a:ea typeface="Calibri" pitchFamily="34" charset="-122"/>
+                          <a:cs typeface="Calibri" pitchFamily="34" charset="-120"/>
+                        </a:rPr>
+                        <a:t>AB CENTER</a:t>
+                      </a:r>
+                      <a:endParaRPr lang="en-US" sz="850" dirty="0">
+                        <a:latin typeface="Calibri" charset="0"/>
+                        <a:ea typeface="Calibri" charset="0"/>
+                        <a:cs typeface="Calibri" charset="0"/>
+                      </a:endParaRPr>
+                    </a:p>
+                  </a:txBody>
+                  <a:tcPr marL="64008" marR="64008" marT="0" marB="0" anchor="ctr">
+                    <a:lnL w="6350" cap="flat" cmpd="sng" algn="ctr">
+                      <a:solidFill>
+                        <a:srgbClr val="D5DBE3"/>
+                      </a:solidFill>
+                      <a:prstDash val="solid"/>
+                      <a:round/>
+                      <a:headEnd type="none" w="med" len="med"/>
+                      <a:tailEnd type="none" w="med" len="med"/>
+                    </a:lnL>
+                    <a:lnR w="6350" cap="flat" cmpd="sng" algn="ctr">
+                      <a:solidFill>
+                        <a:srgbClr val="D5DBE3"/>
+                      </a:solidFill>
+                      <a:prstDash val="solid"/>
+                      <a:round/>
+                      <a:headEnd type="none" w="med" len="med"/>
+                      <a:tailEnd type="none" w="med" len="med"/>
+                    </a:lnR>
+                    <a:lnT w="6350" cap="flat" cmpd="sng" algn="ctr">
+                      <a:solidFill>
+                        <a:srgbClr val="D5DBE3"/>
+                      </a:solidFill>
+                      <a:prstDash val="solid"/>
+                      <a:round/>
+                      <a:headEnd type="none" w="med" len="med"/>
+                      <a:tailEnd type="none" w="med" len="med"/>
+                    </a:lnT>
+                    <a:lnB w="6350" cap="flat" cmpd="sng" algn="ctr">
+                      <a:solidFill>
+                        <a:srgbClr val="D5DBE3"/>
+                      </a:solidFill>
+                      <a:prstDash val="solid"/>
+                      <a:round/>
+                      <a:headEnd type="none" w="med" len="med"/>
+                      <a:tailEnd type="none" w="med" len="med"/>
+                    </a:lnB>
+                  </a:tcPr>
+                </a:tc>
                 <a:tc>
                   <a:txBody>
                     <a:bodyPr/>
@@ -26108,6 +26240,201 @@
                         <a:buNone/>
                       </a:pPr>
                       <a:r>
+                        <a:rPr lang="en-US" sz="850" dirty="0">
+                          <a:solidFill>
+                            <a:srgbClr val="1F2933"/>
+                          </a:solidFill>
+                          <a:latin typeface="Calibri" pitchFamily="34" charset="0"/>
+                          <a:ea typeface="Calibri" pitchFamily="34" charset="-122"/>
+                          <a:cs typeface="Calibri" pitchFamily="34" charset="-120"/>
+                        </a:rPr>
+                        <a:t>–</a:t>
+                      </a:r>
+                      <a:endParaRPr lang="en-US" sz="850" dirty="0">
+                        <a:latin typeface="Calibri" charset="0"/>
+                        <a:ea typeface="Calibri" charset="0"/>
+                        <a:cs typeface="Calibri" charset="0"/>
+                      </a:endParaRPr>
+                    </a:p>
+                  </a:txBody>
+                  <a:tcPr marL="64008" marR="64008" marT="0" marB="0" anchor="ctr">
+                    <a:lnL w="6350" cap="flat" cmpd="sng" algn="ctr">
+                      <a:solidFill>
+                        <a:srgbClr val="D5DBE3"/>
+                      </a:solidFill>
+                      <a:prstDash val="solid"/>
+                      <a:round/>
+                      <a:headEnd type="none" w="med" len="med"/>
+                      <a:tailEnd type="none" w="med" len="med"/>
+                    </a:lnL>
+                    <a:lnR w="6350" cap="flat" cmpd="sng" algn="ctr">
+                      <a:solidFill>
+                        <a:srgbClr val="D5DBE3"/>
+                      </a:solidFill>
+                      <a:prstDash val="solid"/>
+                      <a:round/>
+                      <a:headEnd type="none" w="med" len="med"/>
+                      <a:tailEnd type="none" w="med" len="med"/>
+                    </a:lnR>
+                    <a:lnT w="6350" cap="flat" cmpd="sng" algn="ctr">
+                      <a:solidFill>
+                        <a:srgbClr val="D5DBE3"/>
+                      </a:solidFill>
+                      <a:prstDash val="solid"/>
+                      <a:round/>
+                      <a:headEnd type="none" w="med" len="med"/>
+                      <a:tailEnd type="none" w="med" len="med"/>
+                    </a:lnT>
+                    <a:lnB w="6350" cap="flat" cmpd="sng" algn="ctr">
+                      <a:solidFill>
+                        <a:srgbClr val="D5DBE3"/>
+                      </a:solidFill>
+                      <a:prstDash val="solid"/>
+                      <a:round/>
+                      <a:headEnd type="none" w="med" len="med"/>
+                      <a:tailEnd type="none" w="med" len="med"/>
+                    </a:lnB>
+                  </a:tcPr>
+                </a:tc>
+                <a:tc>
+                  <a:txBody>
+                    <a:bodyPr/>
+                    <a:lstStyle/>
+                    <a:p>
+                      <a:pPr algn="r" indent="0" marL="0">
+                        <a:buNone/>
+                      </a:pPr>
+                      <a:r>
+                        <a:rPr lang="en-US" sz="850" dirty="0">
+                          <a:solidFill>
+                            <a:srgbClr val="1F2933"/>
+                          </a:solidFill>
+                          <a:latin typeface="Calibri" pitchFamily="34" charset="0"/>
+                          <a:ea typeface="Calibri" pitchFamily="34" charset="-122"/>
+                          <a:cs typeface="Calibri" pitchFamily="34" charset="-120"/>
+                        </a:rPr>
+                        <a:t>-6,3</a:t>
+                      </a:r>
+                      <a:endParaRPr lang="en-US" sz="850" dirty="0">
+                        <a:latin typeface="Calibri" charset="0"/>
+                        <a:ea typeface="Calibri" charset="0"/>
+                        <a:cs typeface="Calibri" charset="0"/>
+                      </a:endParaRPr>
+                    </a:p>
+                  </a:txBody>
+                  <a:tcPr marL="64008" marR="64008" marT="0" marB="0" anchor="ctr">
+                    <a:lnL w="6350" cap="flat" cmpd="sng" algn="ctr">
+                      <a:solidFill>
+                        <a:srgbClr val="D5DBE3"/>
+                      </a:solidFill>
+                      <a:prstDash val="solid"/>
+                      <a:round/>
+                      <a:headEnd type="none" w="med" len="med"/>
+                      <a:tailEnd type="none" w="med" len="med"/>
+                    </a:lnL>
+                    <a:lnR w="6350" cap="flat" cmpd="sng" algn="ctr">
+                      <a:solidFill>
+                        <a:srgbClr val="D5DBE3"/>
+                      </a:solidFill>
+                      <a:prstDash val="solid"/>
+                      <a:round/>
+                      <a:headEnd type="none" w="med" len="med"/>
+                      <a:tailEnd type="none" w="med" len="med"/>
+                    </a:lnR>
+                    <a:lnT w="6350" cap="flat" cmpd="sng" algn="ctr">
+                      <a:solidFill>
+                        <a:srgbClr val="D5DBE3"/>
+                      </a:solidFill>
+                      <a:prstDash val="solid"/>
+                      <a:round/>
+                      <a:headEnd type="none" w="med" len="med"/>
+                      <a:tailEnd type="none" w="med" len="med"/>
+                    </a:lnT>
+                    <a:lnB w="6350" cap="flat" cmpd="sng" algn="ctr">
+                      <a:solidFill>
+                        <a:srgbClr val="D5DBE3"/>
+                      </a:solidFill>
+                      <a:prstDash val="solid"/>
+                      <a:round/>
+                      <a:headEnd type="none" w="med" len="med"/>
+                      <a:tailEnd type="none" w="med" len="med"/>
+                    </a:lnB>
+                  </a:tcPr>
+                </a:tc>
+                <a:tc>
+                  <a:txBody>
+                    <a:bodyPr/>
+                    <a:lstStyle/>
+                    <a:p>
+                      <a:pPr algn="r" indent="0" marL="0">
+                        <a:buNone/>
+                      </a:pPr>
+                      <a:r>
+                        <a:rPr lang="en-US" sz="850" dirty="0">
+                          <a:solidFill>
+                            <a:srgbClr val="1F2933"/>
+                          </a:solidFill>
+                          <a:latin typeface="Calibri" pitchFamily="34" charset="0"/>
+                          <a:ea typeface="Calibri" pitchFamily="34" charset="-122"/>
+                          <a:cs typeface="Calibri" pitchFamily="34" charset="-120"/>
+                        </a:rPr>
+                        <a:t>–</a:t>
+                      </a:r>
+                      <a:endParaRPr lang="en-US" sz="850" dirty="0">
+                        <a:latin typeface="Calibri" charset="0"/>
+                        <a:ea typeface="Calibri" charset="0"/>
+                        <a:cs typeface="Calibri" charset="0"/>
+                      </a:endParaRPr>
+                    </a:p>
+                  </a:txBody>
+                  <a:tcPr marL="64008" marR="64008" marT="0" marB="0" anchor="ctr">
+                    <a:lnL w="6350" cap="flat" cmpd="sng" algn="ctr">
+                      <a:solidFill>
+                        <a:srgbClr val="D5DBE3"/>
+                      </a:solidFill>
+                      <a:prstDash val="solid"/>
+                      <a:round/>
+                      <a:headEnd type="none" w="med" len="med"/>
+                      <a:tailEnd type="none" w="med" len="med"/>
+                    </a:lnL>
+                    <a:lnR w="6350" cap="flat" cmpd="sng" algn="ctr">
+                      <a:solidFill>
+                        <a:srgbClr val="D5DBE3"/>
+                      </a:solidFill>
+                      <a:prstDash val="solid"/>
+                      <a:round/>
+                      <a:headEnd type="none" w="med" len="med"/>
+                      <a:tailEnd type="none" w="med" len="med"/>
+                    </a:lnR>
+                    <a:lnT w="6350" cap="flat" cmpd="sng" algn="ctr">
+                      <a:solidFill>
+                        <a:srgbClr val="D5DBE3"/>
+                      </a:solidFill>
+                      <a:prstDash val="solid"/>
+                      <a:round/>
+                      <a:headEnd type="none" w="med" len="med"/>
+                      <a:tailEnd type="none" w="med" len="med"/>
+                    </a:lnT>
+                    <a:lnB w="6350" cap="flat" cmpd="sng" algn="ctr">
+                      <a:solidFill>
+                        <a:srgbClr val="D5DBE3"/>
+                      </a:solidFill>
+                      <a:prstDash val="solid"/>
+                      <a:round/>
+                      <a:headEnd type="none" w="med" len="med"/>
+                      <a:tailEnd type="none" w="med" len="med"/>
+                    </a:lnB>
+                  </a:tcPr>
+                </a:tc>
+                <a:tc>
+                  <a:txBody>
+                    <a:bodyPr/>
+                    <a:lstStyle/>
+                    <a:p>
+                      <a:pPr algn="r" indent="0" marL="0">
+                        <a:buNone/>
+                      </a:pPr>
+                      <a:r>
                         <a:rPr lang="en-US" sz="850" b="1" dirty="0">
                           <a:solidFill>
                             <a:srgbClr val="B3261E"/>
@@ -26116,7 +26443,7 @@
                           <a:ea typeface="Calibri" pitchFamily="34" charset="-122"/>
                           <a:cs typeface="Calibri" pitchFamily="34" charset="-120"/>
                         </a:rPr>
-                        <a:t>3,5</a:t>
+                        <a:t>-6,3</a:t>
                       </a:r>
                       <a:endParaRPr lang="en-US" sz="850" dirty="0">
                         <a:latin typeface="Calibri" charset="0"/>
@@ -26167,286 +26494,24 @@
                     </a:solidFill>
                   </a:tcPr>
                 </a:tc>
-              </a:tr>
-              <a:tr h="224028">
-                <a:tc>
-                  <a:txBody>
-                    <a:bodyPr/>
-                    <a:lstStyle/>
-                    <a:p>
-                      <a:pPr algn="l" indent="0" marL="0">
+                <a:tc>
+                  <a:txBody>
+                    <a:bodyPr/>
+                    <a:lstStyle/>
+                    <a:p>
+                      <a:pPr algn="r" indent="0" marL="0">
                         <a:buNone/>
                       </a:pPr>
                       <a:r>
                         <a:rPr lang="en-US" sz="850" b="1" dirty="0">
                           <a:solidFill>
-                            <a:srgbClr val="1F2933"/>
-                          </a:solidFill>
-                          <a:latin typeface="Calibri" pitchFamily="34" charset="0"/>
-                          <a:ea typeface="Calibri" pitchFamily="34" charset="-122"/>
-                          <a:cs typeface="Calibri" pitchFamily="34" charset="-120"/>
-                        </a:rPr>
-                        <a:t>AB CENTER</a:t>
-                      </a:r>
-                      <a:endParaRPr lang="en-US" sz="850" dirty="0">
-                        <a:latin typeface="Calibri" charset="0"/>
-                        <a:ea typeface="Calibri" charset="0"/>
-                        <a:cs typeface="Calibri" charset="0"/>
-                      </a:endParaRPr>
-                    </a:p>
-                  </a:txBody>
-                  <a:tcPr marL="64008" marR="64008" marT="0" marB="0" anchor="ctr">
-                    <a:lnL w="6350" cap="flat" cmpd="sng" algn="ctr">
-                      <a:solidFill>
-                        <a:srgbClr val="D5DBE3"/>
-                      </a:solidFill>
-                      <a:prstDash val="solid"/>
-                      <a:round/>
-                      <a:headEnd type="none" w="med" len="med"/>
-                      <a:tailEnd type="none" w="med" len="med"/>
-                    </a:lnL>
-                    <a:lnR w="6350" cap="flat" cmpd="sng" algn="ctr">
-                      <a:solidFill>
-                        <a:srgbClr val="D5DBE3"/>
-                      </a:solidFill>
-                      <a:prstDash val="solid"/>
-                      <a:round/>
-                      <a:headEnd type="none" w="med" len="med"/>
-                      <a:tailEnd type="none" w="med" len="med"/>
-                    </a:lnR>
-                    <a:lnT w="6350" cap="flat" cmpd="sng" algn="ctr">
-                      <a:solidFill>
-                        <a:srgbClr val="D5DBE3"/>
-                      </a:solidFill>
-                      <a:prstDash val="solid"/>
-                      <a:round/>
-                      <a:headEnd type="none" w="med" len="med"/>
-                      <a:tailEnd type="none" w="med" len="med"/>
-                    </a:lnT>
-                    <a:lnB w="6350" cap="flat" cmpd="sng" algn="ctr">
-                      <a:solidFill>
-                        <a:srgbClr val="D5DBE3"/>
-                      </a:solidFill>
-                      <a:prstDash val="solid"/>
-                      <a:round/>
-                      <a:headEnd type="none" w="med" len="med"/>
-                      <a:tailEnd type="none" w="med" len="med"/>
-                    </a:lnB>
-                  </a:tcPr>
-                </a:tc>
-                <a:tc>
-                  <a:txBody>
-                    <a:bodyPr/>
-                    <a:lstStyle/>
-                    <a:p>
-                      <a:pPr algn="r" indent="0" marL="0">
-                        <a:buNone/>
-                      </a:pPr>
-                      <a:r>
-                        <a:rPr lang="en-US" sz="850" dirty="0">
-                          <a:solidFill>
-                            <a:srgbClr val="1F2933"/>
-                          </a:solidFill>
-                          <a:latin typeface="Calibri" pitchFamily="34" charset="0"/>
-                          <a:ea typeface="Calibri" pitchFamily="34" charset="-122"/>
-                          <a:cs typeface="Calibri" pitchFamily="34" charset="-120"/>
-                        </a:rPr>
-                        <a:t>–</a:t>
-                      </a:r>
-                      <a:endParaRPr lang="en-US" sz="850" dirty="0">
-                        <a:latin typeface="Calibri" charset="0"/>
-                        <a:ea typeface="Calibri" charset="0"/>
-                        <a:cs typeface="Calibri" charset="0"/>
-                      </a:endParaRPr>
-                    </a:p>
-                  </a:txBody>
-                  <a:tcPr marL="64008" marR="64008" marT="0" marB="0" anchor="ctr">
-                    <a:lnL w="6350" cap="flat" cmpd="sng" algn="ctr">
-                      <a:solidFill>
-                        <a:srgbClr val="D5DBE3"/>
-                      </a:solidFill>
-                      <a:prstDash val="solid"/>
-                      <a:round/>
-                      <a:headEnd type="none" w="med" len="med"/>
-                      <a:tailEnd type="none" w="med" len="med"/>
-                    </a:lnL>
-                    <a:lnR w="6350" cap="flat" cmpd="sng" algn="ctr">
-                      <a:solidFill>
-                        <a:srgbClr val="D5DBE3"/>
-                      </a:solidFill>
-                      <a:prstDash val="solid"/>
-                      <a:round/>
-                      <a:headEnd type="none" w="med" len="med"/>
-                      <a:tailEnd type="none" w="med" len="med"/>
-                    </a:lnR>
-                    <a:lnT w="6350" cap="flat" cmpd="sng" algn="ctr">
-                      <a:solidFill>
-                        <a:srgbClr val="D5DBE3"/>
-                      </a:solidFill>
-                      <a:prstDash val="solid"/>
-                      <a:round/>
-                      <a:headEnd type="none" w="med" len="med"/>
-                      <a:tailEnd type="none" w="med" len="med"/>
-                    </a:lnT>
-                    <a:lnB w="6350" cap="flat" cmpd="sng" algn="ctr">
-                      <a:solidFill>
-                        <a:srgbClr val="D5DBE3"/>
-                      </a:solidFill>
-                      <a:prstDash val="solid"/>
-                      <a:round/>
-                      <a:headEnd type="none" w="med" len="med"/>
-                      <a:tailEnd type="none" w="med" len="med"/>
-                    </a:lnB>
-                  </a:tcPr>
-                </a:tc>
-                <a:tc>
-                  <a:txBody>
-                    <a:bodyPr/>
-                    <a:lstStyle/>
-                    <a:p>
-                      <a:pPr algn="r" indent="0" marL="0">
-                        <a:buNone/>
-                      </a:pPr>
-                      <a:r>
-                        <a:rPr lang="en-US" sz="850" dirty="0">
-                          <a:solidFill>
-                            <a:srgbClr val="1F2933"/>
-                          </a:solidFill>
-                          <a:latin typeface="Calibri" pitchFamily="34" charset="0"/>
-                          <a:ea typeface="Calibri" pitchFamily="34" charset="-122"/>
-                          <a:cs typeface="Calibri" pitchFamily="34" charset="-120"/>
-                        </a:rPr>
-                        <a:t>-6,3</a:t>
-                      </a:r>
-                      <a:endParaRPr lang="en-US" sz="850" dirty="0">
-                        <a:latin typeface="Calibri" charset="0"/>
-                        <a:ea typeface="Calibri" charset="0"/>
-                        <a:cs typeface="Calibri" charset="0"/>
-                      </a:endParaRPr>
-                    </a:p>
-                  </a:txBody>
-                  <a:tcPr marL="64008" marR="64008" marT="0" marB="0" anchor="ctr">
-                    <a:lnL w="6350" cap="flat" cmpd="sng" algn="ctr">
-                      <a:solidFill>
-                        <a:srgbClr val="D5DBE3"/>
-                      </a:solidFill>
-                      <a:prstDash val="solid"/>
-                      <a:round/>
-                      <a:headEnd type="none" w="med" len="med"/>
-                      <a:tailEnd type="none" w="med" len="med"/>
-                    </a:lnL>
-                    <a:lnR w="6350" cap="flat" cmpd="sng" algn="ctr">
-                      <a:solidFill>
-                        <a:srgbClr val="D5DBE3"/>
-                      </a:solidFill>
-                      <a:prstDash val="solid"/>
-                      <a:round/>
-                      <a:headEnd type="none" w="med" len="med"/>
-                      <a:tailEnd type="none" w="med" len="med"/>
-                    </a:lnR>
-                    <a:lnT w="6350" cap="flat" cmpd="sng" algn="ctr">
-                      <a:solidFill>
-                        <a:srgbClr val="D5DBE3"/>
-                      </a:solidFill>
-                      <a:prstDash val="solid"/>
-                      <a:round/>
-                      <a:headEnd type="none" w="med" len="med"/>
-                      <a:tailEnd type="none" w="med" len="med"/>
-                    </a:lnT>
-                    <a:lnB w="6350" cap="flat" cmpd="sng" algn="ctr">
-                      <a:solidFill>
-                        <a:srgbClr val="D5DBE3"/>
-                      </a:solidFill>
-                      <a:prstDash val="solid"/>
-                      <a:round/>
-                      <a:headEnd type="none" w="med" len="med"/>
-                      <a:tailEnd type="none" w="med" len="med"/>
-                    </a:lnB>
-                  </a:tcPr>
-                </a:tc>
-                <a:tc>
-                  <a:txBody>
-                    <a:bodyPr/>
-                    <a:lstStyle/>
-                    <a:p>
-                      <a:pPr algn="r" indent="0" marL="0">
-                        <a:buNone/>
-                      </a:pPr>
-                      <a:r>
-                        <a:rPr lang="en-US" sz="850" dirty="0">
-                          <a:solidFill>
-                            <a:srgbClr val="1F2933"/>
-                          </a:solidFill>
-                          <a:latin typeface="Calibri" pitchFamily="34" charset="0"/>
-                          <a:ea typeface="Calibri" pitchFamily="34" charset="-122"/>
-                          <a:cs typeface="Calibri" pitchFamily="34" charset="-120"/>
-                        </a:rPr>
-                        <a:t>–</a:t>
-                      </a:r>
-                      <a:endParaRPr lang="en-US" sz="850" dirty="0">
-                        <a:latin typeface="Calibri" charset="0"/>
-                        <a:ea typeface="Calibri" charset="0"/>
-                        <a:cs typeface="Calibri" charset="0"/>
-                      </a:endParaRPr>
-                    </a:p>
-                  </a:txBody>
-                  <a:tcPr marL="64008" marR="64008" marT="0" marB="0" anchor="ctr">
-                    <a:lnL w="6350" cap="flat" cmpd="sng" algn="ctr">
-                      <a:solidFill>
-                        <a:srgbClr val="D5DBE3"/>
-                      </a:solidFill>
-                      <a:prstDash val="solid"/>
-                      <a:round/>
-                      <a:headEnd type="none" w="med" len="med"/>
-                      <a:tailEnd type="none" w="med" len="med"/>
-                    </a:lnL>
-                    <a:lnR w="6350" cap="flat" cmpd="sng" algn="ctr">
-                      <a:solidFill>
-                        <a:srgbClr val="D5DBE3"/>
-                      </a:solidFill>
-                      <a:prstDash val="solid"/>
-                      <a:round/>
-                      <a:headEnd type="none" w="med" len="med"/>
-                      <a:tailEnd type="none" w="med" len="med"/>
-                    </a:lnR>
-                    <a:lnT w="6350" cap="flat" cmpd="sng" algn="ctr">
-                      <a:solidFill>
-                        <a:srgbClr val="D5DBE3"/>
-                      </a:solidFill>
-                      <a:prstDash val="solid"/>
-                      <a:round/>
-                      <a:headEnd type="none" w="med" len="med"/>
-                      <a:tailEnd type="none" w="med" len="med"/>
-                    </a:lnT>
-                    <a:lnB w="6350" cap="flat" cmpd="sng" algn="ctr">
-                      <a:solidFill>
-                        <a:srgbClr val="D5DBE3"/>
-                      </a:solidFill>
-                      <a:prstDash val="solid"/>
-                      <a:round/>
-                      <a:headEnd type="none" w="med" len="med"/>
-                      <a:tailEnd type="none" w="med" len="med"/>
-                    </a:lnB>
-                  </a:tcPr>
-                </a:tc>
-                <a:tc>
-                  <a:txBody>
-                    <a:bodyPr/>
-                    <a:lstStyle/>
-                    <a:p>
-                      <a:pPr algn="r" indent="0" marL="0">
-                        <a:buNone/>
-                      </a:pPr>
-                      <a:r>
-                        <a:rPr lang="en-US" sz="850" b="1" dirty="0">
-                          <a:solidFill>
                             <a:srgbClr val="B3261E"/>
                           </a:solidFill>
                           <a:latin typeface="Calibri" pitchFamily="34" charset="0"/>
                           <a:ea typeface="Calibri" pitchFamily="34" charset="-122"/>
                           <a:cs typeface="Calibri" pitchFamily="34" charset="-120"/>
                         </a:rPr>
-                        <a:t>-6,3</a:t>
+                        <a:t>6,3</a:t>
                       </a:r>
                       <a:endParaRPr lang="en-US" sz="850" dirty="0">
                         <a:latin typeface="Calibri" charset="0"/>
@@ -26497,6 +26562,73 @@
                     </a:solidFill>
                   </a:tcPr>
                 </a:tc>
+              </a:tr>
+              <a:tr h="224028">
+                <a:tc>
+                  <a:txBody>
+                    <a:bodyPr/>
+                    <a:lstStyle/>
+                    <a:p>
+                      <a:pPr algn="l" indent="0" marL="0">
+                        <a:buNone/>
+                      </a:pPr>
+                      <a:r>
+                        <a:rPr lang="en-US" sz="850" b="1" dirty="0">
+                          <a:solidFill>
+                            <a:srgbClr val="1F2933"/>
+                          </a:solidFill>
+                          <a:latin typeface="Calibri" pitchFamily="34" charset="0"/>
+                          <a:ea typeface="Calibri" pitchFamily="34" charset="-122"/>
+                          <a:cs typeface="Calibri" pitchFamily="34" charset="-120"/>
+                        </a:rPr>
+                        <a:t>RHD CI</a:t>
+                      </a:r>
+                      <a:endParaRPr lang="en-US" sz="850" dirty="0">
+                        <a:latin typeface="Calibri" charset="0"/>
+                        <a:ea typeface="Calibri" charset="0"/>
+                        <a:cs typeface="Calibri" charset="0"/>
+                      </a:endParaRPr>
+                    </a:p>
+                  </a:txBody>
+                  <a:tcPr marL="64008" marR="64008" marT="0" marB="0" anchor="ctr">
+                    <a:lnL w="6350" cap="flat" cmpd="sng" algn="ctr">
+                      <a:solidFill>
+                        <a:srgbClr val="D5DBE3"/>
+                      </a:solidFill>
+                      <a:prstDash val="solid"/>
+                      <a:round/>
+                      <a:headEnd type="none" w="med" len="med"/>
+                      <a:tailEnd type="none" w="med" len="med"/>
+                    </a:lnL>
+                    <a:lnR w="6350" cap="flat" cmpd="sng" algn="ctr">
+                      <a:solidFill>
+                        <a:srgbClr val="D5DBE3"/>
+                      </a:solidFill>
+                      <a:prstDash val="solid"/>
+                      <a:round/>
+                      <a:headEnd type="none" w="med" len="med"/>
+                      <a:tailEnd type="none" w="med" len="med"/>
+                    </a:lnR>
+                    <a:lnT w="6350" cap="flat" cmpd="sng" algn="ctr">
+                      <a:solidFill>
+                        <a:srgbClr val="D5DBE3"/>
+                      </a:solidFill>
+                      <a:prstDash val="solid"/>
+                      <a:round/>
+                      <a:headEnd type="none" w="med" len="med"/>
+                      <a:tailEnd type="none" w="med" len="med"/>
+                    </a:lnT>
+                    <a:lnB w="6350" cap="flat" cmpd="sng" algn="ctr">
+                      <a:solidFill>
+                        <a:srgbClr val="D5DBE3"/>
+                      </a:solidFill>
+                      <a:prstDash val="solid"/>
+                      <a:round/>
+                      <a:headEnd type="none" w="med" len="med"/>
+                      <a:tailEnd type="none" w="med" len="med"/>
+                    </a:lnB>
+                  </a:tcPr>
+                </a:tc>
                 <a:tc>
                   <a:txBody>
                     <a:bodyPr/>
@@ -26506,6 +26638,201 @@
                         <a:buNone/>
                       </a:pPr>
                       <a:r>
+                        <a:rPr lang="en-US" sz="850" dirty="0">
+                          <a:solidFill>
+                            <a:srgbClr val="1F2933"/>
+                          </a:solidFill>
+                          <a:latin typeface="Calibri" pitchFamily="34" charset="0"/>
+                          <a:ea typeface="Calibri" pitchFamily="34" charset="-122"/>
+                          <a:cs typeface="Calibri" pitchFamily="34" charset="-120"/>
+                        </a:rPr>
+                        <a:t>–</a:t>
+                      </a:r>
+                      <a:endParaRPr lang="en-US" sz="850" dirty="0">
+                        <a:latin typeface="Calibri" charset="0"/>
+                        <a:ea typeface="Calibri" charset="0"/>
+                        <a:cs typeface="Calibri" charset="0"/>
+                      </a:endParaRPr>
+                    </a:p>
+                  </a:txBody>
+                  <a:tcPr marL="64008" marR="64008" marT="0" marB="0" anchor="ctr">
+                    <a:lnL w="6350" cap="flat" cmpd="sng" algn="ctr">
+                      <a:solidFill>
+                        <a:srgbClr val="D5DBE3"/>
+                      </a:solidFill>
+                      <a:prstDash val="solid"/>
+                      <a:round/>
+                      <a:headEnd type="none" w="med" len="med"/>
+                      <a:tailEnd type="none" w="med" len="med"/>
+                    </a:lnL>
+                    <a:lnR w="6350" cap="flat" cmpd="sng" algn="ctr">
+                      <a:solidFill>
+                        <a:srgbClr val="D5DBE3"/>
+                      </a:solidFill>
+                      <a:prstDash val="solid"/>
+                      <a:round/>
+                      <a:headEnd type="none" w="med" len="med"/>
+                      <a:tailEnd type="none" w="med" len="med"/>
+                    </a:lnR>
+                    <a:lnT w="6350" cap="flat" cmpd="sng" algn="ctr">
+                      <a:solidFill>
+                        <a:srgbClr val="D5DBE3"/>
+                      </a:solidFill>
+                      <a:prstDash val="solid"/>
+                      <a:round/>
+                      <a:headEnd type="none" w="med" len="med"/>
+                      <a:tailEnd type="none" w="med" len="med"/>
+                    </a:lnT>
+                    <a:lnB w="6350" cap="flat" cmpd="sng" algn="ctr">
+                      <a:solidFill>
+                        <a:srgbClr val="D5DBE3"/>
+                      </a:solidFill>
+                      <a:prstDash val="solid"/>
+                      <a:round/>
+                      <a:headEnd type="none" w="med" len="med"/>
+                      <a:tailEnd type="none" w="med" len="med"/>
+                    </a:lnB>
+                  </a:tcPr>
+                </a:tc>
+                <a:tc>
+                  <a:txBody>
+                    <a:bodyPr/>
+                    <a:lstStyle/>
+                    <a:p>
+                      <a:pPr algn="r" indent="0" marL="0">
+                        <a:buNone/>
+                      </a:pPr>
+                      <a:r>
+                        <a:rPr lang="en-US" sz="850" dirty="0">
+                          <a:solidFill>
+                            <a:srgbClr val="1F2933"/>
+                          </a:solidFill>
+                          <a:latin typeface="Calibri" pitchFamily="34" charset="0"/>
+                          <a:ea typeface="Calibri" pitchFamily="34" charset="-122"/>
+                          <a:cs typeface="Calibri" pitchFamily="34" charset="-120"/>
+                        </a:rPr>
+                        <a:t>-45,1</a:t>
+                      </a:r>
+                      <a:endParaRPr lang="en-US" sz="850" dirty="0">
+                        <a:latin typeface="Calibri" charset="0"/>
+                        <a:ea typeface="Calibri" charset="0"/>
+                        <a:cs typeface="Calibri" charset="0"/>
+                      </a:endParaRPr>
+                    </a:p>
+                  </a:txBody>
+                  <a:tcPr marL="64008" marR="64008" marT="0" marB="0" anchor="ctr">
+                    <a:lnL w="6350" cap="flat" cmpd="sng" algn="ctr">
+                      <a:solidFill>
+                        <a:srgbClr val="D5DBE3"/>
+                      </a:solidFill>
+                      <a:prstDash val="solid"/>
+                      <a:round/>
+                      <a:headEnd type="none" w="med" len="med"/>
+                      <a:tailEnd type="none" w="med" len="med"/>
+                    </a:lnL>
+                    <a:lnR w="6350" cap="flat" cmpd="sng" algn="ctr">
+                      <a:solidFill>
+                        <a:srgbClr val="D5DBE3"/>
+                      </a:solidFill>
+                      <a:prstDash val="solid"/>
+                      <a:round/>
+                      <a:headEnd type="none" w="med" len="med"/>
+                      <a:tailEnd type="none" w="med" len="med"/>
+                    </a:lnR>
+                    <a:lnT w="6350" cap="flat" cmpd="sng" algn="ctr">
+                      <a:solidFill>
+                        <a:srgbClr val="D5DBE3"/>
+                      </a:solidFill>
+                      <a:prstDash val="solid"/>
+                      <a:round/>
+                      <a:headEnd type="none" w="med" len="med"/>
+                      <a:tailEnd type="none" w="med" len="med"/>
+                    </a:lnT>
+                    <a:lnB w="6350" cap="flat" cmpd="sng" algn="ctr">
+                      <a:solidFill>
+                        <a:srgbClr val="D5DBE3"/>
+                      </a:solidFill>
+                      <a:prstDash val="solid"/>
+                      <a:round/>
+                      <a:headEnd type="none" w="med" len="med"/>
+                      <a:tailEnd type="none" w="med" len="med"/>
+                    </a:lnB>
+                  </a:tcPr>
+                </a:tc>
+                <a:tc>
+                  <a:txBody>
+                    <a:bodyPr/>
+                    <a:lstStyle/>
+                    <a:p>
+                      <a:pPr algn="r" indent="0" marL="0">
+                        <a:buNone/>
+                      </a:pPr>
+                      <a:r>
+                        <a:rPr lang="en-US" sz="850" dirty="0">
+                          <a:solidFill>
+                            <a:srgbClr val="1F2933"/>
+                          </a:solidFill>
+                          <a:latin typeface="Calibri" pitchFamily="34" charset="0"/>
+                          <a:ea typeface="Calibri" pitchFamily="34" charset="-122"/>
+                          <a:cs typeface="Calibri" pitchFamily="34" charset="-120"/>
+                        </a:rPr>
+                        <a:t>–</a:t>
+                      </a:r>
+                      <a:endParaRPr lang="en-US" sz="850" dirty="0">
+                        <a:latin typeface="Calibri" charset="0"/>
+                        <a:ea typeface="Calibri" charset="0"/>
+                        <a:cs typeface="Calibri" charset="0"/>
+                      </a:endParaRPr>
+                    </a:p>
+                  </a:txBody>
+                  <a:tcPr marL="64008" marR="64008" marT="0" marB="0" anchor="ctr">
+                    <a:lnL w="6350" cap="flat" cmpd="sng" algn="ctr">
+                      <a:solidFill>
+                        <a:srgbClr val="D5DBE3"/>
+                      </a:solidFill>
+                      <a:prstDash val="solid"/>
+                      <a:round/>
+                      <a:headEnd type="none" w="med" len="med"/>
+                      <a:tailEnd type="none" w="med" len="med"/>
+                    </a:lnL>
+                    <a:lnR w="6350" cap="flat" cmpd="sng" algn="ctr">
+                      <a:solidFill>
+                        <a:srgbClr val="D5DBE3"/>
+                      </a:solidFill>
+                      <a:prstDash val="solid"/>
+                      <a:round/>
+                      <a:headEnd type="none" w="med" len="med"/>
+                      <a:tailEnd type="none" w="med" len="med"/>
+                    </a:lnR>
+                    <a:lnT w="6350" cap="flat" cmpd="sng" algn="ctr">
+                      <a:solidFill>
+                        <a:srgbClr val="D5DBE3"/>
+                      </a:solidFill>
+                      <a:prstDash val="solid"/>
+                      <a:round/>
+                      <a:headEnd type="none" w="med" len="med"/>
+                      <a:tailEnd type="none" w="med" len="med"/>
+                    </a:lnT>
+                    <a:lnB w="6350" cap="flat" cmpd="sng" algn="ctr">
+                      <a:solidFill>
+                        <a:srgbClr val="D5DBE3"/>
+                      </a:solidFill>
+                      <a:prstDash val="solid"/>
+                      <a:round/>
+                      <a:headEnd type="none" w="med" len="med"/>
+                      <a:tailEnd type="none" w="med" len="med"/>
+                    </a:lnB>
+                  </a:tcPr>
+                </a:tc>
+                <a:tc>
+                  <a:txBody>
+                    <a:bodyPr/>
+                    <a:lstStyle/>
+                    <a:p>
+                      <a:pPr algn="r" indent="0" marL="0">
+                        <a:buNone/>
+                      </a:pPr>
+                      <a:r>
                         <a:rPr lang="en-US" sz="850" b="1" dirty="0">
                           <a:solidFill>
                             <a:srgbClr val="B3261E"/>
@@ -26514,7 +26841,7 @@
                           <a:ea typeface="Calibri" pitchFamily="34" charset="-122"/>
                           <a:cs typeface="Calibri" pitchFamily="34" charset="-120"/>
                         </a:rPr>
-                        <a:t>6,3</a:t>
+                        <a:t>-45,1</a:t>
                       </a:r>
                       <a:endParaRPr lang="en-US" sz="850" dirty="0">
                         <a:latin typeface="Calibri" charset="0"/>
@@ -26565,286 +26892,24 @@
                     </a:solidFill>
                   </a:tcPr>
                 </a:tc>
-              </a:tr>
-              <a:tr h="224028">
-                <a:tc>
-                  <a:txBody>
-                    <a:bodyPr/>
-                    <a:lstStyle/>
-                    <a:p>
-                      <a:pPr algn="l" indent="0" marL="0">
+                <a:tc>
+                  <a:txBody>
+                    <a:bodyPr/>
+                    <a:lstStyle/>
+                    <a:p>
+                      <a:pPr algn="r" indent="0" marL="0">
                         <a:buNone/>
                       </a:pPr>
                       <a:r>
                         <a:rPr lang="en-US" sz="850" b="1" dirty="0">
                           <a:solidFill>
-                            <a:srgbClr val="1F2933"/>
-                          </a:solidFill>
-                          <a:latin typeface="Calibri" pitchFamily="34" charset="0"/>
-                          <a:ea typeface="Calibri" pitchFamily="34" charset="-122"/>
-                          <a:cs typeface="Calibri" pitchFamily="34" charset="-120"/>
-                        </a:rPr>
-                        <a:t>RHD CI</a:t>
-                      </a:r>
-                      <a:endParaRPr lang="en-US" sz="850" dirty="0">
-                        <a:latin typeface="Calibri" charset="0"/>
-                        <a:ea typeface="Calibri" charset="0"/>
-                        <a:cs typeface="Calibri" charset="0"/>
-                      </a:endParaRPr>
-                    </a:p>
-                  </a:txBody>
-                  <a:tcPr marL="64008" marR="64008" marT="0" marB="0" anchor="ctr">
-                    <a:lnL w="6350" cap="flat" cmpd="sng" algn="ctr">
-                      <a:solidFill>
-                        <a:srgbClr val="D5DBE3"/>
-                      </a:solidFill>
-                      <a:prstDash val="solid"/>
-                      <a:round/>
-                      <a:headEnd type="none" w="med" len="med"/>
-                      <a:tailEnd type="none" w="med" len="med"/>
-                    </a:lnL>
-                    <a:lnR w="6350" cap="flat" cmpd="sng" algn="ctr">
-                      <a:solidFill>
-                        <a:srgbClr val="D5DBE3"/>
-                      </a:solidFill>
-                      <a:prstDash val="solid"/>
-                      <a:round/>
-                      <a:headEnd type="none" w="med" len="med"/>
-                      <a:tailEnd type="none" w="med" len="med"/>
-                    </a:lnR>
-                    <a:lnT w="6350" cap="flat" cmpd="sng" algn="ctr">
-                      <a:solidFill>
-                        <a:srgbClr val="D5DBE3"/>
-                      </a:solidFill>
-                      <a:prstDash val="solid"/>
-                      <a:round/>
-                      <a:headEnd type="none" w="med" len="med"/>
-                      <a:tailEnd type="none" w="med" len="med"/>
-                    </a:lnT>
-                    <a:lnB w="6350" cap="flat" cmpd="sng" algn="ctr">
-                      <a:solidFill>
-                        <a:srgbClr val="D5DBE3"/>
-                      </a:solidFill>
-                      <a:prstDash val="solid"/>
-                      <a:round/>
-                      <a:headEnd type="none" w="med" len="med"/>
-                      <a:tailEnd type="none" w="med" len="med"/>
-                    </a:lnB>
-                  </a:tcPr>
-                </a:tc>
-                <a:tc>
-                  <a:txBody>
-                    <a:bodyPr/>
-                    <a:lstStyle/>
-                    <a:p>
-                      <a:pPr algn="r" indent="0" marL="0">
-                        <a:buNone/>
-                      </a:pPr>
-                      <a:r>
-                        <a:rPr lang="en-US" sz="850" dirty="0">
-                          <a:solidFill>
-                            <a:srgbClr val="1F2933"/>
-                          </a:solidFill>
-                          <a:latin typeface="Calibri" pitchFamily="34" charset="0"/>
-                          <a:ea typeface="Calibri" pitchFamily="34" charset="-122"/>
-                          <a:cs typeface="Calibri" pitchFamily="34" charset="-120"/>
-                        </a:rPr>
-                        <a:t>–</a:t>
-                      </a:r>
-                      <a:endParaRPr lang="en-US" sz="850" dirty="0">
-                        <a:latin typeface="Calibri" charset="0"/>
-                        <a:ea typeface="Calibri" charset="0"/>
-                        <a:cs typeface="Calibri" charset="0"/>
-                      </a:endParaRPr>
-                    </a:p>
-                  </a:txBody>
-                  <a:tcPr marL="64008" marR="64008" marT="0" marB="0" anchor="ctr">
-                    <a:lnL w="6350" cap="flat" cmpd="sng" algn="ctr">
-                      <a:solidFill>
-                        <a:srgbClr val="D5DBE3"/>
-                      </a:solidFill>
-                      <a:prstDash val="solid"/>
-                      <a:round/>
-                      <a:headEnd type="none" w="med" len="med"/>
-                      <a:tailEnd type="none" w="med" len="med"/>
-                    </a:lnL>
-                    <a:lnR w="6350" cap="flat" cmpd="sng" algn="ctr">
-                      <a:solidFill>
-                        <a:srgbClr val="D5DBE3"/>
-                      </a:solidFill>
-                      <a:prstDash val="solid"/>
-                      <a:round/>
-                      <a:headEnd type="none" w="med" len="med"/>
-                      <a:tailEnd type="none" w="med" len="med"/>
-                    </a:lnR>
-                    <a:lnT w="6350" cap="flat" cmpd="sng" algn="ctr">
-                      <a:solidFill>
-                        <a:srgbClr val="D5DBE3"/>
-                      </a:solidFill>
-                      <a:prstDash val="solid"/>
-                      <a:round/>
-                      <a:headEnd type="none" w="med" len="med"/>
-                      <a:tailEnd type="none" w="med" len="med"/>
-                    </a:lnT>
-                    <a:lnB w="6350" cap="flat" cmpd="sng" algn="ctr">
-                      <a:solidFill>
-                        <a:srgbClr val="D5DBE3"/>
-                      </a:solidFill>
-                      <a:prstDash val="solid"/>
-                      <a:round/>
-                      <a:headEnd type="none" w="med" len="med"/>
-                      <a:tailEnd type="none" w="med" len="med"/>
-                    </a:lnB>
-                  </a:tcPr>
-                </a:tc>
-                <a:tc>
-                  <a:txBody>
-                    <a:bodyPr/>
-                    <a:lstStyle/>
-                    <a:p>
-                      <a:pPr algn="r" indent="0" marL="0">
-                        <a:buNone/>
-                      </a:pPr>
-                      <a:r>
-                        <a:rPr lang="en-US" sz="850" dirty="0">
-                          <a:solidFill>
-                            <a:srgbClr val="1F2933"/>
-                          </a:solidFill>
-                          <a:latin typeface="Calibri" pitchFamily="34" charset="0"/>
-                          <a:ea typeface="Calibri" pitchFamily="34" charset="-122"/>
-                          <a:cs typeface="Calibri" pitchFamily="34" charset="-120"/>
-                        </a:rPr>
-                        <a:t>-45,1</a:t>
-                      </a:r>
-                      <a:endParaRPr lang="en-US" sz="850" dirty="0">
-                        <a:latin typeface="Calibri" charset="0"/>
-                        <a:ea typeface="Calibri" charset="0"/>
-                        <a:cs typeface="Calibri" charset="0"/>
-                      </a:endParaRPr>
-                    </a:p>
-                  </a:txBody>
-                  <a:tcPr marL="64008" marR="64008" marT="0" marB="0" anchor="ctr">
-                    <a:lnL w="6350" cap="flat" cmpd="sng" algn="ctr">
-                      <a:solidFill>
-                        <a:srgbClr val="D5DBE3"/>
-                      </a:solidFill>
-                      <a:prstDash val="solid"/>
-                      <a:round/>
-                      <a:headEnd type="none" w="med" len="med"/>
-                      <a:tailEnd type="none" w="med" len="med"/>
-                    </a:lnL>
-                    <a:lnR w="6350" cap="flat" cmpd="sng" algn="ctr">
-                      <a:solidFill>
-                        <a:srgbClr val="D5DBE3"/>
-                      </a:solidFill>
-                      <a:prstDash val="solid"/>
-                      <a:round/>
-                      <a:headEnd type="none" w="med" len="med"/>
-                      <a:tailEnd type="none" w="med" len="med"/>
-                    </a:lnR>
-                    <a:lnT w="6350" cap="flat" cmpd="sng" algn="ctr">
-                      <a:solidFill>
-                        <a:srgbClr val="D5DBE3"/>
-                      </a:solidFill>
-                      <a:prstDash val="solid"/>
-                      <a:round/>
-                      <a:headEnd type="none" w="med" len="med"/>
-                      <a:tailEnd type="none" w="med" len="med"/>
-                    </a:lnT>
-                    <a:lnB w="6350" cap="flat" cmpd="sng" algn="ctr">
-                      <a:solidFill>
-                        <a:srgbClr val="D5DBE3"/>
-                      </a:solidFill>
-                      <a:prstDash val="solid"/>
-                      <a:round/>
-                      <a:headEnd type="none" w="med" len="med"/>
-                      <a:tailEnd type="none" w="med" len="med"/>
-                    </a:lnB>
-                  </a:tcPr>
-                </a:tc>
-                <a:tc>
-                  <a:txBody>
-                    <a:bodyPr/>
-                    <a:lstStyle/>
-                    <a:p>
-                      <a:pPr algn="r" indent="0" marL="0">
-                        <a:buNone/>
-                      </a:pPr>
-                      <a:r>
-                        <a:rPr lang="en-US" sz="850" dirty="0">
-                          <a:solidFill>
-                            <a:srgbClr val="1F2933"/>
-                          </a:solidFill>
-                          <a:latin typeface="Calibri" pitchFamily="34" charset="0"/>
-                          <a:ea typeface="Calibri" pitchFamily="34" charset="-122"/>
-                          <a:cs typeface="Calibri" pitchFamily="34" charset="-120"/>
-                        </a:rPr>
-                        <a:t>–</a:t>
-                      </a:r>
-                      <a:endParaRPr lang="en-US" sz="850" dirty="0">
-                        <a:latin typeface="Calibri" charset="0"/>
-                        <a:ea typeface="Calibri" charset="0"/>
-                        <a:cs typeface="Calibri" charset="0"/>
-                      </a:endParaRPr>
-                    </a:p>
-                  </a:txBody>
-                  <a:tcPr marL="64008" marR="64008" marT="0" marB="0" anchor="ctr">
-                    <a:lnL w="6350" cap="flat" cmpd="sng" algn="ctr">
-                      <a:solidFill>
-                        <a:srgbClr val="D5DBE3"/>
-                      </a:solidFill>
-                      <a:prstDash val="solid"/>
-                      <a:round/>
-                      <a:headEnd type="none" w="med" len="med"/>
-                      <a:tailEnd type="none" w="med" len="med"/>
-                    </a:lnL>
-                    <a:lnR w="6350" cap="flat" cmpd="sng" algn="ctr">
-                      <a:solidFill>
-                        <a:srgbClr val="D5DBE3"/>
-                      </a:solidFill>
-                      <a:prstDash val="solid"/>
-                      <a:round/>
-                      <a:headEnd type="none" w="med" len="med"/>
-                      <a:tailEnd type="none" w="med" len="med"/>
-                    </a:lnR>
-                    <a:lnT w="6350" cap="flat" cmpd="sng" algn="ctr">
-                      <a:solidFill>
-                        <a:srgbClr val="D5DBE3"/>
-                      </a:solidFill>
-                      <a:prstDash val="solid"/>
-                      <a:round/>
-                      <a:headEnd type="none" w="med" len="med"/>
-                      <a:tailEnd type="none" w="med" len="med"/>
-                    </a:lnT>
-                    <a:lnB w="6350" cap="flat" cmpd="sng" algn="ctr">
-                      <a:solidFill>
-                        <a:srgbClr val="D5DBE3"/>
-                      </a:solidFill>
-                      <a:prstDash val="solid"/>
-                      <a:round/>
-                      <a:headEnd type="none" w="med" len="med"/>
-                      <a:tailEnd type="none" w="med" len="med"/>
-                    </a:lnB>
-                  </a:tcPr>
-                </a:tc>
-                <a:tc>
-                  <a:txBody>
-                    <a:bodyPr/>
-                    <a:lstStyle/>
-                    <a:p>
-                      <a:pPr algn="r" indent="0" marL="0">
-                        <a:buNone/>
-                      </a:pPr>
-                      <a:r>
-                        <a:rPr lang="en-US" sz="850" b="1" dirty="0">
-                          <a:solidFill>
                             <a:srgbClr val="B3261E"/>
                           </a:solidFill>
                           <a:latin typeface="Calibri" pitchFamily="34" charset="0"/>
                           <a:ea typeface="Calibri" pitchFamily="34" charset="-122"/>
                           <a:cs typeface="Calibri" pitchFamily="34" charset="-120"/>
                         </a:rPr>
-                        <a:t>-45,1</a:t>
+                        <a:t>45,1</a:t>
                       </a:r>
                       <a:endParaRPr lang="en-US" sz="850" dirty="0">
                         <a:latin typeface="Calibri" charset="0"/>
@@ -26895,74 +26960,6 @@
                     </a:solidFill>
                   </a:tcPr>
                 </a:tc>
-                <a:tc>
-                  <a:txBody>
-                    <a:bodyPr/>
-                    <a:lstStyle/>
-                    <a:p>
-                      <a:pPr algn="r" indent="0" marL="0">
-                        <a:buNone/>
-                      </a:pPr>
-                      <a:r>
-                        <a:rPr lang="en-US" sz="850" b="1" dirty="0">
-                          <a:solidFill>
-                            <a:srgbClr val="B3261E"/>
-                          </a:solidFill>
-                          <a:latin typeface="Calibri" pitchFamily="34" charset="0"/>
-                          <a:ea typeface="Calibri" pitchFamily="34" charset="-122"/>
-                          <a:cs typeface="Calibri" pitchFamily="34" charset="-120"/>
-                        </a:rPr>
-                        <a:t>45,1</a:t>
-                      </a:r>
-                      <a:endParaRPr lang="en-US" sz="850" dirty="0">
-                        <a:latin typeface="Calibri" charset="0"/>
-                        <a:ea typeface="Calibri" charset="0"/>
-                        <a:cs typeface="Calibri" charset="0"/>
-                      </a:endParaRPr>
-                    </a:p>
-                  </a:txBody>
-                  <a:tcPr marL="64008" marR="64008" marT="0" marB="0" anchor="ctr">
-                    <a:lnL w="6350" cap="flat" cmpd="sng" algn="ctr">
-                      <a:solidFill>
-                        <a:srgbClr val="D5DBE3"/>
-                      </a:solidFill>
-                      <a:prstDash val="solid"/>
-                      <a:round/>
-                      <a:headEnd type="none" w="med" len="med"/>
-                      <a:tailEnd type="none" w="med" len="med"/>
-                    </a:lnL>
-                    <a:lnR w="6350" cap="flat" cmpd="sng" algn="ctr">
-                      <a:solidFill>
-                        <a:srgbClr val="D5DBE3"/>
-                      </a:solidFill>
-                      <a:prstDash val="solid"/>
-                      <a:round/>
-                      <a:headEnd type="none" w="med" len="med"/>
-                      <a:tailEnd type="none" w="med" len="med"/>
-                    </a:lnR>
-                    <a:lnT w="6350" cap="flat" cmpd="sng" algn="ctr">
-                      <a:solidFill>
-                        <a:srgbClr val="D5DBE3"/>
-                      </a:solidFill>
-                      <a:prstDash val="solid"/>
-                      <a:round/>
-                      <a:headEnd type="none" w="med" len="med"/>
-                      <a:tailEnd type="none" w="med" len="med"/>
-                    </a:lnT>
-                    <a:lnB w="6350" cap="flat" cmpd="sng" algn="ctr">
-                      <a:solidFill>
-                        <a:srgbClr val="D5DBE3"/>
-                      </a:solidFill>
-                      <a:prstDash val="solid"/>
-                      <a:round/>
-                      <a:headEnd type="none" w="med" len="med"/>
-                      <a:tailEnd type="none" w="med" len="med"/>
-                    </a:lnB>
-                    <a:solidFill>
-                      <a:srgbClr val="F7E7E5"/>
-                    </a:solidFill>
-                  </a:tcPr>
-                </a:tc>
               </a:tr>
               <a:tr h="224028">
                 <a:tc>
@@ -27118,7 +27115,7 @@
                           <a:ea typeface="Calibri" pitchFamily="34" charset="-122"/>
                           <a:cs typeface="Calibri" pitchFamily="34" charset="-120"/>
                         </a:rPr>
-                        <a:t>-5 273,4</a:t>
+                        <a:t>-5 100,4</a:t>
                       </a:r>
                       <a:endParaRPr lang="en-US" sz="850" dirty="0">
                         <a:latin typeface="Calibri" charset="0"/>
@@ -27254,7 +27251,7 @@
                           <a:ea typeface="Calibri" pitchFamily="34" charset="-122"/>
                           <a:cs typeface="Calibri" pitchFamily="34" charset="-120"/>
                         </a:rPr>
-                        <a:t>696,1</a:t>
+                        <a:t>869,1</a:t>
                       </a:r>
                       <a:endParaRPr lang="en-US" sz="850" dirty="0">
                         <a:latin typeface="Calibri" charset="0"/>
@@ -27322,7 +27319,7 @@
                           <a:ea typeface="Calibri" pitchFamily="34" charset="-122"/>
                           <a:cs typeface="Calibri" pitchFamily="34" charset="-120"/>
                         </a:rPr>
-                        <a:t>1 659,6</a:t>
+                        <a:t>1 509,2</a:t>
                       </a:r>
                       <a:endParaRPr lang="en-US" sz="850" dirty="0">
                         <a:latin typeface="Calibri" charset="0"/>
@@ -27566,28 +27563,7 @@
                 <a:ea typeface="Calibri" pitchFamily="34" charset="-122"/>
                 <a:cs typeface="Calibri" pitchFamily="34" charset="-120"/>
               </a:rPr>
-              <a:t>Financer le reste de 1 659,6 M, dont PICI – ECO 336,4, TERASSON – BNI fonds projet 324,8, PICI – STB 238,1.</a:t>
-            </a:r>
-            <a:endParaRPr lang="en-US" sz="1250" dirty="0"/>
-          </a:p>
-          <a:p>
-            <a:pPr marL="127000" indent="-127000">
-              <a:spcAft>
-                <a:spcPts val="300"/>
-              </a:spcAft>
-              <a:buSzPct val="100000"/>
-              <a:buChar char="•"/>
-            </a:pPr>
-            <a:r>
-              <a:rPr lang="en-US" sz="1000" dirty="0">
-                <a:solidFill>
-                  <a:srgbClr val="FFFFFF"/>
-                </a:solidFill>
-                <a:latin typeface="Calibri" pitchFamily="34" charset="0"/>
-                <a:ea typeface="Calibri" pitchFamily="34" charset="-122"/>
-                <a:cs typeface="Calibri" pitchFamily="34" charset="-120"/>
-              </a:rPr>
-              <a:t>Décalages appliqués : salaires SCO AO 24,3 M en S3.</a:t>
+              <a:t>Financer le reste de 1 509,2 M, dont PICI – ECO 336,4, TERASSON – BNI fonds projet 324,8, PICI – STB 238,1.</a:t>
             </a:r>
             <a:endParaRPr lang="en-US" sz="1250" dirty="0"/>
           </a:p>

</xml_diff>

<commit_message>
Présentation : Semaine au lieu de S, slide Options de couverture retirée
Date des soldes reprise du reporting modifié chargé (sans décaler les
semaines) ; « Trésorerie & Financement » au lieu de « Direction Trésorerie
& Financement ».

Co-Authored-By: Claude Opus 5.5 <noreply@anthropic.com>
Claude-Session: https://claude.ai/code/session_01NEhkcxCB327Mdpf33KqYQU
</commit_message>
<xml_diff>
--- a/RCI_Besoins_Tresorerie_Comptes_Paiement_30-09-2026.pptx
+++ b/RCI_Besoins_Tresorerie_Comptes_Paiement_30-09-2026.pptx
@@ -10,10 +10,9 @@
     <p:sldId id="258" r:id="rId4"/>
     <p:sldId id="259" r:id="rId5"/>
     <p:sldId id="260" r:id="rId6"/>
-    <p:sldId id="261" r:id="rId7"/>
   </p:sldIdLst>
   <p:notesMasterIdLst>
-    <p:notesMasterId r:id="rId8"/>
+    <p:notesMasterId r:id="rId7"/>
   </p:notesMasterIdLst>
   <p:sldSz cx="12192000" cy="6858000"/>
   <p:notesSz cx="6858000" cy="12192000"/>
@@ -901,94 +900,6 @@
 </p:notes>
 </file>
 
-<file path=ppt/notesSlides/notesSlide6.xml><?xml version="1.0" encoding="utf-8"?>
-<p:notes xmlns:a="http://schemas.openxmlformats.org/drawingml/2006/main" xmlns:r="http://schemas.openxmlformats.org/officeDocument/2006/relationships" xmlns:p="http://schemas.openxmlformats.org/presentationml/2006/main">
-  <p:cSld>
-    <p:spTree>
-      <p:nvGrpSpPr>
-        <p:cNvPr id="1" name=""/>
-        <p:cNvGrpSpPr/>
-        <p:nvPr/>
-      </p:nvGrpSpPr>
-      <p:grpSpPr>
-        <a:xfrm>
-          <a:off x="0" y="0"/>
-          <a:ext cx="0" cy="0"/>
-          <a:chOff x="0" y="0"/>
-          <a:chExt cx="0" cy="0"/>
-        </a:xfrm>
-      </p:grpSpPr>
-      <p:sp>
-        <p:nvSpPr>
-          <p:cNvPr id="2" name="Slide Image Placeholder 1"/>
-          <p:cNvSpPr>
-            <a:spLocks noGrp="1" noRot="1" noChangeAspect="1"/>
-          </p:cNvSpPr>
-          <p:nvPr>
-            <p:ph type="sldImg"/>
-          </p:nvPr>
-        </p:nvSpPr>
-        <p:spPr/>
-      </p:sp>
-      <p:sp>
-        <p:nvSpPr>
-          <p:cNvPr id="3" name="Notes Placeholder 2"/>
-          <p:cNvSpPr>
-            <a:spLocks noGrp="1"/>
-          </p:cNvSpPr>
-          <p:nvPr>
-            <p:ph type="body" idx="1"/>
-          </p:nvPr>
-        </p:nvSpPr>
-        <p:spPr/>
-        <p:txBody>
-          <a:bodyPr/>
-          <a:lstStyle/>
-          <a:p>
-            <a:r>
-              <a:rPr lang="en-US" dirty="0"/>
-              <a:t/>
-            </a:r>
-            <a:endParaRPr lang="en-US" dirty="0"/>
-          </a:p>
-        </p:txBody>
-      </p:sp>
-      <p:sp>
-        <p:nvSpPr>
-          <p:cNvPr id="4" name="Slide Number Placeholder 3"/>
-          <p:cNvSpPr>
-            <a:spLocks noGrp="1"/>
-          </p:cNvSpPr>
-          <p:nvPr>
-            <p:ph type="sldNum" sz="quarter" idx="10"/>
-          </p:nvPr>
-        </p:nvSpPr>
-        <p:spPr/>
-        <p:txBody>
-          <a:bodyPr/>
-          <a:lstStyle/>
-          <a:p>
-            <a:fld id="{F7021451-1387-4CA6-816F-3879F97B5CBC}" type="slidenum">
-              <a:rPr lang="en-US"/>
-              <a:t>6</a:t>
-            </a:fld>
-            <a:endParaRPr lang="en-US"/>
-          </a:p>
-        </p:txBody>
-      </p:sp>
-    </p:spTree>
-    <p:extLst>
-      <p:ext uri="{BB962C8B-B14F-4D97-AF65-F5344CB8AC3E}">
-        <p14:creationId xmlns:p14="http://schemas.microsoft.com/office/powerpoint/2010/main" val="1024086991"/>
-      </p:ext>
-    </p:extLst>
-  </p:cSld>
-  <p:clrMapOvr>
-    <a:masterClrMapping/>
-  </p:clrMapOvr>
-</p:notes>
-</file>
-
 <file path=ppt/slideLayouts/slideLayout1.xml><?xml version="1.0" encoding="utf-8"?>
 <p:sldLayout xmlns:a="http://schemas.openxmlformats.org/drawingml/2006/main" xmlns:r="http://schemas.openxmlformats.org/officeDocument/2006/relationships" xmlns:p="http://schemas.openxmlformats.org/presentationml/2006/main" preserve="1">
   <p:cSld name="DEFAULT">
@@ -1455,7 +1366,7 @@
                 <a:ea typeface="Calibri" pitchFamily="34" charset="-122"/>
                 <a:cs typeface="Calibri" pitchFamily="34" charset="-120"/>
               </a:rPr>
-              <a:t>Situation au 30/09/2026 – échéancier S1 à S5 (05/10 → 08/11/2026)</a:t>
+              <a:t>Situation au 30/09/2026 – échéancier Semaines 1 à 5 (05/10 → 08/11/2026)</a:t>
             </a:r>
             <a:endParaRPr lang="en-US" sz="1500" dirty="0"/>
           </a:p>
@@ -1494,7 +1405,7 @@
                 <a:ea typeface="Calibri" pitchFamily="34" charset="-122"/>
                 <a:cs typeface="Calibri" pitchFamily="34" charset="-120"/>
               </a:rPr>
-              <a:t>Direction Trésorerie &amp; Financement – Groupe Duval Afrique  |  Octobre 2026</a:t>
+              <a:t>Trésorerie &amp; Financement – Groupe Duval Afrique  |  Octobre 2026</a:t>
             </a:r>
             <a:endParaRPr lang="en-US" sz="1100" dirty="0"/>
           </a:p>
@@ -1604,7 +1515,7 @@
                 <a:ea typeface="Calibri" pitchFamily="34" charset="-122"/>
                 <a:cs typeface="Calibri" pitchFamily="34" charset="-120"/>
               </a:rPr>
-              <a:t>Position de trésorerie au 30/09/2026 – échéancier S1 à S5 (05/10 → 08/11/2026), antériorités en S1 – montants en MFCFA</a:t>
+              <a:t>Position au 30/09/2026 – Semaines 1 à 5 (05/10 → 08/11/2026), antériorités en Semaine 1 – MFCFA</a:t>
             </a:r>
             <a:endParaRPr lang="en-US" sz="1300" dirty="0"/>
           </a:p>
@@ -1851,7 +1762,7 @@
                 <a:ea typeface="Calibri" pitchFamily="34" charset="-122"/>
                 <a:cs typeface="Calibri" pitchFamily="34" charset="-120"/>
               </a:rPr>
-              <a:t>6 974,1 M à payer de S1 à S5, dont 5 115,2 M dès S1 ; 1 925,7 M de déficits</a:t>
+              <a:t>6 974,1 M à payer de Semaines 1 à 5, dont 5 115,2 M dès Semaine 1 ; 1 925,7 M de déficits</a:t>
             </a:r>
             <a:endParaRPr lang="en-US" sz="1400" dirty="0"/>
           </a:p>
@@ -2201,7 +2112,7 @@
                 <a:ea typeface="Calibri" pitchFamily="34" charset="-122"/>
                 <a:cs typeface="Calibri" pitchFamily="34" charset="-120"/>
               </a:rPr>
-              <a:t>Options de couverture et décisions</a:t>
+              <a:t>Équilibrage Semaine 1 : virements et reste à financer</a:t>
             </a:r>
             <a:endParaRPr lang="en-US" sz="1500" dirty="0"/>
           </a:p>
@@ -2209,110 +2120,7 @@
       </p:sp>
       <p:sp>
         <p:nvSpPr>
-          <p:cNvPr id="21" name="Shape 19"/>
-          <p:cNvSpPr/>
-          <p:nvPr/>
-        </p:nvSpPr>
-        <p:spPr>
-          <a:xfrm>
-            <a:off x="6583680" y="4032504"/>
-            <a:ext cx="420624" cy="420624"/>
-          </a:xfrm>
-          <a:prstGeom prst="ellipse">
-            <a:avLst/>
-          </a:prstGeom>
-          <a:solidFill>
-            <a:srgbClr val="002C50"/>
-          </a:solidFill>
-          <a:ln w="12700">
-            <a:solidFill>
-              <a:srgbClr val="002C50"/>
-            </a:solidFill>
-            <a:prstDash val="solid"/>
-          </a:ln>
-        </p:spPr>
-      </p:sp>
-      <p:sp>
-        <p:nvSpPr>
-          <p:cNvPr id="22" name="Text 20"/>
-          <p:cNvSpPr txBox="1"/>
-          <p:nvPr/>
-        </p:nvSpPr>
-        <p:spPr>
-          <a:xfrm>
-            <a:off x="6583680" y="4032504"/>
-            <a:ext cx="420624" cy="420624"/>
-          </a:xfrm>
-          <a:prstGeom prst="rect">
-            <a:avLst/>
-          </a:prstGeom>
-          <a:noFill/>
-          <a:ln/>
-        </p:spPr>
-        <p:txBody>
-          <a:bodyPr wrap="square" lIns="0" tIns="0" rIns="0" bIns="0" rtlCol="0" anchor="ctr"/>
-          <a:lstStyle/>
-          <a:p>
-            <a:pPr algn="ctr" indent="0" marL="0">
-              <a:buNone/>
-            </a:pPr>
-            <a:r>
-              <a:rPr lang="en-US" sz="1300" b="1" dirty="0">
-                <a:solidFill>
-                  <a:srgbClr val="FFFFFF"/>
-                </a:solidFill>
-                <a:latin typeface="Calibri" pitchFamily="34" charset="0"/>
-                <a:ea typeface="Calibri" pitchFamily="34" charset="-122"/>
-                <a:cs typeface="Calibri" pitchFamily="34" charset="-120"/>
-              </a:rPr>
-              <a:t>6</a:t>
-            </a:r>
-            <a:endParaRPr lang="en-US" sz="1300" dirty="0"/>
-          </a:p>
-        </p:txBody>
-      </p:sp>
-      <p:sp>
-        <p:nvSpPr>
-          <p:cNvPr id="23" name="Text 21"/>
-          <p:cNvSpPr txBox="1"/>
-          <p:nvPr/>
-        </p:nvSpPr>
-        <p:spPr>
-          <a:xfrm>
-            <a:off x="7178040" y="4032504"/>
-            <a:ext cx="4297680" cy="420624"/>
-          </a:xfrm>
-          <a:prstGeom prst="rect">
-            <a:avLst/>
-          </a:prstGeom>
-          <a:noFill/>
-          <a:ln/>
-        </p:spPr>
-        <p:txBody>
-          <a:bodyPr wrap="square" lIns="0" tIns="0" rIns="0" bIns="0" rtlCol="0" anchor="ctr"/>
-          <a:lstStyle/>
-          <a:p>
-            <a:pPr indent="0" marL="0">
-              <a:buNone/>
-            </a:pPr>
-            <a:r>
-              <a:rPr lang="en-US" sz="1500" dirty="0">
-                <a:solidFill>
-                  <a:srgbClr val="1F2933"/>
-                </a:solidFill>
-                <a:latin typeface="Calibri" pitchFamily="34" charset="0"/>
-                <a:ea typeface="Calibri" pitchFamily="34" charset="-122"/>
-                <a:cs typeface="Calibri" pitchFamily="34" charset="-120"/>
-              </a:rPr>
-              <a:t>Équilibrage S1 : virements et reste à financer</a:t>
-            </a:r>
-            <a:endParaRPr lang="en-US" sz="1500" dirty="0"/>
-          </a:p>
-        </p:txBody>
-      </p:sp>
-      <p:sp>
-        <p:nvSpPr>
-          <p:cNvPr id="24" name="Text 22"/>
+          <p:cNvPr id="21" name="Text 19"/>
           <p:cNvSpPr txBox="1"/>
           <p:nvPr/>
         </p:nvSpPr>
@@ -2343,7 +2151,7 @@
                 <a:ea typeface="Calibri" pitchFamily="34" charset="-122"/>
                 <a:cs typeface="Calibri" pitchFamily="34" charset="-120"/>
               </a:rPr>
-              <a:t>Couverture des déficits : crédit spot, avances intragroupe ou comptes à arbitrer</a:t>
+              <a:t>Équilibrage de la Semaine 1 : virements entre comptes et reste à financer</a:t>
             </a:r>
             <a:endParaRPr lang="en-US" sz="1400" dirty="0"/>
           </a:p>
@@ -2351,7 +2159,7 @@
       </p:sp>
       <p:sp>
         <p:nvSpPr>
-          <p:cNvPr id="25" name="Text 23"/>
+          <p:cNvPr id="22" name="Text 20"/>
           <p:cNvSpPr txBox="1"/>
           <p:nvPr/>
         </p:nvSpPr>
@@ -2390,7 +2198,7 @@
       </p:sp>
       <p:pic>
         <p:nvPicPr>
-          <p:cNvPr id="26" name="Image 0" descr="preencoded.png">    </p:cNvPr>
+          <p:cNvPr id="23" name="Image 0" descr="preencoded.png">    </p:cNvPr>
           <p:cNvPicPr>
             <a:picLocks noChangeAspect="1"/>
           </p:cNvPicPr>
@@ -2414,7 +2222,7 @@
       </p:pic>
       <p:sp>
         <p:nvSpPr>
-          <p:cNvPr id="27" name="Text 24"/>
+          <p:cNvPr id="24" name="Text 21"/>
           <p:cNvSpPr txBox="1"/>
           <p:nvPr/>
         </p:nvSpPr>
@@ -2555,7 +2363,7 @@
                 <a:ea typeface="Calibri" pitchFamily="34" charset="-122"/>
                 <a:cs typeface="Calibri" pitchFamily="34" charset="-120"/>
               </a:rPr>
-              <a:t>Soldes au 30/09/2026, échéancier S1 à S5 (05/10 → 08/11/2026), antériorités reportées en S1 – MFCFA</a:t>
+              <a:t>Soldes au 30/09/2026, échéancier Semaines 1 à 5 (05/10 → 08/11/2026), antériorités reportées en Semaine 1 – MFCFA</a:t>
             </a:r>
             <a:endParaRPr lang="en-US" sz="1300" dirty="0"/>
           </a:p>
@@ -2660,7 +2468,7 @@
                 <a:ea typeface="Calibri" pitchFamily="34" charset="-122"/>
                 <a:cs typeface="Calibri" pitchFamily="34" charset="-120"/>
               </a:rPr>
-              <a:t>Besoin S1 à S5 (10,6 M€) : fonctionnement, projets et dette</a:t>
+              <a:t>Besoin Semaines 1 à 5 (10,6 M€) : fonctionnement, projets et dette</a:t>
             </a:r>
             <a:endParaRPr lang="en-US" sz="1050" dirty="0"/>
           </a:p>
@@ -2765,7 +2573,7 @@
                 <a:ea typeface="Calibri" pitchFamily="34" charset="-122"/>
                 <a:cs typeface="Calibri" pitchFamily="34" charset="-120"/>
               </a:rPr>
-              <a:t>À régler dès S1 (antériorités incluses), 73 % du besoin</a:t>
+              <a:t>Dès Semaine 1, antériorités incluses (73 % du besoin)</a:t>
             </a:r>
             <a:endParaRPr lang="en-US" sz="1050" dirty="0"/>
           </a:p>
@@ -2975,7 +2783,7 @@
                 <a:ea typeface="Calibri" pitchFamily="34" charset="-122"/>
                 <a:cs typeface="Calibri" pitchFamily="34" charset="-120"/>
               </a:rPr>
-              <a:t>Besoin fin S5 – comptes de sociétés ; comptes dédiés +745,6 M</a:t>
+              <a:t>Besoin fin Semaine 5 des sociétés ; comptes dédiés +745,6 M</a:t>
             </a:r>
             <a:endParaRPr lang="en-US" sz="1050" dirty="0"/>
           </a:p>
@@ -3100,7 +2908,7 @@
                           <a:ea typeface="Calibri" pitchFamily="34" charset="-122"/>
                           <a:cs typeface="Calibri" pitchFamily="34" charset="-120"/>
                         </a:rPr>
-                        <a:t>S1 05/10</a:t>
+                        <a:t>Semaine 1 05/10</a:t>
                       </a:r>
                       <a:endParaRPr lang="en-US" sz="900" dirty="0">
                         <a:latin typeface="Calibri" charset="0"/>
@@ -3168,7 +2976,7 @@
                           <a:ea typeface="Calibri" pitchFamily="34" charset="-122"/>
                           <a:cs typeface="Calibri" pitchFamily="34" charset="-120"/>
                         </a:rPr>
-                        <a:t>S2 12/10</a:t>
+                        <a:t>Semaine 2 12/10</a:t>
                       </a:r>
                       <a:endParaRPr lang="en-US" sz="900" dirty="0">
                         <a:latin typeface="Calibri" charset="0"/>
@@ -3236,7 +3044,7 @@
                           <a:ea typeface="Calibri" pitchFamily="34" charset="-122"/>
                           <a:cs typeface="Calibri" pitchFamily="34" charset="-120"/>
                         </a:rPr>
-                        <a:t>S3 19/10</a:t>
+                        <a:t>Semaine 3 19/10</a:t>
                       </a:r>
                       <a:endParaRPr lang="en-US" sz="900" dirty="0">
                         <a:latin typeface="Calibri" charset="0"/>
@@ -3304,7 +3112,7 @@
                           <a:ea typeface="Calibri" pitchFamily="34" charset="-122"/>
                           <a:cs typeface="Calibri" pitchFamily="34" charset="-120"/>
                         </a:rPr>
-                        <a:t>S4 26/10</a:t>
+                        <a:t>Semaine 4 26/10</a:t>
                       </a:r>
                       <a:endParaRPr lang="en-US" sz="900" dirty="0">
                         <a:latin typeface="Calibri" charset="0"/>
@@ -3372,7 +3180,7 @@
                           <a:ea typeface="Calibri" pitchFamily="34" charset="-122"/>
                           <a:cs typeface="Calibri" pitchFamily="34" charset="-120"/>
                         </a:rPr>
-                        <a:t>S5 02/11</a:t>
+                        <a:t>Semaine 5 02/11</a:t>
                       </a:r>
                       <a:endParaRPr lang="en-US" sz="900" dirty="0">
                         <a:latin typeface="Calibri" charset="0"/>
@@ -3440,7 +3248,7 @@
                           <a:ea typeface="Calibri" pitchFamily="34" charset="-122"/>
                           <a:cs typeface="Calibri" pitchFamily="34" charset="-120"/>
                         </a:rPr>
-                        <a:t>Total S1 à S5</a:t>
+                        <a:t>Total Semaines 1 à 5</a:t>
                       </a:r>
                       <a:endParaRPr lang="en-US" sz="900" dirty="0">
                         <a:latin typeface="Calibri" charset="0"/>
@@ -3576,7 +3384,7 @@
                           <a:ea typeface="Calibri" pitchFamily="34" charset="-122"/>
                           <a:cs typeface="Calibri" pitchFamily="34" charset="-120"/>
                         </a:rPr>
-                        <a:t>Déficit fin S5</a:t>
+                        <a:t>Déficit fin Semaine 5</a:t>
                       </a:r>
                       <a:endParaRPr lang="en-US" sz="900" dirty="0">
                         <a:latin typeface="Calibri" charset="0"/>
@@ -10113,7 +9921,7 @@
                 <a:ea typeface="Calibri" pitchFamily="34" charset="-122"/>
                 <a:cs typeface="Calibri" pitchFamily="34" charset="-120"/>
               </a:rPr>
-              <a:t>5 227,7 M. RIVIERA en déficit de 601,4 M dès S2 ; TERASSON en déficit de 501,3 M dès S1.</a:t>
+              <a:t>5 227,7 M. RIVIERA en déficit de 601,4 M dès Semaine 2 ; TERASSON en déficit de 501,3 M dès Semaine 1.</a:t>
             </a:r>
             <a:endParaRPr lang="en-US" sz="1000" dirty="0"/>
           </a:p>
@@ -10360,7 +10168,7 @@
                 <a:ea typeface="Calibri" pitchFamily="34" charset="-122"/>
                 <a:cs typeface="Calibri" pitchFamily="34" charset="-120"/>
               </a:rPr>
-              <a:t>Compte payeur par entité et nature d'opération, trésorerie au 30/09/2026 et solde théorique fin S5 – MFCFA</a:t>
+              <a:t>Compte payeur par entité et nature d'opération, trésorerie au 30/09/2026 et solde théorique fin Semaine 5 – MFCFA</a:t>
             </a:r>
             <a:endParaRPr lang="en-US" sz="1300" dirty="0"/>
           </a:p>
@@ -10550,7 +10358,7 @@
                           <a:ea typeface="Calibri" pitchFamily="34" charset="-122"/>
                           <a:cs typeface="Calibri" pitchFamily="34" charset="-120"/>
                         </a:rPr>
-                        <a:t>Montant S1 à S5</a:t>
+                        <a:t>Montant Semaines 1 à 5</a:t>
                       </a:r>
                       <a:endParaRPr lang="en-US" sz="950" dirty="0">
                         <a:latin typeface="Calibri" charset="0"/>
@@ -10754,7 +10562,7 @@
                           <a:ea typeface="Calibri" pitchFamily="34" charset="-122"/>
                           <a:cs typeface="Calibri" pitchFamily="34" charset="-120"/>
                         </a:rPr>
-                        <a:t>Solde fin S5</a:t>
+                        <a:t>Solde fin Semaine 5</a:t>
                       </a:r>
                       <a:endParaRPr lang="en-US" sz="950" dirty="0">
                         <a:latin typeface="Calibri" charset="0"/>
@@ -15865,7 +15673,7 @@
                 <a:ea typeface="Calibri" pitchFamily="34" charset="-122"/>
                 <a:cs typeface="Calibri" pitchFamily="34" charset="-120"/>
               </a:rPr>
-              <a:t>Solde fin S5 = trésorerie au 30/09 + flux prévus de S1 à S5 (encaissements compris).</a:t>
+              <a:t>Solde fin Semaine 5 = trésorerie au 30/09 + flux prévus de Semaines 1 à 5 (encaissements compris).</a:t>
             </a:r>
             <a:endParaRPr lang="en-US" sz="950" dirty="0"/>
           </a:p>
@@ -15999,4251 +15807,7 @@
                 <a:ea typeface="Calibri" pitchFamily="34" charset="-122"/>
                 <a:cs typeface="Calibri" pitchFamily="34" charset="-120"/>
               </a:rPr>
-              <a:t>B. Paiement – 2. Options de couverture</a:t>
-            </a:r>
-            <a:endParaRPr lang="en-US" sz="2600" dirty="0"/>
-          </a:p>
-        </p:txBody>
-      </p:sp>
-      <p:sp>
-        <p:nvSpPr>
-          <p:cNvPr id="3" name="Text 1"/>
-          <p:cNvSpPr txBox="1"/>
-          <p:nvPr/>
-        </p:nvSpPr>
-        <p:spPr>
-          <a:xfrm>
-            <a:off x="457200" y="822960"/>
-            <a:ext cx="11247120" cy="320040"/>
-          </a:xfrm>
-          <a:prstGeom prst="rect">
-            <a:avLst/>
-          </a:prstGeom>
-          <a:noFill/>
-          <a:ln/>
-        </p:spPr>
-        <p:txBody>
-          <a:bodyPr wrap="square" lIns="0" tIns="0" rIns="0" bIns="0" rtlCol="0" anchor="ctr"/>
-          <a:lstStyle/>
-          <a:p>
-            <a:pPr indent="0" marL="0">
-              <a:buNone/>
-            </a:pPr>
-            <a:r>
-              <a:rPr lang="en-US" sz="1300" dirty="0">
-                <a:solidFill>
-                  <a:srgbClr val="9D8C74"/>
-                </a:solidFill>
-                <a:latin typeface="Calibri" pitchFamily="34" charset="0"/>
-                <a:ea typeface="Calibri" pitchFamily="34" charset="-122"/>
-                <a:cs typeface="Calibri" pitchFamily="34" charset="-120"/>
-              </a:rPr>
-              <a:t>Déficits à couvrir d'ici S5 : 1 925,7 M – MFCFA</a:t>
-            </a:r>
-            <a:endParaRPr lang="en-US" sz="1300" dirty="0"/>
-          </a:p>
-        </p:txBody>
-      </p:sp>
-      <p:graphicFrame>
-        <p:nvGraphicFramePr>
-          <p:cNvPr id="6" name="Table 0"/>
-          <p:cNvGraphicFramePr>
-            <a:graphicFrameLocks noGrp="1"/>
-          </p:cNvGraphicFramePr>
-          <p:nvPr>
-            <p:extLst>
-              <p:ext uri="{D42A27DB-BD31-4B8C-83A1-F6EECF244321}">
-                <p14:modId xmlns:p14="http://schemas.microsoft.com/office/powerpoint/2010/main" val="1579011935"/>
-              </p:ext>
-            </p:extLst>
-          </p:nvPr>
-        </p:nvGraphicFramePr>
-        <p:xfrm>
-          <a:off x="457200" y="1325880"/>
-          <a:ext cx="5760720" cy="914400"/>
-        </p:xfrm>
-        <a:graphic>
-          <a:graphicData uri="http://schemas.openxmlformats.org/drawingml/2006/table">
-            <a:tbl>
-              <a:tblPr/>
-              <a:tblGrid>
-                <a:gridCol w="2103120"/>
-                <a:gridCol w="868680"/>
-                <a:gridCol w="2194560"/>
-                <a:gridCol w="594360"/>
-              </a:tblGrid>
-              <a:tr h="237744">
-                <a:tc>
-                  <a:txBody>
-                    <a:bodyPr/>
-                    <a:lstStyle/>
-                    <a:p>
-                      <a:pPr algn="l" indent="0" marL="0">
-                        <a:buNone/>
-                      </a:pPr>
-                      <a:r>
-                        <a:rPr lang="en-US" sz="950" b="1" dirty="0">
-                          <a:solidFill>
-                            <a:srgbClr val="FFFFFF"/>
-                          </a:solidFill>
-                          <a:latin typeface="Calibri" pitchFamily="34" charset="0"/>
-                          <a:ea typeface="Calibri" pitchFamily="34" charset="-122"/>
-                          <a:cs typeface="Calibri" pitchFamily="34" charset="-120"/>
-                        </a:rPr>
-                        <a:t>Déficit à couvrir</a:t>
-                      </a:r>
-                      <a:endParaRPr lang="en-US" sz="950" dirty="0">
-                        <a:latin typeface="Calibri" charset="0"/>
-                        <a:ea typeface="Calibri" charset="0"/>
-                        <a:cs typeface="Calibri" charset="0"/>
-                      </a:endParaRPr>
-                    </a:p>
-                  </a:txBody>
-                  <a:tcPr marL="64008" marR="64008" marT="0" marB="0" anchor="ctr">
-                    <a:lnL w="6350" cap="flat" cmpd="sng" algn="ctr">
-                      <a:solidFill>
-                        <a:srgbClr val="D5DBE3"/>
-                      </a:solidFill>
-                      <a:prstDash val="solid"/>
-                      <a:round/>
-                      <a:headEnd type="none" w="med" len="med"/>
-                      <a:tailEnd type="none" w="med" len="med"/>
-                    </a:lnL>
-                    <a:lnR w="6350" cap="flat" cmpd="sng" algn="ctr">
-                      <a:solidFill>
-                        <a:srgbClr val="D5DBE3"/>
-                      </a:solidFill>
-                      <a:prstDash val="solid"/>
-                      <a:round/>
-                      <a:headEnd type="none" w="med" len="med"/>
-                      <a:tailEnd type="none" w="med" len="med"/>
-                    </a:lnR>
-                    <a:lnT w="6350" cap="flat" cmpd="sng" algn="ctr">
-                      <a:solidFill>
-                        <a:srgbClr val="D5DBE3"/>
-                      </a:solidFill>
-                      <a:prstDash val="solid"/>
-                      <a:round/>
-                      <a:headEnd type="none" w="med" len="med"/>
-                      <a:tailEnd type="none" w="med" len="med"/>
-                    </a:lnT>
-                    <a:lnB w="6350" cap="flat" cmpd="sng" algn="ctr">
-                      <a:solidFill>
-                        <a:srgbClr val="D5DBE3"/>
-                      </a:solidFill>
-                      <a:prstDash val="solid"/>
-                      <a:round/>
-                      <a:headEnd type="none" w="med" len="med"/>
-                      <a:tailEnd type="none" w="med" len="med"/>
-                    </a:lnB>
-                    <a:solidFill>
-                      <a:srgbClr val="002C50"/>
-                    </a:solidFill>
-                  </a:tcPr>
-                </a:tc>
-                <a:tc>
-                  <a:txBody>
-                    <a:bodyPr/>
-                    <a:lstStyle/>
-                    <a:p>
-                      <a:pPr algn="ctr" indent="0" marL="0">
-                        <a:buNone/>
-                      </a:pPr>
-                      <a:r>
-                        <a:rPr lang="en-US" sz="950" b="1" dirty="0">
-                          <a:solidFill>
-                            <a:srgbClr val="FFFFFF"/>
-                          </a:solidFill>
-                          <a:latin typeface="Calibri" pitchFamily="34" charset="0"/>
-                          <a:ea typeface="Calibri" pitchFamily="34" charset="-122"/>
-                          <a:cs typeface="Calibri" pitchFamily="34" charset="-120"/>
-                        </a:rPr>
-                        <a:t>Montant</a:t>
-                      </a:r>
-                      <a:endParaRPr lang="en-US" sz="950" dirty="0">
-                        <a:latin typeface="Calibri" charset="0"/>
-                        <a:ea typeface="Calibri" charset="0"/>
-                        <a:cs typeface="Calibri" charset="0"/>
-                      </a:endParaRPr>
-                    </a:p>
-                  </a:txBody>
-                  <a:tcPr marL="64008" marR="64008" marT="0" marB="0" anchor="ctr">
-                    <a:lnL w="6350" cap="flat" cmpd="sng" algn="ctr">
-                      <a:solidFill>
-                        <a:srgbClr val="D5DBE3"/>
-                      </a:solidFill>
-                      <a:prstDash val="solid"/>
-                      <a:round/>
-                      <a:headEnd type="none" w="med" len="med"/>
-                      <a:tailEnd type="none" w="med" len="med"/>
-                    </a:lnL>
-                    <a:lnR w="6350" cap="flat" cmpd="sng" algn="ctr">
-                      <a:solidFill>
-                        <a:srgbClr val="D5DBE3"/>
-                      </a:solidFill>
-                      <a:prstDash val="solid"/>
-                      <a:round/>
-                      <a:headEnd type="none" w="med" len="med"/>
-                      <a:tailEnd type="none" w="med" len="med"/>
-                    </a:lnR>
-                    <a:lnT w="6350" cap="flat" cmpd="sng" algn="ctr">
-                      <a:solidFill>
-                        <a:srgbClr val="D5DBE3"/>
-                      </a:solidFill>
-                      <a:prstDash val="solid"/>
-                      <a:round/>
-                      <a:headEnd type="none" w="med" len="med"/>
-                      <a:tailEnd type="none" w="med" len="med"/>
-                    </a:lnT>
-                    <a:lnB w="6350" cap="flat" cmpd="sng" algn="ctr">
-                      <a:solidFill>
-                        <a:srgbClr val="D5DBE3"/>
-                      </a:solidFill>
-                      <a:prstDash val="solid"/>
-                      <a:round/>
-                      <a:headEnd type="none" w="med" len="med"/>
-                      <a:tailEnd type="none" w="med" len="med"/>
-                    </a:lnB>
-                    <a:solidFill>
-                      <a:srgbClr val="002C50"/>
-                    </a:solidFill>
-                  </a:tcPr>
-                </a:tc>
-                <a:tc>
-                  <a:txBody>
-                    <a:bodyPr/>
-                    <a:lstStyle/>
-                    <a:p>
-                      <a:pPr algn="l" indent="0" marL="0">
-                        <a:buNone/>
-                      </a:pPr>
-                      <a:r>
-                        <a:rPr lang="en-US" sz="950" b="1" dirty="0">
-                          <a:solidFill>
-                            <a:srgbClr val="FFFFFF"/>
-                          </a:solidFill>
-                          <a:latin typeface="Calibri" pitchFamily="34" charset="0"/>
-                          <a:ea typeface="Calibri" pitchFamily="34" charset="-122"/>
-                          <a:cs typeface="Calibri" pitchFamily="34" charset="-120"/>
-                        </a:rPr>
-                        <a:t>Options</a:t>
-                      </a:r>
-                      <a:endParaRPr lang="en-US" sz="950" dirty="0">
-                        <a:latin typeface="Calibri" charset="0"/>
-                        <a:ea typeface="Calibri" charset="0"/>
-                        <a:cs typeface="Calibri" charset="0"/>
-                      </a:endParaRPr>
-                    </a:p>
-                  </a:txBody>
-                  <a:tcPr marL="64008" marR="64008" marT="0" marB="0" anchor="ctr">
-                    <a:lnL w="6350" cap="flat" cmpd="sng" algn="ctr">
-                      <a:solidFill>
-                        <a:srgbClr val="D5DBE3"/>
-                      </a:solidFill>
-                      <a:prstDash val="solid"/>
-                      <a:round/>
-                      <a:headEnd type="none" w="med" len="med"/>
-                      <a:tailEnd type="none" w="med" len="med"/>
-                    </a:lnL>
-                    <a:lnR w="6350" cap="flat" cmpd="sng" algn="ctr">
-                      <a:solidFill>
-                        <a:srgbClr val="D5DBE3"/>
-                      </a:solidFill>
-                      <a:prstDash val="solid"/>
-                      <a:round/>
-                      <a:headEnd type="none" w="med" len="med"/>
-                      <a:tailEnd type="none" w="med" len="med"/>
-                    </a:lnR>
-                    <a:lnT w="6350" cap="flat" cmpd="sng" algn="ctr">
-                      <a:solidFill>
-                        <a:srgbClr val="D5DBE3"/>
-                      </a:solidFill>
-                      <a:prstDash val="solid"/>
-                      <a:round/>
-                      <a:headEnd type="none" w="med" len="med"/>
-                      <a:tailEnd type="none" w="med" len="med"/>
-                    </a:lnT>
-                    <a:lnB w="6350" cap="flat" cmpd="sng" algn="ctr">
-                      <a:solidFill>
-                        <a:srgbClr val="D5DBE3"/>
-                      </a:solidFill>
-                      <a:prstDash val="solid"/>
-                      <a:round/>
-                      <a:headEnd type="none" w="med" len="med"/>
-                      <a:tailEnd type="none" w="med" len="med"/>
-                    </a:lnB>
-                    <a:solidFill>
-                      <a:srgbClr val="002C50"/>
-                    </a:solidFill>
-                  </a:tcPr>
-                </a:tc>
-                <a:tc>
-                  <a:txBody>
-                    <a:bodyPr/>
-                    <a:lstStyle/>
-                    <a:p>
-                      <a:pPr algn="ctr" indent="0" marL="0">
-                        <a:buNone/>
-                      </a:pPr>
-                      <a:r>
-                        <a:rPr lang="en-US" sz="950" b="1" dirty="0">
-                          <a:solidFill>
-                            <a:srgbClr val="FFFFFF"/>
-                          </a:solidFill>
-                          <a:latin typeface="Calibri" pitchFamily="34" charset="0"/>
-                          <a:ea typeface="Calibri" pitchFamily="34" charset="-122"/>
-                          <a:cs typeface="Calibri" pitchFamily="34" charset="-120"/>
-                        </a:rPr>
-                        <a:t>Dès</a:t>
-                      </a:r>
-                      <a:endParaRPr lang="en-US" sz="950" dirty="0">
-                        <a:latin typeface="Calibri" charset="0"/>
-                        <a:ea typeface="Calibri" charset="0"/>
-                        <a:cs typeface="Calibri" charset="0"/>
-                      </a:endParaRPr>
-                    </a:p>
-                  </a:txBody>
-                  <a:tcPr marL="64008" marR="64008" marT="0" marB="0" anchor="ctr">
-                    <a:lnL w="6350" cap="flat" cmpd="sng" algn="ctr">
-                      <a:solidFill>
-                        <a:srgbClr val="D5DBE3"/>
-                      </a:solidFill>
-                      <a:prstDash val="solid"/>
-                      <a:round/>
-                      <a:headEnd type="none" w="med" len="med"/>
-                      <a:tailEnd type="none" w="med" len="med"/>
-                    </a:lnL>
-                    <a:lnR w="6350" cap="flat" cmpd="sng" algn="ctr">
-                      <a:solidFill>
-                        <a:srgbClr val="D5DBE3"/>
-                      </a:solidFill>
-                      <a:prstDash val="solid"/>
-                      <a:round/>
-                      <a:headEnd type="none" w="med" len="med"/>
-                      <a:tailEnd type="none" w="med" len="med"/>
-                    </a:lnR>
-                    <a:lnT w="6350" cap="flat" cmpd="sng" algn="ctr">
-                      <a:solidFill>
-                        <a:srgbClr val="D5DBE3"/>
-                      </a:solidFill>
-                      <a:prstDash val="solid"/>
-                      <a:round/>
-                      <a:headEnd type="none" w="med" len="med"/>
-                      <a:tailEnd type="none" w="med" len="med"/>
-                    </a:lnT>
-                    <a:lnB w="6350" cap="flat" cmpd="sng" algn="ctr">
-                      <a:solidFill>
-                        <a:srgbClr val="D5DBE3"/>
-                      </a:solidFill>
-                      <a:prstDash val="solid"/>
-                      <a:round/>
-                      <a:headEnd type="none" w="med" len="med"/>
-                      <a:tailEnd type="none" w="med" len="med"/>
-                    </a:lnB>
-                    <a:solidFill>
-                      <a:srgbClr val="002C50"/>
-                    </a:solidFill>
-                  </a:tcPr>
-                </a:tc>
-              </a:tr>
-              <a:tr h="237744">
-                <a:tc>
-                  <a:txBody>
-                    <a:bodyPr/>
-                    <a:lstStyle/>
-                    <a:p>
-                      <a:pPr algn="l" indent="0" marL="0">
-                        <a:buNone/>
-                      </a:pPr>
-                      <a:r>
-                        <a:rPr lang="en-US" sz="950" b="1" dirty="0">
-                          <a:solidFill>
-                            <a:srgbClr val="1F2933"/>
-                          </a:solidFill>
-                          <a:latin typeface="Calibri" pitchFamily="34" charset="0"/>
-                          <a:ea typeface="Calibri" pitchFamily="34" charset="-122"/>
-                          <a:cs typeface="Calibri" pitchFamily="34" charset="-120"/>
-                        </a:rPr>
-                        <a:t>TERASSON</a:t>
-                      </a:r>
-                      <a:endParaRPr lang="en-US" sz="950" dirty="0">
-                        <a:latin typeface="Calibri" charset="0"/>
-                        <a:ea typeface="Calibri" charset="0"/>
-                        <a:cs typeface="Calibri" charset="0"/>
-                      </a:endParaRPr>
-                    </a:p>
-                  </a:txBody>
-                  <a:tcPr marL="64008" marR="64008" marT="0" marB="0" anchor="ctr">
-                    <a:lnL w="6350" cap="flat" cmpd="sng" algn="ctr">
-                      <a:solidFill>
-                        <a:srgbClr val="D5DBE3"/>
-                      </a:solidFill>
-                      <a:prstDash val="solid"/>
-                      <a:round/>
-                      <a:headEnd type="none" w="med" len="med"/>
-                      <a:tailEnd type="none" w="med" len="med"/>
-                    </a:lnL>
-                    <a:lnR w="6350" cap="flat" cmpd="sng" algn="ctr">
-                      <a:solidFill>
-                        <a:srgbClr val="D5DBE3"/>
-                      </a:solidFill>
-                      <a:prstDash val="solid"/>
-                      <a:round/>
-                      <a:headEnd type="none" w="med" len="med"/>
-                      <a:tailEnd type="none" w="med" len="med"/>
-                    </a:lnR>
-                    <a:lnT w="6350" cap="flat" cmpd="sng" algn="ctr">
-                      <a:solidFill>
-                        <a:srgbClr val="D5DBE3"/>
-                      </a:solidFill>
-                      <a:prstDash val="solid"/>
-                      <a:round/>
-                      <a:headEnd type="none" w="med" len="med"/>
-                      <a:tailEnd type="none" w="med" len="med"/>
-                    </a:lnT>
-                    <a:lnB w="6350" cap="flat" cmpd="sng" algn="ctr">
-                      <a:solidFill>
-                        <a:srgbClr val="D5DBE3"/>
-                      </a:solidFill>
-                      <a:prstDash val="solid"/>
-                      <a:round/>
-                      <a:headEnd type="none" w="med" len="med"/>
-                      <a:tailEnd type="none" w="med" len="med"/>
-                    </a:lnB>
-                  </a:tcPr>
-                </a:tc>
-                <a:tc>
-                  <a:txBody>
-                    <a:bodyPr/>
-                    <a:lstStyle/>
-                    <a:p>
-                      <a:pPr algn="r" indent="0" marL="0">
-                        <a:buNone/>
-                      </a:pPr>
-                      <a:r>
-                        <a:rPr lang="en-US" sz="950" b="1" dirty="0">
-                          <a:solidFill>
-                            <a:srgbClr val="B3261E"/>
-                          </a:solidFill>
-                          <a:latin typeface="Calibri" pitchFamily="34" charset="0"/>
-                          <a:ea typeface="Calibri" pitchFamily="34" charset="-122"/>
-                          <a:cs typeface="Calibri" pitchFamily="34" charset="-120"/>
-                        </a:rPr>
-                        <a:t>206,4</a:t>
-                      </a:r>
-                      <a:endParaRPr lang="en-US" sz="950" dirty="0">
-                        <a:latin typeface="Calibri" charset="0"/>
-                        <a:ea typeface="Calibri" charset="0"/>
-                        <a:cs typeface="Calibri" charset="0"/>
-                      </a:endParaRPr>
-                    </a:p>
-                  </a:txBody>
-                  <a:tcPr marL="64008" marR="64008" marT="0" marB="0" anchor="ctr">
-                    <a:lnL w="6350" cap="flat" cmpd="sng" algn="ctr">
-                      <a:solidFill>
-                        <a:srgbClr val="D5DBE3"/>
-                      </a:solidFill>
-                      <a:prstDash val="solid"/>
-                      <a:round/>
-                      <a:headEnd type="none" w="med" len="med"/>
-                      <a:tailEnd type="none" w="med" len="med"/>
-                    </a:lnL>
-                    <a:lnR w="6350" cap="flat" cmpd="sng" algn="ctr">
-                      <a:solidFill>
-                        <a:srgbClr val="D5DBE3"/>
-                      </a:solidFill>
-                      <a:prstDash val="solid"/>
-                      <a:round/>
-                      <a:headEnd type="none" w="med" len="med"/>
-                      <a:tailEnd type="none" w="med" len="med"/>
-                    </a:lnR>
-                    <a:lnT w="6350" cap="flat" cmpd="sng" algn="ctr">
-                      <a:solidFill>
-                        <a:srgbClr val="D5DBE3"/>
-                      </a:solidFill>
-                      <a:prstDash val="solid"/>
-                      <a:round/>
-                      <a:headEnd type="none" w="med" len="med"/>
-                      <a:tailEnd type="none" w="med" len="med"/>
-                    </a:lnT>
-                    <a:lnB w="6350" cap="flat" cmpd="sng" algn="ctr">
-                      <a:solidFill>
-                        <a:srgbClr val="D5DBE3"/>
-                      </a:solidFill>
-                      <a:prstDash val="solid"/>
-                      <a:round/>
-                      <a:headEnd type="none" w="med" len="med"/>
-                      <a:tailEnd type="none" w="med" len="med"/>
-                    </a:lnB>
-                    <a:solidFill>
-                      <a:srgbClr val="F7E7E5"/>
-                    </a:solidFill>
-                  </a:tcPr>
-                </a:tc>
-                <a:tc>
-                  <a:txBody>
-                    <a:bodyPr/>
-                    <a:lstStyle/>
-                    <a:p>
-                      <a:pPr algn="l" indent="0" marL="0">
-                        <a:buNone/>
-                      </a:pPr>
-                      <a:r>
-                        <a:rPr lang="en-US" sz="950" dirty="0">
-                          <a:solidFill>
-                            <a:srgbClr val="1F2933"/>
-                          </a:solidFill>
-                          <a:latin typeface="Calibri" pitchFamily="34" charset="0"/>
-                          <a:ea typeface="Calibri" pitchFamily="34" charset="-122"/>
-                          <a:cs typeface="Calibri" pitchFamily="34" charset="-120"/>
-                        </a:rPr>
-                        <a:t>Spot (A) ou avance (B)</a:t>
-                      </a:r>
-                      <a:endParaRPr lang="en-US" sz="950" dirty="0">
-                        <a:latin typeface="Calibri" charset="0"/>
-                        <a:ea typeface="Calibri" charset="0"/>
-                        <a:cs typeface="Calibri" charset="0"/>
-                      </a:endParaRPr>
-                    </a:p>
-                  </a:txBody>
-                  <a:tcPr marL="64008" marR="64008" marT="0" marB="0" anchor="ctr">
-                    <a:lnL w="6350" cap="flat" cmpd="sng" algn="ctr">
-                      <a:solidFill>
-                        <a:srgbClr val="D5DBE3"/>
-                      </a:solidFill>
-                      <a:prstDash val="solid"/>
-                      <a:round/>
-                      <a:headEnd type="none" w="med" len="med"/>
-                      <a:tailEnd type="none" w="med" len="med"/>
-                    </a:lnL>
-                    <a:lnR w="6350" cap="flat" cmpd="sng" algn="ctr">
-                      <a:solidFill>
-                        <a:srgbClr val="D5DBE3"/>
-                      </a:solidFill>
-                      <a:prstDash val="solid"/>
-                      <a:round/>
-                      <a:headEnd type="none" w="med" len="med"/>
-                      <a:tailEnd type="none" w="med" len="med"/>
-                    </a:lnR>
-                    <a:lnT w="6350" cap="flat" cmpd="sng" algn="ctr">
-                      <a:solidFill>
-                        <a:srgbClr val="D5DBE3"/>
-                      </a:solidFill>
-                      <a:prstDash val="solid"/>
-                      <a:round/>
-                      <a:headEnd type="none" w="med" len="med"/>
-                      <a:tailEnd type="none" w="med" len="med"/>
-                    </a:lnT>
-                    <a:lnB w="6350" cap="flat" cmpd="sng" algn="ctr">
-                      <a:solidFill>
-                        <a:srgbClr val="D5DBE3"/>
-                      </a:solidFill>
-                      <a:prstDash val="solid"/>
-                      <a:round/>
-                      <a:headEnd type="none" w="med" len="med"/>
-                      <a:tailEnd type="none" w="med" len="med"/>
-                    </a:lnB>
-                  </a:tcPr>
-                </a:tc>
-                <a:tc>
-                  <a:txBody>
-                    <a:bodyPr/>
-                    <a:lstStyle/>
-                    <a:p>
-                      <a:pPr algn="ctr" indent="0" marL="0">
-                        <a:buNone/>
-                      </a:pPr>
-                      <a:r>
-                        <a:rPr lang="en-US" sz="950" dirty="0">
-                          <a:solidFill>
-                            <a:srgbClr val="1F2933"/>
-                          </a:solidFill>
-                          <a:latin typeface="Calibri" pitchFamily="34" charset="0"/>
-                          <a:ea typeface="Calibri" pitchFamily="34" charset="-122"/>
-                          <a:cs typeface="Calibri" pitchFamily="34" charset="-120"/>
-                        </a:rPr>
-                        <a:t>S1</a:t>
-                      </a:r>
-                      <a:endParaRPr lang="en-US" sz="950" dirty="0">
-                        <a:latin typeface="Calibri" charset="0"/>
-                        <a:ea typeface="Calibri" charset="0"/>
-                        <a:cs typeface="Calibri" charset="0"/>
-                      </a:endParaRPr>
-                    </a:p>
-                  </a:txBody>
-                  <a:tcPr marL="64008" marR="64008" marT="0" marB="0" anchor="ctr">
-                    <a:lnL w="6350" cap="flat" cmpd="sng" algn="ctr">
-                      <a:solidFill>
-                        <a:srgbClr val="D5DBE3"/>
-                      </a:solidFill>
-                      <a:prstDash val="solid"/>
-                      <a:round/>
-                      <a:headEnd type="none" w="med" len="med"/>
-                      <a:tailEnd type="none" w="med" len="med"/>
-                    </a:lnL>
-                    <a:lnR w="6350" cap="flat" cmpd="sng" algn="ctr">
-                      <a:solidFill>
-                        <a:srgbClr val="D5DBE3"/>
-                      </a:solidFill>
-                      <a:prstDash val="solid"/>
-                      <a:round/>
-                      <a:headEnd type="none" w="med" len="med"/>
-                      <a:tailEnd type="none" w="med" len="med"/>
-                    </a:lnR>
-                    <a:lnT w="6350" cap="flat" cmpd="sng" algn="ctr">
-                      <a:solidFill>
-                        <a:srgbClr val="D5DBE3"/>
-                      </a:solidFill>
-                      <a:prstDash val="solid"/>
-                      <a:round/>
-                      <a:headEnd type="none" w="med" len="med"/>
-                      <a:tailEnd type="none" w="med" len="med"/>
-                    </a:lnT>
-                    <a:lnB w="6350" cap="flat" cmpd="sng" algn="ctr">
-                      <a:solidFill>
-                        <a:srgbClr val="D5DBE3"/>
-                      </a:solidFill>
-                      <a:prstDash val="solid"/>
-                      <a:round/>
-                      <a:headEnd type="none" w="med" len="med"/>
-                      <a:tailEnd type="none" w="med" len="med"/>
-                    </a:lnB>
-                  </a:tcPr>
-                </a:tc>
-              </a:tr>
-              <a:tr h="237744">
-                <a:tc>
-                  <a:txBody>
-                    <a:bodyPr/>
-                    <a:lstStyle/>
-                    <a:p>
-                      <a:pPr algn="l" indent="0" marL="0">
-                        <a:buNone/>
-                      </a:pPr>
-                      <a:r>
-                        <a:rPr lang="en-US" sz="950" b="1" dirty="0">
-                          <a:solidFill>
-                            <a:srgbClr val="1F2933"/>
-                          </a:solidFill>
-                          <a:latin typeface="Calibri" pitchFamily="34" charset="0"/>
-                          <a:ea typeface="Calibri" pitchFamily="34" charset="-122"/>
-                          <a:cs typeface="Calibri" pitchFamily="34" charset="-120"/>
-                        </a:rPr>
-                        <a:t>FINAFRICA</a:t>
-                      </a:r>
-                      <a:endParaRPr lang="en-US" sz="950" dirty="0">
-                        <a:latin typeface="Calibri" charset="0"/>
-                        <a:ea typeface="Calibri" charset="0"/>
-                        <a:cs typeface="Calibri" charset="0"/>
-                      </a:endParaRPr>
-                    </a:p>
-                  </a:txBody>
-                  <a:tcPr marL="64008" marR="64008" marT="0" marB="0" anchor="ctr">
-                    <a:lnL w="6350" cap="flat" cmpd="sng" algn="ctr">
-                      <a:solidFill>
-                        <a:srgbClr val="D5DBE3"/>
-                      </a:solidFill>
-                      <a:prstDash val="solid"/>
-                      <a:round/>
-                      <a:headEnd type="none" w="med" len="med"/>
-                      <a:tailEnd type="none" w="med" len="med"/>
-                    </a:lnL>
-                    <a:lnR w="6350" cap="flat" cmpd="sng" algn="ctr">
-                      <a:solidFill>
-                        <a:srgbClr val="D5DBE3"/>
-                      </a:solidFill>
-                      <a:prstDash val="solid"/>
-                      <a:round/>
-                      <a:headEnd type="none" w="med" len="med"/>
-                      <a:tailEnd type="none" w="med" len="med"/>
-                    </a:lnR>
-                    <a:lnT w="6350" cap="flat" cmpd="sng" algn="ctr">
-                      <a:solidFill>
-                        <a:srgbClr val="D5DBE3"/>
-                      </a:solidFill>
-                      <a:prstDash val="solid"/>
-                      <a:round/>
-                      <a:headEnd type="none" w="med" len="med"/>
-                      <a:tailEnd type="none" w="med" len="med"/>
-                    </a:lnT>
-                    <a:lnB w="6350" cap="flat" cmpd="sng" algn="ctr">
-                      <a:solidFill>
-                        <a:srgbClr val="D5DBE3"/>
-                      </a:solidFill>
-                      <a:prstDash val="solid"/>
-                      <a:round/>
-                      <a:headEnd type="none" w="med" len="med"/>
-                      <a:tailEnd type="none" w="med" len="med"/>
-                    </a:lnB>
-                  </a:tcPr>
-                </a:tc>
-                <a:tc>
-                  <a:txBody>
-                    <a:bodyPr/>
-                    <a:lstStyle/>
-                    <a:p>
-                      <a:pPr algn="r" indent="0" marL="0">
-                        <a:buNone/>
-                      </a:pPr>
-                      <a:r>
-                        <a:rPr lang="en-US" sz="950" b="1" dirty="0">
-                          <a:solidFill>
-                            <a:srgbClr val="B3261E"/>
-                          </a:solidFill>
-                          <a:latin typeface="Calibri" pitchFamily="34" charset="0"/>
-                          <a:ea typeface="Calibri" pitchFamily="34" charset="-122"/>
-                          <a:cs typeface="Calibri" pitchFamily="34" charset="-120"/>
-                        </a:rPr>
-                        <a:t>198,7</a:t>
-                      </a:r>
-                      <a:endParaRPr lang="en-US" sz="950" dirty="0">
-                        <a:latin typeface="Calibri" charset="0"/>
-                        <a:ea typeface="Calibri" charset="0"/>
-                        <a:cs typeface="Calibri" charset="0"/>
-                      </a:endParaRPr>
-                    </a:p>
-                  </a:txBody>
-                  <a:tcPr marL="64008" marR="64008" marT="0" marB="0" anchor="ctr">
-                    <a:lnL w="6350" cap="flat" cmpd="sng" algn="ctr">
-                      <a:solidFill>
-                        <a:srgbClr val="D5DBE3"/>
-                      </a:solidFill>
-                      <a:prstDash val="solid"/>
-                      <a:round/>
-                      <a:headEnd type="none" w="med" len="med"/>
-                      <a:tailEnd type="none" w="med" len="med"/>
-                    </a:lnL>
-                    <a:lnR w="6350" cap="flat" cmpd="sng" algn="ctr">
-                      <a:solidFill>
-                        <a:srgbClr val="D5DBE3"/>
-                      </a:solidFill>
-                      <a:prstDash val="solid"/>
-                      <a:round/>
-                      <a:headEnd type="none" w="med" len="med"/>
-                      <a:tailEnd type="none" w="med" len="med"/>
-                    </a:lnR>
-                    <a:lnT w="6350" cap="flat" cmpd="sng" algn="ctr">
-                      <a:solidFill>
-                        <a:srgbClr val="D5DBE3"/>
-                      </a:solidFill>
-                      <a:prstDash val="solid"/>
-                      <a:round/>
-                      <a:headEnd type="none" w="med" len="med"/>
-                      <a:tailEnd type="none" w="med" len="med"/>
-                    </a:lnT>
-                    <a:lnB w="6350" cap="flat" cmpd="sng" algn="ctr">
-                      <a:solidFill>
-                        <a:srgbClr val="D5DBE3"/>
-                      </a:solidFill>
-                      <a:prstDash val="solid"/>
-                      <a:round/>
-                      <a:headEnd type="none" w="med" len="med"/>
-                      <a:tailEnd type="none" w="med" len="med"/>
-                    </a:lnB>
-                    <a:solidFill>
-                      <a:srgbClr val="F7E7E5"/>
-                    </a:solidFill>
-                  </a:tcPr>
-                </a:tc>
-                <a:tc>
-                  <a:txBody>
-                    <a:bodyPr/>
-                    <a:lstStyle/>
-                    <a:p>
-                      <a:pPr algn="l" indent="0" marL="0">
-                        <a:buNone/>
-                      </a:pPr>
-                      <a:r>
-                        <a:rPr lang="en-US" sz="950" dirty="0">
-                          <a:solidFill>
-                            <a:srgbClr val="1F2933"/>
-                          </a:solidFill>
-                          <a:latin typeface="Calibri" pitchFamily="34" charset="0"/>
-                          <a:ea typeface="Calibri" pitchFamily="34" charset="-122"/>
-                          <a:cs typeface="Calibri" pitchFamily="34" charset="-120"/>
-                        </a:rPr>
-                        <a:t>Spot (A) ou avance (B)</a:t>
-                      </a:r>
-                      <a:endParaRPr lang="en-US" sz="950" dirty="0">
-                        <a:latin typeface="Calibri" charset="0"/>
-                        <a:ea typeface="Calibri" charset="0"/>
-                        <a:cs typeface="Calibri" charset="0"/>
-                      </a:endParaRPr>
-                    </a:p>
-                  </a:txBody>
-                  <a:tcPr marL="64008" marR="64008" marT="0" marB="0" anchor="ctr">
-                    <a:lnL w="6350" cap="flat" cmpd="sng" algn="ctr">
-                      <a:solidFill>
-                        <a:srgbClr val="D5DBE3"/>
-                      </a:solidFill>
-                      <a:prstDash val="solid"/>
-                      <a:round/>
-                      <a:headEnd type="none" w="med" len="med"/>
-                      <a:tailEnd type="none" w="med" len="med"/>
-                    </a:lnL>
-                    <a:lnR w="6350" cap="flat" cmpd="sng" algn="ctr">
-                      <a:solidFill>
-                        <a:srgbClr val="D5DBE3"/>
-                      </a:solidFill>
-                      <a:prstDash val="solid"/>
-                      <a:round/>
-                      <a:headEnd type="none" w="med" len="med"/>
-                      <a:tailEnd type="none" w="med" len="med"/>
-                    </a:lnR>
-                    <a:lnT w="6350" cap="flat" cmpd="sng" algn="ctr">
-                      <a:solidFill>
-                        <a:srgbClr val="D5DBE3"/>
-                      </a:solidFill>
-                      <a:prstDash val="solid"/>
-                      <a:round/>
-                      <a:headEnd type="none" w="med" len="med"/>
-                      <a:tailEnd type="none" w="med" len="med"/>
-                    </a:lnT>
-                    <a:lnB w="6350" cap="flat" cmpd="sng" algn="ctr">
-                      <a:solidFill>
-                        <a:srgbClr val="D5DBE3"/>
-                      </a:solidFill>
-                      <a:prstDash val="solid"/>
-                      <a:round/>
-                      <a:headEnd type="none" w="med" len="med"/>
-                      <a:tailEnd type="none" w="med" len="med"/>
-                    </a:lnB>
-                  </a:tcPr>
-                </a:tc>
-                <a:tc>
-                  <a:txBody>
-                    <a:bodyPr/>
-                    <a:lstStyle/>
-                    <a:p>
-                      <a:pPr algn="ctr" indent="0" marL="0">
-                        <a:buNone/>
-                      </a:pPr>
-                      <a:r>
-                        <a:rPr lang="en-US" sz="950" dirty="0">
-                          <a:solidFill>
-                            <a:srgbClr val="1F2933"/>
-                          </a:solidFill>
-                          <a:latin typeface="Calibri" pitchFamily="34" charset="0"/>
-                          <a:ea typeface="Calibri" pitchFamily="34" charset="-122"/>
-                          <a:cs typeface="Calibri" pitchFamily="34" charset="-120"/>
-                        </a:rPr>
-                        <a:t>S1</a:t>
-                      </a:r>
-                      <a:endParaRPr lang="en-US" sz="950" dirty="0">
-                        <a:latin typeface="Calibri" charset="0"/>
-                        <a:ea typeface="Calibri" charset="0"/>
-                        <a:cs typeface="Calibri" charset="0"/>
-                      </a:endParaRPr>
-                    </a:p>
-                  </a:txBody>
-                  <a:tcPr marL="64008" marR="64008" marT="0" marB="0" anchor="ctr">
-                    <a:lnL w="6350" cap="flat" cmpd="sng" algn="ctr">
-                      <a:solidFill>
-                        <a:srgbClr val="D5DBE3"/>
-                      </a:solidFill>
-                      <a:prstDash val="solid"/>
-                      <a:round/>
-                      <a:headEnd type="none" w="med" len="med"/>
-                      <a:tailEnd type="none" w="med" len="med"/>
-                    </a:lnL>
-                    <a:lnR w="6350" cap="flat" cmpd="sng" algn="ctr">
-                      <a:solidFill>
-                        <a:srgbClr val="D5DBE3"/>
-                      </a:solidFill>
-                      <a:prstDash val="solid"/>
-                      <a:round/>
-                      <a:headEnd type="none" w="med" len="med"/>
-                      <a:tailEnd type="none" w="med" len="med"/>
-                    </a:lnR>
-                    <a:lnT w="6350" cap="flat" cmpd="sng" algn="ctr">
-                      <a:solidFill>
-                        <a:srgbClr val="D5DBE3"/>
-                      </a:solidFill>
-                      <a:prstDash val="solid"/>
-                      <a:round/>
-                      <a:headEnd type="none" w="med" len="med"/>
-                      <a:tailEnd type="none" w="med" len="med"/>
-                    </a:lnT>
-                    <a:lnB w="6350" cap="flat" cmpd="sng" algn="ctr">
-                      <a:solidFill>
-                        <a:srgbClr val="D5DBE3"/>
-                      </a:solidFill>
-                      <a:prstDash val="solid"/>
-                      <a:round/>
-                      <a:headEnd type="none" w="med" len="med"/>
-                      <a:tailEnd type="none" w="med" len="med"/>
-                    </a:lnB>
-                  </a:tcPr>
-                </a:tc>
-              </a:tr>
-              <a:tr h="237744">
-                <a:tc>
-                  <a:txBody>
-                    <a:bodyPr/>
-                    <a:lstStyle/>
-                    <a:p>
-                      <a:pPr algn="l" indent="0" marL="0">
-                        <a:buNone/>
-                      </a:pPr>
-                      <a:r>
-                        <a:rPr lang="en-US" sz="950" b="1" dirty="0">
-                          <a:solidFill>
-                            <a:srgbClr val="1F2933"/>
-                          </a:solidFill>
-                          <a:latin typeface="Calibri" pitchFamily="34" charset="0"/>
-                          <a:ea typeface="Calibri" pitchFamily="34" charset="-122"/>
-                          <a:cs typeface="Calibri" pitchFamily="34" charset="-120"/>
-                        </a:rPr>
-                        <a:t>FIRST</a:t>
-                      </a:r>
-                      <a:endParaRPr lang="en-US" sz="950" dirty="0">
-                        <a:latin typeface="Calibri" charset="0"/>
-                        <a:ea typeface="Calibri" charset="0"/>
-                        <a:cs typeface="Calibri" charset="0"/>
-                      </a:endParaRPr>
-                    </a:p>
-                  </a:txBody>
-                  <a:tcPr marL="64008" marR="64008" marT="0" marB="0" anchor="ctr">
-                    <a:lnL w="6350" cap="flat" cmpd="sng" algn="ctr">
-                      <a:solidFill>
-                        <a:srgbClr val="D5DBE3"/>
-                      </a:solidFill>
-                      <a:prstDash val="solid"/>
-                      <a:round/>
-                      <a:headEnd type="none" w="med" len="med"/>
-                      <a:tailEnd type="none" w="med" len="med"/>
-                    </a:lnL>
-                    <a:lnR w="6350" cap="flat" cmpd="sng" algn="ctr">
-                      <a:solidFill>
-                        <a:srgbClr val="D5DBE3"/>
-                      </a:solidFill>
-                      <a:prstDash val="solid"/>
-                      <a:round/>
-                      <a:headEnd type="none" w="med" len="med"/>
-                      <a:tailEnd type="none" w="med" len="med"/>
-                    </a:lnR>
-                    <a:lnT w="6350" cap="flat" cmpd="sng" algn="ctr">
-                      <a:solidFill>
-                        <a:srgbClr val="D5DBE3"/>
-                      </a:solidFill>
-                      <a:prstDash val="solid"/>
-                      <a:round/>
-                      <a:headEnd type="none" w="med" len="med"/>
-                      <a:tailEnd type="none" w="med" len="med"/>
-                    </a:lnT>
-                    <a:lnB w="6350" cap="flat" cmpd="sng" algn="ctr">
-                      <a:solidFill>
-                        <a:srgbClr val="D5DBE3"/>
-                      </a:solidFill>
-                      <a:prstDash val="solid"/>
-                      <a:round/>
-                      <a:headEnd type="none" w="med" len="med"/>
-                      <a:tailEnd type="none" w="med" len="med"/>
-                    </a:lnB>
-                  </a:tcPr>
-                </a:tc>
-                <a:tc>
-                  <a:txBody>
-                    <a:bodyPr/>
-                    <a:lstStyle/>
-                    <a:p>
-                      <a:pPr algn="r" indent="0" marL="0">
-                        <a:buNone/>
-                      </a:pPr>
-                      <a:r>
-                        <a:rPr lang="en-US" sz="950" b="1" dirty="0">
-                          <a:solidFill>
-                            <a:srgbClr val="B3261E"/>
-                          </a:solidFill>
-                          <a:latin typeface="Calibri" pitchFamily="34" charset="0"/>
-                          <a:ea typeface="Calibri" pitchFamily="34" charset="-122"/>
-                          <a:cs typeface="Calibri" pitchFamily="34" charset="-120"/>
-                        </a:rPr>
-                        <a:t>175,3</a:t>
-                      </a:r>
-                      <a:endParaRPr lang="en-US" sz="950" dirty="0">
-                        <a:latin typeface="Calibri" charset="0"/>
-                        <a:ea typeface="Calibri" charset="0"/>
-                        <a:cs typeface="Calibri" charset="0"/>
-                      </a:endParaRPr>
-                    </a:p>
-                  </a:txBody>
-                  <a:tcPr marL="64008" marR="64008" marT="0" marB="0" anchor="ctr">
-                    <a:lnL w="6350" cap="flat" cmpd="sng" algn="ctr">
-                      <a:solidFill>
-                        <a:srgbClr val="D5DBE3"/>
-                      </a:solidFill>
-                      <a:prstDash val="solid"/>
-                      <a:round/>
-                      <a:headEnd type="none" w="med" len="med"/>
-                      <a:tailEnd type="none" w="med" len="med"/>
-                    </a:lnL>
-                    <a:lnR w="6350" cap="flat" cmpd="sng" algn="ctr">
-                      <a:solidFill>
-                        <a:srgbClr val="D5DBE3"/>
-                      </a:solidFill>
-                      <a:prstDash val="solid"/>
-                      <a:round/>
-                      <a:headEnd type="none" w="med" len="med"/>
-                      <a:tailEnd type="none" w="med" len="med"/>
-                    </a:lnR>
-                    <a:lnT w="6350" cap="flat" cmpd="sng" algn="ctr">
-                      <a:solidFill>
-                        <a:srgbClr val="D5DBE3"/>
-                      </a:solidFill>
-                      <a:prstDash val="solid"/>
-                      <a:round/>
-                      <a:headEnd type="none" w="med" len="med"/>
-                      <a:tailEnd type="none" w="med" len="med"/>
-                    </a:lnT>
-                    <a:lnB w="6350" cap="flat" cmpd="sng" algn="ctr">
-                      <a:solidFill>
-                        <a:srgbClr val="D5DBE3"/>
-                      </a:solidFill>
-                      <a:prstDash val="solid"/>
-                      <a:round/>
-                      <a:headEnd type="none" w="med" len="med"/>
-                      <a:tailEnd type="none" w="med" len="med"/>
-                    </a:lnB>
-                    <a:solidFill>
-                      <a:srgbClr val="F7E7E5"/>
-                    </a:solidFill>
-                  </a:tcPr>
-                </a:tc>
-                <a:tc>
-                  <a:txBody>
-                    <a:bodyPr/>
-                    <a:lstStyle/>
-                    <a:p>
-                      <a:pPr algn="l" indent="0" marL="0">
-                        <a:buNone/>
-                      </a:pPr>
-                      <a:r>
-                        <a:rPr lang="en-US" sz="950" dirty="0">
-                          <a:solidFill>
-                            <a:srgbClr val="1F2933"/>
-                          </a:solidFill>
-                          <a:latin typeface="Calibri" pitchFamily="34" charset="0"/>
-                          <a:ea typeface="Calibri" pitchFamily="34" charset="-122"/>
-                          <a:cs typeface="Calibri" pitchFamily="34" charset="-120"/>
-                        </a:rPr>
-                        <a:t>Spot (A) ou avance (B)</a:t>
-                      </a:r>
-                      <a:endParaRPr lang="en-US" sz="950" dirty="0">
-                        <a:latin typeface="Calibri" charset="0"/>
-                        <a:ea typeface="Calibri" charset="0"/>
-                        <a:cs typeface="Calibri" charset="0"/>
-                      </a:endParaRPr>
-                    </a:p>
-                  </a:txBody>
-                  <a:tcPr marL="64008" marR="64008" marT="0" marB="0" anchor="ctr">
-                    <a:lnL w="6350" cap="flat" cmpd="sng" algn="ctr">
-                      <a:solidFill>
-                        <a:srgbClr val="D5DBE3"/>
-                      </a:solidFill>
-                      <a:prstDash val="solid"/>
-                      <a:round/>
-                      <a:headEnd type="none" w="med" len="med"/>
-                      <a:tailEnd type="none" w="med" len="med"/>
-                    </a:lnL>
-                    <a:lnR w="6350" cap="flat" cmpd="sng" algn="ctr">
-                      <a:solidFill>
-                        <a:srgbClr val="D5DBE3"/>
-                      </a:solidFill>
-                      <a:prstDash val="solid"/>
-                      <a:round/>
-                      <a:headEnd type="none" w="med" len="med"/>
-                      <a:tailEnd type="none" w="med" len="med"/>
-                    </a:lnR>
-                    <a:lnT w="6350" cap="flat" cmpd="sng" algn="ctr">
-                      <a:solidFill>
-                        <a:srgbClr val="D5DBE3"/>
-                      </a:solidFill>
-                      <a:prstDash val="solid"/>
-                      <a:round/>
-                      <a:headEnd type="none" w="med" len="med"/>
-                      <a:tailEnd type="none" w="med" len="med"/>
-                    </a:lnT>
-                    <a:lnB w="6350" cap="flat" cmpd="sng" algn="ctr">
-                      <a:solidFill>
-                        <a:srgbClr val="D5DBE3"/>
-                      </a:solidFill>
-                      <a:prstDash val="solid"/>
-                      <a:round/>
-                      <a:headEnd type="none" w="med" len="med"/>
-                      <a:tailEnd type="none" w="med" len="med"/>
-                    </a:lnB>
-                  </a:tcPr>
-                </a:tc>
-                <a:tc>
-                  <a:txBody>
-                    <a:bodyPr/>
-                    <a:lstStyle/>
-                    <a:p>
-                      <a:pPr algn="ctr" indent="0" marL="0">
-                        <a:buNone/>
-                      </a:pPr>
-                      <a:r>
-                        <a:rPr lang="en-US" sz="950" dirty="0">
-                          <a:solidFill>
-                            <a:srgbClr val="1F2933"/>
-                          </a:solidFill>
-                          <a:latin typeface="Calibri" pitchFamily="34" charset="0"/>
-                          <a:ea typeface="Calibri" pitchFamily="34" charset="-122"/>
-                          <a:cs typeface="Calibri" pitchFamily="34" charset="-120"/>
-                        </a:rPr>
-                        <a:t>S1</a:t>
-                      </a:r>
-                      <a:endParaRPr lang="en-US" sz="950" dirty="0">
-                        <a:latin typeface="Calibri" charset="0"/>
-                        <a:ea typeface="Calibri" charset="0"/>
-                        <a:cs typeface="Calibri" charset="0"/>
-                      </a:endParaRPr>
-                    </a:p>
-                  </a:txBody>
-                  <a:tcPr marL="64008" marR="64008" marT="0" marB="0" anchor="ctr">
-                    <a:lnL w="6350" cap="flat" cmpd="sng" algn="ctr">
-                      <a:solidFill>
-                        <a:srgbClr val="D5DBE3"/>
-                      </a:solidFill>
-                      <a:prstDash val="solid"/>
-                      <a:round/>
-                      <a:headEnd type="none" w="med" len="med"/>
-                      <a:tailEnd type="none" w="med" len="med"/>
-                    </a:lnL>
-                    <a:lnR w="6350" cap="flat" cmpd="sng" algn="ctr">
-                      <a:solidFill>
-                        <a:srgbClr val="D5DBE3"/>
-                      </a:solidFill>
-                      <a:prstDash val="solid"/>
-                      <a:round/>
-                      <a:headEnd type="none" w="med" len="med"/>
-                      <a:tailEnd type="none" w="med" len="med"/>
-                    </a:lnR>
-                    <a:lnT w="6350" cap="flat" cmpd="sng" algn="ctr">
-                      <a:solidFill>
-                        <a:srgbClr val="D5DBE3"/>
-                      </a:solidFill>
-                      <a:prstDash val="solid"/>
-                      <a:round/>
-                      <a:headEnd type="none" w="med" len="med"/>
-                      <a:tailEnd type="none" w="med" len="med"/>
-                    </a:lnT>
-                    <a:lnB w="6350" cap="flat" cmpd="sng" algn="ctr">
-                      <a:solidFill>
-                        <a:srgbClr val="D5DBE3"/>
-                      </a:solidFill>
-                      <a:prstDash val="solid"/>
-                      <a:round/>
-                      <a:headEnd type="none" w="med" len="med"/>
-                      <a:tailEnd type="none" w="med" len="med"/>
-                    </a:lnB>
-                  </a:tcPr>
-                </a:tc>
-              </a:tr>
-              <a:tr h="237744">
-                <a:tc>
-                  <a:txBody>
-                    <a:bodyPr/>
-                    <a:lstStyle/>
-                    <a:p>
-                      <a:pPr algn="l" indent="0" marL="0">
-                        <a:buNone/>
-                      </a:pPr>
-                      <a:r>
-                        <a:rPr lang="en-US" sz="950" b="1" dirty="0">
-                          <a:solidFill>
-                            <a:srgbClr val="1F2933"/>
-                          </a:solidFill>
-                          <a:latin typeface="Calibri" pitchFamily="34" charset="0"/>
-                          <a:ea typeface="Calibri" pitchFamily="34" charset="-122"/>
-                          <a:cs typeface="Calibri" pitchFamily="34" charset="-120"/>
-                        </a:rPr>
-                        <a:t>RIVIERA</a:t>
-                      </a:r>
-                      <a:endParaRPr lang="en-US" sz="950" dirty="0">
-                        <a:latin typeface="Calibri" charset="0"/>
-                        <a:ea typeface="Calibri" charset="0"/>
-                        <a:cs typeface="Calibri" charset="0"/>
-                      </a:endParaRPr>
-                    </a:p>
-                  </a:txBody>
-                  <a:tcPr marL="64008" marR="64008" marT="0" marB="0" anchor="ctr">
-                    <a:lnL w="6350" cap="flat" cmpd="sng" algn="ctr">
-                      <a:solidFill>
-                        <a:srgbClr val="D5DBE3"/>
-                      </a:solidFill>
-                      <a:prstDash val="solid"/>
-                      <a:round/>
-                      <a:headEnd type="none" w="med" len="med"/>
-                      <a:tailEnd type="none" w="med" len="med"/>
-                    </a:lnL>
-                    <a:lnR w="6350" cap="flat" cmpd="sng" algn="ctr">
-                      <a:solidFill>
-                        <a:srgbClr val="D5DBE3"/>
-                      </a:solidFill>
-                      <a:prstDash val="solid"/>
-                      <a:round/>
-                      <a:headEnd type="none" w="med" len="med"/>
-                      <a:tailEnd type="none" w="med" len="med"/>
-                    </a:lnR>
-                    <a:lnT w="6350" cap="flat" cmpd="sng" algn="ctr">
-                      <a:solidFill>
-                        <a:srgbClr val="D5DBE3"/>
-                      </a:solidFill>
-                      <a:prstDash val="solid"/>
-                      <a:round/>
-                      <a:headEnd type="none" w="med" len="med"/>
-                      <a:tailEnd type="none" w="med" len="med"/>
-                    </a:lnT>
-                    <a:lnB w="6350" cap="flat" cmpd="sng" algn="ctr">
-                      <a:solidFill>
-                        <a:srgbClr val="D5DBE3"/>
-                      </a:solidFill>
-                      <a:prstDash val="solid"/>
-                      <a:round/>
-                      <a:headEnd type="none" w="med" len="med"/>
-                      <a:tailEnd type="none" w="med" len="med"/>
-                    </a:lnB>
-                  </a:tcPr>
-                </a:tc>
-                <a:tc>
-                  <a:txBody>
-                    <a:bodyPr/>
-                    <a:lstStyle/>
-                    <a:p>
-                      <a:pPr algn="r" indent="0" marL="0">
-                        <a:buNone/>
-                      </a:pPr>
-                      <a:r>
-                        <a:rPr lang="en-US" sz="950" b="1" dirty="0">
-                          <a:solidFill>
-                            <a:srgbClr val="B3261E"/>
-                          </a:solidFill>
-                          <a:latin typeface="Calibri" pitchFamily="34" charset="0"/>
-                          <a:ea typeface="Calibri" pitchFamily="34" charset="-122"/>
-                          <a:cs typeface="Calibri" pitchFamily="34" charset="-120"/>
-                        </a:rPr>
-                        <a:t>87,3</a:t>
-                      </a:r>
-                      <a:endParaRPr lang="en-US" sz="950" dirty="0">
-                        <a:latin typeface="Calibri" charset="0"/>
-                        <a:ea typeface="Calibri" charset="0"/>
-                        <a:cs typeface="Calibri" charset="0"/>
-                      </a:endParaRPr>
-                    </a:p>
-                  </a:txBody>
-                  <a:tcPr marL="64008" marR="64008" marT="0" marB="0" anchor="ctr">
-                    <a:lnL w="6350" cap="flat" cmpd="sng" algn="ctr">
-                      <a:solidFill>
-                        <a:srgbClr val="D5DBE3"/>
-                      </a:solidFill>
-                      <a:prstDash val="solid"/>
-                      <a:round/>
-                      <a:headEnd type="none" w="med" len="med"/>
-                      <a:tailEnd type="none" w="med" len="med"/>
-                    </a:lnL>
-                    <a:lnR w="6350" cap="flat" cmpd="sng" algn="ctr">
-                      <a:solidFill>
-                        <a:srgbClr val="D5DBE3"/>
-                      </a:solidFill>
-                      <a:prstDash val="solid"/>
-                      <a:round/>
-                      <a:headEnd type="none" w="med" len="med"/>
-                      <a:tailEnd type="none" w="med" len="med"/>
-                    </a:lnR>
-                    <a:lnT w="6350" cap="flat" cmpd="sng" algn="ctr">
-                      <a:solidFill>
-                        <a:srgbClr val="D5DBE3"/>
-                      </a:solidFill>
-                      <a:prstDash val="solid"/>
-                      <a:round/>
-                      <a:headEnd type="none" w="med" len="med"/>
-                      <a:tailEnd type="none" w="med" len="med"/>
-                    </a:lnT>
-                    <a:lnB w="6350" cap="flat" cmpd="sng" algn="ctr">
-                      <a:solidFill>
-                        <a:srgbClr val="D5DBE3"/>
-                      </a:solidFill>
-                      <a:prstDash val="solid"/>
-                      <a:round/>
-                      <a:headEnd type="none" w="med" len="med"/>
-                      <a:tailEnd type="none" w="med" len="med"/>
-                    </a:lnB>
-                    <a:solidFill>
-                      <a:srgbClr val="F7E7E5"/>
-                    </a:solidFill>
-                  </a:tcPr>
-                </a:tc>
-                <a:tc>
-                  <a:txBody>
-                    <a:bodyPr/>
-                    <a:lstStyle/>
-                    <a:p>
-                      <a:pPr algn="l" indent="0" marL="0">
-                        <a:buNone/>
-                      </a:pPr>
-                      <a:r>
-                        <a:rPr lang="en-US" sz="950" dirty="0">
-                          <a:solidFill>
-                            <a:srgbClr val="1F2933"/>
-                          </a:solidFill>
-                          <a:latin typeface="Calibri" pitchFamily="34" charset="0"/>
-                          <a:ea typeface="Calibri" pitchFamily="34" charset="-122"/>
-                          <a:cs typeface="Calibri" pitchFamily="34" charset="-120"/>
-                        </a:rPr>
-                        <a:t>Spot (A) ou avance (B)</a:t>
-                      </a:r>
-                      <a:endParaRPr lang="en-US" sz="950" dirty="0">
-                        <a:latin typeface="Calibri" charset="0"/>
-                        <a:ea typeface="Calibri" charset="0"/>
-                        <a:cs typeface="Calibri" charset="0"/>
-                      </a:endParaRPr>
-                    </a:p>
-                  </a:txBody>
-                  <a:tcPr marL="64008" marR="64008" marT="0" marB="0" anchor="ctr">
-                    <a:lnL w="6350" cap="flat" cmpd="sng" algn="ctr">
-                      <a:solidFill>
-                        <a:srgbClr val="D5DBE3"/>
-                      </a:solidFill>
-                      <a:prstDash val="solid"/>
-                      <a:round/>
-                      <a:headEnd type="none" w="med" len="med"/>
-                      <a:tailEnd type="none" w="med" len="med"/>
-                    </a:lnL>
-                    <a:lnR w="6350" cap="flat" cmpd="sng" algn="ctr">
-                      <a:solidFill>
-                        <a:srgbClr val="D5DBE3"/>
-                      </a:solidFill>
-                      <a:prstDash val="solid"/>
-                      <a:round/>
-                      <a:headEnd type="none" w="med" len="med"/>
-                      <a:tailEnd type="none" w="med" len="med"/>
-                    </a:lnR>
-                    <a:lnT w="6350" cap="flat" cmpd="sng" algn="ctr">
-                      <a:solidFill>
-                        <a:srgbClr val="D5DBE3"/>
-                      </a:solidFill>
-                      <a:prstDash val="solid"/>
-                      <a:round/>
-                      <a:headEnd type="none" w="med" len="med"/>
-                      <a:tailEnd type="none" w="med" len="med"/>
-                    </a:lnT>
-                    <a:lnB w="6350" cap="flat" cmpd="sng" algn="ctr">
-                      <a:solidFill>
-                        <a:srgbClr val="D5DBE3"/>
-                      </a:solidFill>
-                      <a:prstDash val="solid"/>
-                      <a:round/>
-                      <a:headEnd type="none" w="med" len="med"/>
-                      <a:tailEnd type="none" w="med" len="med"/>
-                    </a:lnB>
-                  </a:tcPr>
-                </a:tc>
-                <a:tc>
-                  <a:txBody>
-                    <a:bodyPr/>
-                    <a:lstStyle/>
-                    <a:p>
-                      <a:pPr algn="ctr" indent="0" marL="0">
-                        <a:buNone/>
-                      </a:pPr>
-                      <a:r>
-                        <a:rPr lang="en-US" sz="950" dirty="0">
-                          <a:solidFill>
-                            <a:srgbClr val="1F2933"/>
-                          </a:solidFill>
-                          <a:latin typeface="Calibri" pitchFamily="34" charset="0"/>
-                          <a:ea typeface="Calibri" pitchFamily="34" charset="-122"/>
-                          <a:cs typeface="Calibri" pitchFamily="34" charset="-120"/>
-                        </a:rPr>
-                        <a:t>S1</a:t>
-                      </a:r>
-                      <a:endParaRPr lang="en-US" sz="950" dirty="0">
-                        <a:latin typeface="Calibri" charset="0"/>
-                        <a:ea typeface="Calibri" charset="0"/>
-                        <a:cs typeface="Calibri" charset="0"/>
-                      </a:endParaRPr>
-                    </a:p>
-                  </a:txBody>
-                  <a:tcPr marL="64008" marR="64008" marT="0" marB="0" anchor="ctr">
-                    <a:lnL w="6350" cap="flat" cmpd="sng" algn="ctr">
-                      <a:solidFill>
-                        <a:srgbClr val="D5DBE3"/>
-                      </a:solidFill>
-                      <a:prstDash val="solid"/>
-                      <a:round/>
-                      <a:headEnd type="none" w="med" len="med"/>
-                      <a:tailEnd type="none" w="med" len="med"/>
-                    </a:lnL>
-                    <a:lnR w="6350" cap="flat" cmpd="sng" algn="ctr">
-                      <a:solidFill>
-                        <a:srgbClr val="D5DBE3"/>
-                      </a:solidFill>
-                      <a:prstDash val="solid"/>
-                      <a:round/>
-                      <a:headEnd type="none" w="med" len="med"/>
-                      <a:tailEnd type="none" w="med" len="med"/>
-                    </a:lnR>
-                    <a:lnT w="6350" cap="flat" cmpd="sng" algn="ctr">
-                      <a:solidFill>
-                        <a:srgbClr val="D5DBE3"/>
-                      </a:solidFill>
-                      <a:prstDash val="solid"/>
-                      <a:round/>
-                      <a:headEnd type="none" w="med" len="med"/>
-                      <a:tailEnd type="none" w="med" len="med"/>
-                    </a:lnT>
-                    <a:lnB w="6350" cap="flat" cmpd="sng" algn="ctr">
-                      <a:solidFill>
-                        <a:srgbClr val="D5DBE3"/>
-                      </a:solidFill>
-                      <a:prstDash val="solid"/>
-                      <a:round/>
-                      <a:headEnd type="none" w="med" len="med"/>
-                      <a:tailEnd type="none" w="med" len="med"/>
-                    </a:lnB>
-                  </a:tcPr>
-                </a:tc>
-              </a:tr>
-              <a:tr h="237744">
-                <a:tc>
-                  <a:txBody>
-                    <a:bodyPr/>
-                    <a:lstStyle/>
-                    <a:p>
-                      <a:pPr algn="l" indent="0" marL="0">
-                        <a:buNone/>
-                      </a:pPr>
-                      <a:r>
-                        <a:rPr lang="en-US" sz="950" b="1" dirty="0">
-                          <a:solidFill>
-                            <a:srgbClr val="1F2933"/>
-                          </a:solidFill>
-                          <a:latin typeface="Calibri" pitchFamily="34" charset="0"/>
-                          <a:ea typeface="Calibri" pitchFamily="34" charset="-122"/>
-                          <a:cs typeface="Calibri" pitchFamily="34" charset="-120"/>
-                        </a:rPr>
-                        <a:t>IMMONEUF</a:t>
-                      </a:r>
-                      <a:endParaRPr lang="en-US" sz="950" dirty="0">
-                        <a:latin typeface="Calibri" charset="0"/>
-                        <a:ea typeface="Calibri" charset="0"/>
-                        <a:cs typeface="Calibri" charset="0"/>
-                      </a:endParaRPr>
-                    </a:p>
-                  </a:txBody>
-                  <a:tcPr marL="64008" marR="64008" marT="0" marB="0" anchor="ctr">
-                    <a:lnL w="6350" cap="flat" cmpd="sng" algn="ctr">
-                      <a:solidFill>
-                        <a:srgbClr val="D5DBE3"/>
-                      </a:solidFill>
-                      <a:prstDash val="solid"/>
-                      <a:round/>
-                      <a:headEnd type="none" w="med" len="med"/>
-                      <a:tailEnd type="none" w="med" len="med"/>
-                    </a:lnL>
-                    <a:lnR w="6350" cap="flat" cmpd="sng" algn="ctr">
-                      <a:solidFill>
-                        <a:srgbClr val="D5DBE3"/>
-                      </a:solidFill>
-                      <a:prstDash val="solid"/>
-                      <a:round/>
-                      <a:headEnd type="none" w="med" len="med"/>
-                      <a:tailEnd type="none" w="med" len="med"/>
-                    </a:lnR>
-                    <a:lnT w="6350" cap="flat" cmpd="sng" algn="ctr">
-                      <a:solidFill>
-                        <a:srgbClr val="D5DBE3"/>
-                      </a:solidFill>
-                      <a:prstDash val="solid"/>
-                      <a:round/>
-                      <a:headEnd type="none" w="med" len="med"/>
-                      <a:tailEnd type="none" w="med" len="med"/>
-                    </a:lnT>
-                    <a:lnB w="6350" cap="flat" cmpd="sng" algn="ctr">
-                      <a:solidFill>
-                        <a:srgbClr val="D5DBE3"/>
-                      </a:solidFill>
-                      <a:prstDash val="solid"/>
-                      <a:round/>
-                      <a:headEnd type="none" w="med" len="med"/>
-                      <a:tailEnd type="none" w="med" len="med"/>
-                    </a:lnB>
-                  </a:tcPr>
-                </a:tc>
-                <a:tc>
-                  <a:txBody>
-                    <a:bodyPr/>
-                    <a:lstStyle/>
-                    <a:p>
-                      <a:pPr algn="r" indent="0" marL="0">
-                        <a:buNone/>
-                      </a:pPr>
-                      <a:r>
-                        <a:rPr lang="en-US" sz="950" b="1" dirty="0">
-                          <a:solidFill>
-                            <a:srgbClr val="B3261E"/>
-                          </a:solidFill>
-                          <a:latin typeface="Calibri" pitchFamily="34" charset="0"/>
-                          <a:ea typeface="Calibri" pitchFamily="34" charset="-122"/>
-                          <a:cs typeface="Calibri" pitchFamily="34" charset="-120"/>
-                        </a:rPr>
-                        <a:t>66,0</a:t>
-                      </a:r>
-                      <a:endParaRPr lang="en-US" sz="950" dirty="0">
-                        <a:latin typeface="Calibri" charset="0"/>
-                        <a:ea typeface="Calibri" charset="0"/>
-                        <a:cs typeface="Calibri" charset="0"/>
-                      </a:endParaRPr>
-                    </a:p>
-                  </a:txBody>
-                  <a:tcPr marL="64008" marR="64008" marT="0" marB="0" anchor="ctr">
-                    <a:lnL w="6350" cap="flat" cmpd="sng" algn="ctr">
-                      <a:solidFill>
-                        <a:srgbClr val="D5DBE3"/>
-                      </a:solidFill>
-                      <a:prstDash val="solid"/>
-                      <a:round/>
-                      <a:headEnd type="none" w="med" len="med"/>
-                      <a:tailEnd type="none" w="med" len="med"/>
-                    </a:lnL>
-                    <a:lnR w="6350" cap="flat" cmpd="sng" algn="ctr">
-                      <a:solidFill>
-                        <a:srgbClr val="D5DBE3"/>
-                      </a:solidFill>
-                      <a:prstDash val="solid"/>
-                      <a:round/>
-                      <a:headEnd type="none" w="med" len="med"/>
-                      <a:tailEnd type="none" w="med" len="med"/>
-                    </a:lnR>
-                    <a:lnT w="6350" cap="flat" cmpd="sng" algn="ctr">
-                      <a:solidFill>
-                        <a:srgbClr val="D5DBE3"/>
-                      </a:solidFill>
-                      <a:prstDash val="solid"/>
-                      <a:round/>
-                      <a:headEnd type="none" w="med" len="med"/>
-                      <a:tailEnd type="none" w="med" len="med"/>
-                    </a:lnT>
-                    <a:lnB w="6350" cap="flat" cmpd="sng" algn="ctr">
-                      <a:solidFill>
-                        <a:srgbClr val="D5DBE3"/>
-                      </a:solidFill>
-                      <a:prstDash val="solid"/>
-                      <a:round/>
-                      <a:headEnd type="none" w="med" len="med"/>
-                      <a:tailEnd type="none" w="med" len="med"/>
-                    </a:lnB>
-                    <a:solidFill>
-                      <a:srgbClr val="F7E7E5"/>
-                    </a:solidFill>
-                  </a:tcPr>
-                </a:tc>
-                <a:tc>
-                  <a:txBody>
-                    <a:bodyPr/>
-                    <a:lstStyle/>
-                    <a:p>
-                      <a:pPr algn="l" indent="0" marL="0">
-                        <a:buNone/>
-                      </a:pPr>
-                      <a:r>
-                        <a:rPr lang="en-US" sz="950" dirty="0">
-                          <a:solidFill>
-                            <a:srgbClr val="1F2933"/>
-                          </a:solidFill>
-                          <a:latin typeface="Calibri" pitchFamily="34" charset="0"/>
-                          <a:ea typeface="Calibri" pitchFamily="34" charset="-122"/>
-                          <a:cs typeface="Calibri" pitchFamily="34" charset="-120"/>
-                        </a:rPr>
-                        <a:t>Spot (A) ou avance (B)</a:t>
-                      </a:r>
-                      <a:endParaRPr lang="en-US" sz="950" dirty="0">
-                        <a:latin typeface="Calibri" charset="0"/>
-                        <a:ea typeface="Calibri" charset="0"/>
-                        <a:cs typeface="Calibri" charset="0"/>
-                      </a:endParaRPr>
-                    </a:p>
-                  </a:txBody>
-                  <a:tcPr marL="64008" marR="64008" marT="0" marB="0" anchor="ctr">
-                    <a:lnL w="6350" cap="flat" cmpd="sng" algn="ctr">
-                      <a:solidFill>
-                        <a:srgbClr val="D5DBE3"/>
-                      </a:solidFill>
-                      <a:prstDash val="solid"/>
-                      <a:round/>
-                      <a:headEnd type="none" w="med" len="med"/>
-                      <a:tailEnd type="none" w="med" len="med"/>
-                    </a:lnL>
-                    <a:lnR w="6350" cap="flat" cmpd="sng" algn="ctr">
-                      <a:solidFill>
-                        <a:srgbClr val="D5DBE3"/>
-                      </a:solidFill>
-                      <a:prstDash val="solid"/>
-                      <a:round/>
-                      <a:headEnd type="none" w="med" len="med"/>
-                      <a:tailEnd type="none" w="med" len="med"/>
-                    </a:lnR>
-                    <a:lnT w="6350" cap="flat" cmpd="sng" algn="ctr">
-                      <a:solidFill>
-                        <a:srgbClr val="D5DBE3"/>
-                      </a:solidFill>
-                      <a:prstDash val="solid"/>
-                      <a:round/>
-                      <a:headEnd type="none" w="med" len="med"/>
-                      <a:tailEnd type="none" w="med" len="med"/>
-                    </a:lnT>
-                    <a:lnB w="6350" cap="flat" cmpd="sng" algn="ctr">
-                      <a:solidFill>
-                        <a:srgbClr val="D5DBE3"/>
-                      </a:solidFill>
-                      <a:prstDash val="solid"/>
-                      <a:round/>
-                      <a:headEnd type="none" w="med" len="med"/>
-                      <a:tailEnd type="none" w="med" len="med"/>
-                    </a:lnB>
-                  </a:tcPr>
-                </a:tc>
-                <a:tc>
-                  <a:txBody>
-                    <a:bodyPr/>
-                    <a:lstStyle/>
-                    <a:p>
-                      <a:pPr algn="ctr" indent="0" marL="0">
-                        <a:buNone/>
-                      </a:pPr>
-                      <a:r>
-                        <a:rPr lang="en-US" sz="950" dirty="0">
-                          <a:solidFill>
-                            <a:srgbClr val="1F2933"/>
-                          </a:solidFill>
-                          <a:latin typeface="Calibri" pitchFamily="34" charset="0"/>
-                          <a:ea typeface="Calibri" pitchFamily="34" charset="-122"/>
-                          <a:cs typeface="Calibri" pitchFamily="34" charset="-120"/>
-                        </a:rPr>
-                        <a:t>S1</a:t>
-                      </a:r>
-                      <a:endParaRPr lang="en-US" sz="950" dirty="0">
-                        <a:latin typeface="Calibri" charset="0"/>
-                        <a:ea typeface="Calibri" charset="0"/>
-                        <a:cs typeface="Calibri" charset="0"/>
-                      </a:endParaRPr>
-                    </a:p>
-                  </a:txBody>
-                  <a:tcPr marL="64008" marR="64008" marT="0" marB="0" anchor="ctr">
-                    <a:lnL w="6350" cap="flat" cmpd="sng" algn="ctr">
-                      <a:solidFill>
-                        <a:srgbClr val="D5DBE3"/>
-                      </a:solidFill>
-                      <a:prstDash val="solid"/>
-                      <a:round/>
-                      <a:headEnd type="none" w="med" len="med"/>
-                      <a:tailEnd type="none" w="med" len="med"/>
-                    </a:lnL>
-                    <a:lnR w="6350" cap="flat" cmpd="sng" algn="ctr">
-                      <a:solidFill>
-                        <a:srgbClr val="D5DBE3"/>
-                      </a:solidFill>
-                      <a:prstDash val="solid"/>
-                      <a:round/>
-                      <a:headEnd type="none" w="med" len="med"/>
-                      <a:tailEnd type="none" w="med" len="med"/>
-                    </a:lnR>
-                    <a:lnT w="6350" cap="flat" cmpd="sng" algn="ctr">
-                      <a:solidFill>
-                        <a:srgbClr val="D5DBE3"/>
-                      </a:solidFill>
-                      <a:prstDash val="solid"/>
-                      <a:round/>
-                      <a:headEnd type="none" w="med" len="med"/>
-                      <a:tailEnd type="none" w="med" len="med"/>
-                    </a:lnT>
-                    <a:lnB w="6350" cap="flat" cmpd="sng" algn="ctr">
-                      <a:solidFill>
-                        <a:srgbClr val="D5DBE3"/>
-                      </a:solidFill>
-                      <a:prstDash val="solid"/>
-                      <a:round/>
-                      <a:headEnd type="none" w="med" len="med"/>
-                      <a:tailEnd type="none" w="med" len="med"/>
-                    </a:lnB>
-                  </a:tcPr>
-                </a:tc>
-              </a:tr>
-              <a:tr h="237744">
-                <a:tc>
-                  <a:txBody>
-                    <a:bodyPr/>
-                    <a:lstStyle/>
-                    <a:p>
-                      <a:pPr algn="l" indent="0" marL="0">
-                        <a:buNone/>
-                      </a:pPr>
-                      <a:r>
-                        <a:rPr lang="en-US" sz="950" b="1" dirty="0">
-                          <a:solidFill>
-                            <a:srgbClr val="1F2933"/>
-                          </a:solidFill>
-                          <a:latin typeface="Calibri" pitchFamily="34" charset="0"/>
-                          <a:ea typeface="Calibri" pitchFamily="34" charset="-122"/>
-                          <a:cs typeface="Calibri" pitchFamily="34" charset="-120"/>
-                        </a:rPr>
-                        <a:t>RHD CI</a:t>
-                      </a:r>
-                      <a:endParaRPr lang="en-US" sz="950" dirty="0">
-                        <a:latin typeface="Calibri" charset="0"/>
-                        <a:ea typeface="Calibri" charset="0"/>
-                        <a:cs typeface="Calibri" charset="0"/>
-                      </a:endParaRPr>
-                    </a:p>
-                  </a:txBody>
-                  <a:tcPr marL="64008" marR="64008" marT="0" marB="0" anchor="ctr">
-                    <a:lnL w="6350" cap="flat" cmpd="sng" algn="ctr">
-                      <a:solidFill>
-                        <a:srgbClr val="D5DBE3"/>
-                      </a:solidFill>
-                      <a:prstDash val="solid"/>
-                      <a:round/>
-                      <a:headEnd type="none" w="med" len="med"/>
-                      <a:tailEnd type="none" w="med" len="med"/>
-                    </a:lnL>
-                    <a:lnR w="6350" cap="flat" cmpd="sng" algn="ctr">
-                      <a:solidFill>
-                        <a:srgbClr val="D5DBE3"/>
-                      </a:solidFill>
-                      <a:prstDash val="solid"/>
-                      <a:round/>
-                      <a:headEnd type="none" w="med" len="med"/>
-                      <a:tailEnd type="none" w="med" len="med"/>
-                    </a:lnR>
-                    <a:lnT w="6350" cap="flat" cmpd="sng" algn="ctr">
-                      <a:solidFill>
-                        <a:srgbClr val="D5DBE3"/>
-                      </a:solidFill>
-                      <a:prstDash val="solid"/>
-                      <a:round/>
-                      <a:headEnd type="none" w="med" len="med"/>
-                      <a:tailEnd type="none" w="med" len="med"/>
-                    </a:lnT>
-                    <a:lnB w="6350" cap="flat" cmpd="sng" algn="ctr">
-                      <a:solidFill>
-                        <a:srgbClr val="D5DBE3"/>
-                      </a:solidFill>
-                      <a:prstDash val="solid"/>
-                      <a:round/>
-                      <a:headEnd type="none" w="med" len="med"/>
-                      <a:tailEnd type="none" w="med" len="med"/>
-                    </a:lnB>
-                  </a:tcPr>
-                </a:tc>
-                <a:tc>
-                  <a:txBody>
-                    <a:bodyPr/>
-                    <a:lstStyle/>
-                    <a:p>
-                      <a:pPr algn="r" indent="0" marL="0">
-                        <a:buNone/>
-                      </a:pPr>
-                      <a:r>
-                        <a:rPr lang="en-US" sz="950" b="1" dirty="0">
-                          <a:solidFill>
-                            <a:srgbClr val="B3261E"/>
-                          </a:solidFill>
-                          <a:latin typeface="Calibri" pitchFamily="34" charset="0"/>
-                          <a:ea typeface="Calibri" pitchFamily="34" charset="-122"/>
-                          <a:cs typeface="Calibri" pitchFamily="34" charset="-120"/>
-                        </a:rPr>
-                        <a:t>50,0</a:t>
-                      </a:r>
-                      <a:endParaRPr lang="en-US" sz="950" dirty="0">
-                        <a:latin typeface="Calibri" charset="0"/>
-                        <a:ea typeface="Calibri" charset="0"/>
-                        <a:cs typeface="Calibri" charset="0"/>
-                      </a:endParaRPr>
-                    </a:p>
-                  </a:txBody>
-                  <a:tcPr marL="64008" marR="64008" marT="0" marB="0" anchor="ctr">
-                    <a:lnL w="6350" cap="flat" cmpd="sng" algn="ctr">
-                      <a:solidFill>
-                        <a:srgbClr val="D5DBE3"/>
-                      </a:solidFill>
-                      <a:prstDash val="solid"/>
-                      <a:round/>
-                      <a:headEnd type="none" w="med" len="med"/>
-                      <a:tailEnd type="none" w="med" len="med"/>
-                    </a:lnL>
-                    <a:lnR w="6350" cap="flat" cmpd="sng" algn="ctr">
-                      <a:solidFill>
-                        <a:srgbClr val="D5DBE3"/>
-                      </a:solidFill>
-                      <a:prstDash val="solid"/>
-                      <a:round/>
-                      <a:headEnd type="none" w="med" len="med"/>
-                      <a:tailEnd type="none" w="med" len="med"/>
-                    </a:lnR>
-                    <a:lnT w="6350" cap="flat" cmpd="sng" algn="ctr">
-                      <a:solidFill>
-                        <a:srgbClr val="D5DBE3"/>
-                      </a:solidFill>
-                      <a:prstDash val="solid"/>
-                      <a:round/>
-                      <a:headEnd type="none" w="med" len="med"/>
-                      <a:tailEnd type="none" w="med" len="med"/>
-                    </a:lnT>
-                    <a:lnB w="6350" cap="flat" cmpd="sng" algn="ctr">
-                      <a:solidFill>
-                        <a:srgbClr val="D5DBE3"/>
-                      </a:solidFill>
-                      <a:prstDash val="solid"/>
-                      <a:round/>
-                      <a:headEnd type="none" w="med" len="med"/>
-                      <a:tailEnd type="none" w="med" len="med"/>
-                    </a:lnB>
-                    <a:solidFill>
-                      <a:srgbClr val="F7E7E5"/>
-                    </a:solidFill>
-                  </a:tcPr>
-                </a:tc>
-                <a:tc>
-                  <a:txBody>
-                    <a:bodyPr/>
-                    <a:lstStyle/>
-                    <a:p>
-                      <a:pPr algn="l" indent="0" marL="0">
-                        <a:buNone/>
-                      </a:pPr>
-                      <a:r>
-                        <a:rPr lang="en-US" sz="950" dirty="0">
-                          <a:solidFill>
-                            <a:srgbClr val="1F2933"/>
-                          </a:solidFill>
-                          <a:latin typeface="Calibri" pitchFamily="34" charset="0"/>
-                          <a:ea typeface="Calibri" pitchFamily="34" charset="-122"/>
-                          <a:cs typeface="Calibri" pitchFamily="34" charset="-120"/>
-                        </a:rPr>
-                        <a:t>Spot (A) ou avance (B)</a:t>
-                      </a:r>
-                      <a:endParaRPr lang="en-US" sz="950" dirty="0">
-                        <a:latin typeface="Calibri" charset="0"/>
-                        <a:ea typeface="Calibri" charset="0"/>
-                        <a:cs typeface="Calibri" charset="0"/>
-                      </a:endParaRPr>
-                    </a:p>
-                  </a:txBody>
-                  <a:tcPr marL="64008" marR="64008" marT="0" marB="0" anchor="ctr">
-                    <a:lnL w="6350" cap="flat" cmpd="sng" algn="ctr">
-                      <a:solidFill>
-                        <a:srgbClr val="D5DBE3"/>
-                      </a:solidFill>
-                      <a:prstDash val="solid"/>
-                      <a:round/>
-                      <a:headEnd type="none" w="med" len="med"/>
-                      <a:tailEnd type="none" w="med" len="med"/>
-                    </a:lnL>
-                    <a:lnR w="6350" cap="flat" cmpd="sng" algn="ctr">
-                      <a:solidFill>
-                        <a:srgbClr val="D5DBE3"/>
-                      </a:solidFill>
-                      <a:prstDash val="solid"/>
-                      <a:round/>
-                      <a:headEnd type="none" w="med" len="med"/>
-                      <a:tailEnd type="none" w="med" len="med"/>
-                    </a:lnR>
-                    <a:lnT w="6350" cap="flat" cmpd="sng" algn="ctr">
-                      <a:solidFill>
-                        <a:srgbClr val="D5DBE3"/>
-                      </a:solidFill>
-                      <a:prstDash val="solid"/>
-                      <a:round/>
-                      <a:headEnd type="none" w="med" len="med"/>
-                      <a:tailEnd type="none" w="med" len="med"/>
-                    </a:lnT>
-                    <a:lnB w="6350" cap="flat" cmpd="sng" algn="ctr">
-                      <a:solidFill>
-                        <a:srgbClr val="D5DBE3"/>
-                      </a:solidFill>
-                      <a:prstDash val="solid"/>
-                      <a:round/>
-                      <a:headEnd type="none" w="med" len="med"/>
-                      <a:tailEnd type="none" w="med" len="med"/>
-                    </a:lnB>
-                  </a:tcPr>
-                </a:tc>
-                <a:tc>
-                  <a:txBody>
-                    <a:bodyPr/>
-                    <a:lstStyle/>
-                    <a:p>
-                      <a:pPr algn="ctr" indent="0" marL="0">
-                        <a:buNone/>
-                      </a:pPr>
-                      <a:r>
-                        <a:rPr lang="en-US" sz="950" dirty="0">
-                          <a:solidFill>
-                            <a:srgbClr val="1F2933"/>
-                          </a:solidFill>
-                          <a:latin typeface="Calibri" pitchFamily="34" charset="0"/>
-                          <a:ea typeface="Calibri" pitchFamily="34" charset="-122"/>
-                          <a:cs typeface="Calibri" pitchFamily="34" charset="-120"/>
-                        </a:rPr>
-                        <a:t>S1</a:t>
-                      </a:r>
-                      <a:endParaRPr lang="en-US" sz="950" dirty="0">
-                        <a:latin typeface="Calibri" charset="0"/>
-                        <a:ea typeface="Calibri" charset="0"/>
-                        <a:cs typeface="Calibri" charset="0"/>
-                      </a:endParaRPr>
-                    </a:p>
-                  </a:txBody>
-                  <a:tcPr marL="64008" marR="64008" marT="0" marB="0" anchor="ctr">
-                    <a:lnL w="6350" cap="flat" cmpd="sng" algn="ctr">
-                      <a:solidFill>
-                        <a:srgbClr val="D5DBE3"/>
-                      </a:solidFill>
-                      <a:prstDash val="solid"/>
-                      <a:round/>
-                      <a:headEnd type="none" w="med" len="med"/>
-                      <a:tailEnd type="none" w="med" len="med"/>
-                    </a:lnL>
-                    <a:lnR w="6350" cap="flat" cmpd="sng" algn="ctr">
-                      <a:solidFill>
-                        <a:srgbClr val="D5DBE3"/>
-                      </a:solidFill>
-                      <a:prstDash val="solid"/>
-                      <a:round/>
-                      <a:headEnd type="none" w="med" len="med"/>
-                      <a:tailEnd type="none" w="med" len="med"/>
-                    </a:lnR>
-                    <a:lnT w="6350" cap="flat" cmpd="sng" algn="ctr">
-                      <a:solidFill>
-                        <a:srgbClr val="D5DBE3"/>
-                      </a:solidFill>
-                      <a:prstDash val="solid"/>
-                      <a:round/>
-                      <a:headEnd type="none" w="med" len="med"/>
-                      <a:tailEnd type="none" w="med" len="med"/>
-                    </a:lnT>
-                    <a:lnB w="6350" cap="flat" cmpd="sng" algn="ctr">
-                      <a:solidFill>
-                        <a:srgbClr val="D5DBE3"/>
-                      </a:solidFill>
-                      <a:prstDash val="solid"/>
-                      <a:round/>
-                      <a:headEnd type="none" w="med" len="med"/>
-                      <a:tailEnd type="none" w="med" len="med"/>
-                    </a:lnB>
-                  </a:tcPr>
-                </a:tc>
-              </a:tr>
-              <a:tr h="237744">
-                <a:tc>
-                  <a:txBody>
-                    <a:bodyPr/>
-                    <a:lstStyle/>
-                    <a:p>
-                      <a:pPr algn="l" indent="0" marL="0">
-                        <a:buNone/>
-                      </a:pPr>
-                      <a:r>
-                        <a:rPr lang="en-US" sz="950" b="1" dirty="0">
-                          <a:solidFill>
-                            <a:srgbClr val="1F2933"/>
-                          </a:solidFill>
-                          <a:latin typeface="Calibri" pitchFamily="34" charset="0"/>
-                          <a:ea typeface="Calibri" pitchFamily="34" charset="-122"/>
-                          <a:cs typeface="Calibri" pitchFamily="34" charset="-120"/>
-                        </a:rPr>
-                        <a:t>SCO AO</a:t>
-                      </a:r>
-                      <a:endParaRPr lang="en-US" sz="950" dirty="0">
-                        <a:latin typeface="Calibri" charset="0"/>
-                        <a:ea typeface="Calibri" charset="0"/>
-                        <a:cs typeface="Calibri" charset="0"/>
-                      </a:endParaRPr>
-                    </a:p>
-                  </a:txBody>
-                  <a:tcPr marL="64008" marR="64008" marT="0" marB="0" anchor="ctr">
-                    <a:lnL w="6350" cap="flat" cmpd="sng" algn="ctr">
-                      <a:solidFill>
-                        <a:srgbClr val="D5DBE3"/>
-                      </a:solidFill>
-                      <a:prstDash val="solid"/>
-                      <a:round/>
-                      <a:headEnd type="none" w="med" len="med"/>
-                      <a:tailEnd type="none" w="med" len="med"/>
-                    </a:lnL>
-                    <a:lnR w="6350" cap="flat" cmpd="sng" algn="ctr">
-                      <a:solidFill>
-                        <a:srgbClr val="D5DBE3"/>
-                      </a:solidFill>
-                      <a:prstDash val="solid"/>
-                      <a:round/>
-                      <a:headEnd type="none" w="med" len="med"/>
-                      <a:tailEnd type="none" w="med" len="med"/>
-                    </a:lnR>
-                    <a:lnT w="6350" cap="flat" cmpd="sng" algn="ctr">
-                      <a:solidFill>
-                        <a:srgbClr val="D5DBE3"/>
-                      </a:solidFill>
-                      <a:prstDash val="solid"/>
-                      <a:round/>
-                      <a:headEnd type="none" w="med" len="med"/>
-                      <a:tailEnd type="none" w="med" len="med"/>
-                    </a:lnT>
-                    <a:lnB w="6350" cap="flat" cmpd="sng" algn="ctr">
-                      <a:solidFill>
-                        <a:srgbClr val="D5DBE3"/>
-                      </a:solidFill>
-                      <a:prstDash val="solid"/>
-                      <a:round/>
-                      <a:headEnd type="none" w="med" len="med"/>
-                      <a:tailEnd type="none" w="med" len="med"/>
-                    </a:lnB>
-                  </a:tcPr>
-                </a:tc>
-                <a:tc>
-                  <a:txBody>
-                    <a:bodyPr/>
-                    <a:lstStyle/>
-                    <a:p>
-                      <a:pPr algn="r" indent="0" marL="0">
-                        <a:buNone/>
-                      </a:pPr>
-                      <a:r>
-                        <a:rPr lang="en-US" sz="950" b="1" dirty="0">
-                          <a:solidFill>
-                            <a:srgbClr val="B3261E"/>
-                          </a:solidFill>
-                          <a:latin typeface="Calibri" pitchFamily="34" charset="0"/>
-                          <a:ea typeface="Calibri" pitchFamily="34" charset="-122"/>
-                          <a:cs typeface="Calibri" pitchFamily="34" charset="-120"/>
-                        </a:rPr>
-                        <a:t>29,5</a:t>
-                      </a:r>
-                      <a:endParaRPr lang="en-US" sz="950" dirty="0">
-                        <a:latin typeface="Calibri" charset="0"/>
-                        <a:ea typeface="Calibri" charset="0"/>
-                        <a:cs typeface="Calibri" charset="0"/>
-                      </a:endParaRPr>
-                    </a:p>
-                  </a:txBody>
-                  <a:tcPr marL="64008" marR="64008" marT="0" marB="0" anchor="ctr">
-                    <a:lnL w="6350" cap="flat" cmpd="sng" algn="ctr">
-                      <a:solidFill>
-                        <a:srgbClr val="D5DBE3"/>
-                      </a:solidFill>
-                      <a:prstDash val="solid"/>
-                      <a:round/>
-                      <a:headEnd type="none" w="med" len="med"/>
-                      <a:tailEnd type="none" w="med" len="med"/>
-                    </a:lnL>
-                    <a:lnR w="6350" cap="flat" cmpd="sng" algn="ctr">
-                      <a:solidFill>
-                        <a:srgbClr val="D5DBE3"/>
-                      </a:solidFill>
-                      <a:prstDash val="solid"/>
-                      <a:round/>
-                      <a:headEnd type="none" w="med" len="med"/>
-                      <a:tailEnd type="none" w="med" len="med"/>
-                    </a:lnR>
-                    <a:lnT w="6350" cap="flat" cmpd="sng" algn="ctr">
-                      <a:solidFill>
-                        <a:srgbClr val="D5DBE3"/>
-                      </a:solidFill>
-                      <a:prstDash val="solid"/>
-                      <a:round/>
-                      <a:headEnd type="none" w="med" len="med"/>
-                      <a:tailEnd type="none" w="med" len="med"/>
-                    </a:lnT>
-                    <a:lnB w="6350" cap="flat" cmpd="sng" algn="ctr">
-                      <a:solidFill>
-                        <a:srgbClr val="D5DBE3"/>
-                      </a:solidFill>
-                      <a:prstDash val="solid"/>
-                      <a:round/>
-                      <a:headEnd type="none" w="med" len="med"/>
-                      <a:tailEnd type="none" w="med" len="med"/>
-                    </a:lnB>
-                    <a:solidFill>
-                      <a:srgbClr val="F7E7E5"/>
-                    </a:solidFill>
-                  </a:tcPr>
-                </a:tc>
-                <a:tc>
-                  <a:txBody>
-                    <a:bodyPr/>
-                    <a:lstStyle/>
-                    <a:p>
-                      <a:pPr algn="l" indent="0" marL="0">
-                        <a:buNone/>
-                      </a:pPr>
-                      <a:r>
-                        <a:rPr lang="en-US" sz="950" dirty="0">
-                          <a:solidFill>
-                            <a:srgbClr val="1F2933"/>
-                          </a:solidFill>
-                          <a:latin typeface="Calibri" pitchFamily="34" charset="0"/>
-                          <a:ea typeface="Calibri" pitchFamily="34" charset="-122"/>
-                          <a:cs typeface="Calibri" pitchFamily="34" charset="-120"/>
-                        </a:rPr>
-                        <a:t>Spot (A) ou avance (B)</a:t>
-                      </a:r>
-                      <a:endParaRPr lang="en-US" sz="950" dirty="0">
-                        <a:latin typeface="Calibri" charset="0"/>
-                        <a:ea typeface="Calibri" charset="0"/>
-                        <a:cs typeface="Calibri" charset="0"/>
-                      </a:endParaRPr>
-                    </a:p>
-                  </a:txBody>
-                  <a:tcPr marL="64008" marR="64008" marT="0" marB="0" anchor="ctr">
-                    <a:lnL w="6350" cap="flat" cmpd="sng" algn="ctr">
-                      <a:solidFill>
-                        <a:srgbClr val="D5DBE3"/>
-                      </a:solidFill>
-                      <a:prstDash val="solid"/>
-                      <a:round/>
-                      <a:headEnd type="none" w="med" len="med"/>
-                      <a:tailEnd type="none" w="med" len="med"/>
-                    </a:lnL>
-                    <a:lnR w="6350" cap="flat" cmpd="sng" algn="ctr">
-                      <a:solidFill>
-                        <a:srgbClr val="D5DBE3"/>
-                      </a:solidFill>
-                      <a:prstDash val="solid"/>
-                      <a:round/>
-                      <a:headEnd type="none" w="med" len="med"/>
-                      <a:tailEnd type="none" w="med" len="med"/>
-                    </a:lnR>
-                    <a:lnT w="6350" cap="flat" cmpd="sng" algn="ctr">
-                      <a:solidFill>
-                        <a:srgbClr val="D5DBE3"/>
-                      </a:solidFill>
-                      <a:prstDash val="solid"/>
-                      <a:round/>
-                      <a:headEnd type="none" w="med" len="med"/>
-                      <a:tailEnd type="none" w="med" len="med"/>
-                    </a:lnT>
-                    <a:lnB w="6350" cap="flat" cmpd="sng" algn="ctr">
-                      <a:solidFill>
-                        <a:srgbClr val="D5DBE3"/>
-                      </a:solidFill>
-                      <a:prstDash val="solid"/>
-                      <a:round/>
-                      <a:headEnd type="none" w="med" len="med"/>
-                      <a:tailEnd type="none" w="med" len="med"/>
-                    </a:lnB>
-                  </a:tcPr>
-                </a:tc>
-                <a:tc>
-                  <a:txBody>
-                    <a:bodyPr/>
-                    <a:lstStyle/>
-                    <a:p>
-                      <a:pPr algn="ctr" indent="0" marL="0">
-                        <a:buNone/>
-                      </a:pPr>
-                      <a:r>
-                        <a:rPr lang="en-US" sz="950" dirty="0">
-                          <a:solidFill>
-                            <a:srgbClr val="1F2933"/>
-                          </a:solidFill>
-                          <a:latin typeface="Calibri" pitchFamily="34" charset="0"/>
-                          <a:ea typeface="Calibri" pitchFamily="34" charset="-122"/>
-                          <a:cs typeface="Calibri" pitchFamily="34" charset="-120"/>
-                        </a:rPr>
-                        <a:t>S5</a:t>
-                      </a:r>
-                      <a:endParaRPr lang="en-US" sz="950" dirty="0">
-                        <a:latin typeface="Calibri" charset="0"/>
-                        <a:ea typeface="Calibri" charset="0"/>
-                        <a:cs typeface="Calibri" charset="0"/>
-                      </a:endParaRPr>
-                    </a:p>
-                  </a:txBody>
-                  <a:tcPr marL="64008" marR="64008" marT="0" marB="0" anchor="ctr">
-                    <a:lnL w="6350" cap="flat" cmpd="sng" algn="ctr">
-                      <a:solidFill>
-                        <a:srgbClr val="D5DBE3"/>
-                      </a:solidFill>
-                      <a:prstDash val="solid"/>
-                      <a:round/>
-                      <a:headEnd type="none" w="med" len="med"/>
-                      <a:tailEnd type="none" w="med" len="med"/>
-                    </a:lnL>
-                    <a:lnR w="6350" cap="flat" cmpd="sng" algn="ctr">
-                      <a:solidFill>
-                        <a:srgbClr val="D5DBE3"/>
-                      </a:solidFill>
-                      <a:prstDash val="solid"/>
-                      <a:round/>
-                      <a:headEnd type="none" w="med" len="med"/>
-                      <a:tailEnd type="none" w="med" len="med"/>
-                    </a:lnR>
-                    <a:lnT w="6350" cap="flat" cmpd="sng" algn="ctr">
-                      <a:solidFill>
-                        <a:srgbClr val="D5DBE3"/>
-                      </a:solidFill>
-                      <a:prstDash val="solid"/>
-                      <a:round/>
-                      <a:headEnd type="none" w="med" len="med"/>
-                      <a:tailEnd type="none" w="med" len="med"/>
-                    </a:lnT>
-                    <a:lnB w="6350" cap="flat" cmpd="sng" algn="ctr">
-                      <a:solidFill>
-                        <a:srgbClr val="D5DBE3"/>
-                      </a:solidFill>
-                      <a:prstDash val="solid"/>
-                      <a:round/>
-                      <a:headEnd type="none" w="med" len="med"/>
-                      <a:tailEnd type="none" w="med" len="med"/>
-                    </a:lnB>
-                  </a:tcPr>
-                </a:tc>
-              </a:tr>
-              <a:tr h="237744">
-                <a:tc>
-                  <a:txBody>
-                    <a:bodyPr/>
-                    <a:lstStyle/>
-                    <a:p>
-                      <a:pPr algn="l" indent="0" marL="0">
-                        <a:buNone/>
-                      </a:pPr>
-                      <a:r>
-                        <a:rPr lang="en-US" sz="950" b="1" dirty="0">
-                          <a:solidFill>
-                            <a:srgbClr val="1F2933"/>
-                          </a:solidFill>
-                          <a:latin typeface="Calibri" pitchFamily="34" charset="0"/>
-                          <a:ea typeface="Calibri" pitchFamily="34" charset="-122"/>
-                          <a:cs typeface="Calibri" pitchFamily="34" charset="-120"/>
-                        </a:rPr>
-                        <a:t>AB CENTER</a:t>
-                      </a:r>
-                      <a:endParaRPr lang="en-US" sz="950" dirty="0">
-                        <a:latin typeface="Calibri" charset="0"/>
-                        <a:ea typeface="Calibri" charset="0"/>
-                        <a:cs typeface="Calibri" charset="0"/>
-                      </a:endParaRPr>
-                    </a:p>
-                  </a:txBody>
-                  <a:tcPr marL="64008" marR="64008" marT="0" marB="0" anchor="ctr">
-                    <a:lnL w="6350" cap="flat" cmpd="sng" algn="ctr">
-                      <a:solidFill>
-                        <a:srgbClr val="D5DBE3"/>
-                      </a:solidFill>
-                      <a:prstDash val="solid"/>
-                      <a:round/>
-                      <a:headEnd type="none" w="med" len="med"/>
-                      <a:tailEnd type="none" w="med" len="med"/>
-                    </a:lnL>
-                    <a:lnR w="6350" cap="flat" cmpd="sng" algn="ctr">
-                      <a:solidFill>
-                        <a:srgbClr val="D5DBE3"/>
-                      </a:solidFill>
-                      <a:prstDash val="solid"/>
-                      <a:round/>
-                      <a:headEnd type="none" w="med" len="med"/>
-                      <a:tailEnd type="none" w="med" len="med"/>
-                    </a:lnR>
-                    <a:lnT w="6350" cap="flat" cmpd="sng" algn="ctr">
-                      <a:solidFill>
-                        <a:srgbClr val="D5DBE3"/>
-                      </a:solidFill>
-                      <a:prstDash val="solid"/>
-                      <a:round/>
-                      <a:headEnd type="none" w="med" len="med"/>
-                      <a:tailEnd type="none" w="med" len="med"/>
-                    </a:lnT>
-                    <a:lnB w="6350" cap="flat" cmpd="sng" algn="ctr">
-                      <a:solidFill>
-                        <a:srgbClr val="D5DBE3"/>
-                      </a:solidFill>
-                      <a:prstDash val="solid"/>
-                      <a:round/>
-                      <a:headEnd type="none" w="med" len="med"/>
-                      <a:tailEnd type="none" w="med" len="med"/>
-                    </a:lnB>
-                  </a:tcPr>
-                </a:tc>
-                <a:tc>
-                  <a:txBody>
-                    <a:bodyPr/>
-                    <a:lstStyle/>
-                    <a:p>
-                      <a:pPr algn="r" indent="0" marL="0">
-                        <a:buNone/>
-                      </a:pPr>
-                      <a:r>
-                        <a:rPr lang="en-US" sz="950" b="1" dirty="0">
-                          <a:solidFill>
-                            <a:srgbClr val="B3261E"/>
-                          </a:solidFill>
-                          <a:latin typeface="Calibri" pitchFamily="34" charset="0"/>
-                          <a:ea typeface="Calibri" pitchFamily="34" charset="-122"/>
-                          <a:cs typeface="Calibri" pitchFamily="34" charset="-120"/>
-                        </a:rPr>
-                        <a:t>6,3</a:t>
-                      </a:r>
-                      <a:endParaRPr lang="en-US" sz="950" dirty="0">
-                        <a:latin typeface="Calibri" charset="0"/>
-                        <a:ea typeface="Calibri" charset="0"/>
-                        <a:cs typeface="Calibri" charset="0"/>
-                      </a:endParaRPr>
-                    </a:p>
-                  </a:txBody>
-                  <a:tcPr marL="64008" marR="64008" marT="0" marB="0" anchor="ctr">
-                    <a:lnL w="6350" cap="flat" cmpd="sng" algn="ctr">
-                      <a:solidFill>
-                        <a:srgbClr val="D5DBE3"/>
-                      </a:solidFill>
-                      <a:prstDash val="solid"/>
-                      <a:round/>
-                      <a:headEnd type="none" w="med" len="med"/>
-                      <a:tailEnd type="none" w="med" len="med"/>
-                    </a:lnL>
-                    <a:lnR w="6350" cap="flat" cmpd="sng" algn="ctr">
-                      <a:solidFill>
-                        <a:srgbClr val="D5DBE3"/>
-                      </a:solidFill>
-                      <a:prstDash val="solid"/>
-                      <a:round/>
-                      <a:headEnd type="none" w="med" len="med"/>
-                      <a:tailEnd type="none" w="med" len="med"/>
-                    </a:lnR>
-                    <a:lnT w="6350" cap="flat" cmpd="sng" algn="ctr">
-                      <a:solidFill>
-                        <a:srgbClr val="D5DBE3"/>
-                      </a:solidFill>
-                      <a:prstDash val="solid"/>
-                      <a:round/>
-                      <a:headEnd type="none" w="med" len="med"/>
-                      <a:tailEnd type="none" w="med" len="med"/>
-                    </a:lnT>
-                    <a:lnB w="6350" cap="flat" cmpd="sng" algn="ctr">
-                      <a:solidFill>
-                        <a:srgbClr val="D5DBE3"/>
-                      </a:solidFill>
-                      <a:prstDash val="solid"/>
-                      <a:round/>
-                      <a:headEnd type="none" w="med" len="med"/>
-                      <a:tailEnd type="none" w="med" len="med"/>
-                    </a:lnB>
-                    <a:solidFill>
-                      <a:srgbClr val="F7E7E5"/>
-                    </a:solidFill>
-                  </a:tcPr>
-                </a:tc>
-                <a:tc>
-                  <a:txBody>
-                    <a:bodyPr/>
-                    <a:lstStyle/>
-                    <a:p>
-                      <a:pPr algn="l" indent="0" marL="0">
-                        <a:buNone/>
-                      </a:pPr>
-                      <a:r>
-                        <a:rPr lang="en-US" sz="950" dirty="0">
-                          <a:solidFill>
-                            <a:srgbClr val="1F2933"/>
-                          </a:solidFill>
-                          <a:latin typeface="Calibri" pitchFamily="34" charset="0"/>
-                          <a:ea typeface="Calibri" pitchFamily="34" charset="-122"/>
-                          <a:cs typeface="Calibri" pitchFamily="34" charset="-120"/>
-                        </a:rPr>
-                        <a:t>Spot (A) ou avance (B)</a:t>
-                      </a:r>
-                      <a:endParaRPr lang="en-US" sz="950" dirty="0">
-                        <a:latin typeface="Calibri" charset="0"/>
-                        <a:ea typeface="Calibri" charset="0"/>
-                        <a:cs typeface="Calibri" charset="0"/>
-                      </a:endParaRPr>
-                    </a:p>
-                  </a:txBody>
-                  <a:tcPr marL="64008" marR="64008" marT="0" marB="0" anchor="ctr">
-                    <a:lnL w="6350" cap="flat" cmpd="sng" algn="ctr">
-                      <a:solidFill>
-                        <a:srgbClr val="D5DBE3"/>
-                      </a:solidFill>
-                      <a:prstDash val="solid"/>
-                      <a:round/>
-                      <a:headEnd type="none" w="med" len="med"/>
-                      <a:tailEnd type="none" w="med" len="med"/>
-                    </a:lnL>
-                    <a:lnR w="6350" cap="flat" cmpd="sng" algn="ctr">
-                      <a:solidFill>
-                        <a:srgbClr val="D5DBE3"/>
-                      </a:solidFill>
-                      <a:prstDash val="solid"/>
-                      <a:round/>
-                      <a:headEnd type="none" w="med" len="med"/>
-                      <a:tailEnd type="none" w="med" len="med"/>
-                    </a:lnR>
-                    <a:lnT w="6350" cap="flat" cmpd="sng" algn="ctr">
-                      <a:solidFill>
-                        <a:srgbClr val="D5DBE3"/>
-                      </a:solidFill>
-                      <a:prstDash val="solid"/>
-                      <a:round/>
-                      <a:headEnd type="none" w="med" len="med"/>
-                      <a:tailEnd type="none" w="med" len="med"/>
-                    </a:lnT>
-                    <a:lnB w="6350" cap="flat" cmpd="sng" algn="ctr">
-                      <a:solidFill>
-                        <a:srgbClr val="D5DBE3"/>
-                      </a:solidFill>
-                      <a:prstDash val="solid"/>
-                      <a:round/>
-                      <a:headEnd type="none" w="med" len="med"/>
-                      <a:tailEnd type="none" w="med" len="med"/>
-                    </a:lnB>
-                  </a:tcPr>
-                </a:tc>
-                <a:tc>
-                  <a:txBody>
-                    <a:bodyPr/>
-                    <a:lstStyle/>
-                    <a:p>
-                      <a:pPr algn="ctr" indent="0" marL="0">
-                        <a:buNone/>
-                      </a:pPr>
-                      <a:r>
-                        <a:rPr lang="en-US" sz="950" dirty="0">
-                          <a:solidFill>
-                            <a:srgbClr val="1F2933"/>
-                          </a:solidFill>
-                          <a:latin typeface="Calibri" pitchFamily="34" charset="0"/>
-                          <a:ea typeface="Calibri" pitchFamily="34" charset="-122"/>
-                          <a:cs typeface="Calibri" pitchFamily="34" charset="-120"/>
-                        </a:rPr>
-                        <a:t>S1</a:t>
-                      </a:r>
-                      <a:endParaRPr lang="en-US" sz="950" dirty="0">
-                        <a:latin typeface="Calibri" charset="0"/>
-                        <a:ea typeface="Calibri" charset="0"/>
-                        <a:cs typeface="Calibri" charset="0"/>
-                      </a:endParaRPr>
-                    </a:p>
-                  </a:txBody>
-                  <a:tcPr marL="64008" marR="64008" marT="0" marB="0" anchor="ctr">
-                    <a:lnL w="6350" cap="flat" cmpd="sng" algn="ctr">
-                      <a:solidFill>
-                        <a:srgbClr val="D5DBE3"/>
-                      </a:solidFill>
-                      <a:prstDash val="solid"/>
-                      <a:round/>
-                      <a:headEnd type="none" w="med" len="med"/>
-                      <a:tailEnd type="none" w="med" len="med"/>
-                    </a:lnL>
-                    <a:lnR w="6350" cap="flat" cmpd="sng" algn="ctr">
-                      <a:solidFill>
-                        <a:srgbClr val="D5DBE3"/>
-                      </a:solidFill>
-                      <a:prstDash val="solid"/>
-                      <a:round/>
-                      <a:headEnd type="none" w="med" len="med"/>
-                      <a:tailEnd type="none" w="med" len="med"/>
-                    </a:lnR>
-                    <a:lnT w="6350" cap="flat" cmpd="sng" algn="ctr">
-                      <a:solidFill>
-                        <a:srgbClr val="D5DBE3"/>
-                      </a:solidFill>
-                      <a:prstDash val="solid"/>
-                      <a:round/>
-                      <a:headEnd type="none" w="med" len="med"/>
-                      <a:tailEnd type="none" w="med" len="med"/>
-                    </a:lnT>
-                    <a:lnB w="6350" cap="flat" cmpd="sng" algn="ctr">
-                      <a:solidFill>
-                        <a:srgbClr val="D5DBE3"/>
-                      </a:solidFill>
-                      <a:prstDash val="solid"/>
-                      <a:round/>
-                      <a:headEnd type="none" w="med" len="med"/>
-                      <a:tailEnd type="none" w="med" len="med"/>
-                    </a:lnB>
-                  </a:tcPr>
-                </a:tc>
-              </a:tr>
-              <a:tr h="237744">
-                <a:tc>
-                  <a:txBody>
-                    <a:bodyPr/>
-                    <a:lstStyle/>
-                    <a:p>
-                      <a:pPr algn="l" indent="0" marL="0">
-                        <a:buNone/>
-                      </a:pPr>
-                      <a:r>
-                        <a:rPr lang="en-US" sz="950" b="1" dirty="0">
-                          <a:solidFill>
-                            <a:srgbClr val="1F2933"/>
-                          </a:solidFill>
-                          <a:latin typeface="Calibri" pitchFamily="34" charset="0"/>
-                          <a:ea typeface="Calibri" pitchFamily="34" charset="-122"/>
-                          <a:cs typeface="Calibri" pitchFamily="34" charset="-120"/>
-                        </a:rPr>
-                        <a:t>ODALYS CI</a:t>
-                      </a:r>
-                      <a:endParaRPr lang="en-US" sz="950" dirty="0">
-                        <a:latin typeface="Calibri" charset="0"/>
-                        <a:ea typeface="Calibri" charset="0"/>
-                        <a:cs typeface="Calibri" charset="0"/>
-                      </a:endParaRPr>
-                    </a:p>
-                  </a:txBody>
-                  <a:tcPr marL="64008" marR="64008" marT="0" marB="0" anchor="ctr">
-                    <a:lnL w="6350" cap="flat" cmpd="sng" algn="ctr">
-                      <a:solidFill>
-                        <a:srgbClr val="D5DBE3"/>
-                      </a:solidFill>
-                      <a:prstDash val="solid"/>
-                      <a:round/>
-                      <a:headEnd type="none" w="med" len="med"/>
-                      <a:tailEnd type="none" w="med" len="med"/>
-                    </a:lnL>
-                    <a:lnR w="6350" cap="flat" cmpd="sng" algn="ctr">
-                      <a:solidFill>
-                        <a:srgbClr val="D5DBE3"/>
-                      </a:solidFill>
-                      <a:prstDash val="solid"/>
-                      <a:round/>
-                      <a:headEnd type="none" w="med" len="med"/>
-                      <a:tailEnd type="none" w="med" len="med"/>
-                    </a:lnR>
-                    <a:lnT w="6350" cap="flat" cmpd="sng" algn="ctr">
-                      <a:solidFill>
-                        <a:srgbClr val="D5DBE3"/>
-                      </a:solidFill>
-                      <a:prstDash val="solid"/>
-                      <a:round/>
-                      <a:headEnd type="none" w="med" len="med"/>
-                      <a:tailEnd type="none" w="med" len="med"/>
-                    </a:lnT>
-                    <a:lnB w="6350" cap="flat" cmpd="sng" algn="ctr">
-                      <a:solidFill>
-                        <a:srgbClr val="D5DBE3"/>
-                      </a:solidFill>
-                      <a:prstDash val="solid"/>
-                      <a:round/>
-                      <a:headEnd type="none" w="med" len="med"/>
-                      <a:tailEnd type="none" w="med" len="med"/>
-                    </a:lnB>
-                  </a:tcPr>
-                </a:tc>
-                <a:tc>
-                  <a:txBody>
-                    <a:bodyPr/>
-                    <a:lstStyle/>
-                    <a:p>
-                      <a:pPr algn="r" indent="0" marL="0">
-                        <a:buNone/>
-                      </a:pPr>
-                      <a:r>
-                        <a:rPr lang="en-US" sz="950" b="1" dirty="0">
-                          <a:solidFill>
-                            <a:srgbClr val="B3261E"/>
-                          </a:solidFill>
-                          <a:latin typeface="Calibri" pitchFamily="34" charset="0"/>
-                          <a:ea typeface="Calibri" pitchFamily="34" charset="-122"/>
-                          <a:cs typeface="Calibri" pitchFamily="34" charset="-120"/>
-                        </a:rPr>
-                        <a:t>3,5</a:t>
-                      </a:r>
-                      <a:endParaRPr lang="en-US" sz="950" dirty="0">
-                        <a:latin typeface="Calibri" charset="0"/>
-                        <a:ea typeface="Calibri" charset="0"/>
-                        <a:cs typeface="Calibri" charset="0"/>
-                      </a:endParaRPr>
-                    </a:p>
-                  </a:txBody>
-                  <a:tcPr marL="64008" marR="64008" marT="0" marB="0" anchor="ctr">
-                    <a:lnL w="6350" cap="flat" cmpd="sng" algn="ctr">
-                      <a:solidFill>
-                        <a:srgbClr val="D5DBE3"/>
-                      </a:solidFill>
-                      <a:prstDash val="solid"/>
-                      <a:round/>
-                      <a:headEnd type="none" w="med" len="med"/>
-                      <a:tailEnd type="none" w="med" len="med"/>
-                    </a:lnL>
-                    <a:lnR w="6350" cap="flat" cmpd="sng" algn="ctr">
-                      <a:solidFill>
-                        <a:srgbClr val="D5DBE3"/>
-                      </a:solidFill>
-                      <a:prstDash val="solid"/>
-                      <a:round/>
-                      <a:headEnd type="none" w="med" len="med"/>
-                      <a:tailEnd type="none" w="med" len="med"/>
-                    </a:lnR>
-                    <a:lnT w="6350" cap="flat" cmpd="sng" algn="ctr">
-                      <a:solidFill>
-                        <a:srgbClr val="D5DBE3"/>
-                      </a:solidFill>
-                      <a:prstDash val="solid"/>
-                      <a:round/>
-                      <a:headEnd type="none" w="med" len="med"/>
-                      <a:tailEnd type="none" w="med" len="med"/>
-                    </a:lnT>
-                    <a:lnB w="6350" cap="flat" cmpd="sng" algn="ctr">
-                      <a:solidFill>
-                        <a:srgbClr val="D5DBE3"/>
-                      </a:solidFill>
-                      <a:prstDash val="solid"/>
-                      <a:round/>
-                      <a:headEnd type="none" w="med" len="med"/>
-                      <a:tailEnd type="none" w="med" len="med"/>
-                    </a:lnB>
-                    <a:solidFill>
-                      <a:srgbClr val="F7E7E5"/>
-                    </a:solidFill>
-                  </a:tcPr>
-                </a:tc>
-                <a:tc>
-                  <a:txBody>
-                    <a:bodyPr/>
-                    <a:lstStyle/>
-                    <a:p>
-                      <a:pPr algn="l" indent="0" marL="0">
-                        <a:buNone/>
-                      </a:pPr>
-                      <a:r>
-                        <a:rPr lang="en-US" sz="950" dirty="0">
-                          <a:solidFill>
-                            <a:srgbClr val="1F2933"/>
-                          </a:solidFill>
-                          <a:latin typeface="Calibri" pitchFamily="34" charset="0"/>
-                          <a:ea typeface="Calibri" pitchFamily="34" charset="-122"/>
-                          <a:cs typeface="Calibri" pitchFamily="34" charset="-120"/>
-                        </a:rPr>
-                        <a:t>Spot (A) ou avance (B)</a:t>
-                      </a:r>
-                      <a:endParaRPr lang="en-US" sz="950" dirty="0">
-                        <a:latin typeface="Calibri" charset="0"/>
-                        <a:ea typeface="Calibri" charset="0"/>
-                        <a:cs typeface="Calibri" charset="0"/>
-                      </a:endParaRPr>
-                    </a:p>
-                  </a:txBody>
-                  <a:tcPr marL="64008" marR="64008" marT="0" marB="0" anchor="ctr">
-                    <a:lnL w="6350" cap="flat" cmpd="sng" algn="ctr">
-                      <a:solidFill>
-                        <a:srgbClr val="D5DBE3"/>
-                      </a:solidFill>
-                      <a:prstDash val="solid"/>
-                      <a:round/>
-                      <a:headEnd type="none" w="med" len="med"/>
-                      <a:tailEnd type="none" w="med" len="med"/>
-                    </a:lnL>
-                    <a:lnR w="6350" cap="flat" cmpd="sng" algn="ctr">
-                      <a:solidFill>
-                        <a:srgbClr val="D5DBE3"/>
-                      </a:solidFill>
-                      <a:prstDash val="solid"/>
-                      <a:round/>
-                      <a:headEnd type="none" w="med" len="med"/>
-                      <a:tailEnd type="none" w="med" len="med"/>
-                    </a:lnR>
-                    <a:lnT w="6350" cap="flat" cmpd="sng" algn="ctr">
-                      <a:solidFill>
-                        <a:srgbClr val="D5DBE3"/>
-                      </a:solidFill>
-                      <a:prstDash val="solid"/>
-                      <a:round/>
-                      <a:headEnd type="none" w="med" len="med"/>
-                      <a:tailEnd type="none" w="med" len="med"/>
-                    </a:lnT>
-                    <a:lnB w="6350" cap="flat" cmpd="sng" algn="ctr">
-                      <a:solidFill>
-                        <a:srgbClr val="D5DBE3"/>
-                      </a:solidFill>
-                      <a:prstDash val="solid"/>
-                      <a:round/>
-                      <a:headEnd type="none" w="med" len="med"/>
-                      <a:tailEnd type="none" w="med" len="med"/>
-                    </a:lnB>
-                  </a:tcPr>
-                </a:tc>
-                <a:tc>
-                  <a:txBody>
-                    <a:bodyPr/>
-                    <a:lstStyle/>
-                    <a:p>
-                      <a:pPr algn="ctr" indent="0" marL="0">
-                        <a:buNone/>
-                      </a:pPr>
-                      <a:r>
-                        <a:rPr lang="en-US" sz="950" dirty="0">
-                          <a:solidFill>
-                            <a:srgbClr val="1F2933"/>
-                          </a:solidFill>
-                          <a:latin typeface="Calibri" pitchFamily="34" charset="0"/>
-                          <a:ea typeface="Calibri" pitchFamily="34" charset="-122"/>
-                          <a:cs typeface="Calibri" pitchFamily="34" charset="-120"/>
-                        </a:rPr>
-                        <a:t>S1</a:t>
-                      </a:r>
-                      <a:endParaRPr lang="en-US" sz="950" dirty="0">
-                        <a:latin typeface="Calibri" charset="0"/>
-                        <a:ea typeface="Calibri" charset="0"/>
-                        <a:cs typeface="Calibri" charset="0"/>
-                      </a:endParaRPr>
-                    </a:p>
-                  </a:txBody>
-                  <a:tcPr marL="64008" marR="64008" marT="0" marB="0" anchor="ctr">
-                    <a:lnL w="6350" cap="flat" cmpd="sng" algn="ctr">
-                      <a:solidFill>
-                        <a:srgbClr val="D5DBE3"/>
-                      </a:solidFill>
-                      <a:prstDash val="solid"/>
-                      <a:round/>
-                      <a:headEnd type="none" w="med" len="med"/>
-                      <a:tailEnd type="none" w="med" len="med"/>
-                    </a:lnL>
-                    <a:lnR w="6350" cap="flat" cmpd="sng" algn="ctr">
-                      <a:solidFill>
-                        <a:srgbClr val="D5DBE3"/>
-                      </a:solidFill>
-                      <a:prstDash val="solid"/>
-                      <a:round/>
-                      <a:headEnd type="none" w="med" len="med"/>
-                      <a:tailEnd type="none" w="med" len="med"/>
-                    </a:lnR>
-                    <a:lnT w="6350" cap="flat" cmpd="sng" algn="ctr">
-                      <a:solidFill>
-                        <a:srgbClr val="D5DBE3"/>
-                      </a:solidFill>
-                      <a:prstDash val="solid"/>
-                      <a:round/>
-                      <a:headEnd type="none" w="med" len="med"/>
-                      <a:tailEnd type="none" w="med" len="med"/>
-                    </a:lnT>
-                    <a:lnB w="6350" cap="flat" cmpd="sng" algn="ctr">
-                      <a:solidFill>
-                        <a:srgbClr val="D5DBE3"/>
-                      </a:solidFill>
-                      <a:prstDash val="solid"/>
-                      <a:round/>
-                      <a:headEnd type="none" w="med" len="med"/>
-                      <a:tailEnd type="none" w="med" len="med"/>
-                    </a:lnB>
-                  </a:tcPr>
-                </a:tc>
-              </a:tr>
-              <a:tr h="237744">
-                <a:tc>
-                  <a:txBody>
-                    <a:bodyPr/>
-                    <a:lstStyle/>
-                    <a:p>
-                      <a:pPr algn="l" indent="0" marL="0">
-                        <a:buNone/>
-                      </a:pPr>
-                      <a:r>
-                        <a:rPr lang="en-US" sz="950" b="1" dirty="0">
-                          <a:solidFill>
-                            <a:srgbClr val="1F2933"/>
-                          </a:solidFill>
-                          <a:latin typeface="Calibri" pitchFamily="34" charset="0"/>
-                          <a:ea typeface="Calibri" pitchFamily="34" charset="-122"/>
-                          <a:cs typeface="Calibri" pitchFamily="34" charset="-120"/>
-                        </a:rPr>
-                        <a:t>RIVIERA – fonds projet</a:t>
-                      </a:r>
-                      <a:endParaRPr lang="en-US" sz="950" dirty="0">
-                        <a:latin typeface="Calibri" charset="0"/>
-                        <a:ea typeface="Calibri" charset="0"/>
-                        <a:cs typeface="Calibri" charset="0"/>
-                      </a:endParaRPr>
-                    </a:p>
-                  </a:txBody>
-                  <a:tcPr marL="64008" marR="64008" marT="0" marB="0" anchor="ctr">
-                    <a:lnL w="6350" cap="flat" cmpd="sng" algn="ctr">
-                      <a:solidFill>
-                        <a:srgbClr val="D5DBE3"/>
-                      </a:solidFill>
-                      <a:prstDash val="solid"/>
-                      <a:round/>
-                      <a:headEnd type="none" w="med" len="med"/>
-                      <a:tailEnd type="none" w="med" len="med"/>
-                    </a:lnL>
-                    <a:lnR w="6350" cap="flat" cmpd="sng" algn="ctr">
-                      <a:solidFill>
-                        <a:srgbClr val="D5DBE3"/>
-                      </a:solidFill>
-                      <a:prstDash val="solid"/>
-                      <a:round/>
-                      <a:headEnd type="none" w="med" len="med"/>
-                      <a:tailEnd type="none" w="med" len="med"/>
-                    </a:lnR>
-                    <a:lnT w="6350" cap="flat" cmpd="sng" algn="ctr">
-                      <a:solidFill>
-                        <a:srgbClr val="D5DBE3"/>
-                      </a:solidFill>
-                      <a:prstDash val="solid"/>
-                      <a:round/>
-                      <a:headEnd type="none" w="med" len="med"/>
-                      <a:tailEnd type="none" w="med" len="med"/>
-                    </a:lnT>
-                    <a:lnB w="6350" cap="flat" cmpd="sng" algn="ctr">
-                      <a:solidFill>
-                        <a:srgbClr val="D5DBE3"/>
-                      </a:solidFill>
-                      <a:prstDash val="solid"/>
-                      <a:round/>
-                      <a:headEnd type="none" w="med" len="med"/>
-                      <a:tailEnd type="none" w="med" len="med"/>
-                    </a:lnB>
-                  </a:tcPr>
-                </a:tc>
-                <a:tc>
-                  <a:txBody>
-                    <a:bodyPr/>
-                    <a:lstStyle/>
-                    <a:p>
-                      <a:pPr algn="r" indent="0" marL="0">
-                        <a:buNone/>
-                      </a:pPr>
-                      <a:r>
-                        <a:rPr lang="en-US" sz="950" b="1" dirty="0">
-                          <a:solidFill>
-                            <a:srgbClr val="B3261E"/>
-                          </a:solidFill>
-                          <a:latin typeface="Calibri" pitchFamily="34" charset="0"/>
-                          <a:ea typeface="Calibri" pitchFamily="34" charset="-122"/>
-                          <a:cs typeface="Calibri" pitchFamily="34" charset="-120"/>
-                        </a:rPr>
-                        <a:t>601,4</a:t>
-                      </a:r>
-                      <a:endParaRPr lang="en-US" sz="950" dirty="0">
-                        <a:latin typeface="Calibri" charset="0"/>
-                        <a:ea typeface="Calibri" charset="0"/>
-                        <a:cs typeface="Calibri" charset="0"/>
-                      </a:endParaRPr>
-                    </a:p>
-                  </a:txBody>
-                  <a:tcPr marL="64008" marR="64008" marT="0" marB="0" anchor="ctr">
-                    <a:lnL w="6350" cap="flat" cmpd="sng" algn="ctr">
-                      <a:solidFill>
-                        <a:srgbClr val="D5DBE3"/>
-                      </a:solidFill>
-                      <a:prstDash val="solid"/>
-                      <a:round/>
-                      <a:headEnd type="none" w="med" len="med"/>
-                      <a:tailEnd type="none" w="med" len="med"/>
-                    </a:lnL>
-                    <a:lnR w="6350" cap="flat" cmpd="sng" algn="ctr">
-                      <a:solidFill>
-                        <a:srgbClr val="D5DBE3"/>
-                      </a:solidFill>
-                      <a:prstDash val="solid"/>
-                      <a:round/>
-                      <a:headEnd type="none" w="med" len="med"/>
-                      <a:tailEnd type="none" w="med" len="med"/>
-                    </a:lnR>
-                    <a:lnT w="6350" cap="flat" cmpd="sng" algn="ctr">
-                      <a:solidFill>
-                        <a:srgbClr val="D5DBE3"/>
-                      </a:solidFill>
-                      <a:prstDash val="solid"/>
-                      <a:round/>
-                      <a:headEnd type="none" w="med" len="med"/>
-                      <a:tailEnd type="none" w="med" len="med"/>
-                    </a:lnT>
-                    <a:lnB w="6350" cap="flat" cmpd="sng" algn="ctr">
-                      <a:solidFill>
-                        <a:srgbClr val="D5DBE3"/>
-                      </a:solidFill>
-                      <a:prstDash val="solid"/>
-                      <a:round/>
-                      <a:headEnd type="none" w="med" len="med"/>
-                      <a:tailEnd type="none" w="med" len="med"/>
-                    </a:lnB>
-                    <a:solidFill>
-                      <a:srgbClr val="F7E7E5"/>
-                    </a:solidFill>
-                  </a:tcPr>
-                </a:tc>
-                <a:tc>
-                  <a:txBody>
-                    <a:bodyPr/>
-                    <a:lstStyle/>
-                    <a:p>
-                      <a:pPr algn="l" indent="0" marL="0">
-                        <a:buNone/>
-                      </a:pPr>
-                      <a:r>
-                        <a:rPr lang="en-US" sz="950" dirty="0">
-                          <a:solidFill>
-                            <a:srgbClr val="1F2933"/>
-                          </a:solidFill>
-                          <a:latin typeface="Calibri" pitchFamily="34" charset="0"/>
-                          <a:ea typeface="Calibri" pitchFamily="34" charset="-122"/>
-                          <a:cs typeface="Calibri" pitchFamily="34" charset="-120"/>
-                        </a:rPr>
-                        <a:t>Compte à arbitrer (C) ou prêts</a:t>
-                      </a:r>
-                      <a:endParaRPr lang="en-US" sz="950" dirty="0">
-                        <a:latin typeface="Calibri" charset="0"/>
-                        <a:ea typeface="Calibri" charset="0"/>
-                        <a:cs typeface="Calibri" charset="0"/>
-                      </a:endParaRPr>
-                    </a:p>
-                  </a:txBody>
-                  <a:tcPr marL="64008" marR="64008" marT="0" marB="0" anchor="ctr">
-                    <a:lnL w="6350" cap="flat" cmpd="sng" algn="ctr">
-                      <a:solidFill>
-                        <a:srgbClr val="D5DBE3"/>
-                      </a:solidFill>
-                      <a:prstDash val="solid"/>
-                      <a:round/>
-                      <a:headEnd type="none" w="med" len="med"/>
-                      <a:tailEnd type="none" w="med" len="med"/>
-                    </a:lnL>
-                    <a:lnR w="6350" cap="flat" cmpd="sng" algn="ctr">
-                      <a:solidFill>
-                        <a:srgbClr val="D5DBE3"/>
-                      </a:solidFill>
-                      <a:prstDash val="solid"/>
-                      <a:round/>
-                      <a:headEnd type="none" w="med" len="med"/>
-                      <a:tailEnd type="none" w="med" len="med"/>
-                    </a:lnR>
-                    <a:lnT w="6350" cap="flat" cmpd="sng" algn="ctr">
-                      <a:solidFill>
-                        <a:srgbClr val="D5DBE3"/>
-                      </a:solidFill>
-                      <a:prstDash val="solid"/>
-                      <a:round/>
-                      <a:headEnd type="none" w="med" len="med"/>
-                      <a:tailEnd type="none" w="med" len="med"/>
-                    </a:lnT>
-                    <a:lnB w="6350" cap="flat" cmpd="sng" algn="ctr">
-                      <a:solidFill>
-                        <a:srgbClr val="D5DBE3"/>
-                      </a:solidFill>
-                      <a:prstDash val="solid"/>
-                      <a:round/>
-                      <a:headEnd type="none" w="med" len="med"/>
-                      <a:tailEnd type="none" w="med" len="med"/>
-                    </a:lnB>
-                  </a:tcPr>
-                </a:tc>
-                <a:tc>
-                  <a:txBody>
-                    <a:bodyPr/>
-                    <a:lstStyle/>
-                    <a:p>
-                      <a:pPr algn="ctr" indent="0" marL="0">
-                        <a:buNone/>
-                      </a:pPr>
-                      <a:r>
-                        <a:rPr lang="en-US" sz="950" dirty="0">
-                          <a:solidFill>
-                            <a:srgbClr val="1F2933"/>
-                          </a:solidFill>
-                          <a:latin typeface="Calibri" pitchFamily="34" charset="0"/>
-                          <a:ea typeface="Calibri" pitchFamily="34" charset="-122"/>
-                          <a:cs typeface="Calibri" pitchFamily="34" charset="-120"/>
-                        </a:rPr>
-                        <a:t>S2</a:t>
-                      </a:r>
-                      <a:endParaRPr lang="en-US" sz="950" dirty="0">
-                        <a:latin typeface="Calibri" charset="0"/>
-                        <a:ea typeface="Calibri" charset="0"/>
-                        <a:cs typeface="Calibri" charset="0"/>
-                      </a:endParaRPr>
-                    </a:p>
-                  </a:txBody>
-                  <a:tcPr marL="64008" marR="64008" marT="0" marB="0" anchor="ctr">
-                    <a:lnL w="6350" cap="flat" cmpd="sng" algn="ctr">
-                      <a:solidFill>
-                        <a:srgbClr val="D5DBE3"/>
-                      </a:solidFill>
-                      <a:prstDash val="solid"/>
-                      <a:round/>
-                      <a:headEnd type="none" w="med" len="med"/>
-                      <a:tailEnd type="none" w="med" len="med"/>
-                    </a:lnL>
-                    <a:lnR w="6350" cap="flat" cmpd="sng" algn="ctr">
-                      <a:solidFill>
-                        <a:srgbClr val="D5DBE3"/>
-                      </a:solidFill>
-                      <a:prstDash val="solid"/>
-                      <a:round/>
-                      <a:headEnd type="none" w="med" len="med"/>
-                      <a:tailEnd type="none" w="med" len="med"/>
-                    </a:lnR>
-                    <a:lnT w="6350" cap="flat" cmpd="sng" algn="ctr">
-                      <a:solidFill>
-                        <a:srgbClr val="D5DBE3"/>
-                      </a:solidFill>
-                      <a:prstDash val="solid"/>
-                      <a:round/>
-                      <a:headEnd type="none" w="med" len="med"/>
-                      <a:tailEnd type="none" w="med" len="med"/>
-                    </a:lnT>
-                    <a:lnB w="6350" cap="flat" cmpd="sng" algn="ctr">
-                      <a:solidFill>
-                        <a:srgbClr val="D5DBE3"/>
-                      </a:solidFill>
-                      <a:prstDash val="solid"/>
-                      <a:round/>
-                      <a:headEnd type="none" w="med" len="med"/>
-                      <a:tailEnd type="none" w="med" len="med"/>
-                    </a:lnB>
-                  </a:tcPr>
-                </a:tc>
-              </a:tr>
-              <a:tr h="237744">
-                <a:tc>
-                  <a:txBody>
-                    <a:bodyPr/>
-                    <a:lstStyle/>
-                    <a:p>
-                      <a:pPr algn="l" indent="0" marL="0">
-                        <a:buNone/>
-                      </a:pPr>
-                      <a:r>
-                        <a:rPr lang="en-US" sz="950" b="1" dirty="0">
-                          <a:solidFill>
-                            <a:srgbClr val="1F2933"/>
-                          </a:solidFill>
-                          <a:latin typeface="Calibri" pitchFamily="34" charset="0"/>
-                          <a:ea typeface="Calibri" pitchFamily="34" charset="-122"/>
-                          <a:cs typeface="Calibri" pitchFamily="34" charset="-120"/>
-                        </a:rPr>
-                        <a:t>TERASSON – fonds projet</a:t>
-                      </a:r>
-                      <a:endParaRPr lang="en-US" sz="950" dirty="0">
-                        <a:latin typeface="Calibri" charset="0"/>
-                        <a:ea typeface="Calibri" charset="0"/>
-                        <a:cs typeface="Calibri" charset="0"/>
-                      </a:endParaRPr>
-                    </a:p>
-                  </a:txBody>
-                  <a:tcPr marL="64008" marR="64008" marT="0" marB="0" anchor="ctr">
-                    <a:lnL w="6350" cap="flat" cmpd="sng" algn="ctr">
-                      <a:solidFill>
-                        <a:srgbClr val="D5DBE3"/>
-                      </a:solidFill>
-                      <a:prstDash val="solid"/>
-                      <a:round/>
-                      <a:headEnd type="none" w="med" len="med"/>
-                      <a:tailEnd type="none" w="med" len="med"/>
-                    </a:lnL>
-                    <a:lnR w="6350" cap="flat" cmpd="sng" algn="ctr">
-                      <a:solidFill>
-                        <a:srgbClr val="D5DBE3"/>
-                      </a:solidFill>
-                      <a:prstDash val="solid"/>
-                      <a:round/>
-                      <a:headEnd type="none" w="med" len="med"/>
-                      <a:tailEnd type="none" w="med" len="med"/>
-                    </a:lnR>
-                    <a:lnT w="6350" cap="flat" cmpd="sng" algn="ctr">
-                      <a:solidFill>
-                        <a:srgbClr val="D5DBE3"/>
-                      </a:solidFill>
-                      <a:prstDash val="solid"/>
-                      <a:round/>
-                      <a:headEnd type="none" w="med" len="med"/>
-                      <a:tailEnd type="none" w="med" len="med"/>
-                    </a:lnT>
-                    <a:lnB w="6350" cap="flat" cmpd="sng" algn="ctr">
-                      <a:solidFill>
-                        <a:srgbClr val="D5DBE3"/>
-                      </a:solidFill>
-                      <a:prstDash val="solid"/>
-                      <a:round/>
-                      <a:headEnd type="none" w="med" len="med"/>
-                      <a:tailEnd type="none" w="med" len="med"/>
-                    </a:lnB>
-                  </a:tcPr>
-                </a:tc>
-                <a:tc>
-                  <a:txBody>
-                    <a:bodyPr/>
-                    <a:lstStyle/>
-                    <a:p>
-                      <a:pPr algn="r" indent="0" marL="0">
-                        <a:buNone/>
-                      </a:pPr>
-                      <a:r>
-                        <a:rPr lang="en-US" sz="950" b="1" dirty="0">
-                          <a:solidFill>
-                            <a:srgbClr val="B3261E"/>
-                          </a:solidFill>
-                          <a:latin typeface="Calibri" pitchFamily="34" charset="0"/>
-                          <a:ea typeface="Calibri" pitchFamily="34" charset="-122"/>
-                          <a:cs typeface="Calibri" pitchFamily="34" charset="-120"/>
-                        </a:rPr>
-                        <a:t>501,3</a:t>
-                      </a:r>
-                      <a:endParaRPr lang="en-US" sz="950" dirty="0">
-                        <a:latin typeface="Calibri" charset="0"/>
-                        <a:ea typeface="Calibri" charset="0"/>
-                        <a:cs typeface="Calibri" charset="0"/>
-                      </a:endParaRPr>
-                    </a:p>
-                  </a:txBody>
-                  <a:tcPr marL="64008" marR="64008" marT="0" marB="0" anchor="ctr">
-                    <a:lnL w="6350" cap="flat" cmpd="sng" algn="ctr">
-                      <a:solidFill>
-                        <a:srgbClr val="D5DBE3"/>
-                      </a:solidFill>
-                      <a:prstDash val="solid"/>
-                      <a:round/>
-                      <a:headEnd type="none" w="med" len="med"/>
-                      <a:tailEnd type="none" w="med" len="med"/>
-                    </a:lnL>
-                    <a:lnR w="6350" cap="flat" cmpd="sng" algn="ctr">
-                      <a:solidFill>
-                        <a:srgbClr val="D5DBE3"/>
-                      </a:solidFill>
-                      <a:prstDash val="solid"/>
-                      <a:round/>
-                      <a:headEnd type="none" w="med" len="med"/>
-                      <a:tailEnd type="none" w="med" len="med"/>
-                    </a:lnR>
-                    <a:lnT w="6350" cap="flat" cmpd="sng" algn="ctr">
-                      <a:solidFill>
-                        <a:srgbClr val="D5DBE3"/>
-                      </a:solidFill>
-                      <a:prstDash val="solid"/>
-                      <a:round/>
-                      <a:headEnd type="none" w="med" len="med"/>
-                      <a:tailEnd type="none" w="med" len="med"/>
-                    </a:lnT>
-                    <a:lnB w="6350" cap="flat" cmpd="sng" algn="ctr">
-                      <a:solidFill>
-                        <a:srgbClr val="D5DBE3"/>
-                      </a:solidFill>
-                      <a:prstDash val="solid"/>
-                      <a:round/>
-                      <a:headEnd type="none" w="med" len="med"/>
-                      <a:tailEnd type="none" w="med" len="med"/>
-                    </a:lnB>
-                    <a:solidFill>
-                      <a:srgbClr val="F7E7E5"/>
-                    </a:solidFill>
-                  </a:tcPr>
-                </a:tc>
-                <a:tc>
-                  <a:txBody>
-                    <a:bodyPr/>
-                    <a:lstStyle/>
-                    <a:p>
-                      <a:pPr algn="l" indent="0" marL="0">
-                        <a:buNone/>
-                      </a:pPr>
-                      <a:r>
-                        <a:rPr lang="en-US" sz="950" dirty="0">
-                          <a:solidFill>
-                            <a:srgbClr val="1F2933"/>
-                          </a:solidFill>
-                          <a:latin typeface="Calibri" pitchFamily="34" charset="0"/>
-                          <a:ea typeface="Calibri" pitchFamily="34" charset="-122"/>
-                          <a:cs typeface="Calibri" pitchFamily="34" charset="-120"/>
-                        </a:rPr>
-                        <a:t>Compte à arbitrer (C) ou prêts</a:t>
-                      </a:r>
-                      <a:endParaRPr lang="en-US" sz="950" dirty="0">
-                        <a:latin typeface="Calibri" charset="0"/>
-                        <a:ea typeface="Calibri" charset="0"/>
-                        <a:cs typeface="Calibri" charset="0"/>
-                      </a:endParaRPr>
-                    </a:p>
-                  </a:txBody>
-                  <a:tcPr marL="64008" marR="64008" marT="0" marB="0" anchor="ctr">
-                    <a:lnL w="6350" cap="flat" cmpd="sng" algn="ctr">
-                      <a:solidFill>
-                        <a:srgbClr val="D5DBE3"/>
-                      </a:solidFill>
-                      <a:prstDash val="solid"/>
-                      <a:round/>
-                      <a:headEnd type="none" w="med" len="med"/>
-                      <a:tailEnd type="none" w="med" len="med"/>
-                    </a:lnL>
-                    <a:lnR w="6350" cap="flat" cmpd="sng" algn="ctr">
-                      <a:solidFill>
-                        <a:srgbClr val="D5DBE3"/>
-                      </a:solidFill>
-                      <a:prstDash val="solid"/>
-                      <a:round/>
-                      <a:headEnd type="none" w="med" len="med"/>
-                      <a:tailEnd type="none" w="med" len="med"/>
-                    </a:lnR>
-                    <a:lnT w="6350" cap="flat" cmpd="sng" algn="ctr">
-                      <a:solidFill>
-                        <a:srgbClr val="D5DBE3"/>
-                      </a:solidFill>
-                      <a:prstDash val="solid"/>
-                      <a:round/>
-                      <a:headEnd type="none" w="med" len="med"/>
-                      <a:tailEnd type="none" w="med" len="med"/>
-                    </a:lnT>
-                    <a:lnB w="6350" cap="flat" cmpd="sng" algn="ctr">
-                      <a:solidFill>
-                        <a:srgbClr val="D5DBE3"/>
-                      </a:solidFill>
-                      <a:prstDash val="solid"/>
-                      <a:round/>
-                      <a:headEnd type="none" w="med" len="med"/>
-                      <a:tailEnd type="none" w="med" len="med"/>
-                    </a:lnB>
-                  </a:tcPr>
-                </a:tc>
-                <a:tc>
-                  <a:txBody>
-                    <a:bodyPr/>
-                    <a:lstStyle/>
-                    <a:p>
-                      <a:pPr algn="ctr" indent="0" marL="0">
-                        <a:buNone/>
-                      </a:pPr>
-                      <a:r>
-                        <a:rPr lang="en-US" sz="950" dirty="0">
-                          <a:solidFill>
-                            <a:srgbClr val="1F2933"/>
-                          </a:solidFill>
-                          <a:latin typeface="Calibri" pitchFamily="34" charset="0"/>
-                          <a:ea typeface="Calibri" pitchFamily="34" charset="-122"/>
-                          <a:cs typeface="Calibri" pitchFamily="34" charset="-120"/>
-                        </a:rPr>
-                        <a:t>S1</a:t>
-                      </a:r>
-                      <a:endParaRPr lang="en-US" sz="950" dirty="0">
-                        <a:latin typeface="Calibri" charset="0"/>
-                        <a:ea typeface="Calibri" charset="0"/>
-                        <a:cs typeface="Calibri" charset="0"/>
-                      </a:endParaRPr>
-                    </a:p>
-                  </a:txBody>
-                  <a:tcPr marL="64008" marR="64008" marT="0" marB="0" anchor="ctr">
-                    <a:lnL w="6350" cap="flat" cmpd="sng" algn="ctr">
-                      <a:solidFill>
-                        <a:srgbClr val="D5DBE3"/>
-                      </a:solidFill>
-                      <a:prstDash val="solid"/>
-                      <a:round/>
-                      <a:headEnd type="none" w="med" len="med"/>
-                      <a:tailEnd type="none" w="med" len="med"/>
-                    </a:lnL>
-                    <a:lnR w="6350" cap="flat" cmpd="sng" algn="ctr">
-                      <a:solidFill>
-                        <a:srgbClr val="D5DBE3"/>
-                      </a:solidFill>
-                      <a:prstDash val="solid"/>
-                      <a:round/>
-                      <a:headEnd type="none" w="med" len="med"/>
-                      <a:tailEnd type="none" w="med" len="med"/>
-                    </a:lnR>
-                    <a:lnT w="6350" cap="flat" cmpd="sng" algn="ctr">
-                      <a:solidFill>
-                        <a:srgbClr val="D5DBE3"/>
-                      </a:solidFill>
-                      <a:prstDash val="solid"/>
-                      <a:round/>
-                      <a:headEnd type="none" w="med" len="med"/>
-                      <a:tailEnd type="none" w="med" len="med"/>
-                    </a:lnT>
-                    <a:lnB w="6350" cap="flat" cmpd="sng" algn="ctr">
-                      <a:solidFill>
-                        <a:srgbClr val="D5DBE3"/>
-                      </a:solidFill>
-                      <a:prstDash val="solid"/>
-                      <a:round/>
-                      <a:headEnd type="none" w="med" len="med"/>
-                      <a:tailEnd type="none" w="med" len="med"/>
-                    </a:lnB>
-                  </a:tcPr>
-                </a:tc>
-              </a:tr>
-              <a:tr h="237744">
-                <a:tc>
-                  <a:txBody>
-                    <a:bodyPr/>
-                    <a:lstStyle/>
-                    <a:p>
-                      <a:pPr algn="l" indent="0" marL="0">
-                        <a:buNone/>
-                      </a:pPr>
-                      <a:r>
-                        <a:rPr lang="en-US" sz="950" b="1" dirty="0">
-                          <a:solidFill>
-                            <a:srgbClr val="FFFFFF"/>
-                          </a:solidFill>
-                          <a:latin typeface="Calibri" pitchFamily="34" charset="0"/>
-                          <a:ea typeface="Calibri" pitchFamily="34" charset="-122"/>
-                          <a:cs typeface="Calibri" pitchFamily="34" charset="-120"/>
-                        </a:rPr>
-                        <a:t>Total</a:t>
-                      </a:r>
-                      <a:endParaRPr lang="en-US" sz="950" dirty="0">
-                        <a:latin typeface="Calibri" charset="0"/>
-                        <a:ea typeface="Calibri" charset="0"/>
-                        <a:cs typeface="Calibri" charset="0"/>
-                      </a:endParaRPr>
-                    </a:p>
-                  </a:txBody>
-                  <a:tcPr marL="64008" marR="64008" marT="0" marB="0" anchor="ctr">
-                    <a:lnL w="6350" cap="flat" cmpd="sng" algn="ctr">
-                      <a:solidFill>
-                        <a:srgbClr val="D5DBE3"/>
-                      </a:solidFill>
-                      <a:prstDash val="solid"/>
-                      <a:round/>
-                      <a:headEnd type="none" w="med" len="med"/>
-                      <a:tailEnd type="none" w="med" len="med"/>
-                    </a:lnL>
-                    <a:lnR w="6350" cap="flat" cmpd="sng" algn="ctr">
-                      <a:solidFill>
-                        <a:srgbClr val="D5DBE3"/>
-                      </a:solidFill>
-                      <a:prstDash val="solid"/>
-                      <a:round/>
-                      <a:headEnd type="none" w="med" len="med"/>
-                      <a:tailEnd type="none" w="med" len="med"/>
-                    </a:lnR>
-                    <a:lnT w="6350" cap="flat" cmpd="sng" algn="ctr">
-                      <a:solidFill>
-                        <a:srgbClr val="D5DBE3"/>
-                      </a:solidFill>
-                      <a:prstDash val="solid"/>
-                      <a:round/>
-                      <a:headEnd type="none" w="med" len="med"/>
-                      <a:tailEnd type="none" w="med" len="med"/>
-                    </a:lnT>
-                    <a:lnB w="6350" cap="flat" cmpd="sng" algn="ctr">
-                      <a:solidFill>
-                        <a:srgbClr val="D5DBE3"/>
-                      </a:solidFill>
-                      <a:prstDash val="solid"/>
-                      <a:round/>
-                      <a:headEnd type="none" w="med" len="med"/>
-                      <a:tailEnd type="none" w="med" len="med"/>
-                    </a:lnB>
-                    <a:solidFill>
-                      <a:srgbClr val="002C50"/>
-                    </a:solidFill>
-                  </a:tcPr>
-                </a:tc>
-                <a:tc>
-                  <a:txBody>
-                    <a:bodyPr/>
-                    <a:lstStyle/>
-                    <a:p>
-                      <a:pPr algn="r" indent="0" marL="0">
-                        <a:buNone/>
-                      </a:pPr>
-                      <a:r>
-                        <a:rPr lang="en-US" sz="950" b="1" dirty="0">
-                          <a:solidFill>
-                            <a:srgbClr val="FFFFFF"/>
-                          </a:solidFill>
-                          <a:latin typeface="Calibri" pitchFamily="34" charset="0"/>
-                          <a:ea typeface="Calibri" pitchFamily="34" charset="-122"/>
-                          <a:cs typeface="Calibri" pitchFamily="34" charset="-120"/>
-                        </a:rPr>
-                        <a:t>1 925,7</a:t>
-                      </a:r>
-                      <a:endParaRPr lang="en-US" sz="950" dirty="0">
-                        <a:latin typeface="Calibri" charset="0"/>
-                        <a:ea typeface="Calibri" charset="0"/>
-                        <a:cs typeface="Calibri" charset="0"/>
-                      </a:endParaRPr>
-                    </a:p>
-                  </a:txBody>
-                  <a:tcPr marL="64008" marR="64008" marT="0" marB="0" anchor="ctr">
-                    <a:lnL w="6350" cap="flat" cmpd="sng" algn="ctr">
-                      <a:solidFill>
-                        <a:srgbClr val="D5DBE3"/>
-                      </a:solidFill>
-                      <a:prstDash val="solid"/>
-                      <a:round/>
-                      <a:headEnd type="none" w="med" len="med"/>
-                      <a:tailEnd type="none" w="med" len="med"/>
-                    </a:lnL>
-                    <a:lnR w="6350" cap="flat" cmpd="sng" algn="ctr">
-                      <a:solidFill>
-                        <a:srgbClr val="D5DBE3"/>
-                      </a:solidFill>
-                      <a:prstDash val="solid"/>
-                      <a:round/>
-                      <a:headEnd type="none" w="med" len="med"/>
-                      <a:tailEnd type="none" w="med" len="med"/>
-                    </a:lnR>
-                    <a:lnT w="6350" cap="flat" cmpd="sng" algn="ctr">
-                      <a:solidFill>
-                        <a:srgbClr val="D5DBE3"/>
-                      </a:solidFill>
-                      <a:prstDash val="solid"/>
-                      <a:round/>
-                      <a:headEnd type="none" w="med" len="med"/>
-                      <a:tailEnd type="none" w="med" len="med"/>
-                    </a:lnT>
-                    <a:lnB w="6350" cap="flat" cmpd="sng" algn="ctr">
-                      <a:solidFill>
-                        <a:srgbClr val="D5DBE3"/>
-                      </a:solidFill>
-                      <a:prstDash val="solid"/>
-                      <a:round/>
-                      <a:headEnd type="none" w="med" len="med"/>
-                      <a:tailEnd type="none" w="med" len="med"/>
-                    </a:lnB>
-                    <a:solidFill>
-                      <a:srgbClr val="002C50"/>
-                    </a:solidFill>
-                  </a:tcPr>
-                </a:tc>
-                <a:tc>
-                  <a:txBody>
-                    <a:bodyPr/>
-                    <a:lstStyle/>
-                    <a:p>
-                      <a:pPr algn="l" indent="0" marL="0">
-                        <a:buNone/>
-                      </a:pPr>
-                      <a:endParaRPr lang="en-US" sz="950" dirty="0">
-                        <a:latin typeface="Calibri" charset="0"/>
-                        <a:ea typeface="Calibri" charset="0"/>
-                        <a:cs typeface="Calibri" charset="0"/>
-                      </a:endParaRPr>
-                    </a:p>
-                  </a:txBody>
-                  <a:tcPr marL="64008" marR="64008" marT="0" marB="0" anchor="ctr">
-                    <a:lnL w="6350" cap="flat" cmpd="sng" algn="ctr">
-                      <a:solidFill>
-                        <a:srgbClr val="D5DBE3"/>
-                      </a:solidFill>
-                      <a:prstDash val="solid"/>
-                      <a:round/>
-                      <a:headEnd type="none" w="med" len="med"/>
-                      <a:tailEnd type="none" w="med" len="med"/>
-                    </a:lnL>
-                    <a:lnR w="6350" cap="flat" cmpd="sng" algn="ctr">
-                      <a:solidFill>
-                        <a:srgbClr val="D5DBE3"/>
-                      </a:solidFill>
-                      <a:prstDash val="solid"/>
-                      <a:round/>
-                      <a:headEnd type="none" w="med" len="med"/>
-                      <a:tailEnd type="none" w="med" len="med"/>
-                    </a:lnR>
-                    <a:lnT w="6350" cap="flat" cmpd="sng" algn="ctr">
-                      <a:solidFill>
-                        <a:srgbClr val="D5DBE3"/>
-                      </a:solidFill>
-                      <a:prstDash val="solid"/>
-                      <a:round/>
-                      <a:headEnd type="none" w="med" len="med"/>
-                      <a:tailEnd type="none" w="med" len="med"/>
-                    </a:lnT>
-                    <a:lnB w="6350" cap="flat" cmpd="sng" algn="ctr">
-                      <a:solidFill>
-                        <a:srgbClr val="D5DBE3"/>
-                      </a:solidFill>
-                      <a:prstDash val="solid"/>
-                      <a:round/>
-                      <a:headEnd type="none" w="med" len="med"/>
-                      <a:tailEnd type="none" w="med" len="med"/>
-                    </a:lnB>
-                    <a:solidFill>
-                      <a:srgbClr val="002C50"/>
-                    </a:solidFill>
-                  </a:tcPr>
-                </a:tc>
-                <a:tc>
-                  <a:txBody>
-                    <a:bodyPr/>
-                    <a:lstStyle/>
-                    <a:p>
-                      <a:pPr algn="r" indent="0" marL="0">
-                        <a:buNone/>
-                      </a:pPr>
-                      <a:endParaRPr lang="en-US" sz="950" dirty="0">
-                        <a:latin typeface="Calibri" charset="0"/>
-                        <a:ea typeface="Calibri" charset="0"/>
-                        <a:cs typeface="Calibri" charset="0"/>
-                      </a:endParaRPr>
-                    </a:p>
-                  </a:txBody>
-                  <a:tcPr marL="64008" marR="64008" marT="0" marB="0" anchor="ctr">
-                    <a:lnL w="6350" cap="flat" cmpd="sng" algn="ctr">
-                      <a:solidFill>
-                        <a:srgbClr val="D5DBE3"/>
-                      </a:solidFill>
-                      <a:prstDash val="solid"/>
-                      <a:round/>
-                      <a:headEnd type="none" w="med" len="med"/>
-                      <a:tailEnd type="none" w="med" len="med"/>
-                    </a:lnL>
-                    <a:lnR w="6350" cap="flat" cmpd="sng" algn="ctr">
-                      <a:solidFill>
-                        <a:srgbClr val="D5DBE3"/>
-                      </a:solidFill>
-                      <a:prstDash val="solid"/>
-                      <a:round/>
-                      <a:headEnd type="none" w="med" len="med"/>
-                      <a:tailEnd type="none" w="med" len="med"/>
-                    </a:lnR>
-                    <a:lnT w="6350" cap="flat" cmpd="sng" algn="ctr">
-                      <a:solidFill>
-                        <a:srgbClr val="D5DBE3"/>
-                      </a:solidFill>
-                      <a:prstDash val="solid"/>
-                      <a:round/>
-                      <a:headEnd type="none" w="med" len="med"/>
-                      <a:tailEnd type="none" w="med" len="med"/>
-                    </a:lnT>
-                    <a:lnB w="6350" cap="flat" cmpd="sng" algn="ctr">
-                      <a:solidFill>
-                        <a:srgbClr val="D5DBE3"/>
-                      </a:solidFill>
-                      <a:prstDash val="solid"/>
-                      <a:round/>
-                      <a:headEnd type="none" w="med" len="med"/>
-                      <a:tailEnd type="none" w="med" len="med"/>
-                    </a:lnB>
-                    <a:solidFill>
-                      <a:srgbClr val="002C50"/>
-                    </a:solidFill>
-                  </a:tcPr>
-                </a:tc>
-              </a:tr>
-            </a:tbl>
-          </a:graphicData>
-        </a:graphic>
-      </p:graphicFrame>
-      <p:sp>
-        <p:nvSpPr>
-          <p:cNvPr id="5" name="Shape 2"/>
-          <p:cNvSpPr/>
-          <p:nvPr/>
-        </p:nvSpPr>
-        <p:spPr>
-          <a:xfrm>
-            <a:off x="6446520" y="1325880"/>
-            <a:ext cx="5285232" cy="1508760"/>
-          </a:xfrm>
-          <a:prstGeom prst="rect">
-            <a:avLst/>
-          </a:prstGeom>
-          <a:solidFill>
-            <a:srgbClr val="E6F0EA"/>
-          </a:solidFill>
-          <a:ln w="12700">
-            <a:solidFill>
-              <a:srgbClr val="E6F0EA"/>
-            </a:solidFill>
-            <a:prstDash val="solid"/>
-          </a:ln>
-        </p:spPr>
-      </p:sp>
-      <p:sp>
-        <p:nvSpPr>
-          <p:cNvPr id="6" name="Text 3"/>
-          <p:cNvSpPr txBox="1"/>
-          <p:nvPr/>
-        </p:nvSpPr>
-        <p:spPr>
-          <a:xfrm>
-            <a:off x="6629400" y="1417320"/>
-            <a:ext cx="3566160" cy="292608"/>
-          </a:xfrm>
-          <a:prstGeom prst="rect">
-            <a:avLst/>
-          </a:prstGeom>
-          <a:noFill/>
-          <a:ln/>
-        </p:spPr>
-        <p:txBody>
-          <a:bodyPr wrap="square" lIns="0" tIns="0" rIns="0" bIns="0" rtlCol="0" anchor="ctr"/>
-          <a:lstStyle/>
-          <a:p>
-            <a:pPr indent="0" marL="0">
-              <a:buNone/>
-            </a:pPr>
-            <a:r>
-              <a:rPr lang="en-US" sz="1200" b="1" dirty="0">
-                <a:solidFill>
-                  <a:srgbClr val="5E9B7E"/>
-                </a:solidFill>
-                <a:latin typeface="Calibri" pitchFamily="34" charset="0"/>
-                <a:ea typeface="Calibri" pitchFamily="34" charset="-122"/>
-                <a:cs typeface="Calibri" pitchFamily="34" charset="-120"/>
-              </a:rPr>
-              <a:t>A – Crédit spot bancaire, par société</a:t>
-            </a:r>
-            <a:endParaRPr lang="en-US" sz="1200" dirty="0"/>
-          </a:p>
-        </p:txBody>
-      </p:sp>
-      <p:sp>
-        <p:nvSpPr>
-          <p:cNvPr id="7" name="Text 4"/>
-          <p:cNvSpPr txBox="1"/>
-          <p:nvPr/>
-        </p:nvSpPr>
-        <p:spPr>
-          <a:xfrm>
-            <a:off x="10058400" y="1399032"/>
-            <a:ext cx="1508760" cy="329184"/>
-          </a:xfrm>
-          <a:prstGeom prst="rect">
-            <a:avLst/>
-          </a:prstGeom>
-          <a:noFill/>
-          <a:ln/>
-        </p:spPr>
-        <p:txBody>
-          <a:bodyPr wrap="square" lIns="0" tIns="0" rIns="0" bIns="0" rtlCol="0" anchor="ctr"/>
-          <a:lstStyle/>
-          <a:p>
-            <a:pPr algn="r" indent="0" marL="0">
-              <a:buNone/>
-            </a:pPr>
-            <a:r>
-              <a:rPr lang="en-US" sz="1400" b="1" dirty="0">
-                <a:solidFill>
-                  <a:srgbClr val="5E9B7E"/>
-                </a:solidFill>
-                <a:latin typeface="Calibri" pitchFamily="34" charset="0"/>
-                <a:ea typeface="Calibri" pitchFamily="34" charset="-122"/>
-                <a:cs typeface="Calibri" pitchFamily="34" charset="-120"/>
-              </a:rPr>
-              <a:t>823,1 M</a:t>
-            </a:r>
-            <a:endParaRPr lang="en-US" sz="1400" dirty="0"/>
-          </a:p>
-        </p:txBody>
-      </p:sp>
-      <p:sp>
-        <p:nvSpPr>
-          <p:cNvPr id="8" name="Text 5"/>
-          <p:cNvSpPr txBox="1"/>
-          <p:nvPr/>
-        </p:nvSpPr>
-        <p:spPr>
-          <a:xfrm>
-            <a:off x="6629400" y="1764792"/>
-            <a:ext cx="4937760" cy="978408"/>
-          </a:xfrm>
-          <a:prstGeom prst="rect">
-            <a:avLst/>
-          </a:prstGeom>
-          <a:noFill/>
-          <a:ln/>
-        </p:spPr>
-        <p:txBody>
-          <a:bodyPr wrap="square" lIns="0" tIns="0" rIns="0" bIns="0" rtlCol="0" anchor="t"/>
-          <a:lstStyle/>
-          <a:p>
-            <a:pPr indent="0" marL="0">
-              <a:buNone/>
-            </a:pPr>
-            <a:r>
-              <a:rPr lang="en-US" sz="1100" dirty="0">
-                <a:solidFill>
-                  <a:srgbClr val="1F2933"/>
-                </a:solidFill>
-                <a:latin typeface="Calibri" pitchFamily="34" charset="0"/>
-                <a:ea typeface="Calibri" pitchFamily="34" charset="-122"/>
-                <a:cs typeface="Calibri" pitchFamily="34" charset="-120"/>
-              </a:rPr>
-              <a:t>Un dossier par société en déficit (9), tiré par tranche : 685,8 M pour S1, le solde à l'échéance. Remboursement à la mise en place des financements.</a:t>
-            </a:r>
-            <a:endParaRPr lang="en-US" sz="1100" dirty="0"/>
-          </a:p>
-        </p:txBody>
-      </p:sp>
-      <p:sp>
-        <p:nvSpPr>
-          <p:cNvPr id="9" name="Shape 6"/>
-          <p:cNvSpPr/>
-          <p:nvPr/>
-        </p:nvSpPr>
-        <p:spPr>
-          <a:xfrm>
-            <a:off x="6446520" y="2971800"/>
-            <a:ext cx="5285232" cy="1463040"/>
-          </a:xfrm>
-          <a:prstGeom prst="rect">
-            <a:avLst/>
-          </a:prstGeom>
-          <a:solidFill>
-            <a:srgbClr val="EEF2F6"/>
-          </a:solidFill>
-          <a:ln w="12700">
-            <a:solidFill>
-              <a:srgbClr val="EEF2F6"/>
-            </a:solidFill>
-            <a:prstDash val="solid"/>
-          </a:ln>
-        </p:spPr>
-      </p:sp>
-      <p:sp>
-        <p:nvSpPr>
-          <p:cNvPr id="10" name="Text 7"/>
-          <p:cNvSpPr txBox="1"/>
-          <p:nvPr/>
-        </p:nvSpPr>
-        <p:spPr>
-          <a:xfrm>
-            <a:off x="6629400" y="3063240"/>
-            <a:ext cx="3566160" cy="292608"/>
-          </a:xfrm>
-          <a:prstGeom prst="rect">
-            <a:avLst/>
-          </a:prstGeom>
-          <a:noFill/>
-          <a:ln/>
-        </p:spPr>
-        <p:txBody>
-          <a:bodyPr wrap="square" lIns="0" tIns="0" rIns="0" bIns="0" rtlCol="0" anchor="ctr"/>
-          <a:lstStyle/>
-          <a:p>
-            <a:pPr indent="0" marL="0">
-              <a:buNone/>
-            </a:pPr>
-            <a:r>
-              <a:rPr lang="en-US" sz="1200" b="1" dirty="0">
-                <a:solidFill>
-                  <a:srgbClr val="002C50"/>
-                </a:solidFill>
-                <a:latin typeface="Calibri" pitchFamily="34" charset="0"/>
-                <a:ea typeface="Calibri" pitchFamily="34" charset="-122"/>
-                <a:cs typeface="Calibri" pitchFamily="34" charset="-120"/>
-              </a:rPr>
-              <a:t>B – Avances intragroupe</a:t>
-            </a:r>
-            <a:endParaRPr lang="en-US" sz="1200" dirty="0"/>
-          </a:p>
-        </p:txBody>
-      </p:sp>
-      <p:sp>
-        <p:nvSpPr>
-          <p:cNvPr id="11" name="Text 8"/>
-          <p:cNvSpPr txBox="1"/>
-          <p:nvPr/>
-        </p:nvSpPr>
-        <p:spPr>
-          <a:xfrm>
-            <a:off x="10058400" y="3044952"/>
-            <a:ext cx="1508760" cy="329184"/>
-          </a:xfrm>
-          <a:prstGeom prst="rect">
-            <a:avLst/>
-          </a:prstGeom>
-          <a:noFill/>
-          <a:ln/>
-        </p:spPr>
-        <p:txBody>
-          <a:bodyPr wrap="square" lIns="0" tIns="0" rIns="0" bIns="0" rtlCol="0" anchor="ctr"/>
-          <a:lstStyle/>
-          <a:p>
-            <a:pPr algn="r" indent="0" marL="0">
-              <a:buNone/>
-            </a:pPr>
-            <a:r>
-              <a:rPr lang="en-US" sz="1400" b="1" dirty="0">
-                <a:solidFill>
-                  <a:srgbClr val="002C50"/>
-                </a:solidFill>
-                <a:latin typeface="Calibri" pitchFamily="34" charset="0"/>
-                <a:ea typeface="Calibri" pitchFamily="34" charset="-122"/>
-                <a:cs typeface="Calibri" pitchFamily="34" charset="-120"/>
-              </a:rPr>
-              <a:t>102,7 M</a:t>
-            </a:r>
-            <a:endParaRPr lang="en-US" sz="1400" dirty="0"/>
-          </a:p>
-        </p:txBody>
-      </p:sp>
-      <p:sp>
-        <p:nvSpPr>
-          <p:cNvPr id="12" name="Text 9"/>
-          <p:cNvSpPr txBox="1"/>
-          <p:nvPr/>
-        </p:nvSpPr>
-        <p:spPr>
-          <a:xfrm>
-            <a:off x="6629400" y="3410712"/>
-            <a:ext cx="4937760" cy="932688"/>
-          </a:xfrm>
-          <a:prstGeom prst="rect">
-            <a:avLst/>
-          </a:prstGeom>
-          <a:noFill/>
-          <a:ln/>
-        </p:spPr>
-        <p:txBody>
-          <a:bodyPr wrap="square" lIns="0" tIns="0" rIns="0" bIns="0" rtlCol="0" anchor="t"/>
-          <a:lstStyle/>
-          <a:p>
-            <a:pPr indent="0" marL="0">
-              <a:buNone/>
-            </a:pPr>
-            <a:r>
-              <a:rPr lang="en-US" sz="1100" dirty="0">
-                <a:solidFill>
-                  <a:srgbClr val="1F2933"/>
-                </a:solidFill>
-                <a:latin typeface="Calibri" pitchFamily="34" charset="0"/>
-                <a:ea typeface="Calibri" pitchFamily="34" charset="-122"/>
-                <a:cs typeface="Calibri" pitchFamily="34" charset="-120"/>
-              </a:rPr>
-              <a:t>Excédents en fin S5 : PICI 100,0 M, INFI SOFT 2,8 M. Ils couvriraient 12 % des déficits des sociétés, avec conventions de compte courant.</a:t>
-            </a:r>
-            <a:endParaRPr lang="en-US" sz="1100" dirty="0"/>
-          </a:p>
-        </p:txBody>
-      </p:sp>
-      <p:sp>
-        <p:nvSpPr>
-          <p:cNvPr id="13" name="Shape 10"/>
-          <p:cNvSpPr/>
-          <p:nvPr/>
-        </p:nvSpPr>
-        <p:spPr>
-          <a:xfrm>
-            <a:off x="6446520" y="4572000"/>
-            <a:ext cx="5285232" cy="1691640"/>
-          </a:xfrm>
-          <a:prstGeom prst="rect">
-            <a:avLst/>
-          </a:prstGeom>
-          <a:solidFill>
-            <a:srgbClr val="EEF2F6"/>
-          </a:solidFill>
-          <a:ln w="12700">
-            <a:solidFill>
-              <a:srgbClr val="EEF2F6"/>
-            </a:solidFill>
-            <a:prstDash val="solid"/>
-          </a:ln>
-        </p:spPr>
-      </p:sp>
-      <p:sp>
-        <p:nvSpPr>
-          <p:cNvPr id="14" name="Text 11"/>
-          <p:cNvSpPr txBox="1"/>
-          <p:nvPr/>
-        </p:nvSpPr>
-        <p:spPr>
-          <a:xfrm>
-            <a:off x="6629400" y="4663440"/>
-            <a:ext cx="3566160" cy="292608"/>
-          </a:xfrm>
-          <a:prstGeom prst="rect">
-            <a:avLst/>
-          </a:prstGeom>
-          <a:noFill/>
-          <a:ln/>
-        </p:spPr>
-        <p:txBody>
-          <a:bodyPr wrap="square" lIns="0" tIns="0" rIns="0" bIns="0" rtlCol="0" anchor="ctr"/>
-          <a:lstStyle/>
-          <a:p>
-            <a:pPr indent="0" marL="0">
-              <a:buNone/>
-            </a:pPr>
-            <a:r>
-              <a:rPr lang="en-US" sz="1200" b="1" dirty="0">
-                <a:solidFill>
-                  <a:srgbClr val="002C50"/>
-                </a:solidFill>
-                <a:latin typeface="Calibri" pitchFamily="34" charset="0"/>
-                <a:ea typeface="Calibri" pitchFamily="34" charset="-122"/>
-                <a:cs typeface="Calibri" pitchFamily="34" charset="-120"/>
-              </a:rPr>
-              <a:t>C – Projets</a:t>
-            </a:r>
-            <a:endParaRPr lang="en-US" sz="1200" dirty="0"/>
-          </a:p>
-        </p:txBody>
-      </p:sp>
-      <p:sp>
-        <p:nvSpPr>
-          <p:cNvPr id="15" name="Text 12"/>
-          <p:cNvSpPr txBox="1"/>
-          <p:nvPr/>
-        </p:nvSpPr>
-        <p:spPr>
-          <a:xfrm>
-            <a:off x="10058400" y="4645152"/>
-            <a:ext cx="1508760" cy="329184"/>
-          </a:xfrm>
-          <a:prstGeom prst="rect">
-            <a:avLst/>
-          </a:prstGeom>
-          <a:noFill/>
-          <a:ln/>
-        </p:spPr>
-        <p:txBody>
-          <a:bodyPr wrap="square" lIns="0" tIns="0" rIns="0" bIns="0" rtlCol="0" anchor="ctr"/>
-          <a:lstStyle/>
-          <a:p>
-            <a:pPr algn="r" indent="0" marL="0">
-              <a:buNone/>
-            </a:pPr>
-            <a:r>
-              <a:rPr lang="en-US" sz="1400" b="1" dirty="0">
-                <a:solidFill>
-                  <a:srgbClr val="002C50"/>
-                </a:solidFill>
-                <a:latin typeface="Calibri" pitchFamily="34" charset="0"/>
-                <a:ea typeface="Calibri" pitchFamily="34" charset="-122"/>
-                <a:cs typeface="Calibri" pitchFamily="34" charset="-120"/>
-              </a:rPr>
-              <a:t>1 102,6 M</a:t>
-            </a:r>
-            <a:endParaRPr lang="en-US" sz="1400" dirty="0"/>
-          </a:p>
-        </p:txBody>
-      </p:sp>
-      <p:sp>
-        <p:nvSpPr>
-          <p:cNvPr id="16" name="Text 13"/>
-          <p:cNvSpPr txBox="1"/>
-          <p:nvPr/>
-        </p:nvSpPr>
-        <p:spPr>
-          <a:xfrm>
-            <a:off x="6629400" y="5010912"/>
-            <a:ext cx="4937760" cy="1161288"/>
-          </a:xfrm>
-          <a:prstGeom prst="rect">
-            <a:avLst/>
-          </a:prstGeom>
-          <a:noFill/>
-          <a:ln/>
-        </p:spPr>
-        <p:txBody>
-          <a:bodyPr wrap="square" lIns="0" tIns="0" rIns="0" bIns="0" rtlCol="0" anchor="t"/>
-          <a:lstStyle/>
-          <a:p>
-            <a:pPr indent="0" marL="0">
-              <a:buNone/>
-            </a:pPr>
-            <a:r>
-              <a:rPr lang="en-US" sz="1100" dirty="0">
-                <a:solidFill>
-                  <a:srgbClr val="1F2933"/>
-                </a:solidFill>
-                <a:latin typeface="Calibri" pitchFamily="34" charset="0"/>
-                <a:ea typeface="Calibri" pitchFamily="34" charset="-122"/>
-                <a:cs typeface="Calibri" pitchFamily="34" charset="-120"/>
-              </a:rPr>
-              <a:t>Comptes à arbitrer : BNI-RIVIERA(Courant) 1 772,0 M ; affectés aux projets, ils couvriraient 100 % du déficit. À défaut : tirage des prêts des projets ou apport des actionnaires.</a:t>
-            </a:r>
-            <a:endParaRPr lang="en-US" sz="1100" dirty="0"/>
-          </a:p>
-        </p:txBody>
-      </p:sp>
-      <p:sp>
-        <p:nvSpPr>
-          <p:cNvPr id="17" name="Shape 14"/>
-          <p:cNvSpPr/>
-          <p:nvPr/>
-        </p:nvSpPr>
-        <p:spPr>
-          <a:xfrm>
-            <a:off x="457200" y="4850892"/>
-            <a:ext cx="5760720" cy="1458468"/>
-          </a:xfrm>
-          <a:prstGeom prst="rect">
-            <a:avLst/>
-          </a:prstGeom>
-          <a:solidFill>
-            <a:srgbClr val="002C50"/>
-          </a:solidFill>
-          <a:ln w="12700">
-            <a:solidFill>
-              <a:srgbClr val="002C50"/>
-            </a:solidFill>
-            <a:prstDash val="solid"/>
-          </a:ln>
-        </p:spPr>
-      </p:sp>
-      <p:sp>
-        <p:nvSpPr>
-          <p:cNvPr id="18" name="Text 15"/>
-          <p:cNvSpPr txBox="1"/>
-          <p:nvPr/>
-        </p:nvSpPr>
-        <p:spPr>
-          <a:xfrm>
-            <a:off x="640080" y="4942332"/>
-            <a:ext cx="5394960" cy="1293876"/>
-          </a:xfrm>
-          <a:prstGeom prst="rect">
-            <a:avLst/>
-          </a:prstGeom>
-          <a:noFill/>
-          <a:ln/>
-        </p:spPr>
-        <p:txBody>
-          <a:bodyPr wrap="square" lIns="0" tIns="0" rIns="0" bIns="0" rtlCol="0" anchor="t"/>
-          <a:lstStyle/>
-          <a:p>
-            <a:pPr indent="0" marL="0">
-              <a:spcAft>
-                <a:spcPts val="600"/>
-              </a:spcAft>
-              <a:buNone/>
-            </a:pPr>
-            <a:r>
-              <a:rPr lang="en-US" sz="1300" b="1" dirty="0">
-                <a:solidFill>
-                  <a:srgbClr val="D4B483"/>
-                </a:solidFill>
-                <a:latin typeface="Calibri" pitchFamily="34" charset="0"/>
-                <a:ea typeface="Calibri" pitchFamily="34" charset="-122"/>
-                <a:cs typeface="Calibri" pitchFamily="34" charset="-120"/>
-              </a:rPr>
-              <a:t>Décisions attendues</a:t>
-            </a:r>
-            <a:endParaRPr lang="en-US" sz="1300" dirty="0"/>
-          </a:p>
-          <a:p>
-            <a:pPr marL="152400" indent="-152400">
-              <a:spcAft>
-                <a:spcPts val="300"/>
-              </a:spcAft>
-              <a:buSzPct val="100000"/>
-              <a:buChar char="•"/>
-            </a:pPr>
-            <a:r>
-              <a:rPr lang="en-US" sz="900" dirty="0">
-                <a:solidFill>
-                  <a:srgbClr val="FFFFFF"/>
-                </a:solidFill>
-                <a:latin typeface="Calibri" pitchFamily="34" charset="0"/>
-                <a:ea typeface="Calibri" pitchFamily="34" charset="-122"/>
-                <a:cs typeface="Calibri" pitchFamily="34" charset="-120"/>
-              </a:rPr>
-              <a:t>Choisir la solution des sociétés en déficit (823,1 M) : crédit spot, avances intragroupe ou combinaison.</a:t>
-            </a:r>
-            <a:endParaRPr lang="en-US" sz="1300" dirty="0"/>
-          </a:p>
-          <a:p>
-            <a:pPr marL="152400" indent="-152400">
-              <a:spcAft>
-                <a:spcPts val="300"/>
-              </a:spcAft>
-              <a:buSzPct val="100000"/>
-              <a:buChar char="•"/>
-            </a:pPr>
-            <a:r>
-              <a:rPr lang="en-US" sz="900" dirty="0">
-                <a:solidFill>
-                  <a:srgbClr val="FFFFFF"/>
-                </a:solidFill>
-                <a:latin typeface="Calibri" pitchFamily="34" charset="0"/>
-                <a:ea typeface="Calibri" pitchFamily="34" charset="-122"/>
-                <a:cs typeface="Calibri" pitchFamily="34" charset="-120"/>
-              </a:rPr>
-              <a:t>Trancher l'affectation de BNI-RIVIERA(Courant) (1 772,0 M) : elle conditionne l'option C.</a:t>
-            </a:r>
-            <a:endParaRPr lang="en-US" sz="1300" dirty="0"/>
-          </a:p>
-          <a:p>
-            <a:pPr marL="152400" indent="-152400">
-              <a:spcAft>
-                <a:spcPts val="300"/>
-              </a:spcAft>
-              <a:buSzPct val="100000"/>
-              <a:buChar char="•"/>
-            </a:pPr>
-            <a:r>
-              <a:rPr lang="en-US" sz="900" dirty="0">
-                <a:solidFill>
-                  <a:srgbClr val="FFFFFF"/>
-                </a:solidFill>
-                <a:latin typeface="Calibri" pitchFamily="34" charset="0"/>
-                <a:ea typeface="Calibri" pitchFamily="34" charset="-122"/>
-                <a:cs typeface="Calibri" pitchFamily="34" charset="-120"/>
-              </a:rPr>
-              <a:t>Confirmer les encaissements prévus (248,9 M), dont SUD CONSTRUCTION – BCEAO (En attente … relance à effectuer).</a:t>
-            </a:r>
-            <a:endParaRPr lang="en-US" sz="1300" dirty="0"/>
-          </a:p>
-          <a:p>
-            <a:pPr marL="152400" indent="-152400">
-              <a:spcAft>
-                <a:spcPts val="300"/>
-              </a:spcAft>
-              <a:buSzPct val="100000"/>
-              <a:buChar char="•"/>
-            </a:pPr>
-            <a:r>
-              <a:rPr lang="en-US" sz="900" dirty="0">
-                <a:solidFill>
-                  <a:srgbClr val="FFFFFF"/>
-                </a:solidFill>
-                <a:latin typeface="Calibri" pitchFamily="34" charset="0"/>
-                <a:ea typeface="Calibri" pitchFamily="34" charset="-122"/>
-                <a:cs typeface="Calibri" pitchFamily="34" charset="-120"/>
-              </a:rPr>
-              <a:t>Confirmer les loyers de octobre 2026 (129,6 M), encaissés en fonctionnement de FIRST.</a:t>
-            </a:r>
-            <a:endParaRPr lang="en-US" sz="1300" dirty="0"/>
-          </a:p>
-          <a:p>
-            <a:pPr marL="152400" indent="-152400">
-              <a:spcAft>
-                <a:spcPts val="300"/>
-              </a:spcAft>
-              <a:buSzPct val="100000"/>
-              <a:buChar char="•"/>
-            </a:pPr>
-            <a:r>
-              <a:rPr lang="en-US" sz="900" dirty="0">
-                <a:solidFill>
-                  <a:srgbClr val="FFFFFF"/>
-                </a:solidFill>
-                <a:latin typeface="Calibri" pitchFamily="34" charset="0"/>
-                <a:ea typeface="Calibri" pitchFamily="34" charset="-122"/>
-                <a:cs typeface="Calibri" pitchFamily="34" charset="-120"/>
-              </a:rPr>
-              <a:t>Revoir les 25 lignes non retenues du reporting (intragroupe, droits d'enregistrement, loyers encaissés).</a:t>
-            </a:r>
-            <a:endParaRPr lang="en-US" sz="1300" dirty="0"/>
-          </a:p>
-        </p:txBody>
-      </p:sp>
-      <p:pic>
-        <p:nvPicPr>
-          <p:cNvPr id="19" name="Image 0" descr="preencoded.png">    </p:cNvPr>
-          <p:cNvPicPr>
-            <a:picLocks noChangeAspect="1"/>
-          </p:cNvPicPr>
-          <p:nvPr/>
-        </p:nvPicPr>
-        <p:blipFill>
-          <a:blip r:embed="rId1"/>
-          <a:stretch>
-            <a:fillRect/>
-          </a:stretch>
-        </p:blipFill>
-        <p:spPr>
-          <a:xfrm>
-            <a:off x="11018520" y="6382512"/>
-            <a:ext cx="530352" cy="329184"/>
-          </a:xfrm>
-          <a:prstGeom prst="rect">
-            <a:avLst/>
-          </a:prstGeom>
-        </p:spPr>
-      </p:pic>
-      <p:sp>
-        <p:nvSpPr>
-          <p:cNvPr id="20" name="Text 16"/>
-          <p:cNvSpPr txBox="1"/>
-          <p:nvPr/>
-        </p:nvSpPr>
-        <p:spPr>
-          <a:xfrm>
-            <a:off x="11612880" y="6400800"/>
-            <a:ext cx="365760" cy="274320"/>
-          </a:xfrm>
-          <a:prstGeom prst="rect">
-            <a:avLst/>
-          </a:prstGeom>
-          <a:noFill/>
-          <a:ln/>
-        </p:spPr>
-        <p:txBody>
-          <a:bodyPr wrap="square" lIns="0" tIns="0" rIns="0" bIns="0" rtlCol="0" anchor="ctr"/>
-          <a:lstStyle/>
-          <a:p>
-            <a:pPr indent="0" marL="0">
-              <a:buNone/>
-            </a:pPr>
-            <a:r>
-              <a:rPr lang="en-US" sz="900" dirty="0">
-                <a:solidFill>
-                  <a:srgbClr val="6B7280"/>
-                </a:solidFill>
-                <a:latin typeface="Calibri" pitchFamily="34" charset="0"/>
-                <a:ea typeface="Calibri" pitchFamily="34" charset="-122"/>
-                <a:cs typeface="Calibri" pitchFamily="34" charset="-120"/>
-              </a:rPr>
-              <a:t>5</a:t>
-            </a:r>
-            <a:endParaRPr lang="en-US" sz="900" dirty="0"/>
-          </a:p>
-        </p:txBody>
-      </p:sp>
-    </p:spTree>
-  </p:cSld>
-  <p:clrMapOvr>
-    <a:masterClrMapping/>
-  </p:clrMapOvr>
-</p:sld>
-</file>
-
-<file path=ppt/slides/slide6.xml><?xml version="1.0" encoding="utf-8"?>
-<p:sld xmlns:a="http://schemas.openxmlformats.org/drawingml/2006/main" xmlns:r="http://schemas.openxmlformats.org/officeDocument/2006/relationships" xmlns:p="http://schemas.openxmlformats.org/presentationml/2006/main">
-  <p:cSld name="Slide 6">
-    <p:bg>
-      <p:bgPr>
-        <a:solidFill>
-          <a:srgbClr val="FFFFFF"/>
-        </a:solidFill>
-      </p:bgPr>
-    </p:bg>
-    <p:spTree>
-      <p:nvGrpSpPr>
-        <p:cNvPr id="1" name=""/>
-        <p:cNvGrpSpPr/>
-        <p:nvPr/>
-      </p:nvGrpSpPr>
-      <p:grpSpPr>
-        <a:xfrm>
-          <a:off x="0" y="0"/>
-          <a:ext cx="0" cy="0"/>
-          <a:chOff x="0" y="0"/>
-          <a:chExt cx="0" cy="0"/>
-        </a:xfrm>
-      </p:grpSpPr>
-      <p:sp>
-        <p:nvSpPr>
-          <p:cNvPr id="2" name="Text 0"/>
-          <p:cNvSpPr txBox="1"/>
-          <p:nvPr/>
-        </p:nvSpPr>
-        <p:spPr>
-          <a:xfrm>
-            <a:off x="457200" y="274320"/>
-            <a:ext cx="11247120" cy="548640"/>
-          </a:xfrm>
-          <a:prstGeom prst="rect">
-            <a:avLst/>
-          </a:prstGeom>
-          <a:noFill/>
-          <a:ln/>
-        </p:spPr>
-        <p:txBody>
-          <a:bodyPr wrap="square" lIns="0" tIns="0" rIns="0" bIns="0" rtlCol="0" anchor="ctr"/>
-          <a:lstStyle/>
-          <a:p>
-            <a:pPr indent="0" marL="0">
-              <a:buNone/>
-            </a:pPr>
-            <a:r>
-              <a:rPr lang="en-US" sz="2600" b="1" dirty="0">
-                <a:solidFill>
-                  <a:srgbClr val="002C50"/>
-                </a:solidFill>
-                <a:latin typeface="Calibri" pitchFamily="34" charset="0"/>
-                <a:ea typeface="Calibri" pitchFamily="34" charset="-122"/>
-                <a:cs typeface="Calibri" pitchFamily="34" charset="-120"/>
-              </a:rPr>
-              <a:t>B. Paiement – 3. Équilibrage S1</a:t>
+              <a:t>B. Paiement – 2. Équilibrage Semaine 1</a:t>
             </a:r>
             <a:endParaRPr lang="en-US" sz="2600" dirty="0"/>
           </a:p>
@@ -20387,7 +15951,7 @@
                 <a:ea typeface="Calibri" pitchFamily="34" charset="-122"/>
                 <a:cs typeface="Calibri" pitchFamily="34" charset="-120"/>
               </a:rPr>
-              <a:t>À payer en S1 (fonctionnement, projets, échéances)</a:t>
+              <a:t>À payer en Semaine 1 (sociétés et projets)</a:t>
             </a:r>
             <a:endParaRPr lang="en-US" sz="1050" dirty="0"/>
           </a:p>
@@ -20702,7 +16266,7 @@
                 <a:ea typeface="Calibri" pitchFamily="34" charset="-122"/>
                 <a:cs typeface="Calibri" pitchFamily="34" charset="-120"/>
               </a:rPr>
-              <a:t>Reste à financer en S1 après virements</a:t>
+              <a:t>Reste à financer en Semaine 1 après virements</a:t>
             </a:r>
             <a:endParaRPr lang="en-US" sz="1050" dirty="0"/>
           </a:p>
@@ -20710,7 +16274,7 @@
       </p:sp>
       <p:graphicFrame>
         <p:nvGraphicFramePr>
-          <p:cNvPr id="7" name="Table 0"/>
+          <p:cNvPr id="6" name="Table 0"/>
           <p:cNvGraphicFramePr>
             <a:graphicFrameLocks noGrp="1"/>
           </p:cNvGraphicFramePr>
@@ -20892,7 +16456,7 @@
                           <a:ea typeface="Calibri" pitchFamily="34" charset="-122"/>
                           <a:cs typeface="Calibri" pitchFamily="34" charset="-120"/>
                         </a:rPr>
-                        <a:t>Flux S1</a:t>
+                        <a:t>Flux Semaine 1</a:t>
                       </a:r>
                       <a:endParaRPr lang="en-US" sz="850" dirty="0">
                         <a:latin typeface="Calibri" charset="0"/>
@@ -27349,7 +22913,7 @@
                 <a:ea typeface="Calibri" pitchFamily="34" charset="-122"/>
                 <a:cs typeface="Calibri" pitchFamily="34" charset="-120"/>
               </a:rPr>
-              <a:t>Reste à financer = somme des soldes théoriques négatifs, compte par compte (détail dans l'onglet « Équilibrage S1 » du reporting).</a:t>
+              <a:t>Reste à financer = somme des soldes théoriques négatifs, compte par compte (détail dans l'onglet d'équilibrage du reporting).</a:t>
             </a:r>
             <a:endParaRPr lang="en-US" sz="950" dirty="0"/>
           </a:p>
@@ -27412,7 +22976,7 @@
                 <a:ea typeface="Calibri" pitchFamily="34" charset="-122"/>
                 <a:cs typeface="Calibri" pitchFamily="34" charset="-120"/>
               </a:rPr>
-              <a:t>6</a:t>
+              <a:t>5</a:t>
             </a:r>
             <a:endParaRPr lang="en-US" sz="900" dirty="0"/>
           </a:p>

</xml_diff>